<commit_message>
Update presento about memory.
</commit_message>
<xml_diff>
--- a/docs/prompt-shields-vs-guardrails.pptx
+++ b/docs/prompt-shields-vs-guardrails.pptx
@@ -22,7 +22,9 @@
     <p:sldId id="265" r:id="rId16"/>
     <p:sldId id="266" r:id="rId17"/>
     <p:sldId id="267" r:id="rId18"/>
-    <p:sldId id="273" r:id="rId19"/>
+    <p:sldId id="274" r:id="rId19"/>
+    <p:sldId id="275" r:id="rId20"/>
+    <p:sldId id="273" r:id="rId21"/>
   </p:sldIdLst>
   <p:sldSz cx="12192000" cy="6858000"/>
   <p:notesSz cx="6858000" cy="9144000"/>
@@ -319,7 +321,7 @@
           <a:p>
             <a:fld id="{5BCAD085-E8A6-8845-BD4E-CB4CCA059FC4}" type="datetimeFigureOut">
               <a:rPr lang="en-US" smtClean="0"/>
-              <a:t>6/12/2026</a:t>
+              <a:t>6/16/2026</a:t>
             </a:fld>
             <a:endParaRPr lang="en-US"/>
           </a:p>
@@ -487,7 +489,7 @@
           <a:p>
             <a:fld id="{5BCAD085-E8A6-8845-BD4E-CB4CCA059FC4}" type="datetimeFigureOut">
               <a:rPr lang="en-US" smtClean="0"/>
-              <a:t>6/12/2026</a:t>
+              <a:t>6/16/2026</a:t>
             </a:fld>
             <a:endParaRPr lang="en-US"/>
           </a:p>
@@ -665,7 +667,7 @@
           <a:p>
             <a:fld id="{5BCAD085-E8A6-8845-BD4E-CB4CCA059FC4}" type="datetimeFigureOut">
               <a:rPr lang="en-US" smtClean="0"/>
-              <a:t>6/12/2026</a:t>
+              <a:t>6/16/2026</a:t>
             </a:fld>
             <a:endParaRPr lang="en-US"/>
           </a:p>
@@ -833,7 +835,7 @@
           <a:p>
             <a:fld id="{5BCAD085-E8A6-8845-BD4E-CB4CCA059FC4}" type="datetimeFigureOut">
               <a:rPr lang="en-US" smtClean="0"/>
-              <a:t>6/12/2026</a:t>
+              <a:t>6/16/2026</a:t>
             </a:fld>
             <a:endParaRPr lang="en-US"/>
           </a:p>
@@ -1078,7 +1080,7 @@
           <a:p>
             <a:fld id="{5BCAD085-E8A6-8845-BD4E-CB4CCA059FC4}" type="datetimeFigureOut">
               <a:rPr lang="en-US" smtClean="0"/>
-              <a:t>6/12/2026</a:t>
+              <a:t>6/16/2026</a:t>
             </a:fld>
             <a:endParaRPr lang="en-US"/>
           </a:p>
@@ -1363,7 +1365,7 @@
           <a:p>
             <a:fld id="{5BCAD085-E8A6-8845-BD4E-CB4CCA059FC4}" type="datetimeFigureOut">
               <a:rPr lang="en-US" smtClean="0"/>
-              <a:t>6/12/2026</a:t>
+              <a:t>6/16/2026</a:t>
             </a:fld>
             <a:endParaRPr lang="en-US"/>
           </a:p>
@@ -1782,7 +1784,7 @@
           <a:p>
             <a:fld id="{5BCAD085-E8A6-8845-BD4E-CB4CCA059FC4}" type="datetimeFigureOut">
               <a:rPr lang="en-US" smtClean="0"/>
-              <a:t>6/12/2026</a:t>
+              <a:t>6/16/2026</a:t>
             </a:fld>
             <a:endParaRPr lang="en-US"/>
           </a:p>
@@ -1899,7 +1901,7 @@
           <a:p>
             <a:fld id="{5BCAD085-E8A6-8845-BD4E-CB4CCA059FC4}" type="datetimeFigureOut">
               <a:rPr lang="en-US" smtClean="0"/>
-              <a:t>6/12/2026</a:t>
+              <a:t>6/16/2026</a:t>
             </a:fld>
             <a:endParaRPr lang="en-US"/>
           </a:p>
@@ -1994,7 +1996,7 @@
           <a:p>
             <a:fld id="{5BCAD085-E8A6-8845-BD4E-CB4CCA059FC4}" type="datetimeFigureOut">
               <a:rPr lang="en-US" smtClean="0"/>
-              <a:t>6/12/2026</a:t>
+              <a:t>6/16/2026</a:t>
             </a:fld>
             <a:endParaRPr lang="en-US"/>
           </a:p>
@@ -2269,7 +2271,7 @@
           <a:p>
             <a:fld id="{5BCAD085-E8A6-8845-BD4E-CB4CCA059FC4}" type="datetimeFigureOut">
               <a:rPr lang="en-US" smtClean="0"/>
-              <a:t>6/12/2026</a:t>
+              <a:t>6/16/2026</a:t>
             </a:fld>
             <a:endParaRPr lang="en-US"/>
           </a:p>
@@ -2521,7 +2523,7 @@
           <a:p>
             <a:fld id="{5BCAD085-E8A6-8845-BD4E-CB4CCA059FC4}" type="datetimeFigureOut">
               <a:rPr lang="en-US" smtClean="0"/>
-              <a:t>6/12/2026</a:t>
+              <a:t>6/16/2026</a:t>
             </a:fld>
             <a:endParaRPr lang="en-US"/>
           </a:p>
@@ -2732,7 +2734,7 @@
           <a:p>
             <a:fld id="{5BCAD085-E8A6-8845-BD4E-CB4CCA059FC4}" type="datetimeFigureOut">
               <a:rPr lang="en-US" smtClean="0"/>
-              <a:t>6/12/2026</a:t>
+              <a:t>6/16/2026</a:t>
             </a:fld>
             <a:endParaRPr lang="en-US"/>
           </a:p>
@@ -10566,7 +10568,7 @@
         <p:spPr>
           <a:xfrm>
             <a:off x="1051560" y="2286000"/>
-            <a:ext cx="4572000" cy="2880360"/>
+            <a:ext cx="4572000" cy="2211824"/>
           </a:xfrm>
           <a:prstGeom prst="rect">
             <a:avLst/>
@@ -10591,14 +10593,29 @@
               </a:spcAft>
             </a:pPr>
             <a:r>
-              <a:rPr sz="1400" b="1">
+              <a:rPr sz="1400" b="1" dirty="0">
                 <a:solidFill>
                   <a:srgbClr val="5C2D91"/>
                 </a:solidFill>
                 <a:latin typeface="Segoe UI"/>
               </a:rPr>
-              <a:t>INSIDE THE AGENT</a:t>
-            </a:r>
+              <a:t>INSIDE THE </a:t>
+            </a:r>
+            <a:r>
+              <a:rPr lang="en-US" sz="1400" b="1" dirty="0">
+                <a:solidFill>
+                  <a:srgbClr val="5C2D91"/>
+                </a:solidFill>
+                <a:latin typeface="Segoe UI"/>
+              </a:rPr>
+              <a:t>FOUNDRY</a:t>
+            </a:r>
+            <a:endParaRPr sz="1400" b="1" dirty="0">
+              <a:solidFill>
+                <a:srgbClr val="5C2D91"/>
+              </a:solidFill>
+              <a:latin typeface="Segoe UI"/>
+            </a:endParaRPr>
           </a:p>
           <a:p>
             <a:pPr algn="l">
@@ -10613,7 +10630,7 @@
               </a:spcAft>
             </a:pPr>
             <a:r>
-              <a:rPr sz="1250" b="1">
+              <a:rPr sz="1250" b="1" dirty="0">
                 <a:solidFill>
                   <a:srgbClr val="243A5E"/>
                 </a:solidFill>
@@ -10635,7 +10652,7 @@
               </a:spcAft>
             </a:pPr>
             <a:r>
-              <a:rPr sz="1200" b="1">
+              <a:rPr sz="1200" b="1" dirty="0">
                 <a:solidFill>
                   <a:srgbClr val="605E5C"/>
                 </a:solidFill>
@@ -10644,7 +10661,7 @@
               <a:t>Runs in:  </a:t>
             </a:r>
             <a:r>
-              <a:rPr sz="1200" b="0">
+              <a:rPr sz="1200" b="0" dirty="0">
                 <a:solidFill>
                   <a:srgbClr val="201F1E"/>
                 </a:solidFill>
@@ -10666,7 +10683,7 @@
               </a:spcAft>
             </a:pPr>
             <a:r>
-              <a:rPr sz="1200" b="1">
+              <a:rPr sz="1200" b="1" dirty="0">
                 <a:solidFill>
                   <a:srgbClr val="605E5C"/>
                 </a:solidFill>
@@ -10675,7 +10692,7 @@
               <a:t>Shield lives in:  </a:t>
             </a:r>
             <a:r>
-              <a:rPr sz="1200" b="0">
+              <a:rPr sz="1200" b="0" dirty="0">
                 <a:solidFill>
                   <a:srgbClr val="5C2D91"/>
                 </a:solidFill>
@@ -10697,23 +10714,56 @@
               </a:spcAft>
             </a:pPr>
             <a:r>
-              <a:rPr sz="1200" b="1">
+              <a:rPr sz="1200" b="1" dirty="0">
                 <a:solidFill>
                   <a:srgbClr val="605E5C"/>
                 </a:solidFill>
                 <a:latin typeface="Segoe UI"/>
               </a:rPr>
-              <a:t>App seam:  </a:t>
-            </a:r>
-            <a:r>
-              <a:rPr sz="1200" b="0">
+              <a:t>App </a:t>
+            </a:r>
+            <a:r>
+              <a:rPr lang="en-US" sz="1200" b="1" dirty="0">
+                <a:solidFill>
+                  <a:srgbClr val="605E5C"/>
+                </a:solidFill>
+                <a:latin typeface="Segoe UI"/>
+              </a:rPr>
+              <a:t>integration</a:t>
+            </a:r>
+            <a:r>
+              <a:rPr sz="1200" b="1" dirty="0">
+                <a:solidFill>
+                  <a:srgbClr val="605E5C"/>
+                </a:solidFill>
+                <a:latin typeface="Segoe UI"/>
+              </a:rPr>
+              <a:t>:  </a:t>
+            </a:r>
+            <a:r>
+              <a:rPr sz="1200" b="0" dirty="0">
                 <a:solidFill>
                   <a:srgbClr val="C5292A"/>
                 </a:solidFill>
                 <a:latin typeface="Segoe UI"/>
               </a:rPr>
-              <a:t>none</a:t>
-            </a:r>
+              <a:t>no</a:t>
+            </a:r>
+            <a:r>
+              <a:rPr lang="en-US" sz="1200" b="0" dirty="0">
+                <a:solidFill>
+                  <a:srgbClr val="C5292A"/>
+                </a:solidFill>
+                <a:latin typeface="Segoe UI"/>
+              </a:rPr>
+              <a:t>t applicable</a:t>
+            </a:r>
+            <a:endParaRPr sz="1200" b="0" dirty="0">
+              <a:solidFill>
+                <a:srgbClr val="C5292A"/>
+              </a:solidFill>
+              <a:latin typeface="Segoe UI"/>
+            </a:endParaRPr>
           </a:p>
           <a:p>
             <a:pPr algn="l">
@@ -10728,7 +10778,7 @@
               </a:spcAft>
             </a:pPr>
             <a:r>
-              <a:rPr sz="1200" b="1">
+              <a:rPr sz="1200" b="1" dirty="0">
                 <a:solidFill>
                   <a:srgbClr val="605E5C"/>
                 </a:solidFill>
@@ -10737,14 +10787,29 @@
               <a:t>Per-item check:  </a:t>
             </a:r>
             <a:r>
-              <a:rPr sz="1200" b="0">
+              <a:rPr sz="1200" b="0" dirty="0">
                 <a:solidFill>
                   <a:srgbClr val="C5292A"/>
                 </a:solidFill>
                 <a:latin typeface="Segoe UI"/>
               </a:rPr>
-              <a:t>not insertable</a:t>
-            </a:r>
+              <a:t>not </a:t>
+            </a:r>
+            <a:r>
+              <a:rPr lang="en-US" sz="1200" b="0" dirty="0">
+                <a:solidFill>
+                  <a:srgbClr val="C5292A"/>
+                </a:solidFill>
+                <a:latin typeface="Segoe UI"/>
+              </a:rPr>
+              <a:t>applicable</a:t>
+            </a:r>
+            <a:endParaRPr sz="1200" b="0" dirty="0">
+              <a:solidFill>
+                <a:srgbClr val="C5292A"/>
+              </a:solidFill>
+              <a:latin typeface="Segoe UI"/>
+            </a:endParaRPr>
           </a:p>
           <a:p>
             <a:pPr algn="l">
@@ -10759,7 +10824,7 @@
               </a:spcAft>
             </a:pPr>
             <a:r>
-              <a:rPr sz="1200" b="1">
+              <a:rPr sz="1200" b="1" dirty="0">
                 <a:solidFill>
                   <a:srgbClr val="605E5C"/>
                 </a:solidFill>
@@ -10768,7 +10833,7 @@
               <a:t>You rely on:  </a:t>
             </a:r>
             <a:r>
-              <a:rPr sz="1200" b="0">
+              <a:rPr sz="1200" b="0" dirty="0">
                 <a:solidFill>
                   <a:srgbClr val="201F1E"/>
                 </a:solidFill>
@@ -10837,7 +10902,7 @@
         <p:spPr>
           <a:xfrm>
             <a:off x="6537960" y="2286000"/>
-            <a:ext cx="4572000" cy="2880360"/>
+            <a:ext cx="4572000" cy="2012410"/>
           </a:xfrm>
           <a:prstGeom prst="rect">
             <a:avLst/>
@@ -10862,14 +10927,29 @@
               </a:spcAft>
             </a:pPr>
             <a:r>
-              <a:rPr sz="1400" b="1">
+              <a:rPr sz="1400" b="1" dirty="0">
                 <a:solidFill>
                   <a:srgbClr val="107C10"/>
                 </a:solidFill>
                 <a:latin typeface="Segoe UI"/>
               </a:rPr>
-              <a:t>OUTSIDE THE AGENT</a:t>
-            </a:r>
+              <a:t>OUTSIDE THE </a:t>
+            </a:r>
+            <a:r>
+              <a:rPr lang="en-US" sz="1400" b="1" dirty="0">
+                <a:solidFill>
+                  <a:srgbClr val="107C10"/>
+                </a:solidFill>
+                <a:latin typeface="Segoe UI"/>
+              </a:rPr>
+              <a:t>FOUNDRY</a:t>
+            </a:r>
+            <a:endParaRPr sz="1400" b="1" dirty="0">
+              <a:solidFill>
+                <a:srgbClr val="107C10"/>
+              </a:solidFill>
+              <a:latin typeface="Segoe UI"/>
+            </a:endParaRPr>
           </a:p>
           <a:p>
             <a:pPr algn="l">
@@ -10884,7 +10964,7 @@
               </a:spcAft>
             </a:pPr>
             <a:r>
-              <a:rPr sz="1250" b="1">
+              <a:rPr sz="1250" b="1" dirty="0">
                 <a:solidFill>
                   <a:srgbClr val="243A5E"/>
                 </a:solidFill>
@@ -10906,7 +10986,7 @@
               </a:spcAft>
             </a:pPr>
             <a:r>
-              <a:rPr sz="1200" b="1">
+              <a:rPr sz="1200" b="1" dirty="0">
                 <a:solidFill>
                   <a:srgbClr val="605E5C"/>
                 </a:solidFill>
@@ -10915,7 +10995,7 @@
               <a:t>Runs in:  </a:t>
             </a:r>
             <a:r>
-              <a:rPr sz="1200" b="0">
+              <a:rPr sz="1200" b="0" dirty="0">
                 <a:solidFill>
                   <a:srgbClr val="201F1E"/>
                 </a:solidFill>
@@ -10937,7 +11017,7 @@
               </a:spcAft>
             </a:pPr>
             <a:r>
-              <a:rPr sz="1200" b="1">
+              <a:rPr sz="1200" b="1" dirty="0">
                 <a:solidFill>
                   <a:srgbClr val="605E5C"/>
                 </a:solidFill>
@@ -10946,13 +11026,31 @@
               <a:t>Shield lives in:  </a:t>
             </a:r>
             <a:r>
-              <a:rPr sz="1200" b="0">
+              <a:rPr sz="1200" b="0" dirty="0">
                 <a:solidFill>
                   <a:srgbClr val="107C10"/>
                 </a:solidFill>
                 <a:latin typeface="Segoe UI"/>
               </a:rPr>
-              <a:t>explicit shieldPrompt() calls — your app code</a:t>
+              <a:t>explicit </a:t>
+            </a:r>
+            <a:r>
+              <a:rPr sz="1200" b="0" dirty="0" err="1">
+                <a:solidFill>
+                  <a:srgbClr val="107C10"/>
+                </a:solidFill>
+                <a:latin typeface="Segoe UI"/>
+              </a:rPr>
+              <a:t>shieldPrompt</a:t>
+            </a:r>
+            <a:r>
+              <a:rPr sz="1200" b="0" dirty="0">
+                <a:solidFill>
+                  <a:srgbClr val="107C10"/>
+                </a:solidFill>
+                <a:latin typeface="Segoe UI"/>
+              </a:rPr>
+              <a:t>() calls — your app code</a:t>
             </a:r>
           </a:p>
           <a:p>
@@ -10968,16 +11066,34 @@
               </a:spcAft>
             </a:pPr>
             <a:r>
-              <a:rPr sz="1200" b="1">
+              <a:rPr sz="1200" b="1" dirty="0">
                 <a:solidFill>
                   <a:srgbClr val="605E5C"/>
                 </a:solidFill>
                 <a:latin typeface="Segoe UI"/>
               </a:rPr>
-              <a:t>App seam:  </a:t>
-            </a:r>
-            <a:r>
-              <a:rPr sz="1200" b="0">
+              <a:t>App </a:t>
+            </a:r>
+            <a:r>
+              <a:rPr lang="en-US" sz="1200" b="1" dirty="0">
+                <a:solidFill>
+                  <a:srgbClr val="605E5C"/>
+                </a:solidFill>
+                <a:latin typeface="Segoe UI"/>
+              </a:rPr>
+              <a:t>integration</a:t>
+            </a:r>
+            <a:r>
+              <a:rPr sz="1200" b="1" dirty="0">
+                <a:solidFill>
+                  <a:srgbClr val="605E5C"/>
+                </a:solidFill>
+                <a:latin typeface="Segoe UI"/>
+              </a:rPr>
+              <a:t>:  </a:t>
+            </a:r>
+            <a:r>
+              <a:rPr sz="1200" b="0" dirty="0">
                 <a:solidFill>
                   <a:srgbClr val="107C10"/>
                 </a:solidFill>
@@ -10999,7 +11115,7 @@
               </a:spcAft>
             </a:pPr>
             <a:r>
-              <a:rPr sz="1200" b="1">
+              <a:rPr sz="1200" b="1" dirty="0">
                 <a:solidFill>
                   <a:srgbClr val="605E5C"/>
                 </a:solidFill>
@@ -11008,13 +11124,31 @@
               <a:t>Per-item check:  </a:t>
             </a:r>
             <a:r>
-              <a:rPr sz="1200" b="0">
+              <a:rPr sz="1200" b="0" dirty="0">
                 <a:solidFill>
                   <a:srgbClr val="107C10"/>
                 </a:solidFill>
                 <a:latin typeface="Segoe UI"/>
               </a:rPr>
-              <a:t>available — full defence in depth</a:t>
+              <a:t>available — full </a:t>
+            </a:r>
+            <a:r>
+              <a:rPr sz="1200" b="0" dirty="0" err="1">
+                <a:solidFill>
+                  <a:srgbClr val="107C10"/>
+                </a:solidFill>
+                <a:latin typeface="Segoe UI"/>
+              </a:rPr>
+              <a:t>defence</a:t>
+            </a:r>
+            <a:r>
+              <a:rPr sz="1200" b="0" dirty="0">
+                <a:solidFill>
+                  <a:srgbClr val="107C10"/>
+                </a:solidFill>
+                <a:latin typeface="Segoe UI"/>
+              </a:rPr>
+              <a:t> in depth</a:t>
             </a:r>
           </a:p>
           <a:p>
@@ -11030,7 +11164,7 @@
               </a:spcAft>
             </a:pPr>
             <a:r>
-              <a:rPr sz="1200" b="1">
+              <a:rPr sz="1200" b="1" dirty="0">
                 <a:solidFill>
                   <a:srgbClr val="605E5C"/>
                 </a:solidFill>
@@ -11039,7 +11173,7 @@
               <a:t>Cost:  </a:t>
             </a:r>
             <a:r>
-              <a:rPr sz="1200" b="0">
+              <a:rPr sz="1200" b="0" dirty="0">
                 <a:solidFill>
                   <a:srgbClr val="201F1E"/>
                 </a:solidFill>
@@ -11290,14 +11424,6 @@
 <file path=ppt/slides/slide18.xml><?xml version="1.0" encoding="utf-8"?>
 <p:sld xmlns:a="http://schemas.openxmlformats.org/drawingml/2006/main" xmlns:r="http://schemas.openxmlformats.org/officeDocument/2006/relationships" xmlns:p="http://schemas.openxmlformats.org/presentationml/2006/main">
   <p:cSld>
-    <p:bg>
-      <p:bgPr>
-        <a:solidFill>
-          <a:srgbClr val="243A5E"/>
-        </a:solidFill>
-        <a:effectLst/>
-      </p:bgPr>
-    </p:bg>
     <p:spTree>
       <p:nvGrpSpPr>
         <p:cNvPr id="1" name=""/>
@@ -11321,7 +11447,7 @@
         <p:spPr>
           <a:xfrm>
             <a:off x="0" y="0"/>
-            <a:ext cx="12191695" cy="164592"/>
+            <a:ext cx="12188952" cy="164592"/>
           </a:xfrm>
           <a:prstGeom prst="rect">
             <a:avLst/>
@@ -11359,14 +11485,98 @@
       </p:sp>
       <p:sp>
         <p:nvSpPr>
-          <p:cNvPr id="3" name="Rectangle 2"/>
+          <p:cNvPr id="3" name="TextBox 2"/>
+          <p:cNvSpPr txBox="1"/>
+          <p:nvPr/>
+        </p:nvSpPr>
+        <p:spPr>
+          <a:xfrm>
+            <a:off x="640080" y="411480"/>
+            <a:ext cx="10972800" cy="365760"/>
+          </a:xfrm>
+          <a:prstGeom prst="rect">
+            <a:avLst/>
+          </a:prstGeom>
+          <a:noFill/>
+        </p:spPr>
+        <p:txBody>
+          <a:bodyPr wrap="square">
+            <a:spAutoFit/>
+          </a:bodyPr>
+          <a:lstStyle/>
+          <a:p>
+            <a:pPr algn="l">
+              <a:lnSpc>
+                <a:spcPct val="100000"/>
+              </a:lnSpc>
+              <a:spcAft>
+                <a:spcPts val="600"/>
+              </a:spcAft>
+            </a:pPr>
+            <a:r>
+              <a:rPr sz="1300" b="1">
+                <a:solidFill>
+                  <a:srgbClr val="0078D4"/>
+                </a:solidFill>
+                <a:latin typeface="Segoe UI"/>
+              </a:rPr>
+              <a:t>FOUNDRY AGENT SERVICE · BUILT-IN MEMORY</a:t>
+            </a:r>
+          </a:p>
+        </p:txBody>
+      </p:sp>
+      <p:sp>
+        <p:nvSpPr>
+          <p:cNvPr id="4" name="TextBox 3"/>
+          <p:cNvSpPr txBox="1"/>
+          <p:nvPr/>
+        </p:nvSpPr>
+        <p:spPr>
+          <a:xfrm>
+            <a:off x="640080" y="749808"/>
+            <a:ext cx="10972800" cy="822960"/>
+          </a:xfrm>
+          <a:prstGeom prst="rect">
+            <a:avLst/>
+          </a:prstGeom>
+          <a:noFill/>
+        </p:spPr>
+        <p:txBody>
+          <a:bodyPr wrap="square">
+            <a:spAutoFit/>
+          </a:bodyPr>
+          <a:lstStyle/>
+          <a:p>
+            <a:pPr algn="l">
+              <a:lnSpc>
+                <a:spcPct val="100000"/>
+              </a:lnSpc>
+              <a:spcAft>
+                <a:spcPts val="600"/>
+              </a:spcAft>
+            </a:pPr>
+            <a:r>
+              <a:rPr sz="3000" b="1">
+                <a:solidFill>
+                  <a:srgbClr val="243A5E"/>
+                </a:solidFill>
+                <a:latin typeface="Segoe UI"/>
+              </a:rPr>
+              <a:t>A managed memory subsystem</a:t>
+            </a:r>
+          </a:p>
+        </p:txBody>
+      </p:sp>
+      <p:sp>
+        <p:nvSpPr>
+          <p:cNvPr id="5" name="Rectangle 4"/>
           <p:cNvSpPr/>
           <p:nvPr/>
         </p:nvSpPr>
         <p:spPr>
           <a:xfrm>
-            <a:off x="0" y="6355080"/>
-            <a:ext cx="12191695" cy="502920"/>
+            <a:off x="658368" y="1481328"/>
+            <a:ext cx="1005840" cy="45720"/>
           </a:xfrm>
           <a:prstGeom prst="rect">
             <a:avLst/>
@@ -11404,14 +11614,14 @@
       </p:sp>
       <p:sp>
         <p:nvSpPr>
-          <p:cNvPr id="4" name="TextBox 3"/>
+          <p:cNvPr id="6" name="TextBox 5"/>
           <p:cNvSpPr txBox="1"/>
           <p:nvPr/>
         </p:nvSpPr>
         <p:spPr>
           <a:xfrm>
-            <a:off x="822960" y="731520"/>
-            <a:ext cx="10515600" cy="548640"/>
+            <a:off x="777240" y="1627632"/>
+            <a:ext cx="10607040" cy="457200"/>
           </a:xfrm>
           <a:prstGeom prst="rect">
             <a:avLst/>
@@ -11419,44 +11629,41 @@
           <a:noFill/>
         </p:spPr>
         <p:txBody>
-          <a:bodyPr wrap="square" lIns="50800" tIns="25400" rIns="50800" bIns="25400" anchor="t">
+          <a:bodyPr wrap="square">
             <a:spAutoFit/>
           </a:bodyPr>
           <a:lstStyle/>
           <a:p>
             <a:pPr algn="l">
               <a:lnSpc>
-                <a:spcPct val="100000"/>
-              </a:lnSpc>
-              <a:spcBef>
-                <a:spcPts val="0"/>
-              </a:spcBef>
+                <a:spcPct val="105000"/>
+              </a:lnSpc>
               <a:spcAft>
                 <a:spcPts val="600"/>
               </a:spcAft>
             </a:pPr>
             <a:r>
-              <a:rPr sz="1500" b="1">
-                <a:solidFill>
-                  <a:srgbClr val="8AB9E8"/>
-                </a:solidFill>
-                <a:latin typeface="Segoe UI"/>
-              </a:rPr>
-              <a:t>TAKEAWAYS</a:t>
-            </a:r>
-          </a:p>
-        </p:txBody>
-      </p:sp>
-      <p:sp>
-        <p:nvSpPr>
-          <p:cNvPr id="5" name="TextBox 4"/>
+              <a:rPr sz="1600" b="0">
+                <a:solidFill>
+                  <a:srgbClr val="605E5C"/>
+                </a:solidFill>
+                <a:latin typeface="Segoe UI"/>
+              </a:rPr>
+              <a:t>Turn it on and Foundry runs the whole pipeline server-side — no vector database to build or run.</a:t>
+            </a:r>
+          </a:p>
+        </p:txBody>
+      </p:sp>
+      <p:sp>
+        <p:nvSpPr>
+          <p:cNvPr id="7" name="TextBox 6"/>
           <p:cNvSpPr txBox="1"/>
           <p:nvPr/>
         </p:nvSpPr>
         <p:spPr>
           <a:xfrm>
-            <a:off x="822960" y="1280160"/>
-            <a:ext cx="10515600" cy="731520"/>
+            <a:off x="640080" y="6419088"/>
+            <a:ext cx="7315200" cy="320040"/>
           </a:xfrm>
           <a:prstGeom prst="rect">
             <a:avLst/>
@@ -11464,7 +11671,7 @@
           <a:noFill/>
         </p:spPr>
         <p:txBody>
-          <a:bodyPr wrap="square" lIns="50800" tIns="25400" rIns="50800" bIns="25400" anchor="t">
+          <a:bodyPr wrap="square">
             <a:spAutoFit/>
           </a:bodyPr>
           <a:lstStyle/>
@@ -11473,40 +11680,843 @@
               <a:lnSpc>
                 <a:spcPct val="100000"/>
               </a:lnSpc>
-              <a:spcBef>
-                <a:spcPts val="0"/>
-              </a:spcBef>
               <a:spcAft>
                 <a:spcPts val="600"/>
               </a:spcAft>
             </a:pPr>
             <a:r>
-              <a:rPr sz="3000" b="1">
-                <a:solidFill>
-                  <a:srgbClr val="FFFFFF"/>
-                </a:solidFill>
-                <a:latin typeface="Segoe UI"/>
-              </a:rPr>
-              <a:t>Three things to remember</a:t>
-            </a:r>
-          </a:p>
-        </p:txBody>
-      </p:sp>
-      <p:sp>
-        <p:nvSpPr>
-          <p:cNvPr id="6" name="Rounded Rectangle 5"/>
+              <a:rPr sz="900" b="0">
+                <a:solidFill>
+                  <a:srgbClr val="605E5C"/>
+                </a:solidFill>
+                <a:latin typeface="Segoe UI"/>
+              </a:rPr>
+              <a:t>Prompt Shields vs. Guardrails  ·  Gislefoss Meteorologist Agent</a:t>
+            </a:r>
+          </a:p>
+        </p:txBody>
+      </p:sp>
+      <p:sp>
+        <p:nvSpPr>
+          <p:cNvPr id="8" name="TextBox 7"/>
+          <p:cNvSpPr txBox="1"/>
+          <p:nvPr/>
+        </p:nvSpPr>
+        <p:spPr>
+          <a:xfrm>
+            <a:off x="10972800" y="6419088"/>
+            <a:ext cx="822960" cy="320040"/>
+          </a:xfrm>
+          <a:prstGeom prst="rect">
+            <a:avLst/>
+          </a:prstGeom>
+          <a:noFill/>
+        </p:spPr>
+        <p:txBody>
+          <a:bodyPr wrap="square">
+            <a:spAutoFit/>
+          </a:bodyPr>
+          <a:lstStyle/>
+          <a:p>
+            <a:pPr algn="r">
+              <a:lnSpc>
+                <a:spcPct val="100000"/>
+              </a:lnSpc>
+              <a:spcAft>
+                <a:spcPts val="600"/>
+              </a:spcAft>
+            </a:pPr>
+            <a:r>
+              <a:rPr sz="900" b="0">
+                <a:solidFill>
+                  <a:srgbClr val="605E5C"/>
+                </a:solidFill>
+                <a:latin typeface="Segoe UI"/>
+              </a:rPr>
+              <a:t>10</a:t>
+            </a:r>
+          </a:p>
+        </p:txBody>
+      </p:sp>
+      <p:sp>
+        <p:nvSpPr>
+          <p:cNvPr id="9" name="Rounded Rectangle 8"/>
           <p:cNvSpPr/>
           <p:nvPr/>
         </p:nvSpPr>
         <p:spPr>
           <a:xfrm>
-            <a:off x="822960" y="2240280"/>
-            <a:ext cx="502920" cy="1097280"/>
+            <a:off x="777240" y="2331720"/>
+            <a:ext cx="2395728" cy="2240280"/>
           </a:xfrm>
           <a:prstGeom prst="roundRect">
             <a:avLst>
-              <a:gd name="adj" fmla="val 20000"/>
+              <a:gd name="adj" fmla="val 6000"/>
             </a:avLst>
+          </a:prstGeom>
+          <a:solidFill>
+            <a:srgbClr val="FFFFFF"/>
+          </a:solidFill>
+          <a:ln w="25400">
+            <a:solidFill>
+              <a:srgbClr val="0078D4"/>
+            </a:solidFill>
+          </a:ln>
+          <a:effectLst/>
+        </p:spPr>
+        <p:style>
+          <a:lnRef idx="1">
+            <a:schemeClr val="accent1"/>
+          </a:lnRef>
+          <a:fillRef idx="3">
+            <a:schemeClr val="accent1"/>
+          </a:fillRef>
+          <a:effectRef idx="2">
+            <a:schemeClr val="accent1"/>
+          </a:effectRef>
+          <a:fontRef idx="minor">
+            <a:schemeClr val="lt1"/>
+          </a:fontRef>
+        </p:style>
+        <p:txBody>
+          <a:bodyPr rtlCol="0" anchor="ctr"/>
+          <a:lstStyle/>
+          <a:p>
+            <a:pPr algn="ctr"/>
+            <a:endParaRPr/>
+          </a:p>
+        </p:txBody>
+      </p:sp>
+      <p:sp>
+        <p:nvSpPr>
+          <p:cNvPr id="10" name="TextBox 9"/>
+          <p:cNvSpPr txBox="1"/>
+          <p:nvPr/>
+        </p:nvSpPr>
+        <p:spPr>
+          <a:xfrm>
+            <a:off x="960120" y="2532888"/>
+            <a:ext cx="2029968" cy="1874520"/>
+          </a:xfrm>
+          <a:prstGeom prst="rect">
+            <a:avLst/>
+          </a:prstGeom>
+          <a:noFill/>
+        </p:spPr>
+        <p:txBody>
+          <a:bodyPr wrap="square">
+            <a:normAutofit/>
+          </a:bodyPr>
+          <a:lstStyle/>
+          <a:p>
+            <a:pPr algn="l">
+              <a:lnSpc>
+                <a:spcPct val="100000"/>
+              </a:lnSpc>
+              <a:spcAft>
+                <a:spcPts val="300"/>
+              </a:spcAft>
+            </a:pPr>
+            <a:r>
+              <a:rPr sz="1000" b="1">
+                <a:solidFill>
+                  <a:srgbClr val="0078D4"/>
+                </a:solidFill>
+                <a:latin typeface="Segoe UI"/>
+              </a:rPr>
+              <a:t>STEP 1</a:t>
+            </a:r>
+          </a:p>
+          <a:p>
+            <a:pPr algn="l">
+              <a:lnSpc>
+                <a:spcPct val="102000"/>
+              </a:lnSpc>
+              <a:spcAft>
+                <a:spcPts val="500"/>
+              </a:spcAft>
+            </a:pPr>
+            <a:r>
+              <a:rPr sz="1400" b="1">
+                <a:solidFill>
+                  <a:srgbClr val="243A5E"/>
+                </a:solidFill>
+                <a:latin typeface="Segoe UI"/>
+              </a:rPr>
+              <a:t>EXTRACTION</a:t>
+            </a:r>
+          </a:p>
+          <a:p>
+            <a:pPr algn="l">
+              <a:lnSpc>
+                <a:spcPct val="105000"/>
+              </a:lnSpc>
+              <a:spcAft>
+                <a:spcPts val="0"/>
+              </a:spcAft>
+            </a:pPr>
+            <a:r>
+              <a:rPr sz="1100" b="0">
+                <a:solidFill>
+                  <a:srgbClr val="605E5C"/>
+                </a:solidFill>
+                <a:latin typeface="Segoe UI"/>
+              </a:rPr>
+              <a:t>The chat model distils durable facts from each conversation — home city, preferred units.</a:t>
+            </a:r>
+          </a:p>
+        </p:txBody>
+      </p:sp>
+      <p:sp>
+        <p:nvSpPr>
+          <p:cNvPr id="11" name="TextBox 10"/>
+          <p:cNvSpPr txBox="1"/>
+          <p:nvPr/>
+        </p:nvSpPr>
+        <p:spPr>
+          <a:xfrm>
+            <a:off x="3182112" y="3232404"/>
+            <a:ext cx="310896" cy="411480"/>
+          </a:xfrm>
+          <a:prstGeom prst="rect">
+            <a:avLst/>
+          </a:prstGeom>
+          <a:noFill/>
+        </p:spPr>
+        <p:txBody>
+          <a:bodyPr wrap="square" anchor="ctr">
+            <a:spAutoFit/>
+          </a:bodyPr>
+          <a:lstStyle/>
+          <a:p>
+            <a:pPr algn="ctr">
+              <a:lnSpc>
+                <a:spcPct val="100000"/>
+              </a:lnSpc>
+            </a:pPr>
+            <a:r>
+              <a:rPr sz="1800" b="1">
+                <a:solidFill>
+                  <a:srgbClr val="0078D4"/>
+                </a:solidFill>
+                <a:latin typeface="Segoe UI"/>
+              </a:rPr>
+              <a:t>▶</a:t>
+            </a:r>
+          </a:p>
+        </p:txBody>
+      </p:sp>
+      <p:sp>
+        <p:nvSpPr>
+          <p:cNvPr id="12" name="Rounded Rectangle 11"/>
+          <p:cNvSpPr/>
+          <p:nvPr/>
+        </p:nvSpPr>
+        <p:spPr>
+          <a:xfrm>
+            <a:off x="3502152" y="2331720"/>
+            <a:ext cx="2395728" cy="2240280"/>
+          </a:xfrm>
+          <a:prstGeom prst="roundRect">
+            <a:avLst>
+              <a:gd name="adj" fmla="val 6000"/>
+            </a:avLst>
+          </a:prstGeom>
+          <a:solidFill>
+            <a:srgbClr val="FFFFFF"/>
+          </a:solidFill>
+          <a:ln w="25400">
+            <a:solidFill>
+              <a:srgbClr val="0078D4"/>
+            </a:solidFill>
+          </a:ln>
+          <a:effectLst/>
+        </p:spPr>
+        <p:style>
+          <a:lnRef idx="1">
+            <a:schemeClr val="accent1"/>
+          </a:lnRef>
+          <a:fillRef idx="3">
+            <a:schemeClr val="accent1"/>
+          </a:fillRef>
+          <a:effectRef idx="2">
+            <a:schemeClr val="accent1"/>
+          </a:effectRef>
+          <a:fontRef idx="minor">
+            <a:schemeClr val="lt1"/>
+          </a:fontRef>
+        </p:style>
+        <p:txBody>
+          <a:bodyPr rtlCol="0" anchor="ctr"/>
+          <a:lstStyle/>
+          <a:p>
+            <a:pPr algn="ctr"/>
+            <a:endParaRPr/>
+          </a:p>
+        </p:txBody>
+      </p:sp>
+      <p:sp>
+        <p:nvSpPr>
+          <p:cNvPr id="13" name="TextBox 12"/>
+          <p:cNvSpPr txBox="1"/>
+          <p:nvPr/>
+        </p:nvSpPr>
+        <p:spPr>
+          <a:xfrm>
+            <a:off x="3685032" y="2532888"/>
+            <a:ext cx="2029968" cy="1874520"/>
+          </a:xfrm>
+          <a:prstGeom prst="rect">
+            <a:avLst/>
+          </a:prstGeom>
+          <a:noFill/>
+        </p:spPr>
+        <p:txBody>
+          <a:bodyPr wrap="square">
+            <a:normAutofit/>
+          </a:bodyPr>
+          <a:lstStyle/>
+          <a:p>
+            <a:pPr algn="l">
+              <a:lnSpc>
+                <a:spcPct val="100000"/>
+              </a:lnSpc>
+              <a:spcAft>
+                <a:spcPts val="300"/>
+              </a:spcAft>
+            </a:pPr>
+            <a:r>
+              <a:rPr sz="1000" b="1">
+                <a:solidFill>
+                  <a:srgbClr val="0078D4"/>
+                </a:solidFill>
+                <a:latin typeface="Segoe UI"/>
+              </a:rPr>
+              <a:t>STEP 2</a:t>
+            </a:r>
+          </a:p>
+          <a:p>
+            <a:pPr algn="l">
+              <a:lnSpc>
+                <a:spcPct val="102000"/>
+              </a:lnSpc>
+              <a:spcAft>
+                <a:spcPts val="500"/>
+              </a:spcAft>
+            </a:pPr>
+            <a:r>
+              <a:rPr sz="1400" b="1">
+                <a:solidFill>
+                  <a:srgbClr val="243A5E"/>
+                </a:solidFill>
+                <a:latin typeface="Segoe UI"/>
+              </a:rPr>
+              <a:t>CONSOLIDATION</a:t>
+            </a:r>
+          </a:p>
+          <a:p>
+            <a:pPr algn="l">
+              <a:lnSpc>
+                <a:spcPct val="105000"/>
+              </a:lnSpc>
+              <a:spcAft>
+                <a:spcPts val="0"/>
+              </a:spcAft>
+            </a:pPr>
+            <a:r>
+              <a:rPr sz="1100" b="0">
+                <a:solidFill>
+                  <a:srgbClr val="605E5C"/>
+                </a:solidFill>
+                <a:latin typeface="Segoe UI"/>
+              </a:rPr>
+              <a:t>Facts are merged, updated and de-duplicated over time; each write resets the item’s freshness clock.</a:t>
+            </a:r>
+          </a:p>
+        </p:txBody>
+      </p:sp>
+      <p:sp>
+        <p:nvSpPr>
+          <p:cNvPr id="14" name="TextBox 13"/>
+          <p:cNvSpPr txBox="1"/>
+          <p:nvPr/>
+        </p:nvSpPr>
+        <p:spPr>
+          <a:xfrm>
+            <a:off x="5907024" y="3232404"/>
+            <a:ext cx="310896" cy="411480"/>
+          </a:xfrm>
+          <a:prstGeom prst="rect">
+            <a:avLst/>
+          </a:prstGeom>
+          <a:noFill/>
+        </p:spPr>
+        <p:txBody>
+          <a:bodyPr wrap="square" anchor="ctr">
+            <a:spAutoFit/>
+          </a:bodyPr>
+          <a:lstStyle/>
+          <a:p>
+            <a:pPr algn="ctr">
+              <a:lnSpc>
+                <a:spcPct val="100000"/>
+              </a:lnSpc>
+            </a:pPr>
+            <a:r>
+              <a:rPr sz="1800" b="1">
+                <a:solidFill>
+                  <a:srgbClr val="0078D4"/>
+                </a:solidFill>
+                <a:latin typeface="Segoe UI"/>
+              </a:rPr>
+              <a:t>▶</a:t>
+            </a:r>
+          </a:p>
+        </p:txBody>
+      </p:sp>
+      <p:sp>
+        <p:nvSpPr>
+          <p:cNvPr id="15" name="Rounded Rectangle 14"/>
+          <p:cNvSpPr/>
+          <p:nvPr/>
+        </p:nvSpPr>
+        <p:spPr>
+          <a:xfrm>
+            <a:off x="6227064" y="2331720"/>
+            <a:ext cx="2395728" cy="2240280"/>
+          </a:xfrm>
+          <a:prstGeom prst="roundRect">
+            <a:avLst>
+              <a:gd name="adj" fmla="val 6000"/>
+            </a:avLst>
+          </a:prstGeom>
+          <a:solidFill>
+            <a:srgbClr val="FFFFFF"/>
+          </a:solidFill>
+          <a:ln w="25400">
+            <a:solidFill>
+              <a:srgbClr val="0078D4"/>
+            </a:solidFill>
+          </a:ln>
+          <a:effectLst/>
+        </p:spPr>
+        <p:style>
+          <a:lnRef idx="1">
+            <a:schemeClr val="accent1"/>
+          </a:lnRef>
+          <a:fillRef idx="3">
+            <a:schemeClr val="accent1"/>
+          </a:fillRef>
+          <a:effectRef idx="2">
+            <a:schemeClr val="accent1"/>
+          </a:effectRef>
+          <a:fontRef idx="minor">
+            <a:schemeClr val="lt1"/>
+          </a:fontRef>
+        </p:style>
+        <p:txBody>
+          <a:bodyPr rtlCol="0" anchor="ctr"/>
+          <a:lstStyle/>
+          <a:p>
+            <a:pPr algn="ctr"/>
+            <a:endParaRPr/>
+          </a:p>
+        </p:txBody>
+      </p:sp>
+      <p:sp>
+        <p:nvSpPr>
+          <p:cNvPr id="16" name="TextBox 15"/>
+          <p:cNvSpPr txBox="1"/>
+          <p:nvPr/>
+        </p:nvSpPr>
+        <p:spPr>
+          <a:xfrm>
+            <a:off x="6409944" y="2532888"/>
+            <a:ext cx="2029968" cy="1874520"/>
+          </a:xfrm>
+          <a:prstGeom prst="rect">
+            <a:avLst/>
+          </a:prstGeom>
+          <a:noFill/>
+        </p:spPr>
+        <p:txBody>
+          <a:bodyPr wrap="square">
+            <a:normAutofit/>
+          </a:bodyPr>
+          <a:lstStyle/>
+          <a:p>
+            <a:pPr algn="l">
+              <a:lnSpc>
+                <a:spcPct val="100000"/>
+              </a:lnSpc>
+              <a:spcAft>
+                <a:spcPts val="300"/>
+              </a:spcAft>
+            </a:pPr>
+            <a:r>
+              <a:rPr sz="1000" b="1">
+                <a:solidFill>
+                  <a:srgbClr val="0078D4"/>
+                </a:solidFill>
+                <a:latin typeface="Segoe UI"/>
+              </a:rPr>
+              <a:t>STEP 3</a:t>
+            </a:r>
+          </a:p>
+          <a:p>
+            <a:pPr algn="l">
+              <a:lnSpc>
+                <a:spcPct val="102000"/>
+              </a:lnSpc>
+              <a:spcAft>
+                <a:spcPts val="500"/>
+              </a:spcAft>
+            </a:pPr>
+            <a:r>
+              <a:rPr sz="1400" b="1">
+                <a:solidFill>
+                  <a:srgbClr val="243A5E"/>
+                </a:solidFill>
+                <a:latin typeface="Segoe UI"/>
+              </a:rPr>
+              <a:t>VECTOR STORAGE</a:t>
+            </a:r>
+          </a:p>
+          <a:p>
+            <a:pPr algn="l">
+              <a:lnSpc>
+                <a:spcPct val="105000"/>
+              </a:lnSpc>
+              <a:spcAft>
+                <a:spcPts val="0"/>
+              </a:spcAft>
+            </a:pPr>
+            <a:r>
+              <a:rPr sz="1100" b="0">
+                <a:solidFill>
+                  <a:srgbClr val="605E5C"/>
+                </a:solidFill>
+                <a:latin typeface="Segoe UI"/>
+              </a:rPr>
+              <a:t>Every memory is embedded and held in a managed vector store — no search service to run yourself.</a:t>
+            </a:r>
+          </a:p>
+        </p:txBody>
+      </p:sp>
+      <p:sp>
+        <p:nvSpPr>
+          <p:cNvPr id="17" name="TextBox 16"/>
+          <p:cNvSpPr txBox="1"/>
+          <p:nvPr/>
+        </p:nvSpPr>
+        <p:spPr>
+          <a:xfrm>
+            <a:off x="8631936" y="3232404"/>
+            <a:ext cx="310896" cy="411480"/>
+          </a:xfrm>
+          <a:prstGeom prst="rect">
+            <a:avLst/>
+          </a:prstGeom>
+          <a:noFill/>
+        </p:spPr>
+        <p:txBody>
+          <a:bodyPr wrap="square" anchor="ctr">
+            <a:spAutoFit/>
+          </a:bodyPr>
+          <a:lstStyle/>
+          <a:p>
+            <a:pPr algn="ctr">
+              <a:lnSpc>
+                <a:spcPct val="100000"/>
+              </a:lnSpc>
+            </a:pPr>
+            <a:r>
+              <a:rPr sz="1800" b="1">
+                <a:solidFill>
+                  <a:srgbClr val="0078D4"/>
+                </a:solidFill>
+                <a:latin typeface="Segoe UI"/>
+              </a:rPr>
+              <a:t>▶</a:t>
+            </a:r>
+          </a:p>
+        </p:txBody>
+      </p:sp>
+      <p:sp>
+        <p:nvSpPr>
+          <p:cNvPr id="18" name="Rounded Rectangle 17"/>
+          <p:cNvSpPr/>
+          <p:nvPr/>
+        </p:nvSpPr>
+        <p:spPr>
+          <a:xfrm>
+            <a:off x="8951976" y="2331720"/>
+            <a:ext cx="2395728" cy="2240280"/>
+          </a:xfrm>
+          <a:prstGeom prst="roundRect">
+            <a:avLst>
+              <a:gd name="adj" fmla="val 6000"/>
+            </a:avLst>
+          </a:prstGeom>
+          <a:solidFill>
+            <a:srgbClr val="FFFFFF"/>
+          </a:solidFill>
+          <a:ln w="25400">
+            <a:solidFill>
+              <a:srgbClr val="0078D4"/>
+            </a:solidFill>
+          </a:ln>
+          <a:effectLst/>
+        </p:spPr>
+        <p:style>
+          <a:lnRef idx="1">
+            <a:schemeClr val="accent1"/>
+          </a:lnRef>
+          <a:fillRef idx="3">
+            <a:schemeClr val="accent1"/>
+          </a:fillRef>
+          <a:effectRef idx="2">
+            <a:schemeClr val="accent1"/>
+          </a:effectRef>
+          <a:fontRef idx="minor">
+            <a:schemeClr val="lt1"/>
+          </a:fontRef>
+        </p:style>
+        <p:txBody>
+          <a:bodyPr rtlCol="0" anchor="ctr"/>
+          <a:lstStyle/>
+          <a:p>
+            <a:pPr algn="ctr"/>
+            <a:endParaRPr/>
+          </a:p>
+        </p:txBody>
+      </p:sp>
+      <p:sp>
+        <p:nvSpPr>
+          <p:cNvPr id="19" name="TextBox 18"/>
+          <p:cNvSpPr txBox="1"/>
+          <p:nvPr/>
+        </p:nvSpPr>
+        <p:spPr>
+          <a:xfrm>
+            <a:off x="9134855" y="2532888"/>
+            <a:ext cx="2029968" cy="1874520"/>
+          </a:xfrm>
+          <a:prstGeom prst="rect">
+            <a:avLst/>
+          </a:prstGeom>
+          <a:noFill/>
+        </p:spPr>
+        <p:txBody>
+          <a:bodyPr wrap="square">
+            <a:normAutofit/>
+          </a:bodyPr>
+          <a:lstStyle/>
+          <a:p>
+            <a:pPr algn="l">
+              <a:lnSpc>
+                <a:spcPct val="100000"/>
+              </a:lnSpc>
+              <a:spcAft>
+                <a:spcPts val="300"/>
+              </a:spcAft>
+            </a:pPr>
+            <a:r>
+              <a:rPr sz="1000" b="1">
+                <a:solidFill>
+                  <a:srgbClr val="0078D4"/>
+                </a:solidFill>
+                <a:latin typeface="Segoe UI"/>
+              </a:rPr>
+              <a:t>STEP 4</a:t>
+            </a:r>
+          </a:p>
+          <a:p>
+            <a:pPr algn="l">
+              <a:lnSpc>
+                <a:spcPct val="102000"/>
+              </a:lnSpc>
+              <a:spcAft>
+                <a:spcPts val="500"/>
+              </a:spcAft>
+            </a:pPr>
+            <a:r>
+              <a:rPr sz="1400" b="1">
+                <a:solidFill>
+                  <a:srgbClr val="243A5E"/>
+                </a:solidFill>
+                <a:latin typeface="Segoe UI"/>
+              </a:rPr>
+              <a:t>SEMANTIC RETRIEVAL</a:t>
+            </a:r>
+          </a:p>
+          <a:p>
+            <a:pPr algn="l">
+              <a:lnSpc>
+                <a:spcPct val="105000"/>
+              </a:lnSpc>
+              <a:spcAft>
+                <a:spcPts val="0"/>
+              </a:spcAft>
+            </a:pPr>
+            <a:r>
+              <a:rPr sz="1100" b="0">
+                <a:solidFill>
+                  <a:srgbClr val="605E5C"/>
+                </a:solidFill>
+                <a:latin typeface="Segoe UI"/>
+              </a:rPr>
+              <a:t>The most relevant memories are recalled by meaning and added to the next prompt.</a:t>
+            </a:r>
+          </a:p>
+        </p:txBody>
+      </p:sp>
+      <p:sp>
+        <p:nvSpPr>
+          <p:cNvPr id="20" name="Rounded Rectangle 19"/>
+          <p:cNvSpPr/>
+          <p:nvPr/>
+        </p:nvSpPr>
+        <p:spPr>
+          <a:xfrm>
+            <a:off x="777240" y="4773168"/>
+            <a:ext cx="10607040" cy="1024128"/>
+          </a:xfrm>
+          <a:prstGeom prst="roundRect">
+            <a:avLst>
+              <a:gd name="adj" fmla="val 5000"/>
+            </a:avLst>
+          </a:prstGeom>
+          <a:solidFill>
+            <a:srgbClr val="243A5E"/>
+          </a:solidFill>
+          <a:ln>
+            <a:noFill/>
+          </a:ln>
+          <a:effectLst/>
+        </p:spPr>
+        <p:style>
+          <a:lnRef idx="1">
+            <a:schemeClr val="accent1"/>
+          </a:lnRef>
+          <a:fillRef idx="3">
+            <a:schemeClr val="accent1"/>
+          </a:fillRef>
+          <a:effectRef idx="2">
+            <a:schemeClr val="accent1"/>
+          </a:effectRef>
+          <a:fontRef idx="minor">
+            <a:schemeClr val="lt1"/>
+          </a:fontRef>
+        </p:style>
+        <p:txBody>
+          <a:bodyPr rtlCol="0" anchor="ctr"/>
+          <a:lstStyle/>
+          <a:p>
+            <a:pPr algn="ctr"/>
+            <a:endParaRPr/>
+          </a:p>
+        </p:txBody>
+      </p:sp>
+      <p:sp>
+        <p:nvSpPr>
+          <p:cNvPr id="21" name="TextBox 20"/>
+          <p:cNvSpPr txBox="1"/>
+          <p:nvPr/>
+        </p:nvSpPr>
+        <p:spPr>
+          <a:xfrm>
+            <a:off x="1051560" y="4773168"/>
+            <a:ext cx="10058400" cy="1024128"/>
+          </a:xfrm>
+          <a:prstGeom prst="rect">
+            <a:avLst/>
+          </a:prstGeom>
+          <a:noFill/>
+        </p:spPr>
+        <p:txBody>
+          <a:bodyPr wrap="square" anchor="ctr">
+            <a:spAutoFit/>
+          </a:bodyPr>
+          <a:lstStyle/>
+          <a:p>
+            <a:pPr algn="l">
+              <a:lnSpc>
+                <a:spcPct val="105000"/>
+              </a:lnSpc>
+              <a:spcAft>
+                <a:spcPts val="400"/>
+              </a:spcAft>
+            </a:pPr>
+            <a:r>
+              <a:rPr sz="1700" b="1">
+                <a:solidFill>
+                  <a:srgbClr val="FFFFFF"/>
+                </a:solidFill>
+                <a:latin typeface="Segoe UI"/>
+              </a:rPr>
+              <a:t>All four stages run inside Foundry’s managed loop.</a:t>
+            </a:r>
+          </a:p>
+          <a:p>
+            <a:pPr algn="l">
+              <a:lnSpc>
+                <a:spcPct val="105000"/>
+              </a:lnSpc>
+              <a:spcAft>
+                <a:spcPts val="0"/>
+              </a:spcAft>
+            </a:pPr>
+            <a:r>
+              <a:rPr sz="1300" b="0">
+                <a:solidFill>
+                  <a:srgbClr val="C7D6EA"/>
+                </a:solidFill>
+                <a:latin typeface="Segoe UI"/>
+              </a:rPr>
+              <a:t>You bring two model deployments; the platform does the extraction, vectorization, storage and recall. That same convenience is why the next slides treat memory as new attack surface.</a:t>
+            </a:r>
+          </a:p>
+        </p:txBody>
+      </p:sp>
+    </p:spTree>
+  </p:cSld>
+  <p:clrMapOvr>
+    <a:masterClrMapping/>
+  </p:clrMapOvr>
+</p:sld>
+</file>
+
+<file path=ppt/slides/slide19.xml><?xml version="1.0" encoding="utf-8"?>
+<p:sld xmlns:a="http://schemas.openxmlformats.org/drawingml/2006/main" xmlns:r="http://schemas.openxmlformats.org/officeDocument/2006/relationships" xmlns:p="http://schemas.openxmlformats.org/presentationml/2006/main">
+  <p:cSld>
+    <p:spTree>
+      <p:nvGrpSpPr>
+        <p:cNvPr id="1" name=""/>
+        <p:cNvGrpSpPr/>
+        <p:nvPr/>
+      </p:nvGrpSpPr>
+      <p:grpSpPr>
+        <a:xfrm>
+          <a:off x="0" y="0"/>
+          <a:ext cx="0" cy="0"/>
+          <a:chOff x="0" y="0"/>
+          <a:chExt cx="0" cy="0"/>
+        </a:xfrm>
+      </p:grpSpPr>
+      <p:sp>
+        <p:nvSpPr>
+          <p:cNvPr id="2" name="Rectangle 1"/>
+          <p:cNvSpPr/>
+          <p:nvPr/>
+        </p:nvSpPr>
+        <p:spPr>
+          <a:xfrm>
+            <a:off x="0" y="0"/>
+            <a:ext cx="12188952" cy="164592"/>
+          </a:xfrm>
+          <a:prstGeom prst="rect">
+            <a:avLst/>
           </a:prstGeom>
           <a:solidFill>
             <a:srgbClr val="0078D4"/>
@@ -11541,14 +12551,14 @@
       </p:sp>
       <p:sp>
         <p:nvSpPr>
-          <p:cNvPr id="7" name="TextBox 6"/>
+          <p:cNvPr id="3" name="TextBox 2"/>
           <p:cNvSpPr txBox="1"/>
           <p:nvPr/>
         </p:nvSpPr>
         <p:spPr>
           <a:xfrm>
-            <a:off x="822960" y="2496312"/>
-            <a:ext cx="502920" cy="640080"/>
+            <a:off x="640080" y="411480"/>
+            <a:ext cx="10972800" cy="365760"/>
           </a:xfrm>
           <a:prstGeom prst="rect">
             <a:avLst/>
@@ -11556,44 +12566,41 @@
           <a:noFill/>
         </p:spPr>
         <p:txBody>
-          <a:bodyPr wrap="square" lIns="50800" tIns="25400" rIns="50800" bIns="25400" anchor="t">
+          <a:bodyPr wrap="square">
             <a:spAutoFit/>
           </a:bodyPr>
           <a:lstStyle/>
           <a:p>
-            <a:pPr algn="ctr">
+            <a:pPr algn="l">
               <a:lnSpc>
                 <a:spcPct val="100000"/>
               </a:lnSpc>
-              <a:spcBef>
-                <a:spcPts val="0"/>
-              </a:spcBef>
               <a:spcAft>
                 <a:spcPts val="600"/>
               </a:spcAft>
             </a:pPr>
             <a:r>
-              <a:rPr sz="2600" b="1">
-                <a:solidFill>
-                  <a:srgbClr val="FFFFFF"/>
-                </a:solidFill>
-                <a:latin typeface="Segoe UI"/>
-              </a:rPr>
-              <a:t>1</a:t>
-            </a:r>
-          </a:p>
-        </p:txBody>
-      </p:sp>
-      <p:sp>
-        <p:nvSpPr>
-          <p:cNvPr id="8" name="TextBox 7"/>
+              <a:rPr sz="1300" b="1">
+                <a:solidFill>
+                  <a:srgbClr val="0078D4"/>
+                </a:solidFill>
+                <a:latin typeface="Segoe UI"/>
+              </a:rPr>
+              <a:t>BEFORE YOU TURN IT ON · OPERATIONS, COST &amp; CONFIG</a:t>
+            </a:r>
+          </a:p>
+        </p:txBody>
+      </p:sp>
+      <p:sp>
+        <p:nvSpPr>
+          <p:cNvPr id="4" name="TextBox 3"/>
           <p:cNvSpPr txBox="1"/>
           <p:nvPr/>
         </p:nvSpPr>
         <p:spPr>
           <a:xfrm>
-            <a:off x="1554480" y="2286000"/>
-            <a:ext cx="9784080" cy="1188720"/>
+            <a:off x="640080" y="749808"/>
+            <a:ext cx="10972800" cy="822960"/>
           </a:xfrm>
           <a:prstGeom prst="rect">
             <a:avLst/>
@@ -11601,71 +12608,44 @@
           <a:noFill/>
         </p:spPr>
         <p:txBody>
-          <a:bodyPr wrap="square" lIns="50800" tIns="25400" rIns="50800" bIns="25400" anchor="t">
+          <a:bodyPr wrap="square">
             <a:spAutoFit/>
           </a:bodyPr>
           <a:lstStyle/>
           <a:p>
             <a:pPr algn="l">
               <a:lnSpc>
-                <a:spcPct val="105000"/>
-              </a:lnSpc>
-              <a:spcBef>
-                <a:spcPts val="0"/>
-              </a:spcBef>
+                <a:spcPct val="100000"/>
+              </a:lnSpc>
               <a:spcAft>
                 <a:spcPts val="600"/>
               </a:spcAft>
             </a:pPr>
             <a:r>
-              <a:rPr sz="2000" b="1">
-                <a:solidFill>
-                  <a:srgbClr val="FFFFFF"/>
-                </a:solidFill>
-                <a:latin typeface="Segoe UI"/>
-              </a:rPr>
-              <a:t>Containment, not rivalry</a:t>
-            </a:r>
-          </a:p>
-          <a:p>
-            <a:pPr algn="l">
-              <a:lnSpc>
-                <a:spcPct val="105000"/>
-              </a:lnSpc>
-              <a:spcBef>
-                <a:spcPts val="0"/>
-              </a:spcBef>
-              <a:spcAft>
-                <a:spcPts val="600"/>
-              </a:spcAft>
-            </a:pPr>
-            <a:r>
-              <a:rPr sz="1500" b="0">
-                <a:solidFill>
-                  <a:srgbClr val="C7D6EA"/>
-                </a:solidFill>
-                <a:latin typeface="Segoe UI"/>
-              </a:rPr>
-              <a:t>A Prompt Shield is one detector inside the guardrail (RAI policy) — not a competing feature.</a:t>
-            </a:r>
-          </a:p>
-        </p:txBody>
-      </p:sp>
-      <p:sp>
-        <p:nvSpPr>
-          <p:cNvPr id="9" name="Rounded Rectangle 8"/>
+              <a:rPr sz="3000" b="1">
+                <a:solidFill>
+                  <a:srgbClr val="243A5E"/>
+                </a:solidFill>
+                <a:latin typeface="Segoe UI"/>
+              </a:rPr>
+              <a:t>Size, cost, TTL &amp; the embedding dependency</a:t>
+            </a:r>
+          </a:p>
+        </p:txBody>
+      </p:sp>
+      <p:sp>
+        <p:nvSpPr>
+          <p:cNvPr id="5" name="Rectangle 4"/>
           <p:cNvSpPr/>
           <p:nvPr/>
         </p:nvSpPr>
         <p:spPr>
           <a:xfrm>
-            <a:off x="822960" y="3566160"/>
-            <a:ext cx="502920" cy="1097280"/>
-          </a:xfrm>
-          <a:prstGeom prst="roundRect">
-            <a:avLst>
-              <a:gd name="adj" fmla="val 20000"/>
-            </a:avLst>
+            <a:off x="658368" y="1481328"/>
+            <a:ext cx="1005840" cy="45720"/>
+          </a:xfrm>
+          <a:prstGeom prst="rect">
+            <a:avLst/>
           </a:prstGeom>
           <a:solidFill>
             <a:srgbClr val="0078D4"/>
@@ -11700,14 +12680,14 @@
       </p:sp>
       <p:sp>
         <p:nvSpPr>
-          <p:cNvPr id="10" name="TextBox 9"/>
+          <p:cNvPr id="6" name="TextBox 5"/>
           <p:cNvSpPr txBox="1"/>
           <p:nvPr/>
         </p:nvSpPr>
         <p:spPr>
           <a:xfrm>
-            <a:off x="822960" y="3822192"/>
-            <a:ext cx="502920" cy="640080"/>
+            <a:off x="777240" y="1627632"/>
+            <a:ext cx="10607040" cy="457200"/>
           </a:xfrm>
           <a:prstGeom prst="rect">
             <a:avLst/>
@@ -11715,44 +12695,41 @@
           <a:noFill/>
         </p:spPr>
         <p:txBody>
-          <a:bodyPr wrap="square" lIns="50800" tIns="25400" rIns="50800" bIns="25400" anchor="t">
+          <a:bodyPr wrap="square">
             <a:spAutoFit/>
           </a:bodyPr>
           <a:lstStyle/>
           <a:p>
-            <a:pPr algn="ctr">
-              <a:lnSpc>
-                <a:spcPct val="100000"/>
-              </a:lnSpc>
-              <a:spcBef>
-                <a:spcPts val="0"/>
-              </a:spcBef>
+            <a:pPr algn="l">
+              <a:lnSpc>
+                <a:spcPct val="105000"/>
+              </a:lnSpc>
               <a:spcAft>
                 <a:spcPts val="600"/>
               </a:spcAft>
             </a:pPr>
             <a:r>
-              <a:rPr sz="2600" b="1">
-                <a:solidFill>
-                  <a:srgbClr val="FFFFFF"/>
-                </a:solidFill>
-                <a:latin typeface="Segoe UI"/>
-              </a:rPr>
-              <a:t>2</a:t>
-            </a:r>
-          </a:p>
-        </p:txBody>
-      </p:sp>
-      <p:sp>
-        <p:nvSpPr>
-          <p:cNvPr id="11" name="TextBox 10"/>
+              <a:rPr sz="1600" b="0">
+                <a:solidFill>
+                  <a:srgbClr val="605E5C"/>
+                </a:solidFill>
+                <a:latin typeface="Segoe UI"/>
+              </a:rPr>
+              <a:t>Four decisions are yours before flipping deployMemory = true — the loop won’t make them for you.</a:t>
+            </a:r>
+          </a:p>
+        </p:txBody>
+      </p:sp>
+      <p:sp>
+        <p:nvSpPr>
+          <p:cNvPr id="7" name="TextBox 6"/>
           <p:cNvSpPr txBox="1"/>
           <p:nvPr/>
         </p:nvSpPr>
         <p:spPr>
           <a:xfrm>
-            <a:off x="1554480" y="3611880"/>
-            <a:ext cx="9784080" cy="1188720"/>
+            <a:off x="640080" y="6419088"/>
+            <a:ext cx="7315200" cy="320040"/>
           </a:xfrm>
           <a:prstGeom prst="rect">
             <a:avLst/>
@@ -11760,77 +12737,96 @@
           <a:noFill/>
         </p:spPr>
         <p:txBody>
-          <a:bodyPr wrap="square" lIns="50800" tIns="25400" rIns="50800" bIns="25400" anchor="t">
+          <a:bodyPr wrap="square">
             <a:spAutoFit/>
           </a:bodyPr>
           <a:lstStyle/>
           <a:p>
             <a:pPr algn="l">
               <a:lnSpc>
-                <a:spcPct val="105000"/>
-              </a:lnSpc>
-              <a:spcBef>
-                <a:spcPts val="0"/>
-              </a:spcBef>
+                <a:spcPct val="100000"/>
+              </a:lnSpc>
               <a:spcAft>
                 <a:spcPts val="600"/>
               </a:spcAft>
             </a:pPr>
             <a:r>
-              <a:rPr sz="2000" b="1">
-                <a:solidFill>
-                  <a:srgbClr val="FFFFFF"/>
-                </a:solidFill>
-                <a:latin typeface="Segoe UI"/>
-              </a:rPr>
-              <a:t>Content vs. intent</a:t>
-            </a:r>
-          </a:p>
-          <a:p>
-            <a:pPr algn="l">
-              <a:lnSpc>
-                <a:spcPct val="105000"/>
-              </a:lnSpc>
-              <a:spcBef>
-                <a:spcPts val="0"/>
-              </a:spcBef>
+              <a:rPr sz="900" b="0">
+                <a:solidFill>
+                  <a:srgbClr val="605E5C"/>
+                </a:solidFill>
+                <a:latin typeface="Segoe UI"/>
+              </a:rPr>
+              <a:t>Prompt Shields vs. Guardrails  ·  Gislefoss Meteorologist Agent</a:t>
+            </a:r>
+          </a:p>
+        </p:txBody>
+      </p:sp>
+      <p:sp>
+        <p:nvSpPr>
+          <p:cNvPr id="8" name="TextBox 7"/>
+          <p:cNvSpPr txBox="1"/>
+          <p:nvPr/>
+        </p:nvSpPr>
+        <p:spPr>
+          <a:xfrm>
+            <a:off x="10972800" y="6419088"/>
+            <a:ext cx="822960" cy="320040"/>
+          </a:xfrm>
+          <a:prstGeom prst="rect">
+            <a:avLst/>
+          </a:prstGeom>
+          <a:noFill/>
+        </p:spPr>
+        <p:txBody>
+          <a:bodyPr wrap="square">
+            <a:spAutoFit/>
+          </a:bodyPr>
+          <a:lstStyle/>
+          <a:p>
+            <a:pPr algn="r">
+              <a:lnSpc>
+                <a:spcPct val="100000"/>
+              </a:lnSpc>
               <a:spcAft>
                 <a:spcPts val="600"/>
               </a:spcAft>
             </a:pPr>
             <a:r>
-              <a:rPr sz="1500" b="0">
-                <a:solidFill>
-                  <a:srgbClr val="C7D6EA"/>
-                </a:solidFill>
-                <a:latin typeface="Segoe UI"/>
-              </a:rPr>
-              <a:t>Guardrail harm filters catch toxic CONTENT; shields catch adversarial INTENT (hijacking).</a:t>
-            </a:r>
-          </a:p>
-        </p:txBody>
-      </p:sp>
-      <p:sp>
-        <p:nvSpPr>
-          <p:cNvPr id="12" name="Rounded Rectangle 11"/>
+              <a:rPr sz="900" b="0">
+                <a:solidFill>
+                  <a:srgbClr val="605E5C"/>
+                </a:solidFill>
+                <a:latin typeface="Segoe UI"/>
+              </a:rPr>
+              <a:t>11</a:t>
+            </a:r>
+          </a:p>
+        </p:txBody>
+      </p:sp>
+      <p:sp>
+        <p:nvSpPr>
+          <p:cNvPr id="9" name="Rounded Rectangle 8"/>
           <p:cNvSpPr/>
           <p:nvPr/>
         </p:nvSpPr>
         <p:spPr>
           <a:xfrm>
-            <a:off x="822960" y="4892040"/>
-            <a:ext cx="502920" cy="1097280"/>
+            <a:off x="777240" y="2240280"/>
+            <a:ext cx="5120640" cy="1783080"/>
           </a:xfrm>
           <a:prstGeom prst="roundRect">
             <a:avLst>
-              <a:gd name="adj" fmla="val 20000"/>
+              <a:gd name="adj" fmla="val 5000"/>
             </a:avLst>
           </a:prstGeom>
           <a:solidFill>
-            <a:srgbClr val="0078D4"/>
+            <a:srgbClr val="FFFFFF"/>
           </a:solidFill>
-          <a:ln>
-            <a:noFill/>
+          <a:ln w="25400">
+            <a:solidFill>
+              <a:srgbClr val="0078D4"/>
+            </a:solidFill>
           </a:ln>
           <a:effectLst/>
         </p:spPr>
@@ -11859,14 +12855,14 @@
       </p:sp>
       <p:sp>
         <p:nvSpPr>
-          <p:cNvPr id="13" name="TextBox 12"/>
+          <p:cNvPr id="10" name="TextBox 9"/>
           <p:cNvSpPr txBox="1"/>
           <p:nvPr/>
         </p:nvSpPr>
         <p:spPr>
           <a:xfrm>
-            <a:off x="822960" y="5148072"/>
-            <a:ext cx="502920" cy="640080"/>
+            <a:off x="1033271" y="2404872"/>
+            <a:ext cx="4608575" cy="1472184"/>
           </a:xfrm>
           <a:prstGeom prst="rect">
             <a:avLst/>
@@ -11874,97 +12870,509 @@
           <a:noFill/>
         </p:spPr>
         <p:txBody>
-          <a:bodyPr wrap="square" lIns="50800" tIns="25400" rIns="50800" bIns="25400" anchor="t">
+          <a:bodyPr wrap="square">
+            <a:normAutofit/>
+          </a:bodyPr>
+          <a:lstStyle/>
+          <a:p>
+            <a:pPr algn="l">
+              <a:lnSpc>
+                <a:spcPct val="100000"/>
+              </a:lnSpc>
+              <a:spcAft>
+                <a:spcPts val="300"/>
+              </a:spcAft>
+            </a:pPr>
+            <a:r>
+              <a:rPr sz="1300" b="1">
+                <a:solidFill>
+                  <a:srgbClr val="0078D4"/>
+                </a:solidFill>
+                <a:latin typeface="Segoe UI"/>
+              </a:rPr>
+              <a:t>SIZE</a:t>
+            </a:r>
+          </a:p>
+          <a:p>
+            <a:pPr algn="l">
+              <a:lnSpc>
+                <a:spcPct val="102000"/>
+              </a:lnSpc>
+              <a:spcAft>
+                <a:spcPts val="400"/>
+              </a:spcAft>
+            </a:pPr>
+            <a:r>
+              <a:rPr sz="1400" b="1">
+                <a:solidFill>
+                  <a:srgbClr val="243A5E"/>
+                </a:solidFill>
+                <a:latin typeface="Segoe UI"/>
+              </a:rPr>
+              <a:t>Items, not gigabytes.</a:t>
+            </a:r>
+          </a:p>
+          <a:p>
+            <a:pPr algn="l">
+              <a:lnSpc>
+                <a:spcPct val="105000"/>
+              </a:lnSpc>
+              <a:spcAft>
+                <a:spcPts val="0"/>
+              </a:spcAft>
+            </a:pPr>
+            <a:r>
+              <a:rPr sz="1150" b="0">
+                <a:solidFill>
+                  <a:srgbClr val="605E5C"/>
+                </a:solidFill>
+                <a:latin typeface="Segoe UI"/>
+              </a:rPr>
+              <a:t>≈ 10,000 memories per user-scope, ~1,000 req/min (reported · preview · unconfirmed; absent from the official quota doc). A weather bot stores a handful per user.</a:t>
+            </a:r>
+          </a:p>
+        </p:txBody>
+      </p:sp>
+      <p:sp>
+        <p:nvSpPr>
+          <p:cNvPr id="11" name="Rounded Rectangle 10"/>
+          <p:cNvSpPr/>
+          <p:nvPr/>
+        </p:nvSpPr>
+        <p:spPr>
+          <a:xfrm>
+            <a:off x="6263640" y="2240280"/>
+            <a:ext cx="5120640" cy="1783080"/>
+          </a:xfrm>
+          <a:prstGeom prst="roundRect">
+            <a:avLst>
+              <a:gd name="adj" fmla="val 5000"/>
+            </a:avLst>
+          </a:prstGeom>
+          <a:solidFill>
+            <a:srgbClr val="FFFFFF"/>
+          </a:solidFill>
+          <a:ln w="25400">
+            <a:solidFill>
+              <a:srgbClr val="107C10"/>
+            </a:solidFill>
+          </a:ln>
+          <a:effectLst/>
+        </p:spPr>
+        <p:style>
+          <a:lnRef idx="1">
+            <a:schemeClr val="accent1"/>
+          </a:lnRef>
+          <a:fillRef idx="3">
+            <a:schemeClr val="accent1"/>
+          </a:fillRef>
+          <a:effectRef idx="2">
+            <a:schemeClr val="accent1"/>
+          </a:effectRef>
+          <a:fontRef idx="minor">
+            <a:schemeClr val="lt1"/>
+          </a:fontRef>
+        </p:style>
+        <p:txBody>
+          <a:bodyPr rtlCol="0" anchor="ctr"/>
+          <a:lstStyle/>
+          <a:p>
+            <a:pPr algn="ctr"/>
+            <a:endParaRPr/>
+          </a:p>
+        </p:txBody>
+      </p:sp>
+      <p:sp>
+        <p:nvSpPr>
+          <p:cNvPr id="12" name="TextBox 11"/>
+          <p:cNvSpPr txBox="1"/>
+          <p:nvPr/>
+        </p:nvSpPr>
+        <p:spPr>
+          <a:xfrm>
+            <a:off x="6519672" y="2404872"/>
+            <a:ext cx="4608575" cy="1472184"/>
+          </a:xfrm>
+          <a:prstGeom prst="rect">
+            <a:avLst/>
+          </a:prstGeom>
+          <a:noFill/>
+        </p:spPr>
+        <p:txBody>
+          <a:bodyPr wrap="square">
+            <a:normAutofit/>
+          </a:bodyPr>
+          <a:lstStyle/>
+          <a:p>
+            <a:pPr algn="l">
+              <a:lnSpc>
+                <a:spcPct val="100000"/>
+              </a:lnSpc>
+              <a:spcAft>
+                <a:spcPts val="300"/>
+              </a:spcAft>
+            </a:pPr>
+            <a:r>
+              <a:rPr sz="1300" b="1">
+                <a:solidFill>
+                  <a:srgbClr val="107C10"/>
+                </a:solidFill>
+                <a:latin typeface="Segoe UI"/>
+              </a:rPr>
+              <a:t>COST</a:t>
+            </a:r>
+          </a:p>
+          <a:p>
+            <a:pPr algn="l">
+              <a:lnSpc>
+                <a:spcPct val="102000"/>
+              </a:lnSpc>
+              <a:spcAft>
+                <a:spcPts val="400"/>
+              </a:spcAft>
+            </a:pPr>
+            <a:r>
+              <a:rPr sz="1400" b="1">
+                <a:solidFill>
+                  <a:srgbClr val="243A5E"/>
+                </a:solidFill>
+                <a:latin typeface="Segoe UI"/>
+              </a:rPr>
+              <a:t>Free in preview.</a:t>
+            </a:r>
+          </a:p>
+          <a:p>
+            <a:pPr algn="l">
+              <a:lnSpc>
+                <a:spcPct val="105000"/>
+              </a:lnSpc>
+              <a:spcAft>
+                <a:spcPts val="0"/>
+              </a:spcAft>
+            </a:pPr>
+            <a:r>
+              <a:rPr sz="1150" b="0">
+                <a:solidFill>
+                  <a:srgbClr val="605E5C"/>
+                </a:solidFill>
+                <a:latin typeface="Segoe UI"/>
+              </a:rPr>
+              <a:t>You pay only the chat + embedding tokens spent on extraction &amp; retrieval — no fixed memory fee. GA pricing not yet published.</a:t>
+            </a:r>
+          </a:p>
+        </p:txBody>
+      </p:sp>
+      <p:sp>
+        <p:nvSpPr>
+          <p:cNvPr id="13" name="Rounded Rectangle 12"/>
+          <p:cNvSpPr/>
+          <p:nvPr/>
+        </p:nvSpPr>
+        <p:spPr>
+          <a:xfrm>
+            <a:off x="777240" y="4114800"/>
+            <a:ext cx="5120640" cy="1783080"/>
+          </a:xfrm>
+          <a:prstGeom prst="roundRect">
+            <a:avLst>
+              <a:gd name="adj" fmla="val 5000"/>
+            </a:avLst>
+          </a:prstGeom>
+          <a:solidFill>
+            <a:srgbClr val="FFFFFF"/>
+          </a:solidFill>
+          <a:ln w="25400">
+            <a:solidFill>
+              <a:srgbClr val="5C2D91"/>
+            </a:solidFill>
+          </a:ln>
+          <a:effectLst/>
+        </p:spPr>
+        <p:style>
+          <a:lnRef idx="1">
+            <a:schemeClr val="accent1"/>
+          </a:lnRef>
+          <a:fillRef idx="3">
+            <a:schemeClr val="accent1"/>
+          </a:fillRef>
+          <a:effectRef idx="2">
+            <a:schemeClr val="accent1"/>
+          </a:effectRef>
+          <a:fontRef idx="minor">
+            <a:schemeClr val="lt1"/>
+          </a:fontRef>
+        </p:style>
+        <p:txBody>
+          <a:bodyPr rtlCol="0" anchor="ctr"/>
+          <a:lstStyle/>
+          <a:p>
+            <a:pPr algn="ctr"/>
+            <a:endParaRPr/>
+          </a:p>
+        </p:txBody>
+      </p:sp>
+      <p:sp>
+        <p:nvSpPr>
+          <p:cNvPr id="14" name="TextBox 13"/>
+          <p:cNvSpPr txBox="1"/>
+          <p:nvPr/>
+        </p:nvSpPr>
+        <p:spPr>
+          <a:xfrm>
+            <a:off x="1033271" y="4279392"/>
+            <a:ext cx="4608575" cy="1472184"/>
+          </a:xfrm>
+          <a:prstGeom prst="rect">
+            <a:avLst/>
+          </a:prstGeom>
+          <a:noFill/>
+        </p:spPr>
+        <p:txBody>
+          <a:bodyPr wrap="square">
+            <a:normAutofit/>
+          </a:bodyPr>
+          <a:lstStyle/>
+          <a:p>
+            <a:pPr algn="l">
+              <a:lnSpc>
+                <a:spcPct val="100000"/>
+              </a:lnSpc>
+              <a:spcAft>
+                <a:spcPts val="300"/>
+              </a:spcAft>
+            </a:pPr>
+            <a:r>
+              <a:rPr sz="1300" b="1">
+                <a:solidFill>
+                  <a:srgbClr val="5C2D91"/>
+                </a:solidFill>
+                <a:latin typeface="Segoe UI"/>
+              </a:rPr>
+              <a:t>RETENTION · TTL</a:t>
+            </a:r>
+          </a:p>
+          <a:p>
+            <a:pPr algn="l">
+              <a:lnSpc>
+                <a:spcPct val="102000"/>
+              </a:lnSpc>
+              <a:spcAft>
+                <a:spcPts val="400"/>
+              </a:spcAft>
+            </a:pPr>
+            <a:r>
+              <a:rPr sz="1400" b="1">
+                <a:solidFill>
+                  <a:srgbClr val="243A5E"/>
+                </a:solidFill>
+                <a:latin typeface="Segoe UI"/>
+              </a:rPr>
+              <a:t>Sliding, set at create time.</a:t>
+            </a:r>
+          </a:p>
+          <a:p>
+            <a:pPr algn="l">
+              <a:lnSpc>
+                <a:spcPct val="105000"/>
+              </a:lnSpc>
+              <a:spcAft>
+                <a:spcPts val="0"/>
+              </a:spcAft>
+            </a:pPr>
+            <a:r>
+              <a:rPr sz="1150" b="0">
+                <a:solidFill>
+                  <a:srgbClr val="605E5C"/>
+                </a:solidFill>
+                <a:latin typeface="Segoe UI"/>
+              </a:rPr>
+              <a:t>Reset on every update. ~90 days suits low-cadence weather use; 0 = never expires — unbounded PII, avoid.</a:t>
+            </a:r>
+          </a:p>
+        </p:txBody>
+      </p:sp>
+      <p:sp>
+        <p:nvSpPr>
+          <p:cNvPr id="15" name="Rounded Rectangle 14"/>
+          <p:cNvSpPr/>
+          <p:nvPr/>
+        </p:nvSpPr>
+        <p:spPr>
+          <a:xfrm>
+            <a:off x="6263640" y="4114800"/>
+            <a:ext cx="5120640" cy="1783080"/>
+          </a:xfrm>
+          <a:prstGeom prst="roundRect">
+            <a:avLst>
+              <a:gd name="adj" fmla="val 5000"/>
+            </a:avLst>
+          </a:prstGeom>
+          <a:solidFill>
+            <a:srgbClr val="FFFFFF"/>
+          </a:solidFill>
+          <a:ln w="25400">
+            <a:solidFill>
+              <a:srgbClr val="C5292A"/>
+            </a:solidFill>
+          </a:ln>
+          <a:effectLst/>
+        </p:spPr>
+        <p:style>
+          <a:lnRef idx="1">
+            <a:schemeClr val="accent1"/>
+          </a:lnRef>
+          <a:fillRef idx="3">
+            <a:schemeClr val="accent1"/>
+          </a:fillRef>
+          <a:effectRef idx="2">
+            <a:schemeClr val="accent1"/>
+          </a:effectRef>
+          <a:fontRef idx="minor">
+            <a:schemeClr val="lt1"/>
+          </a:fontRef>
+        </p:style>
+        <p:txBody>
+          <a:bodyPr rtlCol="0" anchor="ctr"/>
+          <a:lstStyle/>
+          <a:p>
+            <a:pPr algn="ctr"/>
+            <a:endParaRPr/>
+          </a:p>
+        </p:txBody>
+      </p:sp>
+      <p:sp>
+        <p:nvSpPr>
+          <p:cNvPr id="16" name="TextBox 15"/>
+          <p:cNvSpPr txBox="1"/>
+          <p:nvPr/>
+        </p:nvSpPr>
+        <p:spPr>
+          <a:xfrm>
+            <a:off x="6519672" y="4279392"/>
+            <a:ext cx="4608575" cy="1472184"/>
+          </a:xfrm>
+          <a:prstGeom prst="rect">
+            <a:avLst/>
+          </a:prstGeom>
+          <a:noFill/>
+        </p:spPr>
+        <p:txBody>
+          <a:bodyPr wrap="square">
+            <a:normAutofit/>
+          </a:bodyPr>
+          <a:lstStyle/>
+          <a:p>
+            <a:pPr algn="l">
+              <a:lnSpc>
+                <a:spcPct val="100000"/>
+              </a:lnSpc>
+              <a:spcAft>
+                <a:spcPts val="300"/>
+              </a:spcAft>
+            </a:pPr>
+            <a:r>
+              <a:rPr sz="1300" b="1">
+                <a:solidFill>
+                  <a:srgbClr val="C5292A"/>
+                </a:solidFill>
+                <a:latin typeface="Segoe UI"/>
+              </a:rPr>
+              <a:t>EMBEDDING </a:t>
+            </a:r>
+            <a:r>
+              <a:rPr lang="en-US" sz="1300" b="1">
+                <a:solidFill>
+                  <a:srgbClr val="C5292A"/>
+                </a:solidFill>
+                <a:latin typeface="Segoe UI"/>
+              </a:rPr>
+              <a:t>MODEL </a:t>
+            </a:r>
+            <a:r>
+              <a:rPr sz="1300" b="1">
+                <a:solidFill>
+                  <a:srgbClr val="C5292A"/>
+                </a:solidFill>
+                <a:latin typeface="Segoe UI"/>
+              </a:rPr>
+              <a:t>DEPENDENCY</a:t>
+            </a:r>
+          </a:p>
+          <a:p>
+            <a:pPr algn="l">
+              <a:lnSpc>
+                <a:spcPct val="102000"/>
+              </a:lnSpc>
+              <a:spcAft>
+                <a:spcPts val="400"/>
+              </a:spcAft>
+            </a:pPr>
+            <a:r>
+              <a:rPr sz="1400" b="1" dirty="0">
+                <a:solidFill>
+                  <a:srgbClr val="243A5E"/>
+                </a:solidFill>
+                <a:latin typeface="Segoe UI"/>
+              </a:rPr>
+              <a:t>Not built in — you bring it.</a:t>
+            </a:r>
+          </a:p>
+          <a:p>
+            <a:pPr algn="l">
+              <a:lnSpc>
+                <a:spcPct val="105000"/>
+              </a:lnSpc>
+              <a:spcAft>
+                <a:spcPts val="0"/>
+              </a:spcAft>
+            </a:pPr>
+            <a:r>
+              <a:rPr sz="1150" b="0" dirty="0">
+                <a:solidFill>
+                  <a:srgbClr val="605E5C"/>
+                </a:solidFill>
+                <a:latin typeface="Segoe UI"/>
+              </a:rPr>
+              <a:t>Deploy your own embedding + chat model (e.g. text-embedding-3-small) and name both on the store.</a:t>
+            </a:r>
+          </a:p>
+        </p:txBody>
+      </p:sp>
+      <p:sp>
+        <p:nvSpPr>
+          <p:cNvPr id="17" name="TextBox 16"/>
+          <p:cNvSpPr txBox="1"/>
+          <p:nvPr/>
+        </p:nvSpPr>
+        <p:spPr>
+          <a:xfrm>
+            <a:off x="777240" y="5989320"/>
+            <a:ext cx="10607040" cy="310896"/>
+          </a:xfrm>
+          <a:prstGeom prst="rect">
+            <a:avLst/>
+          </a:prstGeom>
+          <a:noFill/>
+        </p:spPr>
+        <p:txBody>
+          <a:bodyPr wrap="square">
             <a:spAutoFit/>
           </a:bodyPr>
           <a:lstStyle/>
           <a:p>
-            <a:pPr algn="ctr">
+            <a:pPr algn="l">
               <a:lnSpc>
                 <a:spcPct val="100000"/>
               </a:lnSpc>
-              <a:spcBef>
-                <a:spcPts val="0"/>
-              </a:spcBef>
-              <a:spcAft>
-                <a:spcPts val="600"/>
-              </a:spcAft>
-            </a:pPr>
-            <a:r>
-              <a:rPr sz="2600" b="1">
-                <a:solidFill>
-                  <a:srgbClr val="FFFFFF"/>
-                </a:solidFill>
-                <a:latin typeface="Segoe UI"/>
-              </a:rPr>
-              <a:t>3</a:t>
-            </a:r>
-          </a:p>
-        </p:txBody>
-      </p:sp>
-      <p:sp>
-        <p:nvSpPr>
-          <p:cNvPr id="14" name="TextBox 13"/>
-          <p:cNvSpPr txBox="1"/>
-          <p:nvPr/>
-        </p:nvSpPr>
-        <p:spPr>
-          <a:xfrm>
-            <a:off x="1554480" y="4937760"/>
-            <a:ext cx="9784080" cy="1188720"/>
-          </a:xfrm>
-          <a:prstGeom prst="rect">
-            <a:avLst/>
-          </a:prstGeom>
-          <a:noFill/>
-        </p:spPr>
-        <p:txBody>
-          <a:bodyPr wrap="square" lIns="50800" tIns="25400" rIns="50800" bIns="25400" anchor="t">
-            <a:spAutoFit/>
-          </a:bodyPr>
-          <a:lstStyle/>
-          <a:p>
-            <a:pPr algn="l">
-              <a:lnSpc>
-                <a:spcPct val="105000"/>
-              </a:lnSpc>
-              <a:spcBef>
-                <a:spcPts val="0"/>
-              </a:spcBef>
-              <a:spcAft>
-                <a:spcPts val="600"/>
-              </a:spcAft>
-            </a:pPr>
-            <a:r>
-              <a:rPr sz="2000" b="1">
-                <a:solidFill>
-                  <a:srgbClr val="FFFFFF"/>
-                </a:solidFill>
-                <a:latin typeface="Segoe UI"/>
-              </a:rPr>
-              <a:t>Both, platform-side</a:t>
-            </a:r>
-          </a:p>
-          <a:p>
-            <a:pPr algn="l">
-              <a:lnSpc>
-                <a:spcPct val="105000"/>
-              </a:lnSpc>
-              <a:spcBef>
-                <a:spcPts val="0"/>
-              </a:spcBef>
-              <a:spcAft>
-                <a:spcPts val="600"/>
-              </a:spcAft>
-            </a:pPr>
-            <a:r>
-              <a:rPr sz="1500" b="0">
-                <a:solidFill>
-                  <a:srgbClr val="C7D6EA"/>
-                </a:solidFill>
-                <a:latin typeface="Segoe UI"/>
-              </a:rPr>
-              <a:t>The Meteorologist needs both, and in Gislefoss they live in foundry.bicep — not in app code.</a:t>
+            </a:pPr>
+            <a:r>
+              <a:rPr sz="1250" b="1">
+                <a:solidFill>
+                  <a:srgbClr val="243A5E"/>
+                </a:solidFill>
+                <a:latin typeface="Segoe UI"/>
+              </a:rPr>
+              <a:t>Today Gislefoss sets deployMemory = false → the agent is stateless and memory costs nothing.</a:t>
             </a:r>
           </a:p>
         </p:txBody>
@@ -13357,6 +14765,696 @@
 </p:sld>
 </file>
 
+<file path=ppt/slides/slide20.xml><?xml version="1.0" encoding="utf-8"?>
+<p:sld xmlns:a="http://schemas.openxmlformats.org/drawingml/2006/main" xmlns:r="http://schemas.openxmlformats.org/officeDocument/2006/relationships" xmlns:p="http://schemas.openxmlformats.org/presentationml/2006/main">
+  <p:cSld>
+    <p:bg>
+      <p:bgPr>
+        <a:solidFill>
+          <a:srgbClr val="243A5E"/>
+        </a:solidFill>
+        <a:effectLst/>
+      </p:bgPr>
+    </p:bg>
+    <p:spTree>
+      <p:nvGrpSpPr>
+        <p:cNvPr id="1" name=""/>
+        <p:cNvGrpSpPr/>
+        <p:nvPr/>
+      </p:nvGrpSpPr>
+      <p:grpSpPr>
+        <a:xfrm>
+          <a:off x="0" y="0"/>
+          <a:ext cx="0" cy="0"/>
+          <a:chOff x="0" y="0"/>
+          <a:chExt cx="0" cy="0"/>
+        </a:xfrm>
+      </p:grpSpPr>
+      <p:sp>
+        <p:nvSpPr>
+          <p:cNvPr id="2" name="Rectangle 1"/>
+          <p:cNvSpPr/>
+          <p:nvPr/>
+        </p:nvSpPr>
+        <p:spPr>
+          <a:xfrm>
+            <a:off x="0" y="0"/>
+            <a:ext cx="12191695" cy="164592"/>
+          </a:xfrm>
+          <a:prstGeom prst="rect">
+            <a:avLst/>
+          </a:prstGeom>
+          <a:solidFill>
+            <a:srgbClr val="0078D4"/>
+          </a:solidFill>
+          <a:ln>
+            <a:noFill/>
+          </a:ln>
+          <a:effectLst/>
+        </p:spPr>
+        <p:style>
+          <a:lnRef idx="1">
+            <a:schemeClr val="accent1"/>
+          </a:lnRef>
+          <a:fillRef idx="3">
+            <a:schemeClr val="accent1"/>
+          </a:fillRef>
+          <a:effectRef idx="2">
+            <a:schemeClr val="accent1"/>
+          </a:effectRef>
+          <a:fontRef idx="minor">
+            <a:schemeClr val="lt1"/>
+          </a:fontRef>
+        </p:style>
+        <p:txBody>
+          <a:bodyPr rtlCol="0" anchor="ctr"/>
+          <a:lstStyle/>
+          <a:p>
+            <a:pPr algn="ctr"/>
+            <a:endParaRPr/>
+          </a:p>
+        </p:txBody>
+      </p:sp>
+      <p:sp>
+        <p:nvSpPr>
+          <p:cNvPr id="3" name="Rectangle 2"/>
+          <p:cNvSpPr/>
+          <p:nvPr/>
+        </p:nvSpPr>
+        <p:spPr>
+          <a:xfrm>
+            <a:off x="0" y="6355080"/>
+            <a:ext cx="12191695" cy="502920"/>
+          </a:xfrm>
+          <a:prstGeom prst="rect">
+            <a:avLst/>
+          </a:prstGeom>
+          <a:solidFill>
+            <a:srgbClr val="0078D4"/>
+          </a:solidFill>
+          <a:ln>
+            <a:noFill/>
+          </a:ln>
+          <a:effectLst/>
+        </p:spPr>
+        <p:style>
+          <a:lnRef idx="1">
+            <a:schemeClr val="accent1"/>
+          </a:lnRef>
+          <a:fillRef idx="3">
+            <a:schemeClr val="accent1"/>
+          </a:fillRef>
+          <a:effectRef idx="2">
+            <a:schemeClr val="accent1"/>
+          </a:effectRef>
+          <a:fontRef idx="minor">
+            <a:schemeClr val="lt1"/>
+          </a:fontRef>
+        </p:style>
+        <p:txBody>
+          <a:bodyPr rtlCol="0" anchor="ctr"/>
+          <a:lstStyle/>
+          <a:p>
+            <a:pPr algn="ctr"/>
+            <a:endParaRPr/>
+          </a:p>
+        </p:txBody>
+      </p:sp>
+      <p:sp>
+        <p:nvSpPr>
+          <p:cNvPr id="4" name="TextBox 3"/>
+          <p:cNvSpPr txBox="1"/>
+          <p:nvPr/>
+        </p:nvSpPr>
+        <p:spPr>
+          <a:xfrm>
+            <a:off x="822960" y="731520"/>
+            <a:ext cx="10515600" cy="548640"/>
+          </a:xfrm>
+          <a:prstGeom prst="rect">
+            <a:avLst/>
+          </a:prstGeom>
+          <a:noFill/>
+        </p:spPr>
+        <p:txBody>
+          <a:bodyPr wrap="square" lIns="50800" tIns="25400" rIns="50800" bIns="25400" anchor="t">
+            <a:spAutoFit/>
+          </a:bodyPr>
+          <a:lstStyle/>
+          <a:p>
+            <a:pPr algn="l">
+              <a:lnSpc>
+                <a:spcPct val="100000"/>
+              </a:lnSpc>
+              <a:spcBef>
+                <a:spcPts val="0"/>
+              </a:spcBef>
+              <a:spcAft>
+                <a:spcPts val="600"/>
+              </a:spcAft>
+            </a:pPr>
+            <a:r>
+              <a:rPr sz="1500" b="1">
+                <a:solidFill>
+                  <a:srgbClr val="8AB9E8"/>
+                </a:solidFill>
+                <a:latin typeface="Segoe UI"/>
+              </a:rPr>
+              <a:t>TAKEAWAYS</a:t>
+            </a:r>
+          </a:p>
+        </p:txBody>
+      </p:sp>
+      <p:sp>
+        <p:nvSpPr>
+          <p:cNvPr id="5" name="TextBox 4"/>
+          <p:cNvSpPr txBox="1"/>
+          <p:nvPr/>
+        </p:nvSpPr>
+        <p:spPr>
+          <a:xfrm>
+            <a:off x="822960" y="1280160"/>
+            <a:ext cx="10515600" cy="731520"/>
+          </a:xfrm>
+          <a:prstGeom prst="rect">
+            <a:avLst/>
+          </a:prstGeom>
+          <a:noFill/>
+        </p:spPr>
+        <p:txBody>
+          <a:bodyPr wrap="square" lIns="50800" tIns="25400" rIns="50800" bIns="25400" anchor="t">
+            <a:spAutoFit/>
+          </a:bodyPr>
+          <a:lstStyle/>
+          <a:p>
+            <a:pPr algn="l">
+              <a:lnSpc>
+                <a:spcPct val="100000"/>
+              </a:lnSpc>
+              <a:spcBef>
+                <a:spcPts val="0"/>
+              </a:spcBef>
+              <a:spcAft>
+                <a:spcPts val="600"/>
+              </a:spcAft>
+            </a:pPr>
+            <a:r>
+              <a:rPr sz="3000" b="1">
+                <a:solidFill>
+                  <a:srgbClr val="FFFFFF"/>
+                </a:solidFill>
+                <a:latin typeface="Segoe UI"/>
+              </a:rPr>
+              <a:t>Three things to remember</a:t>
+            </a:r>
+          </a:p>
+        </p:txBody>
+      </p:sp>
+      <p:sp>
+        <p:nvSpPr>
+          <p:cNvPr id="6" name="Rounded Rectangle 5"/>
+          <p:cNvSpPr/>
+          <p:nvPr/>
+        </p:nvSpPr>
+        <p:spPr>
+          <a:xfrm>
+            <a:off x="822960" y="2240280"/>
+            <a:ext cx="502920" cy="1097280"/>
+          </a:xfrm>
+          <a:prstGeom prst="roundRect">
+            <a:avLst>
+              <a:gd name="adj" fmla="val 20000"/>
+            </a:avLst>
+          </a:prstGeom>
+          <a:solidFill>
+            <a:srgbClr val="0078D4"/>
+          </a:solidFill>
+          <a:ln>
+            <a:noFill/>
+          </a:ln>
+          <a:effectLst/>
+        </p:spPr>
+        <p:style>
+          <a:lnRef idx="1">
+            <a:schemeClr val="accent1"/>
+          </a:lnRef>
+          <a:fillRef idx="3">
+            <a:schemeClr val="accent1"/>
+          </a:fillRef>
+          <a:effectRef idx="2">
+            <a:schemeClr val="accent1"/>
+          </a:effectRef>
+          <a:fontRef idx="minor">
+            <a:schemeClr val="lt1"/>
+          </a:fontRef>
+        </p:style>
+        <p:txBody>
+          <a:bodyPr rtlCol="0" anchor="ctr"/>
+          <a:lstStyle/>
+          <a:p>
+            <a:pPr algn="ctr"/>
+            <a:endParaRPr/>
+          </a:p>
+        </p:txBody>
+      </p:sp>
+      <p:sp>
+        <p:nvSpPr>
+          <p:cNvPr id="7" name="TextBox 6"/>
+          <p:cNvSpPr txBox="1"/>
+          <p:nvPr/>
+        </p:nvSpPr>
+        <p:spPr>
+          <a:xfrm>
+            <a:off x="822960" y="2496312"/>
+            <a:ext cx="502920" cy="640080"/>
+          </a:xfrm>
+          <a:prstGeom prst="rect">
+            <a:avLst/>
+          </a:prstGeom>
+          <a:noFill/>
+        </p:spPr>
+        <p:txBody>
+          <a:bodyPr wrap="square" lIns="50800" tIns="25400" rIns="50800" bIns="25400" anchor="t">
+            <a:spAutoFit/>
+          </a:bodyPr>
+          <a:lstStyle/>
+          <a:p>
+            <a:pPr algn="ctr">
+              <a:lnSpc>
+                <a:spcPct val="100000"/>
+              </a:lnSpc>
+              <a:spcBef>
+                <a:spcPts val="0"/>
+              </a:spcBef>
+              <a:spcAft>
+                <a:spcPts val="600"/>
+              </a:spcAft>
+            </a:pPr>
+            <a:r>
+              <a:rPr sz="2600" b="1">
+                <a:solidFill>
+                  <a:srgbClr val="FFFFFF"/>
+                </a:solidFill>
+                <a:latin typeface="Segoe UI"/>
+              </a:rPr>
+              <a:t>1</a:t>
+            </a:r>
+          </a:p>
+        </p:txBody>
+      </p:sp>
+      <p:sp>
+        <p:nvSpPr>
+          <p:cNvPr id="8" name="TextBox 7"/>
+          <p:cNvSpPr txBox="1"/>
+          <p:nvPr/>
+        </p:nvSpPr>
+        <p:spPr>
+          <a:xfrm>
+            <a:off x="1554480" y="2286000"/>
+            <a:ext cx="9784080" cy="1188720"/>
+          </a:xfrm>
+          <a:prstGeom prst="rect">
+            <a:avLst/>
+          </a:prstGeom>
+          <a:noFill/>
+        </p:spPr>
+        <p:txBody>
+          <a:bodyPr wrap="square" lIns="50800" tIns="25400" rIns="50800" bIns="25400" anchor="t">
+            <a:spAutoFit/>
+          </a:bodyPr>
+          <a:lstStyle/>
+          <a:p>
+            <a:pPr algn="l">
+              <a:lnSpc>
+                <a:spcPct val="105000"/>
+              </a:lnSpc>
+              <a:spcBef>
+                <a:spcPts val="0"/>
+              </a:spcBef>
+              <a:spcAft>
+                <a:spcPts val="600"/>
+              </a:spcAft>
+            </a:pPr>
+            <a:r>
+              <a:rPr sz="2000" b="1">
+                <a:solidFill>
+                  <a:srgbClr val="FFFFFF"/>
+                </a:solidFill>
+                <a:latin typeface="Segoe UI"/>
+              </a:rPr>
+              <a:t>Containment, not rivalry</a:t>
+            </a:r>
+          </a:p>
+          <a:p>
+            <a:pPr algn="l">
+              <a:lnSpc>
+                <a:spcPct val="105000"/>
+              </a:lnSpc>
+              <a:spcBef>
+                <a:spcPts val="0"/>
+              </a:spcBef>
+              <a:spcAft>
+                <a:spcPts val="600"/>
+              </a:spcAft>
+            </a:pPr>
+            <a:r>
+              <a:rPr sz="1500" b="0">
+                <a:solidFill>
+                  <a:srgbClr val="C7D6EA"/>
+                </a:solidFill>
+                <a:latin typeface="Segoe UI"/>
+              </a:rPr>
+              <a:t>A Prompt Shield is one detector inside the guardrail (RAI policy) — not a competing feature.</a:t>
+            </a:r>
+          </a:p>
+        </p:txBody>
+      </p:sp>
+      <p:sp>
+        <p:nvSpPr>
+          <p:cNvPr id="9" name="Rounded Rectangle 8"/>
+          <p:cNvSpPr/>
+          <p:nvPr/>
+        </p:nvSpPr>
+        <p:spPr>
+          <a:xfrm>
+            <a:off x="822960" y="3566160"/>
+            <a:ext cx="502920" cy="1097280"/>
+          </a:xfrm>
+          <a:prstGeom prst="roundRect">
+            <a:avLst>
+              <a:gd name="adj" fmla="val 20000"/>
+            </a:avLst>
+          </a:prstGeom>
+          <a:solidFill>
+            <a:srgbClr val="0078D4"/>
+          </a:solidFill>
+          <a:ln>
+            <a:noFill/>
+          </a:ln>
+          <a:effectLst/>
+        </p:spPr>
+        <p:style>
+          <a:lnRef idx="1">
+            <a:schemeClr val="accent1"/>
+          </a:lnRef>
+          <a:fillRef idx="3">
+            <a:schemeClr val="accent1"/>
+          </a:fillRef>
+          <a:effectRef idx="2">
+            <a:schemeClr val="accent1"/>
+          </a:effectRef>
+          <a:fontRef idx="minor">
+            <a:schemeClr val="lt1"/>
+          </a:fontRef>
+        </p:style>
+        <p:txBody>
+          <a:bodyPr rtlCol="0" anchor="ctr"/>
+          <a:lstStyle/>
+          <a:p>
+            <a:pPr algn="ctr"/>
+            <a:endParaRPr/>
+          </a:p>
+        </p:txBody>
+      </p:sp>
+      <p:sp>
+        <p:nvSpPr>
+          <p:cNvPr id="10" name="TextBox 9"/>
+          <p:cNvSpPr txBox="1"/>
+          <p:nvPr/>
+        </p:nvSpPr>
+        <p:spPr>
+          <a:xfrm>
+            <a:off x="822960" y="3822192"/>
+            <a:ext cx="502920" cy="640080"/>
+          </a:xfrm>
+          <a:prstGeom prst="rect">
+            <a:avLst/>
+          </a:prstGeom>
+          <a:noFill/>
+        </p:spPr>
+        <p:txBody>
+          <a:bodyPr wrap="square" lIns="50800" tIns="25400" rIns="50800" bIns="25400" anchor="t">
+            <a:spAutoFit/>
+          </a:bodyPr>
+          <a:lstStyle/>
+          <a:p>
+            <a:pPr algn="ctr">
+              <a:lnSpc>
+                <a:spcPct val="100000"/>
+              </a:lnSpc>
+              <a:spcBef>
+                <a:spcPts val="0"/>
+              </a:spcBef>
+              <a:spcAft>
+                <a:spcPts val="600"/>
+              </a:spcAft>
+            </a:pPr>
+            <a:r>
+              <a:rPr sz="2600" b="1">
+                <a:solidFill>
+                  <a:srgbClr val="FFFFFF"/>
+                </a:solidFill>
+                <a:latin typeface="Segoe UI"/>
+              </a:rPr>
+              <a:t>2</a:t>
+            </a:r>
+          </a:p>
+        </p:txBody>
+      </p:sp>
+      <p:sp>
+        <p:nvSpPr>
+          <p:cNvPr id="11" name="TextBox 10"/>
+          <p:cNvSpPr txBox="1"/>
+          <p:nvPr/>
+        </p:nvSpPr>
+        <p:spPr>
+          <a:xfrm>
+            <a:off x="1554480" y="3611880"/>
+            <a:ext cx="9784080" cy="1188720"/>
+          </a:xfrm>
+          <a:prstGeom prst="rect">
+            <a:avLst/>
+          </a:prstGeom>
+          <a:noFill/>
+        </p:spPr>
+        <p:txBody>
+          <a:bodyPr wrap="square" lIns="50800" tIns="25400" rIns="50800" bIns="25400" anchor="t">
+            <a:spAutoFit/>
+          </a:bodyPr>
+          <a:lstStyle/>
+          <a:p>
+            <a:pPr algn="l">
+              <a:lnSpc>
+                <a:spcPct val="105000"/>
+              </a:lnSpc>
+              <a:spcBef>
+                <a:spcPts val="0"/>
+              </a:spcBef>
+              <a:spcAft>
+                <a:spcPts val="600"/>
+              </a:spcAft>
+            </a:pPr>
+            <a:r>
+              <a:rPr sz="2000" b="1">
+                <a:solidFill>
+                  <a:srgbClr val="FFFFFF"/>
+                </a:solidFill>
+                <a:latin typeface="Segoe UI"/>
+              </a:rPr>
+              <a:t>Content vs. intent</a:t>
+            </a:r>
+          </a:p>
+          <a:p>
+            <a:pPr algn="l">
+              <a:lnSpc>
+                <a:spcPct val="105000"/>
+              </a:lnSpc>
+              <a:spcBef>
+                <a:spcPts val="0"/>
+              </a:spcBef>
+              <a:spcAft>
+                <a:spcPts val="600"/>
+              </a:spcAft>
+            </a:pPr>
+            <a:r>
+              <a:rPr sz="1500" b="0">
+                <a:solidFill>
+                  <a:srgbClr val="C7D6EA"/>
+                </a:solidFill>
+                <a:latin typeface="Segoe UI"/>
+              </a:rPr>
+              <a:t>Guardrail harm filters catch toxic CONTENT; shields catch adversarial INTENT (hijacking).</a:t>
+            </a:r>
+          </a:p>
+        </p:txBody>
+      </p:sp>
+      <p:sp>
+        <p:nvSpPr>
+          <p:cNvPr id="12" name="Rounded Rectangle 11"/>
+          <p:cNvSpPr/>
+          <p:nvPr/>
+        </p:nvSpPr>
+        <p:spPr>
+          <a:xfrm>
+            <a:off x="822960" y="4892040"/>
+            <a:ext cx="502920" cy="1097280"/>
+          </a:xfrm>
+          <a:prstGeom prst="roundRect">
+            <a:avLst>
+              <a:gd name="adj" fmla="val 20000"/>
+            </a:avLst>
+          </a:prstGeom>
+          <a:solidFill>
+            <a:srgbClr val="0078D4"/>
+          </a:solidFill>
+          <a:ln>
+            <a:noFill/>
+          </a:ln>
+          <a:effectLst/>
+        </p:spPr>
+        <p:style>
+          <a:lnRef idx="1">
+            <a:schemeClr val="accent1"/>
+          </a:lnRef>
+          <a:fillRef idx="3">
+            <a:schemeClr val="accent1"/>
+          </a:fillRef>
+          <a:effectRef idx="2">
+            <a:schemeClr val="accent1"/>
+          </a:effectRef>
+          <a:fontRef idx="minor">
+            <a:schemeClr val="lt1"/>
+          </a:fontRef>
+        </p:style>
+        <p:txBody>
+          <a:bodyPr rtlCol="0" anchor="ctr"/>
+          <a:lstStyle/>
+          <a:p>
+            <a:pPr algn="ctr"/>
+            <a:endParaRPr/>
+          </a:p>
+        </p:txBody>
+      </p:sp>
+      <p:sp>
+        <p:nvSpPr>
+          <p:cNvPr id="13" name="TextBox 12"/>
+          <p:cNvSpPr txBox="1"/>
+          <p:nvPr/>
+        </p:nvSpPr>
+        <p:spPr>
+          <a:xfrm>
+            <a:off x="822960" y="5148072"/>
+            <a:ext cx="502920" cy="640080"/>
+          </a:xfrm>
+          <a:prstGeom prst="rect">
+            <a:avLst/>
+          </a:prstGeom>
+          <a:noFill/>
+        </p:spPr>
+        <p:txBody>
+          <a:bodyPr wrap="square" lIns="50800" tIns="25400" rIns="50800" bIns="25400" anchor="t">
+            <a:spAutoFit/>
+          </a:bodyPr>
+          <a:lstStyle/>
+          <a:p>
+            <a:pPr algn="ctr">
+              <a:lnSpc>
+                <a:spcPct val="100000"/>
+              </a:lnSpc>
+              <a:spcBef>
+                <a:spcPts val="0"/>
+              </a:spcBef>
+              <a:spcAft>
+                <a:spcPts val="600"/>
+              </a:spcAft>
+            </a:pPr>
+            <a:r>
+              <a:rPr sz="2600" b="1">
+                <a:solidFill>
+                  <a:srgbClr val="FFFFFF"/>
+                </a:solidFill>
+                <a:latin typeface="Segoe UI"/>
+              </a:rPr>
+              <a:t>3</a:t>
+            </a:r>
+          </a:p>
+        </p:txBody>
+      </p:sp>
+      <p:sp>
+        <p:nvSpPr>
+          <p:cNvPr id="14" name="TextBox 13"/>
+          <p:cNvSpPr txBox="1"/>
+          <p:nvPr/>
+        </p:nvSpPr>
+        <p:spPr>
+          <a:xfrm>
+            <a:off x="1554480" y="4937760"/>
+            <a:ext cx="9784080" cy="1188720"/>
+          </a:xfrm>
+          <a:prstGeom prst="rect">
+            <a:avLst/>
+          </a:prstGeom>
+          <a:noFill/>
+        </p:spPr>
+        <p:txBody>
+          <a:bodyPr wrap="square" lIns="50800" tIns="25400" rIns="50800" bIns="25400" anchor="t">
+            <a:spAutoFit/>
+          </a:bodyPr>
+          <a:lstStyle/>
+          <a:p>
+            <a:pPr algn="l">
+              <a:lnSpc>
+                <a:spcPct val="105000"/>
+              </a:lnSpc>
+              <a:spcBef>
+                <a:spcPts val="0"/>
+              </a:spcBef>
+              <a:spcAft>
+                <a:spcPts val="600"/>
+              </a:spcAft>
+            </a:pPr>
+            <a:r>
+              <a:rPr sz="2000" b="1">
+                <a:solidFill>
+                  <a:srgbClr val="FFFFFF"/>
+                </a:solidFill>
+                <a:latin typeface="Segoe UI"/>
+              </a:rPr>
+              <a:t>Both, platform-side</a:t>
+            </a:r>
+          </a:p>
+          <a:p>
+            <a:pPr algn="l">
+              <a:lnSpc>
+                <a:spcPct val="105000"/>
+              </a:lnSpc>
+              <a:spcBef>
+                <a:spcPts val="0"/>
+              </a:spcBef>
+              <a:spcAft>
+                <a:spcPts val="600"/>
+              </a:spcAft>
+            </a:pPr>
+            <a:r>
+              <a:rPr sz="1500" b="0">
+                <a:solidFill>
+                  <a:srgbClr val="C7D6EA"/>
+                </a:solidFill>
+                <a:latin typeface="Segoe UI"/>
+              </a:rPr>
+              <a:t>The Meteorologist needs both, and in Gislefoss they live in foundry.bicep — not in app code.</a:t>
+            </a:r>
+          </a:p>
+        </p:txBody>
+      </p:sp>
+    </p:spTree>
+  </p:cSld>
+  <p:clrMapOvr>
+    <a:masterClrMapping/>
+  </p:clrMapOvr>
+</p:sld>
+</file>
+
 <file path=ppt/slides/slide3.xml><?xml version="1.0" encoding="utf-8"?>
 <p:sld xmlns:a="http://schemas.openxmlformats.org/drawingml/2006/main" xmlns:r="http://schemas.openxmlformats.org/officeDocument/2006/relationships" xmlns:p="http://schemas.openxmlformats.org/presentationml/2006/main">
   <p:cSld>

</xml_diff>

<commit_message>
Add Foundry deployment-types slide to presento.
New slide "Where your inferencing data is processed" (page 4, after
RBAC): two-card comparison of Global Standard (any Azure region
worldwide) vs Data Zone Standard (US/EU zone), with a data-residency
note that data at rest stays in the Azure geography and that Gislefoss
runs gpt-4o as GlobalStandard from Sweden Central, so inference can
still leave the EU.

Co-Authored-By: Claude Opus 4.8 (1M context) <noreply@anthropic.com>
</commit_message>
<xml_diff>
--- a/docs/prompt-shields-vs-guardrails.pptx
+++ b/docs/prompt-shields-vs-guardrails.pptx
@@ -8,6 +8,7 @@
     <p:sldId id="256" r:id="rId2"/>
     <p:sldId id="257" r:id="rId3"/>
     <p:sldId id="258" r:id="rId4"/>
+    <p:sldId id="276" r:id="rId26"/>
     <p:sldId id="260" r:id="rId5"/>
     <p:sldId id="264" r:id="rId6"/>
     <p:sldId id="269" r:id="rId7"/>
@@ -15455,6 +15456,1105 @@
 </p:sld>
 </file>
 
+<file path=ppt/slides/slide21.xml><?xml version="1.0" encoding="utf-8"?>
+<p:sld xmlns:a="http://schemas.openxmlformats.org/drawingml/2006/main" xmlns:p="http://schemas.openxmlformats.org/presentationml/2006/main" xmlns:r="http://schemas.openxmlformats.org/officeDocument/2006/relationships">
+  <p:cSld>
+    <p:spTree>
+      <p:nvGrpSpPr>
+        <p:cNvPr id="1" name=""/>
+        <p:cNvGrpSpPr/>
+        <p:nvPr/>
+      </p:nvGrpSpPr>
+      <p:grpSpPr/>
+      <p:sp>
+        <p:nvSpPr>
+          <p:cNvPr id="2" name="Rectangle 1"/>
+          <p:cNvSpPr/>
+          <p:nvPr/>
+        </p:nvSpPr>
+        <p:spPr>
+          <a:xfrm>
+            <a:off x="0" y="0"/>
+            <a:ext cx="12188952" cy="164592"/>
+          </a:xfrm>
+          <a:prstGeom prst="rect">
+            <a:avLst/>
+          </a:prstGeom>
+          <a:solidFill>
+            <a:srgbClr val="0078D4"/>
+          </a:solidFill>
+          <a:ln>
+            <a:noFill/>
+          </a:ln>
+          <a:effectLst/>
+        </p:spPr>
+        <p:style>
+          <a:lnRef idx="1">
+            <a:schemeClr val="accent1"/>
+          </a:lnRef>
+          <a:fillRef idx="3">
+            <a:schemeClr val="accent1"/>
+          </a:fillRef>
+          <a:effectRef idx="2">
+            <a:schemeClr val="accent1"/>
+          </a:effectRef>
+          <a:fontRef idx="minor">
+            <a:schemeClr val="lt1"/>
+          </a:fontRef>
+        </p:style>
+        <p:txBody>
+          <a:bodyPr rtlCol="0" anchor="ctr"/>
+          <a:lstStyle/>
+          <a:p>
+            <a:pPr algn="ctr"/>
+          </a:p>
+        </p:txBody>
+      </p:sp>
+      <p:sp>
+        <p:nvSpPr>
+          <p:cNvPr id="3" name="TextBox 2"/>
+          <p:cNvSpPr txBox="1"/>
+          <p:nvPr/>
+        </p:nvSpPr>
+        <p:spPr>
+          <a:xfrm>
+            <a:off x="640080" y="411480"/>
+            <a:ext cx="10972800" cy="365760"/>
+          </a:xfrm>
+          <a:prstGeom prst="rect">
+            <a:avLst/>
+          </a:prstGeom>
+          <a:noFill/>
+        </p:spPr>
+        <p:txBody>
+          <a:bodyPr wrap="square">
+            <a:spAutoFit/>
+          </a:bodyPr>
+          <a:lstStyle/>
+          <a:p>
+            <a:pPr algn="l">
+              <a:spcAft>
+                <a:spcPts val="600"/>
+              </a:spcAft>
+            </a:pPr>
+            <a:r>
+              <a:rPr sz="1300" b="1">
+                <a:solidFill>
+                  <a:srgbClr val="0078D4"/>
+                </a:solidFill>
+                <a:latin typeface="Segoe UI"/>
+              </a:rPr>
+              <a:t>AZURE AI FOUNDRY · MODEL DEPLOYMENT TYPES</a:t>
+            </a:r>
+          </a:p>
+        </p:txBody>
+      </p:sp>
+      <p:sp>
+        <p:nvSpPr>
+          <p:cNvPr id="4" name="TextBox 3"/>
+          <p:cNvSpPr txBox="1"/>
+          <p:nvPr/>
+        </p:nvSpPr>
+        <p:spPr>
+          <a:xfrm>
+            <a:off x="640080" y="749808"/>
+            <a:ext cx="10972800" cy="822960"/>
+          </a:xfrm>
+          <a:prstGeom prst="rect">
+            <a:avLst/>
+          </a:prstGeom>
+          <a:noFill/>
+        </p:spPr>
+        <p:txBody>
+          <a:bodyPr wrap="square">
+            <a:spAutoFit/>
+          </a:bodyPr>
+          <a:lstStyle/>
+          <a:p>
+            <a:pPr algn="l">
+              <a:spcAft>
+                <a:spcPts val="600"/>
+              </a:spcAft>
+            </a:pPr>
+            <a:r>
+              <a:rPr sz="3000" b="1">
+                <a:solidFill>
+                  <a:srgbClr val="243A5E"/>
+                </a:solidFill>
+                <a:latin typeface="Segoe UI"/>
+              </a:rPr>
+              <a:t>Where your inferencing data is processed</a:t>
+            </a:r>
+          </a:p>
+        </p:txBody>
+      </p:sp>
+      <p:sp>
+        <p:nvSpPr>
+          <p:cNvPr id="5" name="Rectangle 4"/>
+          <p:cNvSpPr/>
+          <p:nvPr/>
+        </p:nvSpPr>
+        <p:spPr>
+          <a:xfrm>
+            <a:off x="658368" y="1481328"/>
+            <a:ext cx="1005840" cy="45720"/>
+          </a:xfrm>
+          <a:prstGeom prst="rect">
+            <a:avLst/>
+          </a:prstGeom>
+          <a:solidFill>
+            <a:srgbClr val="0078D4"/>
+          </a:solidFill>
+          <a:ln>
+            <a:noFill/>
+          </a:ln>
+          <a:effectLst/>
+        </p:spPr>
+        <p:style>
+          <a:lnRef idx="1">
+            <a:schemeClr val="accent1"/>
+          </a:lnRef>
+          <a:fillRef idx="3">
+            <a:schemeClr val="accent1"/>
+          </a:fillRef>
+          <a:effectRef idx="2">
+            <a:schemeClr val="accent1"/>
+          </a:effectRef>
+          <a:fontRef idx="minor">
+            <a:schemeClr val="lt1"/>
+          </a:fontRef>
+        </p:style>
+        <p:txBody>
+          <a:bodyPr rtlCol="0" anchor="ctr"/>
+          <a:lstStyle/>
+          <a:p>
+            <a:pPr algn="ctr"/>
+          </a:p>
+        </p:txBody>
+      </p:sp>
+      <p:sp>
+        <p:nvSpPr>
+          <p:cNvPr id="6" name="TextBox 5"/>
+          <p:cNvSpPr txBox="1"/>
+          <p:nvPr/>
+        </p:nvSpPr>
+        <p:spPr>
+          <a:xfrm>
+            <a:off x="777240" y="1627632"/>
+            <a:ext cx="10607040" cy="411480"/>
+          </a:xfrm>
+          <a:prstGeom prst="rect">
+            <a:avLst/>
+          </a:prstGeom>
+          <a:noFill/>
+        </p:spPr>
+        <p:txBody>
+          <a:bodyPr wrap="square">
+            <a:spAutoFit/>
+          </a:bodyPr>
+          <a:lstStyle/>
+          <a:p>
+            <a:pPr algn="l">
+              <a:spcAft>
+                <a:spcPts val="600"/>
+              </a:spcAft>
+            </a:pPr>
+            <a:r>
+              <a:rPr sz="1600" b="0">
+                <a:solidFill>
+                  <a:srgbClr val="605E5C"/>
+                </a:solidFill>
+                <a:latin typeface="Segoe UI"/>
+              </a:rPr>
+              <a:t>Deployment type — not region — decides which datacentres may run your inference.</a:t>
+            </a:r>
+          </a:p>
+        </p:txBody>
+      </p:sp>
+      <p:sp>
+        <p:nvSpPr>
+          <p:cNvPr id="7" name="Rounded Rectangle 6"/>
+          <p:cNvSpPr/>
+          <p:nvPr/>
+        </p:nvSpPr>
+        <p:spPr>
+          <a:xfrm>
+            <a:off x="777240" y="2194560"/>
+            <a:ext cx="5074920" cy="2880360"/>
+          </a:xfrm>
+          <a:prstGeom prst="roundRect">
+            <a:avLst>
+              <a:gd name="adj" fmla="val 5000"/>
+            </a:avLst>
+          </a:prstGeom>
+          <a:solidFill>
+            <a:srgbClr val="FFFFFF"/>
+          </a:solidFill>
+          <a:ln w="25400">
+            <a:solidFill>
+              <a:srgbClr val="0078D4"/>
+            </a:solidFill>
+          </a:ln>
+          <a:effectLst/>
+        </p:spPr>
+        <p:style>
+          <a:lnRef idx="1">
+            <a:schemeClr val="accent1"/>
+          </a:lnRef>
+          <a:fillRef idx="3">
+            <a:schemeClr val="accent1"/>
+          </a:fillRef>
+          <a:effectRef idx="2">
+            <a:schemeClr val="accent1"/>
+          </a:effectRef>
+          <a:fontRef idx="minor">
+            <a:schemeClr val="lt1"/>
+          </a:fontRef>
+        </p:style>
+        <p:txBody>
+          <a:bodyPr rtlCol="0" anchor="ctr"/>
+          <a:lstStyle/>
+          <a:p>
+            <a:pPr algn="ctr"/>
+          </a:p>
+        </p:txBody>
+      </p:sp>
+      <p:sp>
+        <p:nvSpPr>
+          <p:cNvPr id="8" name="Rounded Rectangle 7"/>
+          <p:cNvSpPr/>
+          <p:nvPr/>
+        </p:nvSpPr>
+        <p:spPr>
+          <a:xfrm>
+            <a:off x="6309360" y="2194560"/>
+            <a:ext cx="5074920" cy="2880360"/>
+          </a:xfrm>
+          <a:prstGeom prst="roundRect">
+            <a:avLst>
+              <a:gd name="adj" fmla="val 5000"/>
+            </a:avLst>
+          </a:prstGeom>
+          <a:solidFill>
+            <a:srgbClr val="FFFFFF"/>
+          </a:solidFill>
+          <a:ln w="25400">
+            <a:solidFill>
+              <a:srgbClr val="107C10"/>
+            </a:solidFill>
+          </a:ln>
+          <a:effectLst/>
+        </p:spPr>
+        <p:style>
+          <a:lnRef idx="1">
+            <a:schemeClr val="accent1"/>
+          </a:lnRef>
+          <a:fillRef idx="3">
+            <a:schemeClr val="accent1"/>
+          </a:fillRef>
+          <a:effectRef idx="2">
+            <a:schemeClr val="accent1"/>
+          </a:effectRef>
+          <a:fontRef idx="minor">
+            <a:schemeClr val="lt1"/>
+          </a:fontRef>
+        </p:style>
+        <p:txBody>
+          <a:bodyPr rtlCol="0" anchor="ctr"/>
+          <a:lstStyle/>
+          <a:p>
+            <a:pPr algn="ctr"/>
+          </a:p>
+        </p:txBody>
+      </p:sp>
+      <p:sp>
+        <p:nvSpPr>
+          <p:cNvPr id="9" name="TextBox 8"/>
+          <p:cNvSpPr txBox="1"/>
+          <p:nvPr/>
+        </p:nvSpPr>
+        <p:spPr>
+          <a:xfrm>
+            <a:off x="1051560" y="2313432"/>
+            <a:ext cx="4526280" cy="420624"/>
+          </a:xfrm>
+          <a:prstGeom prst="rect">
+            <a:avLst/>
+          </a:prstGeom>
+          <a:noFill/>
+        </p:spPr>
+        <p:txBody>
+          <a:bodyPr wrap="square"/>
+          <a:lstStyle/>
+          <a:p>
+            <a:pPr algn="l">
+              <a:spcAft>
+                <a:spcPts val="400"/>
+              </a:spcAft>
+            </a:pPr>
+            <a:r>
+              <a:rPr sz="1500" b="1">
+                <a:solidFill>
+                  <a:srgbClr val="0078D4"/>
+                </a:solidFill>
+                <a:latin typeface="Segoe UI"/>
+              </a:rPr>
+              <a:t>GLOBAL STANDARD</a:t>
+            </a:r>
+            <a:r>
+              <a:rPr sz="1200" b="0">
+                <a:solidFill>
+                  <a:srgbClr val="605E5C"/>
+                </a:solidFill>
+                <a:latin typeface="Consolas"/>
+              </a:rPr>
+              <a:t>   ·  GlobalStandard</a:t>
+            </a:r>
+          </a:p>
+        </p:txBody>
+      </p:sp>
+      <p:sp>
+        <p:nvSpPr>
+          <p:cNvPr id="10" name="TextBox 9"/>
+          <p:cNvSpPr txBox="1"/>
+          <p:nvPr/>
+        </p:nvSpPr>
+        <p:spPr>
+          <a:xfrm>
+            <a:off x="1051560" y="2779776"/>
+            <a:ext cx="4526280" cy="502920"/>
+          </a:xfrm>
+          <a:prstGeom prst="rect">
+            <a:avLst/>
+          </a:prstGeom>
+          <a:noFill/>
+        </p:spPr>
+        <p:txBody>
+          <a:bodyPr wrap="square"/>
+          <a:lstStyle/>
+          <a:p>
+            <a:pPr algn="l">
+              <a:lnSpc>
+                <a:spcPct val="100000"/>
+              </a:lnSpc>
+              <a:spcAft>
+                <a:spcPts val="400"/>
+              </a:spcAft>
+            </a:pPr>
+            <a:r>
+              <a:rPr sz="1700" b="1">
+                <a:solidFill>
+                  <a:srgbClr val="243A5E"/>
+                </a:solidFill>
+                <a:latin typeface="Segoe UI"/>
+              </a:rPr>
+              <a:t>Any eligible Azure region, worldwide.</a:t>
+            </a:r>
+          </a:p>
+        </p:txBody>
+      </p:sp>
+      <p:sp>
+        <p:nvSpPr>
+          <p:cNvPr id="11" name="TextBox 10"/>
+          <p:cNvSpPr txBox="1"/>
+          <p:nvPr/>
+        </p:nvSpPr>
+        <p:spPr>
+          <a:xfrm>
+            <a:off x="1051560" y="3310128"/>
+            <a:ext cx="4572000" cy="1188720"/>
+          </a:xfrm>
+          <a:prstGeom prst="rect">
+            <a:avLst/>
+          </a:prstGeom>
+          <a:noFill/>
+        </p:spPr>
+        <p:txBody>
+          <a:bodyPr wrap="square"/>
+          <a:lstStyle/>
+          <a:p>
+            <a:pPr algn="l">
+              <a:lnSpc>
+                <a:spcPct val="104000"/>
+              </a:lnSpc>
+              <a:spcBef>
+                <a:spcPts val="0"/>
+              </a:spcBef>
+              <a:spcAft>
+                <a:spcPts val="700"/>
+              </a:spcAft>
+            </a:pPr>
+            <a:r>
+              <a:rPr sz="1300" b="1">
+                <a:solidFill>
+                  <a:srgbClr val="0078D4"/>
+                </a:solidFill>
+                <a:latin typeface="Segoe UI"/>
+              </a:rPr>
+              <a:t>›  </a:t>
+            </a:r>
+            <a:r>
+              <a:rPr sz="1300" b="0">
+                <a:solidFill>
+                  <a:srgbClr val="605E5C"/>
+                </a:solidFill>
+                <a:latin typeface="Segoe UI"/>
+              </a:rPr>
+              <a:t>Highest default quota; broadest model choice.</a:t>
+            </a:r>
+          </a:p>
+          <a:p>
+            <a:pPr algn="l">
+              <a:lnSpc>
+                <a:spcPct val="104000"/>
+              </a:lnSpc>
+              <a:spcBef>
+                <a:spcPts val="0"/>
+              </a:spcBef>
+              <a:spcAft>
+                <a:spcPts val="700"/>
+              </a:spcAft>
+            </a:pPr>
+            <a:r>
+              <a:rPr sz="1300" b="1">
+                <a:solidFill>
+                  <a:srgbClr val="0078D4"/>
+                </a:solidFill>
+                <a:latin typeface="Segoe UI"/>
+              </a:rPr>
+              <a:t>›  </a:t>
+            </a:r>
+            <a:r>
+              <a:rPr sz="1300" b="0">
+                <a:solidFill>
+                  <a:srgbClr val="605E5C"/>
+                </a:solidFill>
+                <a:latin typeface="Segoe UI"/>
+              </a:rPr>
+              <a:t>Receives new models &amp; features first.</a:t>
+            </a:r>
+          </a:p>
+          <a:p>
+            <a:pPr algn="l">
+              <a:lnSpc>
+                <a:spcPct val="104000"/>
+              </a:lnSpc>
+              <a:spcBef>
+                <a:spcPts val="0"/>
+              </a:spcBef>
+              <a:spcAft>
+                <a:spcPts val="700"/>
+              </a:spcAft>
+            </a:pPr>
+            <a:r>
+              <a:rPr sz="1300" b="1">
+                <a:solidFill>
+                  <a:srgbClr val="0078D4"/>
+                </a:solidFill>
+                <a:latin typeface="Segoe UI"/>
+              </a:rPr>
+              <a:t>›  </a:t>
+            </a:r>
+            <a:r>
+              <a:rPr sz="1300" b="0">
+                <a:solidFill>
+                  <a:srgbClr val="605E5C"/>
+                </a:solidFill>
+                <a:latin typeface="Segoe UI"/>
+              </a:rPr>
+              <a:t>Inference may run in any Azure region, globally.</a:t>
+            </a:r>
+          </a:p>
+        </p:txBody>
+      </p:sp>
+      <p:sp>
+        <p:nvSpPr>
+          <p:cNvPr id="12" name="Rounded Rectangle 11"/>
+          <p:cNvSpPr/>
+          <p:nvPr/>
+        </p:nvSpPr>
+        <p:spPr>
+          <a:xfrm>
+            <a:off x="1051560" y="4553712"/>
+            <a:ext cx="4526280" cy="384048"/>
+          </a:xfrm>
+          <a:prstGeom prst="roundRect">
+            <a:avLst>
+              <a:gd name="adj" fmla="val 30000"/>
+            </a:avLst>
+          </a:prstGeom>
+          <a:solidFill>
+            <a:srgbClr val="DEECF9"/>
+          </a:solidFill>
+          <a:ln w="10160">
+            <a:solidFill>
+              <a:srgbClr val="0078D4"/>
+            </a:solidFill>
+          </a:ln>
+          <a:effectLst/>
+        </p:spPr>
+        <p:style>
+          <a:lnRef idx="1">
+            <a:schemeClr val="accent1"/>
+          </a:lnRef>
+          <a:fillRef idx="3">
+            <a:schemeClr val="accent1"/>
+          </a:fillRef>
+          <a:effectRef idx="2">
+            <a:schemeClr val="accent1"/>
+          </a:effectRef>
+          <a:fontRef idx="minor">
+            <a:schemeClr val="lt1"/>
+          </a:fontRef>
+        </p:style>
+        <p:txBody>
+          <a:bodyPr rtlCol="0" anchor="ctr"/>
+          <a:lstStyle/>
+          <a:p>
+            <a:pPr algn="ctr"/>
+          </a:p>
+        </p:txBody>
+      </p:sp>
+      <p:sp>
+        <p:nvSpPr>
+          <p:cNvPr id="13" name="TextBox 12"/>
+          <p:cNvSpPr txBox="1"/>
+          <p:nvPr/>
+        </p:nvSpPr>
+        <p:spPr>
+          <a:xfrm>
+            <a:off x="1051560" y="4581144"/>
+            <a:ext cx="4526280" cy="347472"/>
+          </a:xfrm>
+          <a:prstGeom prst="rect">
+            <a:avLst/>
+          </a:prstGeom>
+          <a:noFill/>
+        </p:spPr>
+        <p:txBody>
+          <a:bodyPr wrap="square" anchor="ctr"/>
+          <a:lstStyle/>
+          <a:p>
+            <a:pPr algn="ctr">
+              <a:spcAft>
+                <a:spcPts val="0"/>
+              </a:spcAft>
+            </a:pPr>
+            <a:r>
+              <a:rPr sz="1250" b="1">
+                <a:solidFill>
+                  <a:srgbClr val="0078D4"/>
+                </a:solidFill>
+                <a:latin typeface="Segoe UI"/>
+              </a:rPr>
+              <a:t>✓  Gislefoss uses this today</a:t>
+            </a:r>
+          </a:p>
+        </p:txBody>
+      </p:sp>
+      <p:sp>
+        <p:nvSpPr>
+          <p:cNvPr id="14" name="TextBox 13"/>
+          <p:cNvSpPr txBox="1"/>
+          <p:nvPr/>
+        </p:nvSpPr>
+        <p:spPr>
+          <a:xfrm>
+            <a:off x="6583680" y="2313432"/>
+            <a:ext cx="4526280" cy="420624"/>
+          </a:xfrm>
+          <a:prstGeom prst="rect">
+            <a:avLst/>
+          </a:prstGeom>
+          <a:noFill/>
+        </p:spPr>
+        <p:txBody>
+          <a:bodyPr wrap="square"/>
+          <a:lstStyle/>
+          <a:p>
+            <a:pPr algn="l">
+              <a:spcAft>
+                <a:spcPts val="400"/>
+              </a:spcAft>
+            </a:pPr>
+            <a:r>
+              <a:rPr sz="1500" b="1">
+                <a:solidFill>
+                  <a:srgbClr val="107C10"/>
+                </a:solidFill>
+                <a:latin typeface="Segoe UI"/>
+              </a:rPr>
+              <a:t>DATA ZONE STANDARD</a:t>
+            </a:r>
+            <a:r>
+              <a:rPr sz="1200" b="0">
+                <a:solidFill>
+                  <a:srgbClr val="605E5C"/>
+                </a:solidFill>
+                <a:latin typeface="Consolas"/>
+              </a:rPr>
+              <a:t>   ·  DataZoneStandard</a:t>
+            </a:r>
+          </a:p>
+        </p:txBody>
+      </p:sp>
+      <p:sp>
+        <p:nvSpPr>
+          <p:cNvPr id="15" name="TextBox 14"/>
+          <p:cNvSpPr txBox="1"/>
+          <p:nvPr/>
+        </p:nvSpPr>
+        <p:spPr>
+          <a:xfrm>
+            <a:off x="6583680" y="2779776"/>
+            <a:ext cx="4526280" cy="502920"/>
+          </a:xfrm>
+          <a:prstGeom prst="rect">
+            <a:avLst/>
+          </a:prstGeom>
+          <a:noFill/>
+        </p:spPr>
+        <p:txBody>
+          <a:bodyPr wrap="square"/>
+          <a:lstStyle/>
+          <a:p>
+            <a:pPr algn="l">
+              <a:lnSpc>
+                <a:spcPct val="100000"/>
+              </a:lnSpc>
+              <a:spcAft>
+                <a:spcPts val="400"/>
+              </a:spcAft>
+            </a:pPr>
+            <a:r>
+              <a:rPr sz="1700" b="1">
+                <a:solidFill>
+                  <a:srgbClr val="243A5E"/>
+                </a:solidFill>
+                <a:latin typeface="Segoe UI"/>
+              </a:rPr>
+              <a:t>Within a chosen data zone — US or EU.</a:t>
+            </a:r>
+          </a:p>
+        </p:txBody>
+      </p:sp>
+      <p:sp>
+        <p:nvSpPr>
+          <p:cNvPr id="16" name="TextBox 15"/>
+          <p:cNvSpPr txBox="1"/>
+          <p:nvPr/>
+        </p:nvSpPr>
+        <p:spPr>
+          <a:xfrm>
+            <a:off x="6583680" y="3310128"/>
+            <a:ext cx="4572000" cy="1188720"/>
+          </a:xfrm>
+          <a:prstGeom prst="rect">
+            <a:avLst/>
+          </a:prstGeom>
+          <a:noFill/>
+        </p:spPr>
+        <p:txBody>
+          <a:bodyPr wrap="square"/>
+          <a:lstStyle/>
+          <a:p>
+            <a:pPr algn="l">
+              <a:lnSpc>
+                <a:spcPct val="104000"/>
+              </a:lnSpc>
+              <a:spcBef>
+                <a:spcPts val="0"/>
+              </a:spcBef>
+              <a:spcAft>
+                <a:spcPts val="700"/>
+              </a:spcAft>
+            </a:pPr>
+            <a:r>
+              <a:rPr sz="1300" b="1">
+                <a:solidFill>
+                  <a:srgbClr val="107C10"/>
+                </a:solidFill>
+                <a:latin typeface="Segoe UI"/>
+              </a:rPr>
+              <a:t>›  </a:t>
+            </a:r>
+            <a:r>
+              <a:rPr sz="1300" b="0">
+                <a:solidFill>
+                  <a:srgbClr val="605E5C"/>
+                </a:solidFill>
+                <a:latin typeface="Segoe UI"/>
+              </a:rPr>
+              <a:t>Processing stays inside the zone boundary.</a:t>
+            </a:r>
+          </a:p>
+          <a:p>
+            <a:pPr algn="l">
+              <a:lnSpc>
+                <a:spcPct val="104000"/>
+              </a:lnSpc>
+              <a:spcBef>
+                <a:spcPts val="0"/>
+              </a:spcBef>
+              <a:spcAft>
+                <a:spcPts val="700"/>
+              </a:spcAft>
+            </a:pPr>
+            <a:r>
+              <a:rPr sz="1300" b="1">
+                <a:solidFill>
+                  <a:srgbClr val="107C10"/>
+                </a:solidFill>
+                <a:latin typeface="Segoe UI"/>
+              </a:rPr>
+              <a:t>›  </a:t>
+            </a:r>
+            <a:r>
+              <a:rPr sz="1300" b="0">
+                <a:solidFill>
+                  <a:srgbClr val="605E5C"/>
+                </a:solidFill>
+                <a:latin typeface="Segoe UI"/>
+              </a:rPr>
+              <a:t>EU zone = EU Data Boundary (Sweden, Norway…).</a:t>
+            </a:r>
+          </a:p>
+          <a:p>
+            <a:pPr algn="l">
+              <a:lnSpc>
+                <a:spcPct val="104000"/>
+              </a:lnSpc>
+              <a:spcBef>
+                <a:spcPts val="0"/>
+              </a:spcBef>
+              <a:spcAft>
+                <a:spcPts val="700"/>
+              </a:spcAft>
+            </a:pPr>
+            <a:r>
+              <a:rPr sz="1300" b="1">
+                <a:solidFill>
+                  <a:srgbClr val="107C10"/>
+                </a:solidFill>
+                <a:latin typeface="Segoe UI"/>
+              </a:rPr>
+              <a:t>›  </a:t>
+            </a:r>
+            <a:r>
+              <a:rPr sz="1300" b="0">
+                <a:solidFill>
+                  <a:srgbClr val="605E5C"/>
+                </a:solidFill>
+                <a:latin typeface="Segoe UI"/>
+              </a:rPr>
+              <a:t>Higher quota than single-region Standard.</a:t>
+            </a:r>
+          </a:p>
+        </p:txBody>
+      </p:sp>
+      <p:sp>
+        <p:nvSpPr>
+          <p:cNvPr id="17" name="Rounded Rectangle 16"/>
+          <p:cNvSpPr/>
+          <p:nvPr/>
+        </p:nvSpPr>
+        <p:spPr>
+          <a:xfrm>
+            <a:off x="6583680" y="4553712"/>
+            <a:ext cx="4526280" cy="384048"/>
+          </a:xfrm>
+          <a:prstGeom prst="roundRect">
+            <a:avLst>
+              <a:gd name="adj" fmla="val 30000"/>
+            </a:avLst>
+          </a:prstGeom>
+          <a:solidFill>
+            <a:srgbClr val="DFF6DD"/>
+          </a:solidFill>
+          <a:ln w="10160">
+            <a:solidFill>
+              <a:srgbClr val="107C10"/>
+            </a:solidFill>
+          </a:ln>
+          <a:effectLst/>
+        </p:spPr>
+        <p:style>
+          <a:lnRef idx="1">
+            <a:schemeClr val="accent1"/>
+          </a:lnRef>
+          <a:fillRef idx="3">
+            <a:schemeClr val="accent1"/>
+          </a:fillRef>
+          <a:effectRef idx="2">
+            <a:schemeClr val="accent1"/>
+          </a:effectRef>
+          <a:fontRef idx="minor">
+            <a:schemeClr val="lt1"/>
+          </a:fontRef>
+        </p:style>
+        <p:txBody>
+          <a:bodyPr rtlCol="0" anchor="ctr"/>
+          <a:lstStyle/>
+          <a:p>
+            <a:pPr algn="ctr"/>
+          </a:p>
+        </p:txBody>
+      </p:sp>
+      <p:sp>
+        <p:nvSpPr>
+          <p:cNvPr id="18" name="TextBox 17"/>
+          <p:cNvSpPr txBox="1"/>
+          <p:nvPr/>
+        </p:nvSpPr>
+        <p:spPr>
+          <a:xfrm>
+            <a:off x="6583680" y="4581144"/>
+            <a:ext cx="4526280" cy="347472"/>
+          </a:xfrm>
+          <a:prstGeom prst="rect">
+            <a:avLst/>
+          </a:prstGeom>
+          <a:noFill/>
+        </p:spPr>
+        <p:txBody>
+          <a:bodyPr wrap="square" anchor="ctr"/>
+          <a:lstStyle/>
+          <a:p>
+            <a:pPr algn="ctr">
+              <a:spcAft>
+                <a:spcPts val="0"/>
+              </a:spcAft>
+            </a:pPr>
+            <a:r>
+              <a:rPr sz="1250" b="1">
+                <a:solidFill>
+                  <a:srgbClr val="107C10"/>
+                </a:solidFill>
+                <a:latin typeface="Segoe UI"/>
+              </a:rPr>
+              <a:t>→  Pick this for EU data residency</a:t>
+            </a:r>
+          </a:p>
+        </p:txBody>
+      </p:sp>
+      <p:sp>
+        <p:nvSpPr>
+          <p:cNvPr id="19" name="Rounded Rectangle 18"/>
+          <p:cNvSpPr/>
+          <p:nvPr/>
+        </p:nvSpPr>
+        <p:spPr>
+          <a:xfrm>
+            <a:off x="777240" y="5239512"/>
+            <a:ext cx="10607040" cy="868680"/>
+          </a:xfrm>
+          <a:prstGeom prst="roundRect">
+            <a:avLst>
+              <a:gd name="adj" fmla="val 5000"/>
+            </a:avLst>
+          </a:prstGeom>
+          <a:solidFill>
+            <a:srgbClr val="243A5E"/>
+          </a:solidFill>
+          <a:ln>
+            <a:noFill/>
+          </a:ln>
+          <a:effectLst/>
+        </p:spPr>
+        <p:style>
+          <a:lnRef idx="1">
+            <a:schemeClr val="accent1"/>
+          </a:lnRef>
+          <a:fillRef idx="3">
+            <a:schemeClr val="accent1"/>
+          </a:fillRef>
+          <a:effectRef idx="2">
+            <a:schemeClr val="accent1"/>
+          </a:effectRef>
+          <a:fontRef idx="minor">
+            <a:schemeClr val="lt1"/>
+          </a:fontRef>
+        </p:style>
+        <p:txBody>
+          <a:bodyPr rtlCol="0" anchor="ctr"/>
+          <a:lstStyle/>
+          <a:p>
+            <a:pPr algn="ctr"/>
+          </a:p>
+        </p:txBody>
+      </p:sp>
+      <p:sp>
+        <p:nvSpPr>
+          <p:cNvPr id="20" name="TextBox 19"/>
+          <p:cNvSpPr txBox="1"/>
+          <p:nvPr/>
+        </p:nvSpPr>
+        <p:spPr>
+          <a:xfrm>
+            <a:off x="1051560" y="5294375"/>
+            <a:ext cx="10058400" cy="786384"/>
+          </a:xfrm>
+          <a:prstGeom prst="rect">
+            <a:avLst/>
+          </a:prstGeom>
+          <a:noFill/>
+        </p:spPr>
+        <p:txBody>
+          <a:bodyPr wrap="square" anchor="ctr"/>
+          <a:lstStyle/>
+          <a:p>
+            <a:pPr algn="l">
+              <a:lnSpc>
+                <a:spcPct val="105000"/>
+              </a:lnSpc>
+              <a:spcAft>
+                <a:spcPts val="300"/>
+              </a:spcAft>
+            </a:pPr>
+            <a:r>
+              <a:rPr sz="1350" b="1">
+                <a:solidFill>
+                  <a:srgbClr val="FFFFFF"/>
+                </a:solidFill>
+                <a:latin typeface="Segoe UI"/>
+              </a:rPr>
+              <a:t>Data at rest always stays in your Azure geography </a:t>
+            </a:r>
+            <a:r>
+              <a:rPr sz="1350" b="0">
+                <a:solidFill>
+                  <a:srgbClr val="C7D6EA"/>
+                </a:solidFill>
+                <a:latin typeface="Segoe UI"/>
+              </a:rPr>
+              <a:t>— only the processing location changes.</a:t>
+            </a:r>
+          </a:p>
+          <a:p>
+            <a:pPr algn="l">
+              <a:lnSpc>
+                <a:spcPct val="105000"/>
+              </a:lnSpc>
+              <a:spcAft>
+                <a:spcPts val="0"/>
+              </a:spcAft>
+            </a:pPr>
+            <a:r>
+              <a:rPr sz="1200" b="0">
+                <a:solidFill>
+                  <a:srgbClr val="C7D6EA"/>
+                </a:solidFill>
+                <a:latin typeface="Segoe UI"/>
+              </a:rPr>
+              <a:t>Gislefoss runs gpt-4o as </a:t>
+            </a:r>
+            <a:r>
+              <a:rPr sz="1200" b="1">
+                <a:solidFill>
+                  <a:srgbClr val="FFFFFF"/>
+                </a:solidFill>
+                <a:latin typeface="Consolas"/>
+              </a:rPr>
+              <a:t>GlobalStandard</a:t>
+            </a:r>
+            <a:r>
+              <a:rPr sz="1200" b="0">
+                <a:solidFill>
+                  <a:srgbClr val="C7D6EA"/>
+                </a:solidFill>
+                <a:latin typeface="Segoe UI"/>
+              </a:rPr>
+              <a:t> from Sweden Central — an EU-boundary region — yet inference can still leave the EU.</a:t>
+            </a:r>
+          </a:p>
+        </p:txBody>
+      </p:sp>
+      <p:sp>
+        <p:nvSpPr>
+          <p:cNvPr id="21" name="TextBox 20"/>
+          <p:cNvSpPr txBox="1"/>
+          <p:nvPr/>
+        </p:nvSpPr>
+        <p:spPr>
+          <a:xfrm>
+            <a:off x="640080" y="6419088"/>
+            <a:ext cx="7315200" cy="320040"/>
+          </a:xfrm>
+          <a:prstGeom prst="rect">
+            <a:avLst/>
+          </a:prstGeom>
+          <a:noFill/>
+        </p:spPr>
+        <p:txBody>
+          <a:bodyPr wrap="square">
+            <a:spAutoFit/>
+          </a:bodyPr>
+          <a:lstStyle/>
+          <a:p>
+            <a:pPr algn="l">
+              <a:spcAft>
+                <a:spcPts val="600"/>
+              </a:spcAft>
+            </a:pPr>
+            <a:r>
+              <a:rPr sz="900" b="0">
+                <a:solidFill>
+                  <a:srgbClr val="605E5C"/>
+                </a:solidFill>
+                <a:latin typeface="Segoe UI"/>
+              </a:rPr>
+              <a:t>Prompt Shields vs. Guardrails  ·  Gislefoss Meteorologist Agent</a:t>
+            </a:r>
+          </a:p>
+        </p:txBody>
+      </p:sp>
+      <p:sp>
+        <p:nvSpPr>
+          <p:cNvPr id="22" name="TextBox 21"/>
+          <p:cNvSpPr txBox="1"/>
+          <p:nvPr/>
+        </p:nvSpPr>
+        <p:spPr>
+          <a:xfrm>
+            <a:off x="10972800" y="6419088"/>
+            <a:ext cx="822960" cy="320040"/>
+          </a:xfrm>
+          <a:prstGeom prst="rect">
+            <a:avLst/>
+          </a:prstGeom>
+          <a:noFill/>
+        </p:spPr>
+        <p:txBody>
+          <a:bodyPr wrap="square">
+            <a:spAutoFit/>
+          </a:bodyPr>
+          <a:lstStyle/>
+          <a:p>
+            <a:pPr algn="r">
+              <a:spcAft>
+                <a:spcPts val="600"/>
+              </a:spcAft>
+            </a:pPr>
+            <a:r>
+              <a:rPr sz="900" b="0">
+                <a:solidFill>
+                  <a:srgbClr val="605E5C"/>
+                </a:solidFill>
+                <a:latin typeface="Segoe UI"/>
+              </a:rPr>
+              <a:t>4</a:t>
+            </a:r>
+          </a:p>
+        </p:txBody>
+      </p:sp>
+    </p:spTree>
+  </p:cSld>
+  <p:clrMapOvr>
+    <a:masterClrMapping/>
+  </p:clrMapOvr>
+</p:sld>
+</file>
+
 <file path=ppt/slides/slide3.xml><?xml version="1.0" encoding="utf-8"?>
 <p:sld xmlns:a="http://schemas.openxmlformats.org/drawingml/2006/main" xmlns:r="http://schemas.openxmlformats.org/officeDocument/2006/relationships" xmlns:p="http://schemas.openxmlformats.org/presentationml/2006/main">
   <p:cSld>

</xml_diff>

<commit_message>
Add types of deployments
</commit_message>
<xml_diff>
--- a/docs/prompt-shields-vs-guardrails.pptx
+++ b/docs/prompt-shields-vs-guardrails.pptx
@@ -9,6 +9,8 @@
     <p:sldId id="257" r:id="rId3"/>
     <p:sldId id="258" r:id="rId4"/>
     <p:sldId id="276" r:id="rId5"/>
+    <p:sldId id="278" r:id="rId28"/>
+    <p:sldId id="279" r:id="rId29"/>
     <p:sldId id="277" r:id="rId6"/>
     <p:sldId id="260" r:id="rId7"/>
     <p:sldId id="264" r:id="rId8"/>
@@ -16750,6 +16752,2886 @@
 </p:sld>
 </file>
 
+<file path=ppt/slides/slide23.xml><?xml version="1.0" encoding="utf-8"?>
+<p:sld xmlns:a="http://schemas.openxmlformats.org/drawingml/2006/main" xmlns:p="http://schemas.openxmlformats.org/presentationml/2006/main" xmlns:r="http://schemas.openxmlformats.org/officeDocument/2006/relationships">
+  <p:cSld>
+    <p:spTree>
+      <p:nvGrpSpPr>
+        <p:cNvPr id="1" name=""/>
+        <p:cNvGrpSpPr/>
+        <p:nvPr/>
+      </p:nvGrpSpPr>
+      <p:grpSpPr/>
+      <p:sp>
+        <p:nvSpPr>
+          <p:cNvPr id="2" name="Rectangle 1"/>
+          <p:cNvSpPr/>
+          <p:nvPr/>
+        </p:nvSpPr>
+        <p:spPr>
+          <a:xfrm>
+            <a:off x="0" y="0"/>
+            <a:ext cx="12188952" cy="164592"/>
+          </a:xfrm>
+          <a:prstGeom prst="rect">
+            <a:avLst/>
+          </a:prstGeom>
+          <a:solidFill>
+            <a:srgbClr val="0078D4"/>
+          </a:solidFill>
+          <a:ln>
+            <a:noFill/>
+          </a:ln>
+          <a:effectLst/>
+        </p:spPr>
+        <p:style>
+          <a:lnRef idx="1">
+            <a:schemeClr val="accent1"/>
+          </a:lnRef>
+          <a:fillRef idx="3">
+            <a:schemeClr val="accent1"/>
+          </a:fillRef>
+          <a:effectRef idx="2">
+            <a:schemeClr val="accent1"/>
+          </a:effectRef>
+          <a:fontRef idx="minor">
+            <a:schemeClr val="lt1"/>
+          </a:fontRef>
+        </p:style>
+        <p:txBody>
+          <a:bodyPr rtlCol="0" anchor="ctr"/>
+          <a:lstStyle/>
+          <a:p>
+            <a:pPr algn="ctr"/>
+            <a:endParaRPr/>
+          </a:p>
+        </p:txBody>
+      </p:sp>
+      <p:sp>
+        <p:nvSpPr>
+          <p:cNvPr id="3" name="TextBox 2"/>
+          <p:cNvSpPr txBox="1"/>
+          <p:nvPr/>
+        </p:nvSpPr>
+        <p:spPr>
+          <a:xfrm>
+            <a:off x="640080" y="411480"/>
+            <a:ext cx="10972800" cy="365760"/>
+          </a:xfrm>
+          <a:prstGeom prst="rect">
+            <a:avLst/>
+          </a:prstGeom>
+          <a:noFill/>
+        </p:spPr>
+        <p:txBody>
+          <a:bodyPr wrap="square">
+            <a:spAutoFit/>
+          </a:bodyPr>
+          <a:lstStyle/>
+          <a:p>
+            <a:pPr algn="l">
+              <a:spcAft>
+                <a:spcPts val="600"/>
+              </a:spcAft>
+            </a:pPr>
+            <a:r>
+              <a:rPr sz="1300" b="1">
+                <a:solidFill>
+                  <a:srgbClr val="0078D4"/>
+                </a:solidFill>
+                <a:latin typeface="Segoe UI"/>
+              </a:rPr>
+              <a:t>AZURE AI FOUNDRY · ANATOMY OF A DEPLOYMENT TYPE</a:t>
+            </a:r>
+          </a:p>
+        </p:txBody>
+      </p:sp>
+      <p:sp>
+        <p:nvSpPr>
+          <p:cNvPr id="4" name="TextBox 3"/>
+          <p:cNvSpPr txBox="1"/>
+          <p:nvPr/>
+        </p:nvSpPr>
+        <p:spPr>
+          <a:xfrm>
+            <a:off x="640080" y="749808"/>
+            <a:ext cx="10972800" cy="553998"/>
+          </a:xfrm>
+          <a:prstGeom prst="rect">
+            <a:avLst/>
+          </a:prstGeom>
+          <a:noFill/>
+        </p:spPr>
+        <p:txBody>
+          <a:bodyPr wrap="square">
+            <a:spAutoFit/>
+          </a:bodyPr>
+          <a:lstStyle/>
+          <a:p>
+            <a:pPr algn="l">
+              <a:spcAft>
+                <a:spcPts val="600"/>
+              </a:spcAft>
+            </a:pPr>
+            <a:r>
+              <a:rPr sz="3000" b="1" dirty="0">
+                <a:solidFill>
+                  <a:srgbClr val="243A5E"/>
+                </a:solidFill>
+                <a:latin typeface="Segoe UI"/>
+              </a:rPr>
+              <a:t>Every deployment type is two choices</a:t>
+            </a:r>
+          </a:p>
+        </p:txBody>
+      </p:sp>
+      <p:sp>
+        <p:nvSpPr>
+          <p:cNvPr id="5" name="Rectangle 4"/>
+          <p:cNvSpPr/>
+          <p:nvPr/>
+        </p:nvSpPr>
+        <p:spPr>
+          <a:xfrm>
+            <a:off x="658368" y="1481328"/>
+            <a:ext cx="1005840" cy="45720"/>
+          </a:xfrm>
+          <a:prstGeom prst="rect">
+            <a:avLst/>
+          </a:prstGeom>
+          <a:solidFill>
+            <a:srgbClr val="0078D4"/>
+          </a:solidFill>
+          <a:ln>
+            <a:noFill/>
+          </a:ln>
+          <a:effectLst/>
+        </p:spPr>
+        <p:style>
+          <a:lnRef idx="1">
+            <a:schemeClr val="accent1"/>
+          </a:lnRef>
+          <a:fillRef idx="3">
+            <a:schemeClr val="accent1"/>
+          </a:fillRef>
+          <a:effectRef idx="2">
+            <a:schemeClr val="accent1"/>
+          </a:effectRef>
+          <a:fontRef idx="minor">
+            <a:schemeClr val="lt1"/>
+          </a:fontRef>
+        </p:style>
+        <p:txBody>
+          <a:bodyPr rtlCol="0" anchor="ctr"/>
+          <a:lstStyle/>
+          <a:p>
+            <a:pPr algn="ctr"/>
+            <a:endParaRPr/>
+          </a:p>
+        </p:txBody>
+      </p:sp>
+      <p:sp>
+        <p:nvSpPr>
+          <p:cNvPr id="6" name="TextBox 5"/>
+          <p:cNvSpPr txBox="1"/>
+          <p:nvPr/>
+        </p:nvSpPr>
+        <p:spPr>
+          <a:xfrm>
+            <a:off x="777240" y="1554480"/>
+            <a:ext cx="10607040" cy="661720"/>
+          </a:xfrm>
+          <a:prstGeom prst="rect">
+            <a:avLst/>
+          </a:prstGeom>
+          <a:noFill/>
+        </p:spPr>
+        <p:txBody>
+          <a:bodyPr wrap="square">
+            <a:spAutoFit/>
+          </a:bodyPr>
+          <a:lstStyle/>
+          <a:p>
+            <a:pPr>
+              <a:spcAft>
+                <a:spcPts val="600"/>
+              </a:spcAft>
+            </a:pPr>
+            <a:r>
+              <a:rPr lang="nb-NO" sz="1600" b="0" dirty="0" err="1">
+                <a:solidFill>
+                  <a:srgbClr val="605E5C"/>
+                </a:solidFill>
+                <a:latin typeface="Segoe UI"/>
+              </a:rPr>
+              <a:t>Pick how you pay and where data is processed — the two combine into one SKU.</a:t>
+            </a:r>
+            <a:endParaRPr lang="nb-NO" sz="1600" dirty="0">
+              <a:solidFill>
+                <a:srgbClr val="605E5C"/>
+              </a:solidFill>
+              <a:latin typeface="Segoe UI"/>
+            </a:endParaRPr>
+          </a:p>
+        </p:txBody>
+      </p:sp>
+      <p:sp>
+        <p:nvSpPr>
+          <p:cNvPr id="21" name="TextBox 20"/>
+          <p:cNvSpPr txBox="1"/>
+          <p:nvPr/>
+        </p:nvSpPr>
+        <p:spPr>
+          <a:xfrm>
+            <a:off x="640080" y="6419088"/>
+            <a:ext cx="7315200" cy="320040"/>
+          </a:xfrm>
+          <a:prstGeom prst="rect">
+            <a:avLst/>
+          </a:prstGeom>
+          <a:noFill/>
+        </p:spPr>
+        <p:txBody>
+          <a:bodyPr wrap="square">
+            <a:spAutoFit/>
+          </a:bodyPr>
+          <a:lstStyle/>
+          <a:p>
+            <a:pPr algn="l">
+              <a:spcAft>
+                <a:spcPts val="600"/>
+              </a:spcAft>
+            </a:pPr>
+            <a:r>
+              <a:rPr sz="900" b="0">
+                <a:solidFill>
+                  <a:srgbClr val="605E5C"/>
+                </a:solidFill>
+                <a:latin typeface="Segoe UI"/>
+              </a:rPr>
+              <a:t>Prompt Shields vs. Guardrails  ·  Gislefoss Meteorologist Agent</a:t>
+            </a:r>
+          </a:p>
+        </p:txBody>
+      </p:sp>
+      <p:sp>
+        <p:nvSpPr>
+          <p:cNvPr id="22" name="TextBox 21"/>
+          <p:cNvSpPr txBox="1"/>
+          <p:nvPr/>
+        </p:nvSpPr>
+        <p:spPr>
+          <a:xfrm>
+            <a:off x="10972800" y="6419088"/>
+            <a:ext cx="822960" cy="320040"/>
+          </a:xfrm>
+          <a:prstGeom prst="rect">
+            <a:avLst/>
+          </a:prstGeom>
+          <a:noFill/>
+        </p:spPr>
+        <p:txBody>
+          <a:bodyPr wrap="square">
+            <a:spAutoFit/>
+          </a:bodyPr>
+          <a:lstStyle/>
+          <a:p>
+            <a:pPr algn="r">
+              <a:spcAft>
+                <a:spcPts val="600"/>
+              </a:spcAft>
+            </a:pPr>
+            <a:r>
+              <a:rPr sz="900" b="0">
+                <a:solidFill>
+                  <a:srgbClr val="605E5C"/>
+                </a:solidFill>
+                <a:latin typeface="Segoe UI"/>
+              </a:rPr>
+              <a:t>5</a:t>
+            </a:r>
+          </a:p>
+        </p:txBody>
+      </p:sp>
+      <p:sp>
+        <p:nvSpPr>
+          <p:cNvPr id="23" name="Rounded Rectangle 22"/>
+          <p:cNvSpPr/>
+          <p:nvPr/>
+        </p:nvSpPr>
+        <p:spPr>
+          <a:xfrm>
+            <a:off x="777240" y="2304288"/>
+            <a:ext cx="1874519" cy="548640"/>
+          </a:xfrm>
+          <a:prstGeom prst="roundRect">
+            <a:avLst>
+              <a:gd name="adj" fmla="val 10000"/>
+            </a:avLst>
+          </a:prstGeom>
+          <a:solidFill>
+            <a:srgbClr val="FFFFFF"/>
+          </a:solidFill>
+          <a:ln w="12700">
+            <a:solidFill>
+              <a:srgbClr val="D0D0D0"/>
+            </a:solidFill>
+          </a:ln>
+          <a:effectLst/>
+        </p:spPr>
+        <p:style>
+          <a:lnRef idx="1">
+            <a:schemeClr val="accent1"/>
+          </a:lnRef>
+          <a:fillRef idx="3">
+            <a:schemeClr val="accent1"/>
+          </a:fillRef>
+          <a:effectRef idx="2">
+            <a:schemeClr val="accent1"/>
+          </a:effectRef>
+          <a:fontRef idx="minor">
+            <a:schemeClr val="lt1"/>
+          </a:fontRef>
+        </p:style>
+        <p:txBody>
+          <a:bodyPr rtlCol="0" anchor="ctr"/>
+          <a:lstStyle/>
+          <a:p>
+            <a:pPr algn="ctr"/>
+          </a:p>
+        </p:txBody>
+      </p:sp>
+      <p:sp>
+        <p:nvSpPr>
+          <p:cNvPr id="24" name="TextBox 23"/>
+          <p:cNvSpPr txBox="1"/>
+          <p:nvPr/>
+        </p:nvSpPr>
+        <p:spPr>
+          <a:xfrm>
+            <a:off x="822960" y="2304288"/>
+            <a:ext cx="1783079" cy="548640"/>
+          </a:xfrm>
+          <a:prstGeom prst="rect">
+            <a:avLst/>
+          </a:prstGeom>
+          <a:noFill/>
+        </p:spPr>
+        <p:txBody>
+          <a:bodyPr wrap="square" anchor="ctr" lIns="25400" rIns="25400" tIns="12700" bIns="12700">
+            <a:spAutoFit/>
+          </a:bodyPr>
+          <a:lstStyle/>
+          <a:p>
+            <a:pPr algn="l">
+              <a:spcAft>
+                <a:spcPts val="200"/>
+              </a:spcAft>
+            </a:pPr>
+            <a:r>
+              <a:rPr sz="950" b="1" i="0">
+                <a:solidFill>
+                  <a:srgbClr val="243A5E"/>
+                </a:solidFill>
+                <a:latin typeface="Segoe UI"/>
+              </a:rPr>
+              <a:t>deployment type =</a:t>
+            </a:r>
+          </a:p>
+          <a:p>
+            <a:pPr algn="l">
+              <a:spcAft>
+                <a:spcPts val="200"/>
+              </a:spcAft>
+            </a:pPr>
+            <a:r>
+              <a:rPr sz="850" b="0" i="0">
+                <a:solidFill>
+                  <a:srgbClr val="605E5C"/>
+                </a:solidFill>
+                <a:latin typeface="Segoe UI"/>
+              </a:rPr>
+              <a:t>↓ how you pay   → where it runs</a:t>
+            </a:r>
+          </a:p>
+        </p:txBody>
+      </p:sp>
+      <p:sp>
+        <p:nvSpPr>
+          <p:cNvPr id="25" name="Rounded Rectangle 24"/>
+          <p:cNvSpPr/>
+          <p:nvPr/>
+        </p:nvSpPr>
+        <p:spPr>
+          <a:xfrm>
+            <a:off x="2770632" y="2304288"/>
+            <a:ext cx="2779776" cy="548640"/>
+          </a:xfrm>
+          <a:prstGeom prst="roundRect">
+            <a:avLst>
+              <a:gd name="adj" fmla="val 10000"/>
+            </a:avLst>
+          </a:prstGeom>
+          <a:solidFill>
+            <a:srgbClr val="0078D4"/>
+          </a:solidFill>
+          <a:ln w="12700">
+            <a:solidFill>
+              <a:srgbClr val="0078D4"/>
+            </a:solidFill>
+          </a:ln>
+          <a:effectLst/>
+        </p:spPr>
+        <p:style>
+          <a:lnRef idx="1">
+            <a:schemeClr val="accent1"/>
+          </a:lnRef>
+          <a:fillRef idx="3">
+            <a:schemeClr val="accent1"/>
+          </a:fillRef>
+          <a:effectRef idx="2">
+            <a:schemeClr val="accent1"/>
+          </a:effectRef>
+          <a:fontRef idx="minor">
+            <a:schemeClr val="lt1"/>
+          </a:fontRef>
+        </p:style>
+        <p:txBody>
+          <a:bodyPr rtlCol="0" anchor="ctr"/>
+          <a:lstStyle/>
+          <a:p>
+            <a:pPr algn="ctr"/>
+          </a:p>
+        </p:txBody>
+      </p:sp>
+      <p:sp>
+        <p:nvSpPr>
+          <p:cNvPr id="26" name="TextBox 25"/>
+          <p:cNvSpPr txBox="1"/>
+          <p:nvPr/>
+        </p:nvSpPr>
+        <p:spPr>
+          <a:xfrm>
+            <a:off x="2770632" y="2304288"/>
+            <a:ext cx="2779776" cy="548640"/>
+          </a:xfrm>
+          <a:prstGeom prst="rect">
+            <a:avLst/>
+          </a:prstGeom>
+          <a:noFill/>
+        </p:spPr>
+        <p:txBody>
+          <a:bodyPr wrap="square" anchor="ctr" lIns="25400" rIns="25400" tIns="12700" bIns="12700">
+            <a:spAutoFit/>
+          </a:bodyPr>
+          <a:lstStyle/>
+          <a:p>
+            <a:pPr algn="ctr">
+              <a:spcAft>
+                <a:spcPts val="0"/>
+              </a:spcAft>
+            </a:pPr>
+            <a:r>
+              <a:rPr sz="1300" b="1" i="0">
+                <a:solidFill>
+                  <a:srgbClr val="FFFFFF"/>
+                </a:solidFill>
+                <a:latin typeface="Segoe UI"/>
+              </a:rPr>
+              <a:t>GLOBAL</a:t>
+            </a:r>
+          </a:p>
+          <a:p>
+            <a:pPr algn="ctr">
+              <a:spcAft>
+                <a:spcPts val="0"/>
+              </a:spcAft>
+            </a:pPr>
+            <a:r>
+              <a:rPr sz="950" b="0" i="0">
+                <a:solidFill>
+                  <a:srgbClr val="FFFFFF"/>
+                </a:solidFill>
+                <a:latin typeface="Segoe UI"/>
+              </a:rPr>
+              <a:t>any Azure region</a:t>
+            </a:r>
+          </a:p>
+        </p:txBody>
+      </p:sp>
+      <p:sp>
+        <p:nvSpPr>
+          <p:cNvPr id="27" name="Rounded Rectangle 26"/>
+          <p:cNvSpPr/>
+          <p:nvPr/>
+        </p:nvSpPr>
+        <p:spPr>
+          <a:xfrm>
+            <a:off x="5669280" y="2304288"/>
+            <a:ext cx="2779776" cy="548640"/>
+          </a:xfrm>
+          <a:prstGeom prst="roundRect">
+            <a:avLst>
+              <a:gd name="adj" fmla="val 10000"/>
+            </a:avLst>
+          </a:prstGeom>
+          <a:solidFill>
+            <a:srgbClr val="107C10"/>
+          </a:solidFill>
+          <a:ln w="12700">
+            <a:solidFill>
+              <a:srgbClr val="107C10"/>
+            </a:solidFill>
+          </a:ln>
+          <a:effectLst/>
+        </p:spPr>
+        <p:style>
+          <a:lnRef idx="1">
+            <a:schemeClr val="accent1"/>
+          </a:lnRef>
+          <a:fillRef idx="3">
+            <a:schemeClr val="accent1"/>
+          </a:fillRef>
+          <a:effectRef idx="2">
+            <a:schemeClr val="accent1"/>
+          </a:effectRef>
+          <a:fontRef idx="minor">
+            <a:schemeClr val="lt1"/>
+          </a:fontRef>
+        </p:style>
+        <p:txBody>
+          <a:bodyPr rtlCol="0" anchor="ctr"/>
+          <a:lstStyle/>
+          <a:p>
+            <a:pPr algn="ctr"/>
+          </a:p>
+        </p:txBody>
+      </p:sp>
+      <p:sp>
+        <p:nvSpPr>
+          <p:cNvPr id="28" name="TextBox 27"/>
+          <p:cNvSpPr txBox="1"/>
+          <p:nvPr/>
+        </p:nvSpPr>
+        <p:spPr>
+          <a:xfrm>
+            <a:off x="5669280" y="2304288"/>
+            <a:ext cx="2779776" cy="548640"/>
+          </a:xfrm>
+          <a:prstGeom prst="rect">
+            <a:avLst/>
+          </a:prstGeom>
+          <a:noFill/>
+        </p:spPr>
+        <p:txBody>
+          <a:bodyPr wrap="square" anchor="ctr" lIns="25400" rIns="25400" tIns="12700" bIns="12700">
+            <a:spAutoFit/>
+          </a:bodyPr>
+          <a:lstStyle/>
+          <a:p>
+            <a:pPr algn="ctr">
+              <a:spcAft>
+                <a:spcPts val="0"/>
+              </a:spcAft>
+            </a:pPr>
+            <a:r>
+              <a:rPr sz="1300" b="1" i="0">
+                <a:solidFill>
+                  <a:srgbClr val="FFFFFF"/>
+                </a:solidFill>
+                <a:latin typeface="Segoe UI"/>
+              </a:rPr>
+              <a:t>DATA ZONE</a:t>
+            </a:r>
+          </a:p>
+          <a:p>
+            <a:pPr algn="ctr">
+              <a:spcAft>
+                <a:spcPts val="0"/>
+              </a:spcAft>
+            </a:pPr>
+            <a:r>
+              <a:rPr sz="950" b="0" i="0">
+                <a:solidFill>
+                  <a:srgbClr val="FFFFFF"/>
+                </a:solidFill>
+                <a:latin typeface="Segoe UI"/>
+              </a:rPr>
+              <a:t>US or EU zone</a:t>
+            </a:r>
+          </a:p>
+        </p:txBody>
+      </p:sp>
+      <p:sp>
+        <p:nvSpPr>
+          <p:cNvPr id="29" name="Rounded Rectangle 28"/>
+          <p:cNvSpPr/>
+          <p:nvPr/>
+        </p:nvSpPr>
+        <p:spPr>
+          <a:xfrm>
+            <a:off x="8567928" y="2304288"/>
+            <a:ext cx="2779776" cy="548640"/>
+          </a:xfrm>
+          <a:prstGeom prst="roundRect">
+            <a:avLst>
+              <a:gd name="adj" fmla="val 10000"/>
+            </a:avLst>
+          </a:prstGeom>
+          <a:solidFill>
+            <a:srgbClr val="5C2D91"/>
+          </a:solidFill>
+          <a:ln w="12700">
+            <a:solidFill>
+              <a:srgbClr val="5C2D91"/>
+            </a:solidFill>
+          </a:ln>
+          <a:effectLst/>
+        </p:spPr>
+        <p:style>
+          <a:lnRef idx="1">
+            <a:schemeClr val="accent1"/>
+          </a:lnRef>
+          <a:fillRef idx="3">
+            <a:schemeClr val="accent1"/>
+          </a:fillRef>
+          <a:effectRef idx="2">
+            <a:schemeClr val="accent1"/>
+          </a:effectRef>
+          <a:fontRef idx="minor">
+            <a:schemeClr val="lt1"/>
+          </a:fontRef>
+        </p:style>
+        <p:txBody>
+          <a:bodyPr rtlCol="0" anchor="ctr"/>
+          <a:lstStyle/>
+          <a:p>
+            <a:pPr algn="ctr"/>
+          </a:p>
+        </p:txBody>
+      </p:sp>
+      <p:sp>
+        <p:nvSpPr>
+          <p:cNvPr id="30" name="TextBox 29"/>
+          <p:cNvSpPr txBox="1"/>
+          <p:nvPr/>
+        </p:nvSpPr>
+        <p:spPr>
+          <a:xfrm>
+            <a:off x="8567928" y="2304288"/>
+            <a:ext cx="2779776" cy="548640"/>
+          </a:xfrm>
+          <a:prstGeom prst="rect">
+            <a:avLst/>
+          </a:prstGeom>
+          <a:noFill/>
+        </p:spPr>
+        <p:txBody>
+          <a:bodyPr wrap="square" anchor="ctr" lIns="25400" rIns="25400" tIns="12700" bIns="12700">
+            <a:spAutoFit/>
+          </a:bodyPr>
+          <a:lstStyle/>
+          <a:p>
+            <a:pPr algn="ctr">
+              <a:spcAft>
+                <a:spcPts val="0"/>
+              </a:spcAft>
+            </a:pPr>
+            <a:r>
+              <a:rPr sz="1300" b="1" i="0">
+                <a:solidFill>
+                  <a:srgbClr val="FFFFFF"/>
+                </a:solidFill>
+                <a:latin typeface="Segoe UI"/>
+              </a:rPr>
+              <a:t>REGIONAL</a:t>
+            </a:r>
+          </a:p>
+          <a:p>
+            <a:pPr algn="ctr">
+              <a:spcAft>
+                <a:spcPts val="0"/>
+              </a:spcAft>
+            </a:pPr>
+            <a:r>
+              <a:rPr sz="950" b="0" i="0">
+                <a:solidFill>
+                  <a:srgbClr val="FFFFFF"/>
+                </a:solidFill>
+                <a:latin typeface="Segoe UI"/>
+              </a:rPr>
+              <a:t>one region</a:t>
+            </a:r>
+          </a:p>
+        </p:txBody>
+      </p:sp>
+      <p:sp>
+        <p:nvSpPr>
+          <p:cNvPr id="31" name="Rounded Rectangle 30"/>
+          <p:cNvSpPr/>
+          <p:nvPr/>
+        </p:nvSpPr>
+        <p:spPr>
+          <a:xfrm>
+            <a:off x="777240" y="2962656"/>
+            <a:ext cx="1874519" cy="1005840"/>
+          </a:xfrm>
+          <a:prstGeom prst="roundRect">
+            <a:avLst>
+              <a:gd name="adj" fmla="val 6000"/>
+            </a:avLst>
+          </a:prstGeom>
+          <a:solidFill>
+            <a:srgbClr val="243A5E"/>
+          </a:solidFill>
+          <a:ln w="12700">
+            <a:solidFill>
+              <a:srgbClr val="243A5E"/>
+            </a:solidFill>
+          </a:ln>
+          <a:effectLst/>
+        </p:spPr>
+        <p:style>
+          <a:lnRef idx="1">
+            <a:schemeClr val="accent1"/>
+          </a:lnRef>
+          <a:fillRef idx="3">
+            <a:schemeClr val="accent1"/>
+          </a:fillRef>
+          <a:effectRef idx="2">
+            <a:schemeClr val="accent1"/>
+          </a:effectRef>
+          <a:fontRef idx="minor">
+            <a:schemeClr val="lt1"/>
+          </a:fontRef>
+        </p:style>
+        <p:txBody>
+          <a:bodyPr rtlCol="0" anchor="ctr"/>
+          <a:lstStyle/>
+          <a:p>
+            <a:pPr algn="ctr"/>
+          </a:p>
+        </p:txBody>
+      </p:sp>
+      <p:sp>
+        <p:nvSpPr>
+          <p:cNvPr id="32" name="TextBox 31"/>
+          <p:cNvSpPr txBox="1"/>
+          <p:nvPr/>
+        </p:nvSpPr>
+        <p:spPr>
+          <a:xfrm>
+            <a:off x="777240" y="2962656"/>
+            <a:ext cx="1874519" cy="1005840"/>
+          </a:xfrm>
+          <a:prstGeom prst="rect">
+            <a:avLst/>
+          </a:prstGeom>
+          <a:noFill/>
+        </p:spPr>
+        <p:txBody>
+          <a:bodyPr wrap="square" anchor="ctr" lIns="25400" rIns="25400" tIns="12700" bIns="12700">
+            <a:spAutoFit/>
+          </a:bodyPr>
+          <a:lstStyle/>
+          <a:p>
+            <a:pPr algn="ctr">
+              <a:spcAft>
+                <a:spcPts val="0"/>
+              </a:spcAft>
+            </a:pPr>
+            <a:r>
+              <a:rPr sz="1400" b="1" i="0">
+                <a:solidFill>
+                  <a:srgbClr val="FFFFFF"/>
+                </a:solidFill>
+                <a:latin typeface="Segoe UI"/>
+              </a:rPr>
+              <a:t>STANDARD</a:t>
+            </a:r>
+          </a:p>
+          <a:p>
+            <a:pPr algn="ctr">
+              <a:spcAft>
+                <a:spcPts val="0"/>
+              </a:spcAft>
+            </a:pPr>
+            <a:r>
+              <a:rPr sz="1000" b="0" i="0">
+                <a:solidFill>
+                  <a:srgbClr val="C7D6EA"/>
+                </a:solidFill>
+                <a:latin typeface="Segoe UI"/>
+              </a:rPr>
+              <a:t>pay-per-token</a:t>
+            </a:r>
+          </a:p>
+        </p:txBody>
+      </p:sp>
+      <p:sp>
+        <p:nvSpPr>
+          <p:cNvPr id="33" name="Rounded Rectangle 32"/>
+          <p:cNvSpPr/>
+          <p:nvPr/>
+        </p:nvSpPr>
+        <p:spPr>
+          <a:xfrm>
+            <a:off x="777240" y="4096512"/>
+            <a:ext cx="1874519" cy="1005840"/>
+          </a:xfrm>
+          <a:prstGeom prst="roundRect">
+            <a:avLst>
+              <a:gd name="adj" fmla="val 6000"/>
+            </a:avLst>
+          </a:prstGeom>
+          <a:solidFill>
+            <a:srgbClr val="243A5E"/>
+          </a:solidFill>
+          <a:ln w="12700">
+            <a:solidFill>
+              <a:srgbClr val="243A5E"/>
+            </a:solidFill>
+          </a:ln>
+          <a:effectLst/>
+        </p:spPr>
+        <p:style>
+          <a:lnRef idx="1">
+            <a:schemeClr val="accent1"/>
+          </a:lnRef>
+          <a:fillRef idx="3">
+            <a:schemeClr val="accent1"/>
+          </a:fillRef>
+          <a:effectRef idx="2">
+            <a:schemeClr val="accent1"/>
+          </a:effectRef>
+          <a:fontRef idx="minor">
+            <a:schemeClr val="lt1"/>
+          </a:fontRef>
+        </p:style>
+        <p:txBody>
+          <a:bodyPr rtlCol="0" anchor="ctr"/>
+          <a:lstStyle/>
+          <a:p>
+            <a:pPr algn="ctr"/>
+          </a:p>
+        </p:txBody>
+      </p:sp>
+      <p:sp>
+        <p:nvSpPr>
+          <p:cNvPr id="34" name="TextBox 33"/>
+          <p:cNvSpPr txBox="1"/>
+          <p:nvPr/>
+        </p:nvSpPr>
+        <p:spPr>
+          <a:xfrm>
+            <a:off x="777240" y="4096512"/>
+            <a:ext cx="1874519" cy="1005840"/>
+          </a:xfrm>
+          <a:prstGeom prst="rect">
+            <a:avLst/>
+          </a:prstGeom>
+          <a:noFill/>
+        </p:spPr>
+        <p:txBody>
+          <a:bodyPr wrap="square" anchor="ctr" lIns="25400" rIns="25400" tIns="12700" bIns="12700">
+            <a:spAutoFit/>
+          </a:bodyPr>
+          <a:lstStyle/>
+          <a:p>
+            <a:pPr algn="ctr">
+              <a:spcAft>
+                <a:spcPts val="0"/>
+              </a:spcAft>
+            </a:pPr>
+            <a:r>
+              <a:rPr sz="1400" b="1" i="0">
+                <a:solidFill>
+                  <a:srgbClr val="FFFFFF"/>
+                </a:solidFill>
+                <a:latin typeface="Segoe UI"/>
+              </a:rPr>
+              <a:t>PROVISIONED</a:t>
+            </a:r>
+          </a:p>
+          <a:p>
+            <a:pPr algn="ctr">
+              <a:spcAft>
+                <a:spcPts val="0"/>
+              </a:spcAft>
+            </a:pPr>
+            <a:r>
+              <a:rPr sz="1000" b="0" i="0">
+                <a:solidFill>
+                  <a:srgbClr val="C7D6EA"/>
+                </a:solidFill>
+                <a:latin typeface="Segoe UI"/>
+              </a:rPr>
+              <a:t>reserved PTU</a:t>
+            </a:r>
+          </a:p>
+        </p:txBody>
+      </p:sp>
+      <p:sp>
+        <p:nvSpPr>
+          <p:cNvPr id="35" name="Rounded Rectangle 34"/>
+          <p:cNvSpPr/>
+          <p:nvPr/>
+        </p:nvSpPr>
+        <p:spPr>
+          <a:xfrm>
+            <a:off x="2770632" y="2962656"/>
+            <a:ext cx="2779776" cy="1005840"/>
+          </a:xfrm>
+          <a:prstGeom prst="roundRect">
+            <a:avLst>
+              <a:gd name="adj" fmla="val 5000"/>
+            </a:avLst>
+          </a:prstGeom>
+          <a:solidFill>
+            <a:srgbClr val="DEECF9"/>
+          </a:solidFill>
+          <a:ln w="17780">
+            <a:solidFill>
+              <a:srgbClr val="0078D4"/>
+            </a:solidFill>
+          </a:ln>
+          <a:effectLst/>
+        </p:spPr>
+        <p:style>
+          <a:lnRef idx="1">
+            <a:schemeClr val="accent1"/>
+          </a:lnRef>
+          <a:fillRef idx="3">
+            <a:schemeClr val="accent1"/>
+          </a:fillRef>
+          <a:effectRef idx="2">
+            <a:schemeClr val="accent1"/>
+          </a:effectRef>
+          <a:fontRef idx="minor">
+            <a:schemeClr val="lt1"/>
+          </a:fontRef>
+        </p:style>
+        <p:txBody>
+          <a:bodyPr rtlCol="0" anchor="ctr"/>
+          <a:lstStyle/>
+          <a:p>
+            <a:pPr algn="ctr"/>
+          </a:p>
+        </p:txBody>
+      </p:sp>
+      <p:sp>
+        <p:nvSpPr>
+          <p:cNvPr id="36" name="TextBox 35"/>
+          <p:cNvSpPr txBox="1"/>
+          <p:nvPr/>
+        </p:nvSpPr>
+        <p:spPr>
+          <a:xfrm>
+            <a:off x="2770632" y="2962656"/>
+            <a:ext cx="2779776" cy="1005840"/>
+          </a:xfrm>
+          <a:prstGeom prst="rect">
+            <a:avLst/>
+          </a:prstGeom>
+          <a:noFill/>
+        </p:spPr>
+        <p:txBody>
+          <a:bodyPr wrap="square" anchor="ctr" lIns="25400" rIns="25400" tIns="12700" bIns="12700">
+            <a:spAutoFit/>
+          </a:bodyPr>
+          <a:lstStyle/>
+          <a:p>
+            <a:pPr algn="ctr">
+              <a:spcAft>
+                <a:spcPts val="300"/>
+              </a:spcAft>
+            </a:pPr>
+            <a:r>
+              <a:rPr sz="1100" b="1" i="0">
+                <a:solidFill>
+                  <a:srgbClr val="243A5E"/>
+                </a:solidFill>
+                <a:latin typeface="Consolas"/>
+              </a:rPr>
+              <a:t>GlobalStandard</a:t>
+            </a:r>
+          </a:p>
+          <a:p>
+            <a:pPr algn="ctr">
+              <a:spcAft>
+                <a:spcPts val="0"/>
+              </a:spcAft>
+            </a:pPr>
+            <a:r>
+              <a:rPr sz="950" b="1" i="0">
+                <a:solidFill>
+                  <a:srgbClr val="0078D4"/>
+                </a:solidFill>
+                <a:latin typeface="Segoe UI"/>
+              </a:rPr>
+              <a:t>Gislefoss today</a:t>
+            </a:r>
+          </a:p>
+        </p:txBody>
+      </p:sp>
+      <p:sp>
+        <p:nvSpPr>
+          <p:cNvPr id="37" name="Rounded Rectangle 36"/>
+          <p:cNvSpPr/>
+          <p:nvPr/>
+        </p:nvSpPr>
+        <p:spPr>
+          <a:xfrm>
+            <a:off x="5669280" y="2962656"/>
+            <a:ext cx="2779776" cy="1005840"/>
+          </a:xfrm>
+          <a:prstGeom prst="roundRect">
+            <a:avLst>
+              <a:gd name="adj" fmla="val 5000"/>
+            </a:avLst>
+          </a:prstGeom>
+          <a:solidFill>
+            <a:srgbClr val="FFFFFF"/>
+          </a:solidFill>
+          <a:ln w="12700">
+            <a:solidFill>
+              <a:srgbClr val="D0D0D0"/>
+            </a:solidFill>
+          </a:ln>
+          <a:effectLst/>
+        </p:spPr>
+        <p:style>
+          <a:lnRef idx="1">
+            <a:schemeClr val="accent1"/>
+          </a:lnRef>
+          <a:fillRef idx="3">
+            <a:schemeClr val="accent1"/>
+          </a:fillRef>
+          <a:effectRef idx="2">
+            <a:schemeClr val="accent1"/>
+          </a:effectRef>
+          <a:fontRef idx="minor">
+            <a:schemeClr val="lt1"/>
+          </a:fontRef>
+        </p:style>
+        <p:txBody>
+          <a:bodyPr rtlCol="0" anchor="ctr"/>
+          <a:lstStyle/>
+          <a:p>
+            <a:pPr algn="ctr"/>
+          </a:p>
+        </p:txBody>
+      </p:sp>
+      <p:sp>
+        <p:nvSpPr>
+          <p:cNvPr id="38" name="TextBox 37"/>
+          <p:cNvSpPr txBox="1"/>
+          <p:nvPr/>
+        </p:nvSpPr>
+        <p:spPr>
+          <a:xfrm>
+            <a:off x="5669280" y="2962656"/>
+            <a:ext cx="2779776" cy="1005840"/>
+          </a:xfrm>
+          <a:prstGeom prst="rect">
+            <a:avLst/>
+          </a:prstGeom>
+          <a:noFill/>
+        </p:spPr>
+        <p:txBody>
+          <a:bodyPr wrap="square" anchor="ctr" lIns="25400" rIns="25400" tIns="12700" bIns="12700">
+            <a:spAutoFit/>
+          </a:bodyPr>
+          <a:lstStyle/>
+          <a:p>
+            <a:pPr algn="ctr">
+              <a:spcAft>
+                <a:spcPts val="300"/>
+              </a:spcAft>
+            </a:pPr>
+            <a:r>
+              <a:rPr sz="1100" b="1" i="0">
+                <a:solidFill>
+                  <a:srgbClr val="243A5E"/>
+                </a:solidFill>
+                <a:latin typeface="Consolas"/>
+              </a:rPr>
+              <a:t>DataZoneStandard</a:t>
+            </a:r>
+          </a:p>
+          <a:p>
+            <a:pPr algn="ctr">
+              <a:spcAft>
+                <a:spcPts val="0"/>
+              </a:spcAft>
+            </a:pPr>
+            <a:r>
+              <a:rPr sz="950" b="0" i="0">
+                <a:solidFill>
+                  <a:srgbClr val="605E5C"/>
+                </a:solidFill>
+                <a:latin typeface="Segoe UI"/>
+              </a:rPr>
+              <a:t>US or EU zone</a:t>
+            </a:r>
+          </a:p>
+        </p:txBody>
+      </p:sp>
+      <p:sp>
+        <p:nvSpPr>
+          <p:cNvPr id="39" name="Rounded Rectangle 38"/>
+          <p:cNvSpPr/>
+          <p:nvPr/>
+        </p:nvSpPr>
+        <p:spPr>
+          <a:xfrm>
+            <a:off x="8567928" y="2962656"/>
+            <a:ext cx="2779776" cy="1005840"/>
+          </a:xfrm>
+          <a:prstGeom prst="roundRect">
+            <a:avLst>
+              <a:gd name="adj" fmla="val 5000"/>
+            </a:avLst>
+          </a:prstGeom>
+          <a:solidFill>
+            <a:srgbClr val="FFFFFF"/>
+          </a:solidFill>
+          <a:ln w="12700">
+            <a:solidFill>
+              <a:srgbClr val="D0D0D0"/>
+            </a:solidFill>
+          </a:ln>
+          <a:effectLst/>
+        </p:spPr>
+        <p:style>
+          <a:lnRef idx="1">
+            <a:schemeClr val="accent1"/>
+          </a:lnRef>
+          <a:fillRef idx="3">
+            <a:schemeClr val="accent1"/>
+          </a:fillRef>
+          <a:effectRef idx="2">
+            <a:schemeClr val="accent1"/>
+          </a:effectRef>
+          <a:fontRef idx="minor">
+            <a:schemeClr val="lt1"/>
+          </a:fontRef>
+        </p:style>
+        <p:txBody>
+          <a:bodyPr rtlCol="0" anchor="ctr"/>
+          <a:lstStyle/>
+          <a:p>
+            <a:pPr algn="ctr"/>
+          </a:p>
+        </p:txBody>
+      </p:sp>
+      <p:sp>
+        <p:nvSpPr>
+          <p:cNvPr id="40" name="TextBox 39"/>
+          <p:cNvSpPr txBox="1"/>
+          <p:nvPr/>
+        </p:nvSpPr>
+        <p:spPr>
+          <a:xfrm>
+            <a:off x="8567928" y="2962656"/>
+            <a:ext cx="2779776" cy="1005840"/>
+          </a:xfrm>
+          <a:prstGeom prst="rect">
+            <a:avLst/>
+          </a:prstGeom>
+          <a:noFill/>
+        </p:spPr>
+        <p:txBody>
+          <a:bodyPr wrap="square" anchor="ctr" lIns="25400" rIns="25400" tIns="12700" bIns="12700">
+            <a:spAutoFit/>
+          </a:bodyPr>
+          <a:lstStyle/>
+          <a:p>
+            <a:pPr algn="ctr">
+              <a:spcAft>
+                <a:spcPts val="300"/>
+              </a:spcAft>
+            </a:pPr>
+            <a:r>
+              <a:rPr sz="1100" b="1" i="0">
+                <a:solidFill>
+                  <a:srgbClr val="243A5E"/>
+                </a:solidFill>
+                <a:latin typeface="Consolas"/>
+              </a:rPr>
+              <a:t>Standard</a:t>
+            </a:r>
+          </a:p>
+          <a:p>
+            <a:pPr algn="ctr">
+              <a:spcAft>
+                <a:spcPts val="0"/>
+              </a:spcAft>
+            </a:pPr>
+            <a:r>
+              <a:rPr sz="950" b="0" i="0">
+                <a:solidFill>
+                  <a:srgbClr val="605E5C"/>
+                </a:solidFill>
+                <a:latin typeface="Segoe UI"/>
+              </a:rPr>
+              <a:t>one region</a:t>
+            </a:r>
+          </a:p>
+        </p:txBody>
+      </p:sp>
+      <p:sp>
+        <p:nvSpPr>
+          <p:cNvPr id="41" name="Rounded Rectangle 40"/>
+          <p:cNvSpPr/>
+          <p:nvPr/>
+        </p:nvSpPr>
+        <p:spPr>
+          <a:xfrm>
+            <a:off x="2770632" y="4096512"/>
+            <a:ext cx="2779776" cy="1005840"/>
+          </a:xfrm>
+          <a:prstGeom prst="roundRect">
+            <a:avLst>
+              <a:gd name="adj" fmla="val 5000"/>
+            </a:avLst>
+          </a:prstGeom>
+          <a:solidFill>
+            <a:srgbClr val="FFFFFF"/>
+          </a:solidFill>
+          <a:ln w="12700">
+            <a:solidFill>
+              <a:srgbClr val="D0D0D0"/>
+            </a:solidFill>
+          </a:ln>
+          <a:effectLst/>
+        </p:spPr>
+        <p:style>
+          <a:lnRef idx="1">
+            <a:schemeClr val="accent1"/>
+          </a:lnRef>
+          <a:fillRef idx="3">
+            <a:schemeClr val="accent1"/>
+          </a:fillRef>
+          <a:effectRef idx="2">
+            <a:schemeClr val="accent1"/>
+          </a:effectRef>
+          <a:fontRef idx="minor">
+            <a:schemeClr val="lt1"/>
+          </a:fontRef>
+        </p:style>
+        <p:txBody>
+          <a:bodyPr rtlCol="0" anchor="ctr"/>
+          <a:lstStyle/>
+          <a:p>
+            <a:pPr algn="ctr"/>
+          </a:p>
+        </p:txBody>
+      </p:sp>
+      <p:sp>
+        <p:nvSpPr>
+          <p:cNvPr id="42" name="TextBox 41"/>
+          <p:cNvSpPr txBox="1"/>
+          <p:nvPr/>
+        </p:nvSpPr>
+        <p:spPr>
+          <a:xfrm>
+            <a:off x="2770632" y="4096512"/>
+            <a:ext cx="2779776" cy="1005840"/>
+          </a:xfrm>
+          <a:prstGeom prst="rect">
+            <a:avLst/>
+          </a:prstGeom>
+          <a:noFill/>
+        </p:spPr>
+        <p:txBody>
+          <a:bodyPr wrap="square" anchor="ctr" lIns="25400" rIns="25400" tIns="12700" bIns="12700">
+            <a:spAutoFit/>
+          </a:bodyPr>
+          <a:lstStyle/>
+          <a:p>
+            <a:pPr algn="ctr">
+              <a:spcAft>
+                <a:spcPts val="300"/>
+              </a:spcAft>
+            </a:pPr>
+            <a:r>
+              <a:rPr sz="1100" b="1" i="0">
+                <a:solidFill>
+                  <a:srgbClr val="243A5E"/>
+                </a:solidFill>
+                <a:latin typeface="Consolas"/>
+              </a:rPr>
+              <a:t>GlobalProvisionedManaged</a:t>
+            </a:r>
+          </a:p>
+          <a:p>
+            <a:pPr algn="ctr">
+              <a:spcAft>
+                <a:spcPts val="0"/>
+              </a:spcAft>
+            </a:pPr>
+            <a:r>
+              <a:rPr sz="950" b="0" i="0">
+                <a:solidFill>
+                  <a:srgbClr val="605E5C"/>
+                </a:solidFill>
+                <a:latin typeface="Segoe UI"/>
+              </a:rPr>
+              <a:t>global + reserved</a:t>
+            </a:r>
+          </a:p>
+        </p:txBody>
+      </p:sp>
+      <p:sp>
+        <p:nvSpPr>
+          <p:cNvPr id="43" name="Rounded Rectangle 42"/>
+          <p:cNvSpPr/>
+          <p:nvPr/>
+        </p:nvSpPr>
+        <p:spPr>
+          <a:xfrm>
+            <a:off x="5669280" y="4096512"/>
+            <a:ext cx="2779776" cy="1005840"/>
+          </a:xfrm>
+          <a:prstGeom prst="roundRect">
+            <a:avLst>
+              <a:gd name="adj" fmla="val 5000"/>
+            </a:avLst>
+          </a:prstGeom>
+          <a:solidFill>
+            <a:srgbClr val="FFFFFF"/>
+          </a:solidFill>
+          <a:ln w="12700">
+            <a:solidFill>
+              <a:srgbClr val="D0D0D0"/>
+            </a:solidFill>
+          </a:ln>
+          <a:effectLst/>
+        </p:spPr>
+        <p:style>
+          <a:lnRef idx="1">
+            <a:schemeClr val="accent1"/>
+          </a:lnRef>
+          <a:fillRef idx="3">
+            <a:schemeClr val="accent1"/>
+          </a:fillRef>
+          <a:effectRef idx="2">
+            <a:schemeClr val="accent1"/>
+          </a:effectRef>
+          <a:fontRef idx="minor">
+            <a:schemeClr val="lt1"/>
+          </a:fontRef>
+        </p:style>
+        <p:txBody>
+          <a:bodyPr rtlCol="0" anchor="ctr"/>
+          <a:lstStyle/>
+          <a:p>
+            <a:pPr algn="ctr"/>
+          </a:p>
+        </p:txBody>
+      </p:sp>
+      <p:sp>
+        <p:nvSpPr>
+          <p:cNvPr id="44" name="TextBox 43"/>
+          <p:cNvSpPr txBox="1"/>
+          <p:nvPr/>
+        </p:nvSpPr>
+        <p:spPr>
+          <a:xfrm>
+            <a:off x="5669280" y="4096512"/>
+            <a:ext cx="2779776" cy="1005840"/>
+          </a:xfrm>
+          <a:prstGeom prst="rect">
+            <a:avLst/>
+          </a:prstGeom>
+          <a:noFill/>
+        </p:spPr>
+        <p:txBody>
+          <a:bodyPr wrap="square" anchor="ctr" lIns="25400" rIns="25400" tIns="12700" bIns="12700">
+            <a:spAutoFit/>
+          </a:bodyPr>
+          <a:lstStyle/>
+          <a:p>
+            <a:pPr algn="ctr">
+              <a:spcAft>
+                <a:spcPts val="300"/>
+              </a:spcAft>
+            </a:pPr>
+            <a:r>
+              <a:rPr sz="1100" b="1" i="0">
+                <a:solidFill>
+                  <a:srgbClr val="243A5E"/>
+                </a:solidFill>
+                <a:latin typeface="Consolas"/>
+              </a:rPr>
+              <a:t>DataZoneProvisionedManaged</a:t>
+            </a:r>
+          </a:p>
+          <a:p>
+            <a:pPr algn="ctr">
+              <a:spcAft>
+                <a:spcPts val="0"/>
+              </a:spcAft>
+            </a:pPr>
+            <a:r>
+              <a:rPr sz="950" b="0" i="0">
+                <a:solidFill>
+                  <a:srgbClr val="605E5C"/>
+                </a:solidFill>
+                <a:latin typeface="Segoe UI"/>
+              </a:rPr>
+              <a:t>zone + reserved</a:t>
+            </a:r>
+          </a:p>
+        </p:txBody>
+      </p:sp>
+      <p:sp>
+        <p:nvSpPr>
+          <p:cNvPr id="45" name="Rounded Rectangle 44"/>
+          <p:cNvSpPr/>
+          <p:nvPr/>
+        </p:nvSpPr>
+        <p:spPr>
+          <a:xfrm>
+            <a:off x="8567928" y="4096512"/>
+            <a:ext cx="2779776" cy="1005840"/>
+          </a:xfrm>
+          <a:prstGeom prst="roundRect">
+            <a:avLst>
+              <a:gd name="adj" fmla="val 5000"/>
+            </a:avLst>
+          </a:prstGeom>
+          <a:solidFill>
+            <a:srgbClr val="FFFFFF"/>
+          </a:solidFill>
+          <a:ln w="12700">
+            <a:solidFill>
+              <a:srgbClr val="D0D0D0"/>
+            </a:solidFill>
+          </a:ln>
+          <a:effectLst/>
+        </p:spPr>
+        <p:style>
+          <a:lnRef idx="1">
+            <a:schemeClr val="accent1"/>
+          </a:lnRef>
+          <a:fillRef idx="3">
+            <a:schemeClr val="accent1"/>
+          </a:fillRef>
+          <a:effectRef idx="2">
+            <a:schemeClr val="accent1"/>
+          </a:effectRef>
+          <a:fontRef idx="minor">
+            <a:schemeClr val="lt1"/>
+          </a:fontRef>
+        </p:style>
+        <p:txBody>
+          <a:bodyPr rtlCol="0" anchor="ctr"/>
+          <a:lstStyle/>
+          <a:p>
+            <a:pPr algn="ctr"/>
+          </a:p>
+        </p:txBody>
+      </p:sp>
+      <p:sp>
+        <p:nvSpPr>
+          <p:cNvPr id="46" name="TextBox 45"/>
+          <p:cNvSpPr txBox="1"/>
+          <p:nvPr/>
+        </p:nvSpPr>
+        <p:spPr>
+          <a:xfrm>
+            <a:off x="8567928" y="4096512"/>
+            <a:ext cx="2779776" cy="1005840"/>
+          </a:xfrm>
+          <a:prstGeom prst="rect">
+            <a:avLst/>
+          </a:prstGeom>
+          <a:noFill/>
+        </p:spPr>
+        <p:txBody>
+          <a:bodyPr wrap="square" anchor="ctr" lIns="25400" rIns="25400" tIns="12700" bIns="12700">
+            <a:spAutoFit/>
+          </a:bodyPr>
+          <a:lstStyle/>
+          <a:p>
+            <a:pPr algn="ctr">
+              <a:spcAft>
+                <a:spcPts val="300"/>
+              </a:spcAft>
+            </a:pPr>
+            <a:r>
+              <a:rPr sz="1100" b="1" i="0">
+                <a:solidFill>
+                  <a:srgbClr val="243A5E"/>
+                </a:solidFill>
+                <a:latin typeface="Consolas"/>
+              </a:rPr>
+              <a:t>ProvisionedManaged</a:t>
+            </a:r>
+          </a:p>
+          <a:p>
+            <a:pPr algn="ctr">
+              <a:spcAft>
+                <a:spcPts val="0"/>
+              </a:spcAft>
+            </a:pPr>
+            <a:r>
+              <a:rPr sz="950" b="0" i="0">
+                <a:solidFill>
+                  <a:srgbClr val="605E5C"/>
+                </a:solidFill>
+                <a:latin typeface="Segoe UI"/>
+              </a:rPr>
+              <a:t>one region + reserved</a:t>
+            </a:r>
+          </a:p>
+        </p:txBody>
+      </p:sp>
+      <p:sp>
+        <p:nvSpPr>
+          <p:cNvPr id="47" name="Rounded Rectangle 46"/>
+          <p:cNvSpPr/>
+          <p:nvPr/>
+        </p:nvSpPr>
+        <p:spPr>
+          <a:xfrm>
+            <a:off x="777240" y="5230368"/>
+            <a:ext cx="10570464" cy="786384"/>
+          </a:xfrm>
+          <a:prstGeom prst="roundRect">
+            <a:avLst>
+              <a:gd name="adj" fmla="val 5000"/>
+            </a:avLst>
+          </a:prstGeom>
+          <a:solidFill>
+            <a:srgbClr val="243A5E"/>
+          </a:solidFill>
+          <a:ln>
+            <a:noFill/>
+          </a:ln>
+          <a:effectLst/>
+        </p:spPr>
+        <p:style>
+          <a:lnRef idx="1">
+            <a:schemeClr val="accent1"/>
+          </a:lnRef>
+          <a:fillRef idx="3">
+            <a:schemeClr val="accent1"/>
+          </a:fillRef>
+          <a:effectRef idx="2">
+            <a:schemeClr val="accent1"/>
+          </a:effectRef>
+          <a:fontRef idx="minor">
+            <a:schemeClr val="lt1"/>
+          </a:fontRef>
+        </p:style>
+        <p:txBody>
+          <a:bodyPr rtlCol="0" anchor="ctr"/>
+          <a:lstStyle/>
+          <a:p>
+            <a:pPr algn="ctr"/>
+          </a:p>
+        </p:txBody>
+      </p:sp>
+      <p:sp>
+        <p:nvSpPr>
+          <p:cNvPr id="48" name="TextBox 47"/>
+          <p:cNvSpPr txBox="1"/>
+          <p:nvPr/>
+        </p:nvSpPr>
+        <p:spPr>
+          <a:xfrm>
+            <a:off x="777240" y="5230368"/>
+            <a:ext cx="10570464" cy="786384"/>
+          </a:xfrm>
+          <a:prstGeom prst="rect">
+            <a:avLst/>
+          </a:prstGeom>
+          <a:noFill/>
+        </p:spPr>
+        <p:txBody>
+          <a:bodyPr wrap="square" anchor="ctr" lIns="177800" rIns="177800" tIns="76200" bIns="76200">
+            <a:spAutoFit/>
+          </a:bodyPr>
+          <a:lstStyle/>
+          <a:p>
+            <a:pPr algn="l">
+              <a:spcAft>
+                <a:spcPts val="300"/>
+              </a:spcAft>
+            </a:pPr>
+            <a:r>
+              <a:rPr sz="1350" b="1" i="0">
+                <a:solidFill>
+                  <a:srgbClr val="FFFFFF"/>
+                </a:solidFill>
+                <a:latin typeface="Segoe UI"/>
+              </a:rPr>
+              <a:t>One SKU = one cell of this grid.</a:t>
+            </a:r>
+          </a:p>
+          <a:p>
+            <a:pPr algn="l">
+              <a:spcAft>
+                <a:spcPts val="0"/>
+              </a:spcAft>
+            </a:pPr>
+            <a:r>
+              <a:rPr sz="1200" b="0" i="0">
+                <a:solidFill>
+                  <a:srgbClr val="C7D6EA"/>
+                </a:solidFill>
+                <a:latin typeface="Segoe UI"/>
+              </a:rPr>
+              <a:t>Gislefoss = </a:t>
+            </a:r>
+            <a:r>
+              <a:rPr sz="1200" b="1" i="0">
+                <a:solidFill>
+                  <a:srgbClr val="FFFFFF"/>
+                </a:solidFill>
+                <a:latin typeface="Consolas"/>
+              </a:rPr>
+              <a:t>GlobalStandard</a:t>
+            </a:r>
+            <a:r>
+              <a:rPr sz="1200" b="0" i="0">
+                <a:solidFill>
+                  <a:srgbClr val="C7D6EA"/>
+                </a:solidFill>
+                <a:latin typeface="Segoe UI"/>
+              </a:rPr>
+              <a:t>.   Plus a Batch flavor (</a:t>
+            </a:r>
+            <a:r>
+              <a:rPr sz="1200" b="0" i="0">
+                <a:solidFill>
+                  <a:srgbClr val="C7D6EA"/>
+                </a:solidFill>
+                <a:latin typeface="Consolas"/>
+              </a:rPr>
+              <a:t>GlobalBatch</a:t>
+            </a:r>
+            <a:r>
+              <a:rPr sz="1200" b="0" i="0">
+                <a:solidFill>
+                  <a:srgbClr val="C7D6EA"/>
+                </a:solidFill>
+                <a:latin typeface="Segoe UI"/>
+              </a:rPr>
+              <a:t> · </a:t>
+            </a:r>
+            <a:r>
+              <a:rPr sz="1200" b="0" i="0">
+                <a:solidFill>
+                  <a:srgbClr val="C7D6EA"/>
+                </a:solidFill>
+                <a:latin typeface="Consolas"/>
+              </a:rPr>
+              <a:t>DataZoneBatch</a:t>
+            </a:r>
+            <a:r>
+              <a:rPr sz="1200" b="0" i="0">
+                <a:solidFill>
+                  <a:srgbClr val="C7D6EA"/>
+                </a:solidFill>
+                <a:latin typeface="Segoe UI"/>
+              </a:rPr>
+              <a:t>) for async bulk processing.</a:t>
+            </a:r>
+          </a:p>
+        </p:txBody>
+      </p:sp>
+    </p:spTree>
+  </p:cSld>
+  <p:clrMapOvr>
+    <a:masterClrMapping/>
+  </p:clrMapOvr>
+</p:sld>
+</file>
+
+<file path=ppt/slides/slide24.xml><?xml version="1.0" encoding="utf-8"?>
+<p:sld xmlns:a="http://schemas.openxmlformats.org/drawingml/2006/main" xmlns:p="http://schemas.openxmlformats.org/presentationml/2006/main" xmlns:r="http://schemas.openxmlformats.org/officeDocument/2006/relationships">
+  <p:cSld>
+    <p:spTree>
+      <p:nvGrpSpPr>
+        <p:cNvPr id="1" name=""/>
+        <p:cNvGrpSpPr/>
+        <p:nvPr/>
+      </p:nvGrpSpPr>
+      <p:grpSpPr/>
+      <p:sp>
+        <p:nvSpPr>
+          <p:cNvPr id="2" name="Rectangle 1"/>
+          <p:cNvSpPr/>
+          <p:nvPr/>
+        </p:nvSpPr>
+        <p:spPr>
+          <a:xfrm>
+            <a:off x="0" y="0"/>
+            <a:ext cx="12188952" cy="164592"/>
+          </a:xfrm>
+          <a:prstGeom prst="rect">
+            <a:avLst/>
+          </a:prstGeom>
+          <a:solidFill>
+            <a:srgbClr val="0078D4"/>
+          </a:solidFill>
+          <a:ln>
+            <a:noFill/>
+          </a:ln>
+          <a:effectLst/>
+        </p:spPr>
+        <p:style>
+          <a:lnRef idx="1">
+            <a:schemeClr val="accent1"/>
+          </a:lnRef>
+          <a:fillRef idx="3">
+            <a:schemeClr val="accent1"/>
+          </a:fillRef>
+          <a:effectRef idx="2">
+            <a:schemeClr val="accent1"/>
+          </a:effectRef>
+          <a:fontRef idx="minor">
+            <a:schemeClr val="lt1"/>
+          </a:fontRef>
+        </p:style>
+        <p:txBody>
+          <a:bodyPr rtlCol="0" anchor="ctr"/>
+          <a:lstStyle/>
+          <a:p>
+            <a:pPr algn="ctr"/>
+            <a:endParaRPr/>
+          </a:p>
+        </p:txBody>
+      </p:sp>
+      <p:sp>
+        <p:nvSpPr>
+          <p:cNvPr id="3" name="TextBox 2"/>
+          <p:cNvSpPr txBox="1"/>
+          <p:nvPr/>
+        </p:nvSpPr>
+        <p:spPr>
+          <a:xfrm>
+            <a:off x="640080" y="411480"/>
+            <a:ext cx="10972800" cy="365760"/>
+          </a:xfrm>
+          <a:prstGeom prst="rect">
+            <a:avLst/>
+          </a:prstGeom>
+          <a:noFill/>
+        </p:spPr>
+        <p:txBody>
+          <a:bodyPr wrap="square">
+            <a:spAutoFit/>
+          </a:bodyPr>
+          <a:lstStyle/>
+          <a:p>
+            <a:pPr algn="l">
+              <a:spcAft>
+                <a:spcPts val="600"/>
+              </a:spcAft>
+            </a:pPr>
+            <a:r>
+              <a:rPr sz="1300" b="1">
+                <a:solidFill>
+                  <a:srgbClr val="0078D4"/>
+                </a:solidFill>
+                <a:latin typeface="Segoe UI"/>
+              </a:rPr>
+              <a:t>AZURE AI FOUNDRY · THE BILLING AXIS</a:t>
+            </a:r>
+          </a:p>
+        </p:txBody>
+      </p:sp>
+      <p:sp>
+        <p:nvSpPr>
+          <p:cNvPr id="4" name="TextBox 3"/>
+          <p:cNvSpPr txBox="1"/>
+          <p:nvPr/>
+        </p:nvSpPr>
+        <p:spPr>
+          <a:xfrm>
+            <a:off x="640080" y="749808"/>
+            <a:ext cx="10972800" cy="553998"/>
+          </a:xfrm>
+          <a:prstGeom prst="rect">
+            <a:avLst/>
+          </a:prstGeom>
+          <a:noFill/>
+        </p:spPr>
+        <p:txBody>
+          <a:bodyPr wrap="square">
+            <a:spAutoFit/>
+          </a:bodyPr>
+          <a:lstStyle/>
+          <a:p>
+            <a:pPr algn="l">
+              <a:spcAft>
+                <a:spcPts val="600"/>
+              </a:spcAft>
+            </a:pPr>
+            <a:r>
+              <a:rPr sz="3000" b="1" dirty="0">
+                <a:solidFill>
+                  <a:srgbClr val="243A5E"/>
+                </a:solidFill>
+                <a:latin typeface="Segoe UI"/>
+              </a:rPr>
+              <a:t>Standard vs Provisioned</a:t>
+            </a:r>
+          </a:p>
+        </p:txBody>
+      </p:sp>
+      <p:sp>
+        <p:nvSpPr>
+          <p:cNvPr id="5" name="Rectangle 4"/>
+          <p:cNvSpPr/>
+          <p:nvPr/>
+        </p:nvSpPr>
+        <p:spPr>
+          <a:xfrm>
+            <a:off x="658368" y="1481328"/>
+            <a:ext cx="1005840" cy="45720"/>
+          </a:xfrm>
+          <a:prstGeom prst="rect">
+            <a:avLst/>
+          </a:prstGeom>
+          <a:solidFill>
+            <a:srgbClr val="0078D4"/>
+          </a:solidFill>
+          <a:ln>
+            <a:noFill/>
+          </a:ln>
+          <a:effectLst/>
+        </p:spPr>
+        <p:style>
+          <a:lnRef idx="1">
+            <a:schemeClr val="accent1"/>
+          </a:lnRef>
+          <a:fillRef idx="3">
+            <a:schemeClr val="accent1"/>
+          </a:fillRef>
+          <a:effectRef idx="2">
+            <a:schemeClr val="accent1"/>
+          </a:effectRef>
+          <a:fontRef idx="minor">
+            <a:schemeClr val="lt1"/>
+          </a:fontRef>
+        </p:style>
+        <p:txBody>
+          <a:bodyPr rtlCol="0" anchor="ctr"/>
+          <a:lstStyle/>
+          <a:p>
+            <a:pPr algn="ctr"/>
+            <a:endParaRPr/>
+          </a:p>
+        </p:txBody>
+      </p:sp>
+      <p:sp>
+        <p:nvSpPr>
+          <p:cNvPr id="6" name="TextBox 5"/>
+          <p:cNvSpPr txBox="1"/>
+          <p:nvPr/>
+        </p:nvSpPr>
+        <p:spPr>
+          <a:xfrm>
+            <a:off x="777240" y="1554480"/>
+            <a:ext cx="10607040" cy="661720"/>
+          </a:xfrm>
+          <a:prstGeom prst="rect">
+            <a:avLst/>
+          </a:prstGeom>
+          <a:noFill/>
+        </p:spPr>
+        <p:txBody>
+          <a:bodyPr wrap="square">
+            <a:spAutoFit/>
+          </a:bodyPr>
+          <a:lstStyle/>
+          <a:p>
+            <a:pPr>
+              <a:spcAft>
+                <a:spcPts val="600"/>
+              </a:spcAft>
+            </a:pPr>
+            <a:r>
+              <a:rPr lang="nb-NO" sz="1600" b="0" dirty="0" err="1">
+                <a:solidFill>
+                  <a:srgbClr val="605E5C"/>
+                </a:solidFill>
+                <a:latin typeface="Segoe UI"/>
+              </a:rPr>
+              <a:t>Pay-per-token elasticity, or reserved capacity with guaranteed throughput.</a:t>
+            </a:r>
+            <a:endParaRPr lang="nb-NO" sz="1600" dirty="0">
+              <a:solidFill>
+                <a:srgbClr val="605E5C"/>
+              </a:solidFill>
+              <a:latin typeface="Segoe UI"/>
+            </a:endParaRPr>
+          </a:p>
+        </p:txBody>
+      </p:sp>
+      <p:sp>
+        <p:nvSpPr>
+          <p:cNvPr id="21" name="TextBox 20"/>
+          <p:cNvSpPr txBox="1"/>
+          <p:nvPr/>
+        </p:nvSpPr>
+        <p:spPr>
+          <a:xfrm>
+            <a:off x="640080" y="6419088"/>
+            <a:ext cx="7315200" cy="320040"/>
+          </a:xfrm>
+          <a:prstGeom prst="rect">
+            <a:avLst/>
+          </a:prstGeom>
+          <a:noFill/>
+        </p:spPr>
+        <p:txBody>
+          <a:bodyPr wrap="square">
+            <a:spAutoFit/>
+          </a:bodyPr>
+          <a:lstStyle/>
+          <a:p>
+            <a:pPr algn="l">
+              <a:spcAft>
+                <a:spcPts val="600"/>
+              </a:spcAft>
+            </a:pPr>
+            <a:r>
+              <a:rPr sz="900" b="0">
+                <a:solidFill>
+                  <a:srgbClr val="605E5C"/>
+                </a:solidFill>
+                <a:latin typeface="Segoe UI"/>
+              </a:rPr>
+              <a:t>Prompt Shields vs. Guardrails  ·  Gislefoss Meteorologist Agent</a:t>
+            </a:r>
+          </a:p>
+        </p:txBody>
+      </p:sp>
+      <p:sp>
+        <p:nvSpPr>
+          <p:cNvPr id="22" name="TextBox 21"/>
+          <p:cNvSpPr txBox="1"/>
+          <p:nvPr/>
+        </p:nvSpPr>
+        <p:spPr>
+          <a:xfrm>
+            <a:off x="10972800" y="6419088"/>
+            <a:ext cx="822960" cy="320040"/>
+          </a:xfrm>
+          <a:prstGeom prst="rect">
+            <a:avLst/>
+          </a:prstGeom>
+          <a:noFill/>
+        </p:spPr>
+        <p:txBody>
+          <a:bodyPr wrap="square">
+            <a:spAutoFit/>
+          </a:bodyPr>
+          <a:lstStyle/>
+          <a:p>
+            <a:pPr algn="r">
+              <a:spcAft>
+                <a:spcPts val="600"/>
+              </a:spcAft>
+            </a:pPr>
+            <a:r>
+              <a:rPr sz="900" b="0">
+                <a:solidFill>
+                  <a:srgbClr val="605E5C"/>
+                </a:solidFill>
+                <a:latin typeface="Segoe UI"/>
+              </a:rPr>
+              <a:t>6</a:t>
+            </a:r>
+          </a:p>
+        </p:txBody>
+      </p:sp>
+      <p:sp>
+        <p:nvSpPr>
+          <p:cNvPr id="23" name="Rounded Rectangle 22"/>
+          <p:cNvSpPr/>
+          <p:nvPr/>
+        </p:nvSpPr>
+        <p:spPr>
+          <a:xfrm>
+            <a:off x="777240" y="2176272"/>
+            <a:ext cx="5074920" cy="3108960"/>
+          </a:xfrm>
+          <a:prstGeom prst="roundRect">
+            <a:avLst>
+              <a:gd name="adj" fmla="val 5000"/>
+            </a:avLst>
+          </a:prstGeom>
+          <a:solidFill>
+            <a:srgbClr val="FFFFFF"/>
+          </a:solidFill>
+          <a:ln w="25400">
+            <a:solidFill>
+              <a:srgbClr val="0078D4"/>
+            </a:solidFill>
+          </a:ln>
+          <a:effectLst/>
+        </p:spPr>
+        <p:style>
+          <a:lnRef idx="1">
+            <a:schemeClr val="accent1"/>
+          </a:lnRef>
+          <a:fillRef idx="3">
+            <a:schemeClr val="accent1"/>
+          </a:fillRef>
+          <a:effectRef idx="2">
+            <a:schemeClr val="accent1"/>
+          </a:effectRef>
+          <a:fontRef idx="minor">
+            <a:schemeClr val="lt1"/>
+          </a:fontRef>
+        </p:style>
+        <p:txBody>
+          <a:bodyPr rtlCol="0" anchor="ctr"/>
+          <a:lstStyle/>
+          <a:p>
+            <a:pPr algn="ctr"/>
+          </a:p>
+        </p:txBody>
+      </p:sp>
+      <p:sp>
+        <p:nvSpPr>
+          <p:cNvPr id="24" name="TextBox 23"/>
+          <p:cNvSpPr txBox="1"/>
+          <p:nvPr/>
+        </p:nvSpPr>
+        <p:spPr>
+          <a:xfrm>
+            <a:off x="1051560" y="2286000"/>
+            <a:ext cx="4526280" cy="384048"/>
+          </a:xfrm>
+          <a:prstGeom prst="rect">
+            <a:avLst/>
+          </a:prstGeom>
+          <a:noFill/>
+        </p:spPr>
+        <p:txBody>
+          <a:bodyPr wrap="square" anchor="t" lIns="25400" rIns="25400" tIns="12700" bIns="12700">
+            <a:spAutoFit/>
+          </a:bodyPr>
+          <a:lstStyle/>
+          <a:p>
+            <a:pPr algn="l">
+              <a:spcAft>
+                <a:spcPts val="0"/>
+              </a:spcAft>
+            </a:pPr>
+            <a:r>
+              <a:rPr sz="1500" b="1" i="0">
+                <a:solidFill>
+                  <a:srgbClr val="0078D4"/>
+                </a:solidFill>
+                <a:latin typeface="Segoe UI"/>
+              </a:rPr>
+              <a:t>STANDARD</a:t>
+            </a:r>
+            <a:r>
+              <a:rPr sz="1200" b="0" i="0">
+                <a:solidFill>
+                  <a:srgbClr val="605E5C"/>
+                </a:solidFill>
+                <a:latin typeface="Consolas"/>
+              </a:rPr>
+              <a:t>   ·  pay-per-token</a:t>
+            </a:r>
+          </a:p>
+        </p:txBody>
+      </p:sp>
+      <p:sp>
+        <p:nvSpPr>
+          <p:cNvPr id="25" name="TextBox 24"/>
+          <p:cNvSpPr txBox="1"/>
+          <p:nvPr/>
+        </p:nvSpPr>
+        <p:spPr>
+          <a:xfrm>
+            <a:off x="1051560" y="2679192"/>
+            <a:ext cx="4526280" cy="384048"/>
+          </a:xfrm>
+          <a:prstGeom prst="rect">
+            <a:avLst/>
+          </a:prstGeom>
+          <a:noFill/>
+        </p:spPr>
+        <p:txBody>
+          <a:bodyPr wrap="square" anchor="t" lIns="25400" rIns="25400" tIns="12700" bIns="12700">
+            <a:spAutoFit/>
+          </a:bodyPr>
+          <a:lstStyle/>
+          <a:p>
+            <a:pPr algn="l">
+              <a:spcAft>
+                <a:spcPts val="0"/>
+              </a:spcAft>
+            </a:pPr>
+            <a:r>
+              <a:rPr sz="1650" b="1" i="0">
+                <a:solidFill>
+                  <a:srgbClr val="243A5E"/>
+                </a:solidFill>
+                <a:latin typeface="Segoe UI"/>
+              </a:rPr>
+              <a:t>Pay only for the tokens you use.</a:t>
+            </a:r>
+          </a:p>
+        </p:txBody>
+      </p:sp>
+      <p:sp>
+        <p:nvSpPr>
+          <p:cNvPr id="26" name="TextBox 25"/>
+          <p:cNvSpPr txBox="1"/>
+          <p:nvPr/>
+        </p:nvSpPr>
+        <p:spPr>
+          <a:xfrm>
+            <a:off x="1051560" y="3108960"/>
+            <a:ext cx="4526280" cy="1691640"/>
+          </a:xfrm>
+          <a:prstGeom prst="rect">
+            <a:avLst/>
+          </a:prstGeom>
+          <a:noFill/>
+        </p:spPr>
+        <p:txBody>
+          <a:bodyPr wrap="square" anchor="t" lIns="25400" rIns="25400" tIns="12700" bIns="12700">
+            <a:spAutoFit/>
+          </a:bodyPr>
+          <a:lstStyle/>
+          <a:p>
+            <a:pPr algn="l">
+              <a:spcAft>
+                <a:spcPts val="400"/>
+              </a:spcAft>
+            </a:pPr>
+            <a:r>
+              <a:rPr sz="1300" b="1" i="0">
+                <a:solidFill>
+                  <a:srgbClr val="0078D4"/>
+                </a:solidFill>
+                <a:latin typeface="Segoe UI"/>
+              </a:rPr>
+              <a:t>›  </a:t>
+            </a:r>
+            <a:r>
+              <a:rPr sz="1300" b="1" i="0">
+                <a:solidFill>
+                  <a:srgbClr val="243A5E"/>
+                </a:solidFill>
+                <a:latin typeface="Segoe UI"/>
+              </a:rPr>
+              <a:t>Billing: </a:t>
+            </a:r>
+            <a:r>
+              <a:rPr sz="1300" b="0" i="0">
+                <a:solidFill>
+                  <a:srgbClr val="605E5C"/>
+                </a:solidFill>
+                <a:latin typeface="Segoe UI"/>
+              </a:rPr>
+              <a:t>per-token consumption — no commitment.</a:t>
+            </a:r>
+          </a:p>
+          <a:p>
+            <a:pPr algn="l">
+              <a:spcAft>
+                <a:spcPts val="400"/>
+              </a:spcAft>
+            </a:pPr>
+            <a:r>
+              <a:rPr sz="1300" b="1" i="0">
+                <a:solidFill>
+                  <a:srgbClr val="0078D4"/>
+                </a:solidFill>
+                <a:latin typeface="Segoe UI"/>
+              </a:rPr>
+              <a:t>›  </a:t>
+            </a:r>
+            <a:r>
+              <a:rPr sz="1300" b="1" i="0">
+                <a:solidFill>
+                  <a:srgbClr val="243A5E"/>
+                </a:solidFill>
+                <a:latin typeface="Segoe UI"/>
+              </a:rPr>
+              <a:t>Capacity: </a:t>
+            </a:r>
+            <a:r>
+              <a:rPr sz="1300" b="0" i="0">
+                <a:solidFill>
+                  <a:srgbClr val="605E5C"/>
+                </a:solidFill>
+                <a:latin typeface="Segoe UI"/>
+              </a:rPr>
+              <a:t>best-effort TPM quota; nothing reserved.</a:t>
+            </a:r>
+          </a:p>
+          <a:p>
+            <a:pPr algn="l">
+              <a:spcAft>
+                <a:spcPts val="400"/>
+              </a:spcAft>
+            </a:pPr>
+            <a:r>
+              <a:rPr sz="1300" b="1" i="0">
+                <a:solidFill>
+                  <a:srgbClr val="0078D4"/>
+                </a:solidFill>
+                <a:latin typeface="Segoe UI"/>
+              </a:rPr>
+              <a:t>›  </a:t>
+            </a:r>
+            <a:r>
+              <a:rPr sz="1300" b="1" i="0">
+                <a:solidFill>
+                  <a:srgbClr val="243A5E"/>
+                </a:solidFill>
+                <a:latin typeface="Segoe UI"/>
+              </a:rPr>
+              <a:t>Latency: </a:t>
+            </a:r>
+            <a:r>
+              <a:rPr sz="1300" b="0" i="0">
+                <a:solidFill>
+                  <a:srgbClr val="605E5C"/>
+                </a:solidFill>
+                <a:latin typeface="Segoe UI"/>
+              </a:rPr>
+              <a:t>variable; no throughput SLA.</a:t>
+            </a:r>
+          </a:p>
+          <a:p>
+            <a:pPr algn="l">
+              <a:spcAft>
+                <a:spcPts val="400"/>
+              </a:spcAft>
+            </a:pPr>
+            <a:r>
+              <a:rPr sz="1300" b="1" i="0">
+                <a:solidFill>
+                  <a:srgbClr val="0078D4"/>
+                </a:solidFill>
+                <a:latin typeface="Segoe UI"/>
+              </a:rPr>
+              <a:t>›  </a:t>
+            </a:r>
+            <a:r>
+              <a:rPr sz="1300" b="1" i="0">
+                <a:solidFill>
+                  <a:srgbClr val="243A5E"/>
+                </a:solidFill>
+                <a:latin typeface="Segoe UI"/>
+              </a:rPr>
+              <a:t>Idle: </a:t>
+            </a:r>
+            <a:r>
+              <a:rPr sz="1300" b="0" i="0">
+                <a:solidFill>
+                  <a:srgbClr val="605E5C"/>
+                </a:solidFill>
+                <a:latin typeface="Segoe UI"/>
+              </a:rPr>
+              <a:t>cost scales to zero when unused.</a:t>
+            </a:r>
+          </a:p>
+          <a:p>
+            <a:pPr algn="l">
+              <a:spcAft>
+                <a:spcPts val="400"/>
+              </a:spcAft>
+            </a:pPr>
+            <a:r>
+              <a:rPr sz="1300" b="1" i="0">
+                <a:solidFill>
+                  <a:srgbClr val="0078D4"/>
+                </a:solidFill>
+                <a:latin typeface="Segoe UI"/>
+              </a:rPr>
+              <a:t>›  </a:t>
+            </a:r>
+            <a:r>
+              <a:rPr sz="1300" b="1" i="0">
+                <a:solidFill>
+                  <a:srgbClr val="243A5E"/>
+                </a:solidFill>
+                <a:latin typeface="Segoe UI"/>
+              </a:rPr>
+              <a:t>Best for: </a:t>
+            </a:r>
+            <a:r>
+              <a:rPr sz="1300" b="0" i="0">
+                <a:solidFill>
+                  <a:srgbClr val="605E5C"/>
+                </a:solidFill>
+                <a:latin typeface="Segoe UI"/>
+              </a:rPr>
+              <a:t>bursty, low–medium volume, prototypes.</a:t>
+            </a:r>
+          </a:p>
+        </p:txBody>
+      </p:sp>
+      <p:sp>
+        <p:nvSpPr>
+          <p:cNvPr id="27" name="TextBox 26"/>
+          <p:cNvSpPr txBox="1"/>
+          <p:nvPr/>
+        </p:nvSpPr>
+        <p:spPr>
+          <a:xfrm>
+            <a:off x="1051560" y="4846320"/>
+            <a:ext cx="4526280" cy="365760"/>
+          </a:xfrm>
+          <a:prstGeom prst="rect">
+            <a:avLst/>
+          </a:prstGeom>
+          <a:noFill/>
+        </p:spPr>
+        <p:txBody>
+          <a:bodyPr wrap="square" anchor="ctr" lIns="25400" rIns="25400" tIns="12700" bIns="12700">
+            <a:spAutoFit/>
+          </a:bodyPr>
+          <a:lstStyle/>
+          <a:p>
+            <a:pPr algn="l">
+              <a:spcAft>
+                <a:spcPts val="0"/>
+              </a:spcAft>
+            </a:pPr>
+            <a:r>
+              <a:rPr sz="900" b="0" i="0">
+                <a:solidFill>
+                  <a:srgbClr val="605E5C"/>
+                </a:solidFill>
+                <a:latin typeface="Consolas"/>
+              </a:rPr>
+              <a:t>Standard · DataZoneStandard · GlobalStandard</a:t>
+            </a:r>
+          </a:p>
+        </p:txBody>
+      </p:sp>
+      <p:sp>
+        <p:nvSpPr>
+          <p:cNvPr id="28" name="Rounded Rectangle 27"/>
+          <p:cNvSpPr/>
+          <p:nvPr/>
+        </p:nvSpPr>
+        <p:spPr>
+          <a:xfrm>
+            <a:off x="6309360" y="2176272"/>
+            <a:ext cx="5074920" cy="3108960"/>
+          </a:xfrm>
+          <a:prstGeom prst="roundRect">
+            <a:avLst>
+              <a:gd name="adj" fmla="val 5000"/>
+            </a:avLst>
+          </a:prstGeom>
+          <a:solidFill>
+            <a:srgbClr val="FFFFFF"/>
+          </a:solidFill>
+          <a:ln w="25400">
+            <a:solidFill>
+              <a:srgbClr val="5C2D91"/>
+            </a:solidFill>
+          </a:ln>
+          <a:effectLst/>
+        </p:spPr>
+        <p:style>
+          <a:lnRef idx="1">
+            <a:schemeClr val="accent1"/>
+          </a:lnRef>
+          <a:fillRef idx="3">
+            <a:schemeClr val="accent1"/>
+          </a:fillRef>
+          <a:effectRef idx="2">
+            <a:schemeClr val="accent1"/>
+          </a:effectRef>
+          <a:fontRef idx="minor">
+            <a:schemeClr val="lt1"/>
+          </a:fontRef>
+        </p:style>
+        <p:txBody>
+          <a:bodyPr rtlCol="0" anchor="ctr"/>
+          <a:lstStyle/>
+          <a:p>
+            <a:pPr algn="ctr"/>
+          </a:p>
+        </p:txBody>
+      </p:sp>
+      <p:sp>
+        <p:nvSpPr>
+          <p:cNvPr id="29" name="TextBox 28"/>
+          <p:cNvSpPr txBox="1"/>
+          <p:nvPr/>
+        </p:nvSpPr>
+        <p:spPr>
+          <a:xfrm>
+            <a:off x="6583680" y="2286000"/>
+            <a:ext cx="4526280" cy="384048"/>
+          </a:xfrm>
+          <a:prstGeom prst="rect">
+            <a:avLst/>
+          </a:prstGeom>
+          <a:noFill/>
+        </p:spPr>
+        <p:txBody>
+          <a:bodyPr wrap="square" anchor="t" lIns="25400" rIns="25400" tIns="12700" bIns="12700">
+            <a:spAutoFit/>
+          </a:bodyPr>
+          <a:lstStyle/>
+          <a:p>
+            <a:pPr algn="l">
+              <a:spcAft>
+                <a:spcPts val="0"/>
+              </a:spcAft>
+            </a:pPr>
+            <a:r>
+              <a:rPr sz="1500" b="1" i="0">
+                <a:solidFill>
+                  <a:srgbClr val="5C2D91"/>
+                </a:solidFill>
+                <a:latin typeface="Segoe UI"/>
+              </a:rPr>
+              <a:t>PROVISIONED</a:t>
+            </a:r>
+            <a:r>
+              <a:rPr sz="1200" b="0" i="0">
+                <a:solidFill>
+                  <a:srgbClr val="605E5C"/>
+                </a:solidFill>
+                <a:latin typeface="Consolas"/>
+              </a:rPr>
+              <a:t>   ·  reserved PTU</a:t>
+            </a:r>
+          </a:p>
+        </p:txBody>
+      </p:sp>
+      <p:sp>
+        <p:nvSpPr>
+          <p:cNvPr id="30" name="TextBox 29"/>
+          <p:cNvSpPr txBox="1"/>
+          <p:nvPr/>
+        </p:nvSpPr>
+        <p:spPr>
+          <a:xfrm>
+            <a:off x="6583680" y="2679192"/>
+            <a:ext cx="4526280" cy="384048"/>
+          </a:xfrm>
+          <a:prstGeom prst="rect">
+            <a:avLst/>
+          </a:prstGeom>
+          <a:noFill/>
+        </p:spPr>
+        <p:txBody>
+          <a:bodyPr wrap="square" anchor="t" lIns="25400" rIns="25400" tIns="12700" bIns="12700">
+            <a:spAutoFit/>
+          </a:bodyPr>
+          <a:lstStyle/>
+          <a:p>
+            <a:pPr algn="l">
+              <a:spcAft>
+                <a:spcPts val="0"/>
+              </a:spcAft>
+            </a:pPr>
+            <a:r>
+              <a:rPr sz="1650" b="1" i="0">
+                <a:solidFill>
+                  <a:srgbClr val="243A5E"/>
+                </a:solidFill>
+                <a:latin typeface="Segoe UI"/>
+              </a:rPr>
+              <a:t>Reserve capacity in PTUs up front.</a:t>
+            </a:r>
+          </a:p>
+        </p:txBody>
+      </p:sp>
+      <p:sp>
+        <p:nvSpPr>
+          <p:cNvPr id="31" name="TextBox 30"/>
+          <p:cNvSpPr txBox="1"/>
+          <p:nvPr/>
+        </p:nvSpPr>
+        <p:spPr>
+          <a:xfrm>
+            <a:off x="6583680" y="3108960"/>
+            <a:ext cx="4526280" cy="1691640"/>
+          </a:xfrm>
+          <a:prstGeom prst="rect">
+            <a:avLst/>
+          </a:prstGeom>
+          <a:noFill/>
+        </p:spPr>
+        <p:txBody>
+          <a:bodyPr wrap="square" anchor="t" lIns="25400" rIns="25400" tIns="12700" bIns="12700">
+            <a:spAutoFit/>
+          </a:bodyPr>
+          <a:lstStyle/>
+          <a:p>
+            <a:pPr algn="l">
+              <a:spcAft>
+                <a:spcPts val="400"/>
+              </a:spcAft>
+            </a:pPr>
+            <a:r>
+              <a:rPr sz="1300" b="1" i="0">
+                <a:solidFill>
+                  <a:srgbClr val="5C2D91"/>
+                </a:solidFill>
+                <a:latin typeface="Segoe UI"/>
+              </a:rPr>
+              <a:t>›  </a:t>
+            </a:r>
+            <a:r>
+              <a:rPr sz="1300" b="1" i="0">
+                <a:solidFill>
+                  <a:srgbClr val="243A5E"/>
+                </a:solidFill>
+                <a:latin typeface="Segoe UI"/>
+              </a:rPr>
+              <a:t>Billing: </a:t>
+            </a:r>
+            <a:r>
+              <a:rPr sz="1300" b="0" i="0">
+                <a:solidFill>
+                  <a:srgbClr val="605E5C"/>
+                </a:solidFill>
+                <a:latin typeface="Segoe UI"/>
+              </a:rPr>
+              <a:t>fixed reserved capacity — pay used or not.</a:t>
+            </a:r>
+          </a:p>
+          <a:p>
+            <a:pPr algn="l">
+              <a:spcAft>
+                <a:spcPts val="400"/>
+              </a:spcAft>
+            </a:pPr>
+            <a:r>
+              <a:rPr sz="1300" b="1" i="0">
+                <a:solidFill>
+                  <a:srgbClr val="5C2D91"/>
+                </a:solidFill>
+                <a:latin typeface="Segoe UI"/>
+              </a:rPr>
+              <a:t>›  </a:t>
+            </a:r>
+            <a:r>
+              <a:rPr sz="1300" b="1" i="0">
+                <a:solidFill>
+                  <a:srgbClr val="243A5E"/>
+                </a:solidFill>
+                <a:latin typeface="Segoe UI"/>
+              </a:rPr>
+              <a:t>Capacity: </a:t>
+            </a:r>
+            <a:r>
+              <a:rPr sz="1300" b="0" i="0">
+                <a:solidFill>
+                  <a:srgbClr val="605E5C"/>
+                </a:solidFill>
+                <a:latin typeface="Segoe UI"/>
+              </a:rPr>
+              <a:t>guaranteed throughput; minimum PTU.</a:t>
+            </a:r>
+          </a:p>
+          <a:p>
+            <a:pPr algn="l">
+              <a:spcAft>
+                <a:spcPts val="400"/>
+              </a:spcAft>
+            </a:pPr>
+            <a:r>
+              <a:rPr sz="1300" b="1" i="0">
+                <a:solidFill>
+                  <a:srgbClr val="5C2D91"/>
+                </a:solidFill>
+                <a:latin typeface="Segoe UI"/>
+              </a:rPr>
+              <a:t>›  </a:t>
+            </a:r>
+            <a:r>
+              <a:rPr sz="1300" b="1" i="0">
+                <a:solidFill>
+                  <a:srgbClr val="243A5E"/>
+                </a:solidFill>
+                <a:latin typeface="Segoe UI"/>
+              </a:rPr>
+              <a:t>Latency: </a:t>
+            </a:r>
+            <a:r>
+              <a:rPr sz="1300" b="0" i="0">
+                <a:solidFill>
+                  <a:srgbClr val="605E5C"/>
+                </a:solidFill>
+                <a:latin typeface="Segoe UI"/>
+              </a:rPr>
+              <a:t>low and consistent — SLA-backed.</a:t>
+            </a:r>
+          </a:p>
+          <a:p>
+            <a:pPr algn="l">
+              <a:spcAft>
+                <a:spcPts val="400"/>
+              </a:spcAft>
+            </a:pPr>
+            <a:r>
+              <a:rPr sz="1300" b="1" i="0">
+                <a:solidFill>
+                  <a:srgbClr val="5C2D91"/>
+                </a:solidFill>
+                <a:latin typeface="Segoe UI"/>
+              </a:rPr>
+              <a:t>›  </a:t>
+            </a:r>
+            <a:r>
+              <a:rPr sz="1300" b="1" i="0">
+                <a:solidFill>
+                  <a:srgbClr val="243A5E"/>
+                </a:solidFill>
+                <a:latin typeface="Segoe UI"/>
+              </a:rPr>
+              <a:t>Idle: </a:t>
+            </a:r>
+            <a:r>
+              <a:rPr sz="1300" b="0" i="0">
+                <a:solidFill>
+                  <a:srgbClr val="605E5C"/>
+                </a:solidFill>
+                <a:latin typeface="Segoe UI"/>
+              </a:rPr>
+              <a:t>always-on cost; built for steady scale.</a:t>
+            </a:r>
+          </a:p>
+          <a:p>
+            <a:pPr algn="l">
+              <a:spcAft>
+                <a:spcPts val="400"/>
+              </a:spcAft>
+            </a:pPr>
+            <a:r>
+              <a:rPr sz="1300" b="1" i="0">
+                <a:solidFill>
+                  <a:srgbClr val="5C2D91"/>
+                </a:solidFill>
+                <a:latin typeface="Segoe UI"/>
+              </a:rPr>
+              <a:t>›  </a:t>
+            </a:r>
+            <a:r>
+              <a:rPr sz="1300" b="1" i="0">
+                <a:solidFill>
+                  <a:srgbClr val="243A5E"/>
+                </a:solidFill>
+                <a:latin typeface="Segoe UI"/>
+              </a:rPr>
+              <a:t>Best for: </a:t>
+            </a:r>
+            <a:r>
+              <a:rPr sz="1300" b="0" i="0">
+                <a:solidFill>
+                  <a:srgbClr val="605E5C"/>
+                </a:solidFill>
+                <a:latin typeface="Segoe UI"/>
+              </a:rPr>
+              <a:t>consistent, high, predictable volume.</a:t>
+            </a:r>
+          </a:p>
+        </p:txBody>
+      </p:sp>
+      <p:sp>
+        <p:nvSpPr>
+          <p:cNvPr id="32" name="TextBox 31"/>
+          <p:cNvSpPr txBox="1"/>
+          <p:nvPr/>
+        </p:nvSpPr>
+        <p:spPr>
+          <a:xfrm>
+            <a:off x="6583680" y="4846320"/>
+            <a:ext cx="4526280" cy="365760"/>
+          </a:xfrm>
+          <a:prstGeom prst="rect">
+            <a:avLst/>
+          </a:prstGeom>
+          <a:noFill/>
+        </p:spPr>
+        <p:txBody>
+          <a:bodyPr wrap="square" anchor="ctr" lIns="25400" rIns="25400" tIns="12700" bIns="12700">
+            <a:spAutoFit/>
+          </a:bodyPr>
+          <a:lstStyle/>
+          <a:p>
+            <a:pPr algn="l">
+              <a:spcAft>
+                <a:spcPts val="0"/>
+              </a:spcAft>
+            </a:pPr>
+            <a:r>
+              <a:rPr sz="800" b="0" i="0">
+                <a:solidFill>
+                  <a:srgbClr val="605E5C"/>
+                </a:solidFill>
+                <a:latin typeface="Consolas"/>
+              </a:rPr>
+              <a:t>ProvisionedManaged · DataZoneProvisionedManaged · GlobalProvisionedManaged</a:t>
+            </a:r>
+          </a:p>
+        </p:txBody>
+      </p:sp>
+      <p:sp>
+        <p:nvSpPr>
+          <p:cNvPr id="33" name="Rounded Rectangle 32"/>
+          <p:cNvSpPr/>
+          <p:nvPr/>
+        </p:nvSpPr>
+        <p:spPr>
+          <a:xfrm>
+            <a:off x="777240" y="5413248"/>
+            <a:ext cx="10570464" cy="749808"/>
+          </a:xfrm>
+          <a:prstGeom prst="roundRect">
+            <a:avLst>
+              <a:gd name="adj" fmla="val 5000"/>
+            </a:avLst>
+          </a:prstGeom>
+          <a:solidFill>
+            <a:srgbClr val="243A5E"/>
+          </a:solidFill>
+          <a:ln>
+            <a:noFill/>
+          </a:ln>
+          <a:effectLst/>
+        </p:spPr>
+        <p:style>
+          <a:lnRef idx="1">
+            <a:schemeClr val="accent1"/>
+          </a:lnRef>
+          <a:fillRef idx="3">
+            <a:schemeClr val="accent1"/>
+          </a:fillRef>
+          <a:effectRef idx="2">
+            <a:schemeClr val="accent1"/>
+          </a:effectRef>
+          <a:fontRef idx="minor">
+            <a:schemeClr val="lt1"/>
+          </a:fontRef>
+        </p:style>
+        <p:txBody>
+          <a:bodyPr rtlCol="0" anchor="ctr"/>
+          <a:lstStyle/>
+          <a:p>
+            <a:pPr algn="ctr"/>
+          </a:p>
+        </p:txBody>
+      </p:sp>
+      <p:sp>
+        <p:nvSpPr>
+          <p:cNvPr id="34" name="TextBox 33"/>
+          <p:cNvSpPr txBox="1"/>
+          <p:nvPr/>
+        </p:nvSpPr>
+        <p:spPr>
+          <a:xfrm>
+            <a:off x="777240" y="5413248"/>
+            <a:ext cx="10570464" cy="749808"/>
+          </a:xfrm>
+          <a:prstGeom prst="rect">
+            <a:avLst/>
+          </a:prstGeom>
+          <a:noFill/>
+        </p:spPr>
+        <p:txBody>
+          <a:bodyPr wrap="square" anchor="ctr" lIns="177800" rIns="177800" tIns="76200" bIns="76200">
+            <a:spAutoFit/>
+          </a:bodyPr>
+          <a:lstStyle/>
+          <a:p>
+            <a:pPr algn="l">
+              <a:spcAft>
+                <a:spcPts val="300"/>
+              </a:spcAft>
+            </a:pPr>
+            <a:r>
+              <a:rPr sz="1300" b="1" i="0">
+                <a:solidFill>
+                  <a:srgbClr val="FFFFFF"/>
+                </a:solidFill>
+                <a:latin typeface="Segoe UI"/>
+              </a:rPr>
+              <a:t>Prompt caching pays off either way — partial discount on Standard, up to 100% off cached input on Provisioned.</a:t>
+            </a:r>
+          </a:p>
+          <a:p>
+            <a:pPr algn="l">
+              <a:spcAft>
+                <a:spcPts val="0"/>
+              </a:spcAft>
+            </a:pPr>
+            <a:r>
+              <a:rPr sz="1200" b="0" i="0">
+                <a:solidFill>
+                  <a:srgbClr val="C7D6EA"/>
+                </a:solidFill>
+                <a:latin typeface="Segoe UI"/>
+              </a:rPr>
+              <a:t>Gislefoss runs </a:t>
+            </a:r>
+            <a:r>
+              <a:rPr sz="1200" b="1" i="0">
+                <a:solidFill>
+                  <a:srgbClr val="FFFFFF"/>
+                </a:solidFill>
+                <a:latin typeface="Consolas"/>
+              </a:rPr>
+              <a:t>GlobalStandard</a:t>
+            </a:r>
+            <a:r>
+              <a:rPr sz="1200" b="0" i="0">
+                <a:solidFill>
+                  <a:srgbClr val="C7D6EA"/>
+                </a:solidFill>
+                <a:latin typeface="Segoe UI"/>
+              </a:rPr>
+              <a:t> today; the production EU path is </a:t>
+            </a:r>
+            <a:r>
+              <a:rPr sz="1200" b="1" i="0">
+                <a:solidFill>
+                  <a:srgbClr val="FFFFFF"/>
+                </a:solidFill>
+                <a:latin typeface="Consolas"/>
+              </a:rPr>
+              <a:t>DataZoneProvisionedManaged</a:t>
+            </a:r>
+            <a:r>
+              <a:rPr sz="1200" b="0" i="0">
+                <a:solidFill>
+                  <a:srgbClr val="C7D6EA"/>
+                </a:solidFill>
+                <a:latin typeface="Segoe UI"/>
+              </a:rPr>
+              <a:t>.</a:t>
+            </a:r>
+          </a:p>
+        </p:txBody>
+      </p:sp>
+    </p:spTree>
+  </p:cSld>
+  <p:clrMapOvr>
+    <a:masterClrMapping/>
+  </p:clrMapOvr>
+</p:sld>
+</file>
+
 <file path=ppt/slides/slide3.xml><?xml version="1.0" encoding="utf-8"?>
 <p:sld xmlns:a="http://schemas.openxmlformats.org/drawingml/2006/main" xmlns:r="http://schemas.openxmlformats.org/officeDocument/2006/relationships" xmlns:p="http://schemas.openxmlformats.org/presentationml/2006/main">
   <p:cSld>
@@ -19466,7 +22348,7 @@
                 </a:solidFill>
                 <a:latin typeface="Segoe UI"/>
               </a:rPr>
-              <a:t>5</a:t>
+              <a:t>7</a:t>
             </a:r>
           </a:p>
         </p:txBody>

</xml_diff>

<commit_message>
Add external-agent memory slide to presento.
Covers using the Foundry memory store from a Web App, Container App or AKS:
any-host access (data-plane, REST/SDK, Entra), the two call modes, limitations
(no VNet/Private Link, explicit scope, preview), quotas, and the Azure OpenAI
chat + embedding model dependency.

Co-Authored-By: Claude Opus 4.8 (1M context) <noreply@anthropic.com>
</commit_message>
<xml_diff>
--- a/docs/prompt-shields-vs-guardrails.pptx
+++ b/docs/prompt-shields-vs-guardrails.pptx
@@ -30,6 +30,7 @@
     <p:sldId id="267" r:id="rId24"/>
     <p:sldId id="274" r:id="rId25"/>
     <p:sldId id="275" r:id="rId26"/>
+    <p:sldId id="284" r:id="rId31"/>
   </p:sldIdLst>
   <p:sldSz cx="12192000" cy="6858000"/>
   <p:notesSz cx="6858000" cy="9144000"/>
@@ -21022,6 +21023,879 @@
                 <a:latin typeface="Segoe UI"/>
               </a:rPr>
               <a:t>Today Gislefoss sets deployMemory = false → the agent is stateless and memory costs nothing.</a:t>
+            </a:r>
+          </a:p>
+        </p:txBody>
+      </p:sp>
+    </p:spTree>
+  </p:cSld>
+  <p:clrMapOvr>
+    <a:masterClrMapping/>
+  </p:clrMapOvr>
+</p:sld>
+</file>
+
+<file path=ppt/slides/slide26.xml><?xml version="1.0" encoding="utf-8"?>
+<p:sld xmlns:a="http://schemas.openxmlformats.org/drawingml/2006/main" xmlns:p="http://schemas.openxmlformats.org/presentationml/2006/main" xmlns:r="http://schemas.openxmlformats.org/officeDocument/2006/relationships">
+  <p:cSld>
+    <p:spTree>
+      <p:nvGrpSpPr>
+        <p:cNvPr id="1" name=""/>
+        <p:cNvGrpSpPr/>
+        <p:nvPr/>
+      </p:nvGrpSpPr>
+      <p:grpSpPr/>
+      <p:sp>
+        <p:nvSpPr>
+          <p:cNvPr id="2" name="Rectangle 1"/>
+          <p:cNvSpPr/>
+          <p:nvPr/>
+        </p:nvSpPr>
+        <p:spPr>
+          <a:xfrm>
+            <a:off x="0" y="0"/>
+            <a:ext cx="12188952" cy="164592"/>
+          </a:xfrm>
+          <a:prstGeom prst="rect">
+            <a:avLst/>
+          </a:prstGeom>
+          <a:solidFill>
+            <a:srgbClr val="0078D4"/>
+          </a:solidFill>
+          <a:ln>
+            <a:noFill/>
+          </a:ln>
+          <a:effectLst/>
+        </p:spPr>
+        <p:style>
+          <a:lnRef idx="1">
+            <a:schemeClr val="accent1"/>
+          </a:lnRef>
+          <a:fillRef idx="3">
+            <a:schemeClr val="accent1"/>
+          </a:fillRef>
+          <a:effectRef idx="2">
+            <a:schemeClr val="accent1"/>
+          </a:effectRef>
+          <a:fontRef idx="minor">
+            <a:schemeClr val="lt1"/>
+          </a:fontRef>
+        </p:style>
+        <p:txBody>
+          <a:bodyPr rtlCol="0" anchor="ctr"/>
+          <a:lstStyle/>
+          <a:p>
+            <a:pPr algn="ctr"/>
+            <a:endParaRPr/>
+          </a:p>
+        </p:txBody>
+      </p:sp>
+      <p:sp>
+        <p:nvSpPr>
+          <p:cNvPr id="3" name="TextBox 2"/>
+          <p:cNvSpPr txBox="1"/>
+          <p:nvPr/>
+        </p:nvSpPr>
+        <p:spPr>
+          <a:xfrm>
+            <a:off x="640080" y="411480"/>
+            <a:ext cx="10972800" cy="365760"/>
+          </a:xfrm>
+          <a:prstGeom prst="rect">
+            <a:avLst/>
+          </a:prstGeom>
+          <a:noFill/>
+        </p:spPr>
+        <p:txBody>
+          <a:bodyPr wrap="square">
+            <a:spAutoFit/>
+          </a:bodyPr>
+          <a:lstStyle/>
+          <a:p>
+            <a:pPr algn="l">
+              <a:lnSpc>
+                <a:spcPct val="100000"/>
+              </a:lnSpc>
+              <a:spcAft>
+                <a:spcPts val="600"/>
+              </a:spcAft>
+            </a:pPr>
+            <a:r>
+              <a:rPr sz="1300" b="1">
+                <a:solidFill>
+                  <a:srgbClr val="0078D4"/>
+                </a:solidFill>
+                <a:latin typeface="Segoe UI"/>
+              </a:rPr>
+              <a:t>FOUNDRY AGENT SERVICE · MEMORY FROM EXTERNAL AGENTS</a:t>
+            </a:r>
+          </a:p>
+        </p:txBody>
+      </p:sp>
+      <p:sp>
+        <p:nvSpPr>
+          <p:cNvPr id="4" name="TextBox 3"/>
+          <p:cNvSpPr txBox="1"/>
+          <p:nvPr/>
+        </p:nvSpPr>
+        <p:spPr>
+          <a:xfrm>
+            <a:off x="640080" y="749808"/>
+            <a:ext cx="10972800" cy="822960"/>
+          </a:xfrm>
+          <a:prstGeom prst="rect">
+            <a:avLst/>
+          </a:prstGeom>
+          <a:noFill/>
+        </p:spPr>
+        <p:txBody>
+          <a:bodyPr wrap="square">
+            <a:spAutoFit/>
+          </a:bodyPr>
+          <a:lstStyle/>
+          <a:p>
+            <a:pPr algn="l">
+              <a:lnSpc>
+                <a:spcPct val="100000"/>
+              </a:lnSpc>
+              <a:spcAft>
+                <a:spcPts val="600"/>
+              </a:spcAft>
+            </a:pPr>
+            <a:r>
+              <a:rPr sz="3000" b="1">
+                <a:solidFill>
+                  <a:srgbClr val="243A5E"/>
+                </a:solidFill>
+                <a:latin typeface="Segoe UI"/>
+              </a:rPr>
+              <a:t>Use the memory store from your own host</a:t>
+            </a:r>
+          </a:p>
+        </p:txBody>
+      </p:sp>
+      <p:sp>
+        <p:nvSpPr>
+          <p:cNvPr id="5" name="Rectangle 4"/>
+          <p:cNvSpPr/>
+          <p:nvPr/>
+        </p:nvSpPr>
+        <p:spPr>
+          <a:xfrm>
+            <a:off x="658368" y="1481328"/>
+            <a:ext cx="1005840" cy="45720"/>
+          </a:xfrm>
+          <a:prstGeom prst="rect">
+            <a:avLst/>
+          </a:prstGeom>
+          <a:solidFill>
+            <a:srgbClr val="0078D4"/>
+          </a:solidFill>
+          <a:ln>
+            <a:noFill/>
+          </a:ln>
+          <a:effectLst/>
+        </p:spPr>
+        <p:style>
+          <a:lnRef idx="1">
+            <a:schemeClr val="accent1"/>
+          </a:lnRef>
+          <a:fillRef idx="3">
+            <a:schemeClr val="accent1"/>
+          </a:fillRef>
+          <a:effectRef idx="2">
+            <a:schemeClr val="accent1"/>
+          </a:effectRef>
+          <a:fontRef idx="minor">
+            <a:schemeClr val="lt1"/>
+          </a:fontRef>
+        </p:style>
+        <p:txBody>
+          <a:bodyPr rtlCol="0" anchor="ctr"/>
+          <a:lstStyle/>
+          <a:p>
+            <a:pPr algn="ctr"/>
+            <a:endParaRPr/>
+          </a:p>
+        </p:txBody>
+      </p:sp>
+      <p:sp>
+        <p:nvSpPr>
+          <p:cNvPr id="6" name="TextBox 5"/>
+          <p:cNvSpPr txBox="1"/>
+          <p:nvPr/>
+        </p:nvSpPr>
+        <p:spPr>
+          <a:xfrm>
+            <a:off x="777240" y="1627632"/>
+            <a:ext cx="10607040" cy="457200"/>
+          </a:xfrm>
+          <a:prstGeom prst="rect">
+            <a:avLst/>
+          </a:prstGeom>
+          <a:noFill/>
+        </p:spPr>
+        <p:txBody>
+          <a:bodyPr wrap="square">
+            <a:spAutoFit/>
+          </a:bodyPr>
+          <a:lstStyle/>
+          <a:p>
+            <a:pPr algn="l">
+              <a:lnSpc>
+                <a:spcPct val="105000"/>
+              </a:lnSpc>
+              <a:spcAft>
+                <a:spcPts val="600"/>
+              </a:spcAft>
+            </a:pPr>
+            <a:r>
+              <a:rPr sz="1600" b="0">
+                <a:solidFill>
+                  <a:srgbClr val="605E5C"/>
+                </a:solidFill>
+                <a:latin typeface="Segoe UI"/>
+              </a:rPr>
+              <a:t>The store is a project data-plane service — reachable from a Web App, Container App or AKS over REST/SDK with Entra auth.</a:t>
+            </a:r>
+          </a:p>
+        </p:txBody>
+      </p:sp>
+      <p:sp>
+        <p:nvSpPr>
+          <p:cNvPr id="7" name="TextBox 6"/>
+          <p:cNvSpPr txBox="1"/>
+          <p:nvPr/>
+        </p:nvSpPr>
+        <p:spPr>
+          <a:xfrm>
+            <a:off x="640080" y="6419088"/>
+            <a:ext cx="7315200" cy="320040"/>
+          </a:xfrm>
+          <a:prstGeom prst="rect">
+            <a:avLst/>
+          </a:prstGeom>
+          <a:noFill/>
+        </p:spPr>
+        <p:txBody>
+          <a:bodyPr wrap="square">
+            <a:spAutoFit/>
+          </a:bodyPr>
+          <a:lstStyle/>
+          <a:p>
+            <a:pPr algn="l">
+              <a:lnSpc>
+                <a:spcPct val="100000"/>
+              </a:lnSpc>
+              <a:spcAft>
+                <a:spcPts val="600"/>
+              </a:spcAft>
+            </a:pPr>
+            <a:r>
+              <a:rPr sz="900" b="0">
+                <a:solidFill>
+                  <a:srgbClr val="605E5C"/>
+                </a:solidFill>
+                <a:latin typeface="Segoe UI"/>
+              </a:rPr>
+              <a:t>Prompt Shields vs. Guardrails  ·  Gislefoss Meteorologist Agent</a:t>
+            </a:r>
+          </a:p>
+        </p:txBody>
+      </p:sp>
+      <p:sp>
+        <p:nvSpPr>
+          <p:cNvPr id="8" name="TextBox 7"/>
+          <p:cNvSpPr txBox="1"/>
+          <p:nvPr/>
+        </p:nvSpPr>
+        <p:spPr>
+          <a:xfrm>
+            <a:off x="10972800" y="6419088"/>
+            <a:ext cx="822960" cy="320040"/>
+          </a:xfrm>
+          <a:prstGeom prst="rect">
+            <a:avLst/>
+          </a:prstGeom>
+          <a:noFill/>
+        </p:spPr>
+        <p:txBody>
+          <a:bodyPr wrap="square">
+            <a:spAutoFit/>
+          </a:bodyPr>
+          <a:lstStyle/>
+          <a:p>
+            <a:pPr algn="r">
+              <a:lnSpc>
+                <a:spcPct val="100000"/>
+              </a:lnSpc>
+              <a:spcAft>
+                <a:spcPts val="600"/>
+              </a:spcAft>
+            </a:pPr>
+            <a:r>
+              <a:rPr sz="900" b="0">
+                <a:solidFill>
+                  <a:srgbClr val="605E5C"/>
+                </a:solidFill>
+                <a:latin typeface="Segoe UI"/>
+              </a:rPr>
+              <a:t>12</a:t>
+            </a:r>
+          </a:p>
+        </p:txBody>
+      </p:sp>
+      <p:sp>
+        <p:nvSpPr>
+          <p:cNvPr id="9" name="Rounded Rectangle 8"/>
+          <p:cNvSpPr/>
+          <p:nvPr/>
+        </p:nvSpPr>
+        <p:spPr>
+          <a:xfrm>
+            <a:off x="777240" y="2240280"/>
+            <a:ext cx="5120640" cy="1783080"/>
+          </a:xfrm>
+          <a:prstGeom prst="roundRect">
+            <a:avLst>
+              <a:gd name="adj" fmla="val 5000"/>
+            </a:avLst>
+          </a:prstGeom>
+          <a:solidFill>
+            <a:srgbClr val="FFFFFF"/>
+          </a:solidFill>
+          <a:ln w="25400">
+            <a:solidFill>
+              <a:srgbClr val="0078D4"/>
+            </a:solidFill>
+          </a:ln>
+          <a:effectLst/>
+        </p:spPr>
+        <p:style>
+          <a:lnRef idx="1">
+            <a:schemeClr val="accent1"/>
+          </a:lnRef>
+          <a:fillRef idx="3">
+            <a:schemeClr val="accent1"/>
+          </a:fillRef>
+          <a:effectRef idx="2">
+            <a:schemeClr val="accent1"/>
+          </a:effectRef>
+          <a:fontRef idx="minor">
+            <a:schemeClr val="lt1"/>
+          </a:fontRef>
+        </p:style>
+        <p:txBody>
+          <a:bodyPr rtlCol="0" anchor="ctr"/>
+          <a:lstStyle/>
+          <a:p>
+            <a:pPr algn="ctr"/>
+            <a:endParaRPr/>
+          </a:p>
+        </p:txBody>
+      </p:sp>
+      <p:sp>
+        <p:nvSpPr>
+          <p:cNvPr id="10" name="TextBox 9"/>
+          <p:cNvSpPr txBox="1"/>
+          <p:nvPr/>
+        </p:nvSpPr>
+        <p:spPr>
+          <a:xfrm>
+            <a:off x="1033271" y="2404872"/>
+            <a:ext cx="4608576" cy="1472184"/>
+          </a:xfrm>
+          <a:prstGeom prst="rect">
+            <a:avLst/>
+          </a:prstGeom>
+          <a:noFill/>
+        </p:spPr>
+        <p:txBody>
+          <a:bodyPr wrap="square">
+            <a:normAutofit/>
+          </a:bodyPr>
+          <a:lstStyle/>
+          <a:p>
+            <a:pPr algn="l">
+              <a:lnSpc>
+                <a:spcPct val="100000"/>
+              </a:lnSpc>
+              <a:spcAft>
+                <a:spcPts val="300"/>
+              </a:spcAft>
+            </a:pPr>
+            <a:r>
+              <a:rPr sz="1300" b="1">
+                <a:solidFill>
+                  <a:srgbClr val="0078D4"/>
+                </a:solidFill>
+                <a:latin typeface="Segoe UI"/>
+              </a:rPr>
+              <a:t>EXTERNAL AGENTS · ANY HOST</a:t>
+            </a:r>
+          </a:p>
+          <a:p>
+            <a:pPr algn="l">
+              <a:lnSpc>
+                <a:spcPct val="102000"/>
+              </a:lnSpc>
+              <a:spcAft>
+                <a:spcPts val="400"/>
+              </a:spcAft>
+            </a:pPr>
+            <a:r>
+              <a:rPr sz="1400" b="1">
+                <a:solidFill>
+                  <a:srgbClr val="243A5E"/>
+                </a:solidFill>
+                <a:latin typeface="Segoe UI"/>
+              </a:rPr>
+              <a:t>Web App, Container App or AKS.</a:t>
+            </a:r>
+          </a:p>
+          <a:p>
+            <a:pPr algn="l">
+              <a:lnSpc>
+                <a:spcPct val="105000"/>
+              </a:lnSpc>
+              <a:spcAft>
+                <a:spcPts val="0"/>
+              </a:spcAft>
+            </a:pPr>
+            <a:r>
+              <a:rPr sz="1150" b="0">
+                <a:solidFill>
+                  <a:srgbClr val="605E5C"/>
+                </a:solidFill>
+                <a:latin typeface="Segoe UI"/>
+              </a:rPr>
+              <a:t>The memory store is a project data-plane resource, decoupled from where the agent runs. Call it over REST/SDK with a Microsoft Entra token (Foundry User role) — from AKS, via workload identity.</a:t>
+            </a:r>
+          </a:p>
+        </p:txBody>
+      </p:sp>
+      <p:sp>
+        <p:nvSpPr>
+          <p:cNvPr id="9" name="Rounded Rectangle 8"/>
+          <p:cNvSpPr/>
+          <p:nvPr/>
+        </p:nvSpPr>
+        <p:spPr>
+          <a:xfrm>
+            <a:off x="6263640" y="2240280"/>
+            <a:ext cx="5120640" cy="1783080"/>
+          </a:xfrm>
+          <a:prstGeom prst="roundRect">
+            <a:avLst>
+              <a:gd name="adj" fmla="val 5000"/>
+            </a:avLst>
+          </a:prstGeom>
+          <a:solidFill>
+            <a:srgbClr val="FFFFFF"/>
+          </a:solidFill>
+          <a:ln w="25400">
+            <a:solidFill>
+              <a:srgbClr val="107C10"/>
+            </a:solidFill>
+          </a:ln>
+          <a:effectLst/>
+        </p:spPr>
+        <p:style>
+          <a:lnRef idx="1">
+            <a:schemeClr val="accent1"/>
+          </a:lnRef>
+          <a:fillRef idx="3">
+            <a:schemeClr val="accent1"/>
+          </a:fillRef>
+          <a:effectRef idx="2">
+            <a:schemeClr val="accent1"/>
+          </a:effectRef>
+          <a:fontRef idx="minor">
+            <a:schemeClr val="lt1"/>
+          </a:fontRef>
+        </p:style>
+        <p:txBody>
+          <a:bodyPr rtlCol="0" anchor="ctr"/>
+          <a:lstStyle/>
+          <a:p>
+            <a:pPr algn="ctr"/>
+            <a:endParaRPr/>
+          </a:p>
+        </p:txBody>
+      </p:sp>
+      <p:sp>
+        <p:nvSpPr>
+          <p:cNvPr id="10" name="TextBox 9"/>
+          <p:cNvSpPr txBox="1"/>
+          <p:nvPr/>
+        </p:nvSpPr>
+        <p:spPr>
+          <a:xfrm>
+            <a:off x="6519672" y="2404872"/>
+            <a:ext cx="4608576" cy="1472184"/>
+          </a:xfrm>
+          <a:prstGeom prst="rect">
+            <a:avLst/>
+          </a:prstGeom>
+          <a:noFill/>
+        </p:spPr>
+        <p:txBody>
+          <a:bodyPr wrap="square">
+            <a:normAutofit/>
+          </a:bodyPr>
+          <a:lstStyle/>
+          <a:p>
+            <a:pPr algn="l">
+              <a:lnSpc>
+                <a:spcPct val="100000"/>
+              </a:lnSpc>
+              <a:spcAft>
+                <a:spcPts val="300"/>
+              </a:spcAft>
+            </a:pPr>
+            <a:r>
+              <a:rPr sz="1300" b="1">
+                <a:solidFill>
+                  <a:srgbClr val="107C10"/>
+                </a:solidFill>
+                <a:latin typeface="Segoe UI"/>
+              </a:rPr>
+              <a:t>TWO WAYS TO CALL IT</a:t>
+            </a:r>
+          </a:p>
+          <a:p>
+            <a:pPr algn="l">
+              <a:lnSpc>
+                <a:spcPct val="102000"/>
+              </a:lnSpc>
+              <a:spcAft>
+                <a:spcPts val="400"/>
+              </a:spcAft>
+            </a:pPr>
+            <a:r>
+              <a:rPr sz="1400" b="1">
+                <a:solidFill>
+                  <a:srgbClr val="243A5E"/>
+                </a:solidFill>
+                <a:latin typeface="Segoe UI"/>
+              </a:rPr>
+              <a:t>Search tool, or low-level APIs.</a:t>
+            </a:r>
+          </a:p>
+          <a:p>
+            <a:pPr algn="l">
+              <a:lnSpc>
+                <a:spcPct val="105000"/>
+              </a:lnSpc>
+              <a:spcAft>
+                <a:spcPts val="0"/>
+              </a:spcAft>
+            </a:pPr>
+            <a:r>
+              <a:rPr sz="1150" b="0">
+                <a:solidFill>
+                  <a:srgbClr val="605E5C"/>
+                </a:solidFill>
+                <a:latin typeface="Segoe UI"/>
+              </a:rPr>
+              <a:t>Attach the memory_search tool to a Foundry prompt agent (auto extract + retrieve via the Responses API), or drive the store yourself: update_memories / search_memories / item CRUD, passing scope on every call.</a:t>
+            </a:r>
+          </a:p>
+        </p:txBody>
+      </p:sp>
+      <p:sp>
+        <p:nvSpPr>
+          <p:cNvPr id="9" name="Rounded Rectangle 8"/>
+          <p:cNvSpPr/>
+          <p:nvPr/>
+        </p:nvSpPr>
+        <p:spPr>
+          <a:xfrm>
+            <a:off x="777240" y="4114800"/>
+            <a:ext cx="5120640" cy="1783080"/>
+          </a:xfrm>
+          <a:prstGeom prst="roundRect">
+            <a:avLst>
+              <a:gd name="adj" fmla="val 5000"/>
+            </a:avLst>
+          </a:prstGeom>
+          <a:solidFill>
+            <a:srgbClr val="FFFFFF"/>
+          </a:solidFill>
+          <a:ln w="25400">
+            <a:solidFill>
+              <a:srgbClr val="5C2D91"/>
+            </a:solidFill>
+          </a:ln>
+          <a:effectLst/>
+        </p:spPr>
+        <p:style>
+          <a:lnRef idx="1">
+            <a:schemeClr val="accent1"/>
+          </a:lnRef>
+          <a:fillRef idx="3">
+            <a:schemeClr val="accent1"/>
+          </a:fillRef>
+          <a:effectRef idx="2">
+            <a:schemeClr val="accent1"/>
+          </a:effectRef>
+          <a:fontRef idx="minor">
+            <a:schemeClr val="lt1"/>
+          </a:fontRef>
+        </p:style>
+        <p:txBody>
+          <a:bodyPr rtlCol="0" anchor="ctr"/>
+          <a:lstStyle/>
+          <a:p>
+            <a:pPr algn="ctr"/>
+            <a:endParaRPr/>
+          </a:p>
+        </p:txBody>
+      </p:sp>
+      <p:sp>
+        <p:nvSpPr>
+          <p:cNvPr id="10" name="TextBox 9"/>
+          <p:cNvSpPr txBox="1"/>
+          <p:nvPr/>
+        </p:nvSpPr>
+        <p:spPr>
+          <a:xfrm>
+            <a:off x="1033271" y="4279392"/>
+            <a:ext cx="4608576" cy="1472184"/>
+          </a:xfrm>
+          <a:prstGeom prst="rect">
+            <a:avLst/>
+          </a:prstGeom>
+          <a:noFill/>
+        </p:spPr>
+        <p:txBody>
+          <a:bodyPr wrap="square">
+            <a:normAutofit/>
+          </a:bodyPr>
+          <a:lstStyle/>
+          <a:p>
+            <a:pPr algn="l">
+              <a:lnSpc>
+                <a:spcPct val="100000"/>
+              </a:lnSpc>
+              <a:spcAft>
+                <a:spcPts val="300"/>
+              </a:spcAft>
+            </a:pPr>
+            <a:r>
+              <a:rPr sz="1300" b="1">
+                <a:solidFill>
+                  <a:srgbClr val="5C2D91"/>
+                </a:solidFill>
+                <a:latin typeface="Segoe UI"/>
+              </a:rPr>
+              <a:t>LIMITATIONS</a:t>
+            </a:r>
+          </a:p>
+          <a:p>
+            <a:pPr algn="l">
+              <a:lnSpc>
+                <a:spcPct val="102000"/>
+              </a:lnSpc>
+              <a:spcAft>
+                <a:spcPts val="400"/>
+              </a:spcAft>
+            </a:pPr>
+            <a:r>
+              <a:rPr sz="1400" b="1">
+                <a:solidFill>
+                  <a:srgbClr val="243A5E"/>
+                </a:solidFill>
+                <a:latin typeface="Segoe UI"/>
+              </a:rPr>
+              <a:t>Public endpoint, explicit scope.</a:t>
+            </a:r>
+          </a:p>
+          <a:p>
+            <a:pPr algn="l">
+              <a:lnSpc>
+                <a:spcPct val="105000"/>
+              </a:lnSpc>
+              <a:spcAft>
+                <a:spcPts val="0"/>
+              </a:spcAft>
+            </a:pPr>
+            <a:r>
+              <a:rPr sz="1150" b="0">
+                <a:solidFill>
+                  <a:srgbClr val="605E5C"/>
+                </a:solidFill>
+                <a:latin typeface="Segoe UI"/>
+              </a:rPr>
+              <a:t>No VNet / Private Link for memory stores — public data-plane only. Low-level calls need an explicit scope (no identity auto-resolution). Preview: some store options are create-time only; poisoning defense is yours.</a:t>
+            </a:r>
+          </a:p>
+        </p:txBody>
+      </p:sp>
+      <p:sp>
+        <p:nvSpPr>
+          <p:cNvPr id="9" name="Rounded Rectangle 8"/>
+          <p:cNvSpPr/>
+          <p:nvPr/>
+        </p:nvSpPr>
+        <p:spPr>
+          <a:xfrm>
+            <a:off x="6263640" y="4114800"/>
+            <a:ext cx="5120640" cy="1783080"/>
+          </a:xfrm>
+          <a:prstGeom prst="roundRect">
+            <a:avLst>
+              <a:gd name="adj" fmla="val 5000"/>
+            </a:avLst>
+          </a:prstGeom>
+          <a:solidFill>
+            <a:srgbClr val="FFFFFF"/>
+          </a:solidFill>
+          <a:ln w="25400">
+            <a:solidFill>
+              <a:srgbClr val="C5292A"/>
+            </a:solidFill>
+          </a:ln>
+          <a:effectLst/>
+        </p:spPr>
+        <p:style>
+          <a:lnRef idx="1">
+            <a:schemeClr val="accent1"/>
+          </a:lnRef>
+          <a:fillRef idx="3">
+            <a:schemeClr val="accent1"/>
+          </a:fillRef>
+          <a:effectRef idx="2">
+            <a:schemeClr val="accent1"/>
+          </a:effectRef>
+          <a:fontRef idx="minor">
+            <a:schemeClr val="lt1"/>
+          </a:fontRef>
+        </p:style>
+        <p:txBody>
+          <a:bodyPr rtlCol="0" anchor="ctr"/>
+          <a:lstStyle/>
+          <a:p>
+            <a:pPr algn="ctr"/>
+            <a:endParaRPr/>
+          </a:p>
+        </p:txBody>
+      </p:sp>
+      <p:sp>
+        <p:nvSpPr>
+          <p:cNvPr id="10" name="TextBox 9"/>
+          <p:cNvSpPr txBox="1"/>
+          <p:nvPr/>
+        </p:nvSpPr>
+        <p:spPr>
+          <a:xfrm>
+            <a:off x="6519672" y="4279392"/>
+            <a:ext cx="4608576" cy="1472184"/>
+          </a:xfrm>
+          <a:prstGeom prst="rect">
+            <a:avLst/>
+          </a:prstGeom>
+          <a:noFill/>
+        </p:spPr>
+        <p:txBody>
+          <a:bodyPr wrap="square">
+            <a:normAutofit/>
+          </a:bodyPr>
+          <a:lstStyle/>
+          <a:p>
+            <a:pPr algn="l">
+              <a:lnSpc>
+                <a:spcPct val="100000"/>
+              </a:lnSpc>
+              <a:spcAft>
+                <a:spcPts val="300"/>
+              </a:spcAft>
+            </a:pPr>
+            <a:r>
+              <a:rPr sz="1300" b="1">
+                <a:solidFill>
+                  <a:srgbClr val="C5292A"/>
+                </a:solidFill>
+                <a:latin typeface="Segoe UI"/>
+              </a:rPr>
+              <a:t>QUOTAS · MODEL DEPENDENCY</a:t>
+            </a:r>
+          </a:p>
+          <a:p>
+            <a:pPr algn="l">
+              <a:lnSpc>
+                <a:spcPct val="102000"/>
+              </a:lnSpc>
+              <a:spcAft>
+                <a:spcPts val="400"/>
+              </a:spcAft>
+            </a:pPr>
+            <a:r>
+              <a:rPr sz="1400" b="1">
+                <a:solidFill>
+                  <a:srgbClr val="243A5E"/>
+                </a:solidFill>
+                <a:latin typeface="Segoe UI"/>
+              </a:rPr>
+              <a:t>Per store; bring your own models.</a:t>
+            </a:r>
+          </a:p>
+          <a:p>
+            <a:pPr algn="l">
+              <a:lnSpc>
+                <a:spcPct val="105000"/>
+              </a:lnSpc>
+              <a:spcAft>
+                <a:spcPts val="0"/>
+              </a:spcAft>
+            </a:pPr>
+            <a:r>
+              <a:rPr sz="1150" b="0">
+                <a:solidFill>
+                  <a:srgbClr val="605E5C"/>
+                </a:solidFill>
+                <a:latin typeface="Segoe UI"/>
+              </a:rPr>
+              <a:t>100 scopes / store · 10,000 memories / scope · 1,000 search/min · 1,000 update/min. Requires compatible Azure OpenAI chat + embedding deployments in the project — you pay for that usage.</a:t>
+            </a:r>
+          </a:p>
+        </p:txBody>
+      </p:sp>
+      <p:sp>
+        <p:nvSpPr>
+          <p:cNvPr id="17" name="TextBox 16"/>
+          <p:cNvSpPr txBox="1"/>
+          <p:nvPr/>
+        </p:nvSpPr>
+        <p:spPr>
+          <a:xfrm>
+            <a:off x="777240" y="5989320"/>
+            <a:ext cx="10607040" cy="310896"/>
+          </a:xfrm>
+          <a:prstGeom prst="rect">
+            <a:avLst/>
+          </a:prstGeom>
+          <a:noFill/>
+        </p:spPr>
+        <p:txBody>
+          <a:bodyPr wrap="square">
+            <a:spAutoFit/>
+          </a:bodyPr>
+          <a:lstStyle/>
+          <a:p>
+            <a:pPr algn="l">
+              <a:lnSpc>
+                <a:spcPct val="100000"/>
+              </a:lnSpc>
+            </a:pPr>
+            <a:r>
+              <a:rPr sz="1250" b="1">
+                <a:solidFill>
+                  <a:srgbClr val="243A5E"/>
+                </a:solidFill>
+                <a:latin typeface="Segoe UI"/>
+              </a:rPr>
+              <a:t>Gislefoss's memory.bicep store is reachable from a Web App, Container App or AKS pod via the low-level APIs.</a:t>
             </a:r>
           </a:p>
         </p:txBody>

</xml_diff>

<commit_message>
Add a slide about Blocklists.
</commit_message>
<xml_diff>
--- a/docs/prompt-shields-vs-guardrails.pptx
+++ b/docs/prompt-shields-vs-guardrails.pptx
@@ -28,14 +28,15 @@
     <p:sldId id="261" r:id="rId22"/>
     <p:sldId id="268" r:id="rId23"/>
     <p:sldId id="271" r:id="rId24"/>
-    <p:sldId id="270" r:id="rId25"/>
-    <p:sldId id="265" r:id="rId26"/>
-    <p:sldId id="266" r:id="rId27"/>
-    <p:sldId id="267" r:id="rId28"/>
-    <p:sldId id="274" r:id="rId29"/>
-    <p:sldId id="275" r:id="rId30"/>
-    <p:sldId id="284" r:id="rId31"/>
-    <p:sldId id="288" r:id="rId32"/>
+    <p:sldId id="290" r:id="rId25"/>
+    <p:sldId id="270" r:id="rId26"/>
+    <p:sldId id="265" r:id="rId27"/>
+    <p:sldId id="266" r:id="rId28"/>
+    <p:sldId id="267" r:id="rId29"/>
+    <p:sldId id="274" r:id="rId30"/>
+    <p:sldId id="275" r:id="rId31"/>
+    <p:sldId id="284" r:id="rId32"/>
+    <p:sldId id="288" r:id="rId33"/>
   </p:sldIdLst>
   <p:sldSz cx="12192000" cy="6858000"/>
   <p:notesSz cx="6858000" cy="9144000"/>
@@ -19289,6 +19290,988 @@
 <file path=ppt/slides/slide24.xml><?xml version="1.0" encoding="utf-8"?>
 <p:sld xmlns:a="http://schemas.openxmlformats.org/drawingml/2006/main" xmlns:r="http://schemas.openxmlformats.org/officeDocument/2006/relationships" xmlns:p="http://schemas.openxmlformats.org/presentationml/2006/main">
   <p:cSld>
+    <p:spTree>
+      <p:nvGrpSpPr>
+        <p:cNvPr id="1" name=""/>
+        <p:cNvGrpSpPr/>
+        <p:nvPr/>
+      </p:nvGrpSpPr>
+      <p:grpSpPr>
+        <a:xfrm>
+          <a:off x="0" y="0"/>
+          <a:ext cx="0" cy="0"/>
+          <a:chOff x="0" y="0"/>
+          <a:chExt cx="0" cy="0"/>
+        </a:xfrm>
+      </p:grpSpPr>
+      <p:sp>
+        <p:nvSpPr>
+          <p:cNvPr id="2" name="Rectangle 1"/>
+          <p:cNvSpPr/>
+          <p:nvPr/>
+        </p:nvSpPr>
+        <p:spPr>
+          <a:xfrm>
+            <a:off x="0" y="0"/>
+            <a:ext cx="12188952" cy="164592"/>
+          </a:xfrm>
+          <a:prstGeom prst="rect">
+            <a:avLst/>
+          </a:prstGeom>
+          <a:solidFill>
+            <a:srgbClr val="0078D4"/>
+          </a:solidFill>
+          <a:ln>
+            <a:noFill/>
+          </a:ln>
+        </p:spPr>
+        <p:style>
+          <a:lnRef idx="1">
+            <a:schemeClr val="accent1"/>
+          </a:lnRef>
+          <a:fillRef idx="3">
+            <a:schemeClr val="accent1"/>
+          </a:fillRef>
+          <a:effectRef idx="2">
+            <a:schemeClr val="accent1"/>
+          </a:effectRef>
+          <a:fontRef idx="minor">
+            <a:schemeClr val="lt1"/>
+          </a:fontRef>
+        </p:style>
+        <p:txBody>
+          <a:bodyPr rtlCol="0" anchor="ctr"/>
+          <a:lstStyle/>
+          <a:p>
+            <a:pPr algn="ctr"/>
+            <a:endParaRPr/>
+          </a:p>
+        </p:txBody>
+      </p:sp>
+      <p:sp>
+        <p:nvSpPr>
+          <p:cNvPr id="3" name="TextBox 2"/>
+          <p:cNvSpPr txBox="1"/>
+          <p:nvPr/>
+        </p:nvSpPr>
+        <p:spPr>
+          <a:xfrm>
+            <a:off x="640080" y="411480"/>
+            <a:ext cx="10972800" cy="365760"/>
+          </a:xfrm>
+          <a:prstGeom prst="rect">
+            <a:avLst/>
+          </a:prstGeom>
+          <a:noFill/>
+        </p:spPr>
+        <p:txBody>
+          <a:bodyPr wrap="none">
+            <a:spAutoFit/>
+          </a:bodyPr>
+          <a:lstStyle/>
+          <a:p>
+            <a:r>
+              <a:rPr sz="1300" b="1">
+                <a:solidFill>
+                  <a:srgbClr val="0078D4"/>
+                </a:solidFill>
+                <a:latin typeface="Segoe UI"/>
+              </a:rPr>
+              <a:t>GUARDRAIL · CUSTOM PII BLOCKLIST</a:t>
+            </a:r>
+          </a:p>
+        </p:txBody>
+      </p:sp>
+      <p:sp>
+        <p:nvSpPr>
+          <p:cNvPr id="4" name="TextBox 3"/>
+          <p:cNvSpPr txBox="1"/>
+          <p:nvPr/>
+        </p:nvSpPr>
+        <p:spPr>
+          <a:xfrm>
+            <a:off x="640080" y="749808"/>
+            <a:ext cx="10972800" cy="822960"/>
+          </a:xfrm>
+          <a:prstGeom prst="rect">
+            <a:avLst/>
+          </a:prstGeom>
+          <a:noFill/>
+        </p:spPr>
+        <p:txBody>
+          <a:bodyPr wrap="none">
+            <a:spAutoFit/>
+          </a:bodyPr>
+          <a:lstStyle/>
+          <a:p>
+            <a:r>
+              <a:rPr sz="3000" b="1">
+                <a:solidFill>
+                  <a:srgbClr val="243A5E"/>
+                </a:solidFill>
+                <a:latin typeface="Segoe UI"/>
+              </a:rPr>
+              <a:t>Custom blocklist — PII patterns the Guardrail blocks</a:t>
+            </a:r>
+          </a:p>
+        </p:txBody>
+      </p:sp>
+      <p:sp>
+        <p:nvSpPr>
+          <p:cNvPr id="5" name="Rectangle 4"/>
+          <p:cNvSpPr/>
+          <p:nvPr/>
+        </p:nvSpPr>
+        <p:spPr>
+          <a:xfrm>
+            <a:off x="658368" y="1280160"/>
+            <a:ext cx="1005840" cy="45720"/>
+          </a:xfrm>
+          <a:prstGeom prst="rect">
+            <a:avLst/>
+          </a:prstGeom>
+          <a:solidFill>
+            <a:srgbClr val="0078D4"/>
+          </a:solidFill>
+          <a:ln>
+            <a:noFill/>
+          </a:ln>
+        </p:spPr>
+        <p:style>
+          <a:lnRef idx="1">
+            <a:schemeClr val="accent1"/>
+          </a:lnRef>
+          <a:fillRef idx="3">
+            <a:schemeClr val="accent1"/>
+          </a:fillRef>
+          <a:effectRef idx="2">
+            <a:schemeClr val="accent1"/>
+          </a:effectRef>
+          <a:fontRef idx="minor">
+            <a:schemeClr val="lt1"/>
+          </a:fontRef>
+        </p:style>
+        <p:txBody>
+          <a:bodyPr rtlCol="0" anchor="ctr"/>
+          <a:lstStyle/>
+          <a:p>
+            <a:pPr algn="ctr"/>
+            <a:endParaRPr/>
+          </a:p>
+        </p:txBody>
+      </p:sp>
+      <p:sp>
+        <p:nvSpPr>
+          <p:cNvPr id="6" name="TextBox 5"/>
+          <p:cNvSpPr txBox="1"/>
+          <p:nvPr/>
+        </p:nvSpPr>
+        <p:spPr>
+          <a:xfrm>
+            <a:off x="777240" y="1412220"/>
+            <a:ext cx="10698480" cy="923330"/>
+          </a:xfrm>
+          <a:prstGeom prst="rect">
+            <a:avLst/>
+          </a:prstGeom>
+          <a:noFill/>
+        </p:spPr>
+        <p:txBody>
+          <a:bodyPr wrap="square">
+            <a:spAutoFit/>
+          </a:bodyPr>
+          <a:lstStyle/>
+          <a:p>
+            <a:pPr algn="l"/>
+            <a:r>
+              <a:rPr sz="1350" b="1" dirty="0">
+                <a:solidFill>
+                  <a:srgbClr val="0078D4"/>
+                </a:solidFill>
+                <a:latin typeface="Segoe UI"/>
+              </a:rPr>
+              <a:t>What it is —</a:t>
+            </a:r>
+            <a:r>
+              <a:rPr lang="nb-NO" sz="1350" b="1" dirty="0">
+                <a:solidFill>
+                  <a:srgbClr val="0078D4"/>
+                </a:solidFill>
+                <a:latin typeface="Segoe UI"/>
+              </a:rPr>
+              <a:t> </a:t>
+            </a:r>
+            <a:r>
+              <a:rPr sz="1350" b="0" dirty="0">
+                <a:solidFill>
+                  <a:srgbClr val="201F1E"/>
+                </a:solidFill>
+                <a:latin typeface="Segoe UI"/>
+              </a:rPr>
+              <a:t>a custom blocklist asks </a:t>
+            </a:r>
+            <a:r>
+              <a:rPr sz="1350" b="1" dirty="0">
+                <a:solidFill>
+                  <a:srgbClr val="201F1E"/>
+                </a:solidFill>
+                <a:latin typeface="Segoe UI"/>
+              </a:rPr>
+              <a:t>“does this match a forbidden pattern?”</a:t>
+            </a:r>
+            <a:r>
+              <a:rPr sz="1350" b="0" dirty="0">
+                <a:solidFill>
+                  <a:srgbClr val="201F1E"/>
+                </a:solidFill>
+                <a:latin typeface="Segoe UI"/>
+              </a:rPr>
+              <a:t> — it blocks </a:t>
+            </a:r>
+            <a:r>
+              <a:rPr lang="nb-NO" sz="1350" b="1" dirty="0" err="1">
+                <a:solidFill>
+                  <a:srgbClr val="201F1E"/>
+                </a:solidFill>
+                <a:latin typeface="Segoe UI"/>
+              </a:rPr>
+              <a:t>Personally</a:t>
+            </a:r>
+            <a:r>
+              <a:rPr lang="nb-NO" sz="1350" b="1" dirty="0">
+                <a:solidFill>
+                  <a:srgbClr val="201F1E"/>
+                </a:solidFill>
+                <a:latin typeface="Segoe UI"/>
+              </a:rPr>
+              <a:t> </a:t>
+            </a:r>
+            <a:r>
+              <a:rPr lang="nb-NO" sz="1350" b="1" dirty="0" err="1">
+                <a:solidFill>
+                  <a:srgbClr val="201F1E"/>
+                </a:solidFill>
+                <a:latin typeface="Segoe UI"/>
+              </a:rPr>
+              <a:t>Identifiable</a:t>
+            </a:r>
+            <a:r>
+              <a:rPr lang="nb-NO" sz="1350" b="1" dirty="0">
+                <a:solidFill>
+                  <a:srgbClr val="201F1E"/>
+                </a:solidFill>
+                <a:latin typeface="Segoe UI"/>
+              </a:rPr>
+              <a:t> Information</a:t>
+            </a:r>
+            <a:r>
+              <a:rPr lang="nb-NO" sz="1350" b="0" dirty="0">
+                <a:solidFill>
+                  <a:srgbClr val="201F1E"/>
+                </a:solidFill>
+                <a:latin typeface="Segoe UI"/>
+              </a:rPr>
+              <a:t> (</a:t>
+            </a:r>
+            <a:r>
+              <a:rPr sz="1350" b="0" dirty="0">
+                <a:solidFill>
+                  <a:srgbClr val="201F1E"/>
+                </a:solidFill>
+                <a:latin typeface="Segoe UI"/>
+              </a:rPr>
+              <a:t>PII</a:t>
+            </a:r>
+            <a:r>
+              <a:rPr lang="nb-NO" sz="1350" dirty="0">
+                <a:solidFill>
+                  <a:srgbClr val="201F1E"/>
+                </a:solidFill>
+                <a:latin typeface="Segoe UI"/>
+              </a:rPr>
+              <a:t>)</a:t>
+            </a:r>
+            <a:r>
+              <a:rPr sz="1350" b="0" dirty="0">
+                <a:solidFill>
+                  <a:srgbClr val="201F1E"/>
+                </a:solidFill>
+                <a:latin typeface="Segoe UI"/>
+              </a:rPr>
+              <a:t>, secrets or names the built-in categories.</a:t>
+            </a:r>
+            <a:r>
+              <a:rPr lang="nb-NO" sz="1350" b="0" dirty="0">
+                <a:solidFill>
+                  <a:srgbClr val="201F1E"/>
+                </a:solidFill>
+                <a:latin typeface="Segoe UI"/>
+              </a:rPr>
+              <a:t> </a:t>
+            </a:r>
+          </a:p>
+          <a:p>
+            <a:pPr algn="l"/>
+            <a:r>
+              <a:rPr lang="en-US" sz="1350" b="1" dirty="0">
+                <a:solidFill>
+                  <a:schemeClr val="tx2">
+                    <a:lumMod val="60000"/>
+                    <a:lumOff val="40000"/>
+                  </a:schemeClr>
+                </a:solidFill>
+                <a:latin typeface="Segoe UI"/>
+              </a:rPr>
+              <a:t>How it works - </a:t>
+            </a:r>
+            <a:r>
+              <a:rPr lang="en-US" sz="1350" dirty="0">
+                <a:solidFill>
+                  <a:srgbClr val="201F1E"/>
+                </a:solidFill>
+                <a:latin typeface="Segoe UI"/>
+              </a:rPr>
+              <a:t>When a user pastes their email into a question, the call gets rejected (HTTP 400) before that PII reaches the model or gets stored.</a:t>
+            </a:r>
+            <a:endParaRPr sz="1350" b="0" dirty="0">
+              <a:solidFill>
+                <a:srgbClr val="201F1E"/>
+              </a:solidFill>
+              <a:latin typeface="Segoe UI"/>
+            </a:endParaRPr>
+          </a:p>
+        </p:txBody>
+      </p:sp>
+      <p:graphicFrame>
+        <p:nvGraphicFramePr>
+          <p:cNvPr id="7" name="Table 6"/>
+          <p:cNvGraphicFramePr>
+            <a:graphicFrameLocks noGrp="1"/>
+          </p:cNvGraphicFramePr>
+          <p:nvPr/>
+        </p:nvGraphicFramePr>
+        <p:xfrm>
+          <a:off x="777240" y="2331720"/>
+          <a:ext cx="10698480" cy="3017520"/>
+        </p:xfrm>
+        <a:graphic>
+          <a:graphicData uri="http://schemas.openxmlformats.org/drawingml/2006/table">
+            <a:tbl>
+              <a:tblPr>
+                <a:tableStyleId>{5C22544A-7EE6-4342-B048-85BDC9FD1C3A}</a:tableStyleId>
+              </a:tblPr>
+              <a:tblGrid>
+                <a:gridCol w="1828800">
+                  <a:extLst>
+                    <a:ext uri="{9D8B030D-6E8A-4147-A177-3AD203B41FA5}">
+                      <a16:colId xmlns:a16="http://schemas.microsoft.com/office/drawing/2014/main" val="20000"/>
+                    </a:ext>
+                  </a:extLst>
+                </a:gridCol>
+                <a:gridCol w="3291840">
+                  <a:extLst>
+                    <a:ext uri="{9D8B030D-6E8A-4147-A177-3AD203B41FA5}">
+                      <a16:colId xmlns:a16="http://schemas.microsoft.com/office/drawing/2014/main" val="20001"/>
+                    </a:ext>
+                  </a:extLst>
+                </a:gridCol>
+                <a:gridCol w="5577840">
+                  <a:extLst>
+                    <a:ext uri="{9D8B030D-6E8A-4147-A177-3AD203B41FA5}">
+                      <a16:colId xmlns:a16="http://schemas.microsoft.com/office/drawing/2014/main" val="20002"/>
+                    </a:ext>
+                  </a:extLst>
+                </a:gridCol>
+              </a:tblGrid>
+              <a:tr h="457200">
+                <a:tc>
+                  <a:txBody>
+                    <a:bodyPr/>
+                    <a:lstStyle/>
+                    <a:p>
+                      <a:r>
+                        <a:rPr sz="1350" b="1">
+                          <a:solidFill>
+                            <a:srgbClr val="FFFFFF"/>
+                          </a:solidFill>
+                          <a:latin typeface="Segoe UI"/>
+                        </a:rPr>
+                        <a:t>Blocklist item</a:t>
+                      </a:r>
+                    </a:p>
+                  </a:txBody>
+                  <a:tcPr marR="73152" marT="18288" marB="18288" anchor="ctr">
+                    <a:solidFill>
+                      <a:srgbClr val="243A5E"/>
+                    </a:solidFill>
+                  </a:tcPr>
+                </a:tc>
+                <a:tc>
+                  <a:txBody>
+                    <a:bodyPr/>
+                    <a:lstStyle/>
+                    <a:p>
+                      <a:r>
+                        <a:rPr sz="1350" b="1">
+                          <a:solidFill>
+                            <a:srgbClr val="FFFFFF"/>
+                          </a:solidFill>
+                          <a:latin typeface="Segoe UI"/>
+                        </a:rPr>
+                        <a:t>What it catches</a:t>
+                      </a:r>
+                    </a:p>
+                  </a:txBody>
+                  <a:tcPr marR="73152" marT="18288" marB="18288" anchor="ctr">
+                    <a:solidFill>
+                      <a:srgbClr val="243A5E"/>
+                    </a:solidFill>
+                  </a:tcPr>
+                </a:tc>
+                <a:tc>
+                  <a:txBody>
+                    <a:bodyPr/>
+                    <a:lstStyle/>
+                    <a:p>
+                      <a:r>
+                        <a:rPr sz="1350" b="1">
+                          <a:solidFill>
+                            <a:srgbClr val="FFFFFF"/>
+                          </a:solidFill>
+                          <a:latin typeface="Segoe UI"/>
+                        </a:rPr>
+                        <a:t>Regex  ·  isRegex=true, unanchored</a:t>
+                      </a:r>
+                    </a:p>
+                  </a:txBody>
+                  <a:tcPr marR="73152" marT="18288" marB="18288" anchor="ctr">
+                    <a:solidFill>
+                      <a:srgbClr val="243A5E"/>
+                    </a:solidFill>
+                  </a:tcPr>
+                </a:tc>
+                <a:extLst>
+                  <a:ext uri="{0D108BD9-81ED-4DB2-BD59-A6C34878D82A}">
+                    <a16:rowId xmlns:a16="http://schemas.microsoft.com/office/drawing/2014/main" val="10000"/>
+                  </a:ext>
+                </a:extLst>
+              </a:tr>
+              <a:tr h="512064">
+                <a:tc>
+                  <a:txBody>
+                    <a:bodyPr/>
+                    <a:lstStyle/>
+                    <a:p>
+                      <a:r>
+                        <a:rPr sz="1250" b="1">
+                          <a:solidFill>
+                            <a:srgbClr val="243A5E"/>
+                          </a:solidFill>
+                          <a:latin typeface="Consolas"/>
+                        </a:rPr>
+                        <a:t>email</a:t>
+                      </a:r>
+                    </a:p>
+                  </a:txBody>
+                  <a:tcPr marR="73152" marT="18288" marB="18288" anchor="ctr">
+                    <a:solidFill>
+                      <a:srgbClr val="FFFFFF"/>
+                    </a:solidFill>
+                  </a:tcPr>
+                </a:tc>
+                <a:tc>
+                  <a:txBody>
+                    <a:bodyPr/>
+                    <a:lstStyle/>
+                    <a:p>
+                      <a:r>
+                        <a:rPr sz="1250" b="0">
+                          <a:solidFill>
+                            <a:srgbClr val="201F1E"/>
+                          </a:solidFill>
+                          <a:latin typeface="Segoe UI"/>
+                        </a:rPr>
+                        <a:t>E-mail addresses</a:t>
+                      </a:r>
+                    </a:p>
+                  </a:txBody>
+                  <a:tcPr marR="73152" marT="18288" marB="18288" anchor="ctr">
+                    <a:solidFill>
+                      <a:srgbClr val="FFFFFF"/>
+                    </a:solidFill>
+                  </a:tcPr>
+                </a:tc>
+                <a:tc>
+                  <a:txBody>
+                    <a:bodyPr/>
+                    <a:lstStyle/>
+                    <a:p>
+                      <a:r>
+                        <a:rPr sz="1100" b="0">
+                          <a:solidFill>
+                            <a:srgbClr val="8A1F11"/>
+                          </a:solidFill>
+                          <a:latin typeface="Consolas"/>
+                        </a:rPr>
+                        <a:t>[A-Za-z0-9._%+-]+@[A-Za-z0-9.-]+\.[A-Za-z]{2,}</a:t>
+                      </a:r>
+                    </a:p>
+                  </a:txBody>
+                  <a:tcPr marR="73152" marT="18288" marB="18288" anchor="ctr">
+                    <a:solidFill>
+                      <a:srgbClr val="FFFFFF"/>
+                    </a:solidFill>
+                  </a:tcPr>
+                </a:tc>
+                <a:extLst>
+                  <a:ext uri="{0D108BD9-81ED-4DB2-BD59-A6C34878D82A}">
+                    <a16:rowId xmlns:a16="http://schemas.microsoft.com/office/drawing/2014/main" val="10001"/>
+                  </a:ext>
+                </a:extLst>
+              </a:tr>
+              <a:tr h="512064">
+                <a:tc>
+                  <a:txBody>
+                    <a:bodyPr/>
+                    <a:lstStyle/>
+                    <a:p>
+                      <a:r>
+                        <a:rPr sz="1250" b="1">
+                          <a:solidFill>
+                            <a:srgbClr val="243A5E"/>
+                          </a:solidFill>
+                          <a:latin typeface="Consolas"/>
+                        </a:rPr>
+                        <a:t>us-ssn</a:t>
+                      </a:r>
+                    </a:p>
+                  </a:txBody>
+                  <a:tcPr marR="73152" marT="18288" marB="18288" anchor="ctr">
+                    <a:solidFill>
+                      <a:srgbClr val="F3F2F1"/>
+                    </a:solidFill>
+                  </a:tcPr>
+                </a:tc>
+                <a:tc>
+                  <a:txBody>
+                    <a:bodyPr/>
+                    <a:lstStyle/>
+                    <a:p>
+                      <a:r>
+                        <a:rPr sz="1250" b="0">
+                          <a:solidFill>
+                            <a:srgbClr val="201F1E"/>
+                          </a:solidFill>
+                          <a:latin typeface="Segoe UI"/>
+                        </a:rPr>
+                        <a:t>US Social-Security numbers</a:t>
+                      </a:r>
+                    </a:p>
+                  </a:txBody>
+                  <a:tcPr marR="73152" marT="18288" marB="18288" anchor="ctr">
+                    <a:solidFill>
+                      <a:srgbClr val="F3F2F1"/>
+                    </a:solidFill>
+                  </a:tcPr>
+                </a:tc>
+                <a:tc>
+                  <a:txBody>
+                    <a:bodyPr/>
+                    <a:lstStyle/>
+                    <a:p>
+                      <a:r>
+                        <a:rPr sz="1100" b="0">
+                          <a:solidFill>
+                            <a:srgbClr val="8A1F11"/>
+                          </a:solidFill>
+                          <a:latin typeface="Consolas"/>
+                        </a:rPr>
+                        <a:t>\b\d{3}-\d{2}-\d{4}\b</a:t>
+                      </a:r>
+                    </a:p>
+                  </a:txBody>
+                  <a:tcPr marR="73152" marT="18288" marB="18288" anchor="ctr">
+                    <a:solidFill>
+                      <a:srgbClr val="F3F2F1"/>
+                    </a:solidFill>
+                  </a:tcPr>
+                </a:tc>
+                <a:extLst>
+                  <a:ext uri="{0D108BD9-81ED-4DB2-BD59-A6C34878D82A}">
+                    <a16:rowId xmlns:a16="http://schemas.microsoft.com/office/drawing/2014/main" val="10002"/>
+                  </a:ext>
+                </a:extLst>
+              </a:tr>
+              <a:tr h="512064">
+                <a:tc>
+                  <a:txBody>
+                    <a:bodyPr/>
+                    <a:lstStyle/>
+                    <a:p>
+                      <a:r>
+                        <a:rPr sz="1250" b="1">
+                          <a:solidFill>
+                            <a:srgbClr val="243A5E"/>
+                          </a:solidFill>
+                          <a:latin typeface="Consolas"/>
+                        </a:rPr>
+                        <a:t>credit-card</a:t>
+                      </a:r>
+                    </a:p>
+                  </a:txBody>
+                  <a:tcPr marR="73152" marT="18288" marB="18288" anchor="ctr">
+                    <a:solidFill>
+                      <a:srgbClr val="FFFFFF"/>
+                    </a:solidFill>
+                  </a:tcPr>
+                </a:tc>
+                <a:tc>
+                  <a:txBody>
+                    <a:bodyPr/>
+                    <a:lstStyle/>
+                    <a:p>
+                      <a:r>
+                        <a:rPr sz="1250" b="0">
+                          <a:solidFill>
+                            <a:srgbClr val="201F1E"/>
+                          </a:solidFill>
+                          <a:latin typeface="Segoe UI"/>
+                        </a:rPr>
+                        <a:t>16-digit payment-card numbers</a:t>
+                      </a:r>
+                    </a:p>
+                  </a:txBody>
+                  <a:tcPr marR="73152" marT="18288" marB="18288" anchor="ctr">
+                    <a:solidFill>
+                      <a:srgbClr val="FFFFFF"/>
+                    </a:solidFill>
+                  </a:tcPr>
+                </a:tc>
+                <a:tc>
+                  <a:txBody>
+                    <a:bodyPr/>
+                    <a:lstStyle/>
+                    <a:p>
+                      <a:r>
+                        <a:rPr sz="1100" b="0">
+                          <a:solidFill>
+                            <a:srgbClr val="8A1F11"/>
+                          </a:solidFill>
+                          <a:latin typeface="Consolas"/>
+                        </a:rPr>
+                        <a:t>\b\d{4}[- ]?\d{4}[- ]?\d{4}[- ]?\d{4}\b</a:t>
+                      </a:r>
+                    </a:p>
+                  </a:txBody>
+                  <a:tcPr marR="73152" marT="18288" marB="18288" anchor="ctr">
+                    <a:solidFill>
+                      <a:srgbClr val="FFFFFF"/>
+                    </a:solidFill>
+                  </a:tcPr>
+                </a:tc>
+                <a:extLst>
+                  <a:ext uri="{0D108BD9-81ED-4DB2-BD59-A6C34878D82A}">
+                    <a16:rowId xmlns:a16="http://schemas.microsoft.com/office/drawing/2014/main" val="10003"/>
+                  </a:ext>
+                </a:extLst>
+              </a:tr>
+              <a:tr h="512064">
+                <a:tc>
+                  <a:txBody>
+                    <a:bodyPr/>
+                    <a:lstStyle/>
+                    <a:p>
+                      <a:r>
+                        <a:rPr sz="1250" b="1">
+                          <a:solidFill>
+                            <a:srgbClr val="243A5E"/>
+                          </a:solidFill>
+                          <a:latin typeface="Consolas"/>
+                        </a:rPr>
+                        <a:t>us-phone</a:t>
+                      </a:r>
+                    </a:p>
+                  </a:txBody>
+                  <a:tcPr marR="73152" marT="18288" marB="18288" anchor="ctr">
+                    <a:solidFill>
+                      <a:srgbClr val="F3F2F1"/>
+                    </a:solidFill>
+                  </a:tcPr>
+                </a:tc>
+                <a:tc>
+                  <a:txBody>
+                    <a:bodyPr/>
+                    <a:lstStyle/>
+                    <a:p>
+                      <a:r>
+                        <a:rPr sz="1250" b="0">
+                          <a:solidFill>
+                            <a:srgbClr val="201F1E"/>
+                          </a:solidFill>
+                          <a:latin typeface="Segoe UI"/>
+                        </a:rPr>
+                        <a:t>US phone numbers</a:t>
+                      </a:r>
+                    </a:p>
+                  </a:txBody>
+                  <a:tcPr marR="73152" marT="18288" marB="18288" anchor="ctr">
+                    <a:solidFill>
+                      <a:srgbClr val="F3F2F1"/>
+                    </a:solidFill>
+                  </a:tcPr>
+                </a:tc>
+                <a:tc>
+                  <a:txBody>
+                    <a:bodyPr/>
+                    <a:lstStyle/>
+                    <a:p>
+                      <a:r>
+                        <a:rPr sz="1100" b="0">
+                          <a:solidFill>
+                            <a:srgbClr val="8A1F11"/>
+                          </a:solidFill>
+                          <a:latin typeface="Consolas"/>
+                        </a:rPr>
+                        <a:t>\b\d{3}[-.]?\d{3}[-.]?\d{4}\b</a:t>
+                      </a:r>
+                    </a:p>
+                  </a:txBody>
+                  <a:tcPr marR="73152" marT="18288" marB="18288" anchor="ctr">
+                    <a:solidFill>
+                      <a:srgbClr val="F3F2F1"/>
+                    </a:solidFill>
+                  </a:tcPr>
+                </a:tc>
+                <a:extLst>
+                  <a:ext uri="{0D108BD9-81ED-4DB2-BD59-A6C34878D82A}">
+                    <a16:rowId xmlns:a16="http://schemas.microsoft.com/office/drawing/2014/main" val="10004"/>
+                  </a:ext>
+                </a:extLst>
+              </a:tr>
+              <a:tr h="512064">
+                <a:tc>
+                  <a:txBody>
+                    <a:bodyPr/>
+                    <a:lstStyle/>
+                    <a:p>
+                      <a:r>
+                        <a:rPr sz="1250" b="1">
+                          <a:solidFill>
+                            <a:srgbClr val="243A5E"/>
+                          </a:solidFill>
+                          <a:latin typeface="Consolas"/>
+                        </a:rPr>
+                        <a:t>ipv4</a:t>
+                      </a:r>
+                    </a:p>
+                  </a:txBody>
+                  <a:tcPr marR="73152" marT="18288" marB="18288" anchor="ctr">
+                    <a:solidFill>
+                      <a:srgbClr val="FFFFFF"/>
+                    </a:solidFill>
+                  </a:tcPr>
+                </a:tc>
+                <a:tc>
+                  <a:txBody>
+                    <a:bodyPr/>
+                    <a:lstStyle/>
+                    <a:p>
+                      <a:r>
+                        <a:rPr sz="1250" b="0">
+                          <a:solidFill>
+                            <a:srgbClr val="201F1E"/>
+                          </a:solidFill>
+                          <a:latin typeface="Segoe UI"/>
+                        </a:rPr>
+                        <a:t>IPv4 addresses</a:t>
+                      </a:r>
+                    </a:p>
+                  </a:txBody>
+                  <a:tcPr marR="73152" marT="18288" marB="18288" anchor="ctr">
+                    <a:solidFill>
+                      <a:srgbClr val="FFFFFF"/>
+                    </a:solidFill>
+                  </a:tcPr>
+                </a:tc>
+                <a:tc>
+                  <a:txBody>
+                    <a:bodyPr/>
+                    <a:lstStyle/>
+                    <a:p>
+                      <a:r>
+                        <a:rPr sz="1100" b="0">
+                          <a:solidFill>
+                            <a:srgbClr val="8A1F11"/>
+                          </a:solidFill>
+                          <a:latin typeface="Consolas"/>
+                        </a:rPr>
+                        <a:t>\b\d{1,3}\.\d{1,3}\.\d{1,3}\.\d{1,3}\b</a:t>
+                      </a:r>
+                    </a:p>
+                  </a:txBody>
+                  <a:tcPr marR="73152" marT="18288" marB="18288" anchor="ctr">
+                    <a:solidFill>
+                      <a:srgbClr val="FFFFFF"/>
+                    </a:solidFill>
+                  </a:tcPr>
+                </a:tc>
+                <a:extLst>
+                  <a:ext uri="{0D108BD9-81ED-4DB2-BD59-A6C34878D82A}">
+                    <a16:rowId xmlns:a16="http://schemas.microsoft.com/office/drawing/2014/main" val="10005"/>
+                  </a:ext>
+                </a:extLst>
+              </a:tr>
+            </a:tbl>
+          </a:graphicData>
+        </a:graphic>
+      </p:graphicFrame>
+      <p:sp>
+        <p:nvSpPr>
+          <p:cNvPr id="8" name="TextBox 7"/>
+          <p:cNvSpPr txBox="1"/>
+          <p:nvPr/>
+        </p:nvSpPr>
+        <p:spPr>
+          <a:xfrm>
+            <a:off x="777240" y="5413248"/>
+            <a:ext cx="10698480" cy="320040"/>
+          </a:xfrm>
+          <a:prstGeom prst="rect">
+            <a:avLst/>
+          </a:prstGeom>
+          <a:noFill/>
+        </p:spPr>
+        <p:txBody>
+          <a:bodyPr wrap="square">
+            <a:spAutoFit/>
+          </a:bodyPr>
+          <a:lstStyle/>
+          <a:p>
+            <a:r>
+              <a:rPr sz="1050" b="0">
+                <a:solidFill>
+                  <a:srgbClr val="605E5C"/>
+                </a:solidFill>
+                <a:latin typeface="Segoe UI"/>
+              </a:rPr>
+              <a:t>Regex shown as compiled — Bicep doubles each backslash (\\d → \d). Demo-grade: illustrative, not production-strength PII detection.</a:t>
+            </a:r>
+          </a:p>
+        </p:txBody>
+      </p:sp>
+      <p:sp>
+        <p:nvSpPr>
+          <p:cNvPr id="9" name="TextBox 8"/>
+          <p:cNvSpPr txBox="1"/>
+          <p:nvPr/>
+        </p:nvSpPr>
+        <p:spPr>
+          <a:xfrm>
+            <a:off x="777240" y="5742432"/>
+            <a:ext cx="10698480" cy="640080"/>
+          </a:xfrm>
+          <a:prstGeom prst="rect">
+            <a:avLst/>
+          </a:prstGeom>
+          <a:noFill/>
+        </p:spPr>
+        <p:txBody>
+          <a:bodyPr wrap="square">
+            <a:spAutoFit/>
+          </a:bodyPr>
+          <a:lstStyle/>
+          <a:p>
+            <a:r>
+              <a:rPr sz="1300" b="0">
+                <a:solidFill>
+                  <a:srgbClr val="605E5C"/>
+                </a:solidFill>
+                <a:latin typeface="Segoe UI"/>
+              </a:rPr>
+              <a:t>Unanchored — fires on PII embedded anywhere, in input and output alike. A hit returns HTTP 400 content_filter (custom_blocklists[].filtered=true). Gated by deployBlocklist, layered on top of the built-in harm + Prompt-Shield filters.</a:t>
+            </a:r>
+          </a:p>
+        </p:txBody>
+      </p:sp>
+      <p:sp>
+        <p:nvSpPr>
+          <p:cNvPr id="10" name="TextBox 9"/>
+          <p:cNvSpPr txBox="1"/>
+          <p:nvPr/>
+        </p:nvSpPr>
+        <p:spPr>
+          <a:xfrm>
+            <a:off x="640080" y="6419088"/>
+            <a:ext cx="7315200" cy="320040"/>
+          </a:xfrm>
+          <a:prstGeom prst="rect">
+            <a:avLst/>
+          </a:prstGeom>
+          <a:noFill/>
+        </p:spPr>
+        <p:txBody>
+          <a:bodyPr wrap="none">
+            <a:spAutoFit/>
+          </a:bodyPr>
+          <a:lstStyle/>
+          <a:p>
+            <a:r>
+              <a:rPr sz="900" b="0">
+                <a:solidFill>
+                  <a:srgbClr val="605E5C"/>
+                </a:solidFill>
+                <a:latin typeface="Segoe UI"/>
+              </a:rPr>
+              <a:t>AI FOUNDRY  ·  security, features and capabilities</a:t>
+            </a:r>
+          </a:p>
+        </p:txBody>
+      </p:sp>
+      <p:sp>
+        <p:nvSpPr>
+          <p:cNvPr id="11" name="TextBox 10"/>
+          <p:cNvSpPr txBox="1"/>
+          <p:nvPr/>
+        </p:nvSpPr>
+        <p:spPr>
+          <a:xfrm>
+            <a:off x="10972800" y="6419088"/>
+            <a:ext cx="822960" cy="320040"/>
+          </a:xfrm>
+          <a:prstGeom prst="rect">
+            <a:avLst/>
+          </a:prstGeom>
+          <a:noFill/>
+        </p:spPr>
+        <p:txBody>
+          <a:bodyPr wrap="none">
+            <a:spAutoFit/>
+          </a:bodyPr>
+          <a:lstStyle/>
+          <a:p>
+            <a:r>
+              <a:rPr sz="900" b="0">
+                <a:solidFill>
+                  <a:srgbClr val="605E5C"/>
+                </a:solidFill>
+                <a:latin typeface="Segoe UI"/>
+              </a:rPr>
+              <a:t>16</a:t>
+            </a:r>
+          </a:p>
+        </p:txBody>
+      </p:sp>
+    </p:spTree>
+  </p:cSld>
+  <p:clrMapOvr>
+    <a:masterClrMapping/>
+  </p:clrMapOvr>
+</p:sld>
+</file>
+
+<file path=ppt/slides/slide25.xml><?xml version="1.0" encoding="utf-8"?>
+<p:sld xmlns:a="http://schemas.openxmlformats.org/drawingml/2006/main" xmlns:r="http://schemas.openxmlformats.org/officeDocument/2006/relationships" xmlns:p="http://schemas.openxmlformats.org/presentationml/2006/main">
+  <p:cSld>
     <p:bg>
       <p:bgPr>
         <a:solidFill>
@@ -19903,12 +20886,238 @@
             <a:r>
               <a:rPr sz="1250" dirty="0">
                 <a:solidFill>
+                  <a:schemeClr val="tx2">
+                    <a:lumMod val="40000"/>
+                    <a:lumOff val="60000"/>
+                  </a:schemeClr>
+                </a:solidFill>
+                <a:latin typeface="Consolas"/>
+              </a:rPr>
+              <a:t>    </a:t>
+            </a:r>
+            <a:r>
+              <a:rPr sz="1250" dirty="0">
+                <a:solidFill>
                   <a:srgbClr val="D4D4D4"/>
                 </a:solidFill>
                 <a:latin typeface="Consolas"/>
               </a:rPr>
-              <a:t>    ]</a:t>
-            </a:r>
+              <a:t>]</a:t>
+            </a:r>
+            <a:endParaRPr lang="nb-NO" sz="1250" dirty="0">
+              <a:solidFill>
+                <a:srgbClr val="D4D4D4"/>
+              </a:solidFill>
+              <a:latin typeface="Consolas"/>
+            </a:endParaRPr>
+          </a:p>
+          <a:p>
+            <a:r>
+              <a:rPr lang="ru-RU" sz="1250" dirty="0">
+                <a:solidFill>
+                  <a:schemeClr val="tx2">
+                    <a:lumMod val="60000"/>
+                    <a:lumOff val="40000"/>
+                  </a:schemeClr>
+                </a:solidFill>
+                <a:latin typeface="Consolas"/>
+              </a:rPr>
+              <a:t>    // Custom PII blocklist     </a:t>
+            </a:r>
+            <a:endParaRPr lang="nb-NO" sz="1250" dirty="0">
+              <a:solidFill>
+                <a:schemeClr val="tx2">
+                  <a:lumMod val="60000"/>
+                  <a:lumOff val="40000"/>
+                </a:schemeClr>
+              </a:solidFill>
+              <a:latin typeface="Consolas"/>
+            </a:endParaRPr>
+          </a:p>
+          <a:p>
+            <a:r>
+              <a:rPr lang="nb-NO" sz="1250" b="1" dirty="0">
+                <a:solidFill>
+                  <a:schemeClr val="tx2">
+                    <a:lumMod val="40000"/>
+                    <a:lumOff val="60000"/>
+                  </a:schemeClr>
+                </a:solidFill>
+                <a:latin typeface="Consolas"/>
+              </a:rPr>
+              <a:t>   </a:t>
+            </a:r>
+            <a:r>
+              <a:rPr lang="ru-RU" sz="1250" b="1" dirty="0">
+                <a:solidFill>
+                  <a:schemeClr val="tx2">
+                    <a:lumMod val="40000"/>
+                    <a:lumOff val="60000"/>
+                  </a:schemeClr>
+                </a:solidFill>
+                <a:latin typeface="Consolas"/>
+              </a:rPr>
+              <a:t>customBlocklists: deployBlocklist ? [</a:t>
+            </a:r>
+          </a:p>
+          <a:p>
+            <a:pPr>
+              <a:lnSpc>
+                <a:spcPts val="1425"/>
+              </a:lnSpc>
+              <a:buNone/>
+            </a:pPr>
+            <a:r>
+              <a:rPr lang="ru-RU" sz="1250" b="1" dirty="0">
+                <a:solidFill>
+                  <a:schemeClr val="tx2">
+                    <a:lumMod val="40000"/>
+                    <a:lumOff val="60000"/>
+                  </a:schemeClr>
+                </a:solidFill>
+                <a:latin typeface="Consolas"/>
+              </a:rPr>
+              <a:t>      { blocklistName: blocklistName, blocking: true, source: 'Prompt’ }</a:t>
+            </a:r>
+            <a:r>
+              <a:rPr lang="nb-NO" sz="1250" b="1" dirty="0">
+                <a:solidFill>
+                  <a:schemeClr val="tx2">
+                    <a:lumMod val="40000"/>
+                    <a:lumOff val="60000"/>
+                  </a:schemeClr>
+                </a:solidFill>
+                <a:latin typeface="Consolas"/>
+              </a:rPr>
+              <a:t>      // </a:t>
+            </a:r>
+            <a:r>
+              <a:rPr lang="ru-RU" sz="1250" dirty="0">
+                <a:solidFill>
+                  <a:schemeClr val="tx2">
+                    <a:lumMod val="60000"/>
+                    <a:lumOff val="40000"/>
+                  </a:schemeClr>
+                </a:solidFill>
+                <a:latin typeface="Consolas"/>
+              </a:rPr>
+              <a:t>PII blocklist</a:t>
+            </a:r>
+            <a:r>
+              <a:rPr lang="nb-NO" sz="1250" dirty="0">
+                <a:solidFill>
+                  <a:schemeClr val="tx2">
+                    <a:lumMod val="60000"/>
+                    <a:lumOff val="40000"/>
+                  </a:schemeClr>
+                </a:solidFill>
+                <a:latin typeface="Consolas"/>
+              </a:rPr>
+              <a:t> prompt</a:t>
+            </a:r>
+            <a:endParaRPr lang="ru-RU" sz="1250" dirty="0">
+              <a:solidFill>
+                <a:schemeClr val="tx2">
+                  <a:lumMod val="60000"/>
+                  <a:lumOff val="40000"/>
+                </a:schemeClr>
+              </a:solidFill>
+              <a:latin typeface="Consolas"/>
+            </a:endParaRPr>
+          </a:p>
+          <a:p>
+            <a:r>
+              <a:rPr lang="ru-RU" sz="1250" b="1" dirty="0">
+                <a:solidFill>
+                  <a:schemeClr val="tx2">
+                    <a:lumMod val="40000"/>
+                    <a:lumOff val="60000"/>
+                  </a:schemeClr>
+                </a:solidFill>
+                <a:latin typeface="Consolas"/>
+              </a:rPr>
+              <a:t>      { blocklistName: blocklistName, blocking: true, source: 'Completion’ }</a:t>
+            </a:r>
+            <a:r>
+              <a:rPr lang="nb-NO" sz="1250" b="1" dirty="0">
+                <a:solidFill>
+                  <a:schemeClr val="tx2">
+                    <a:lumMod val="40000"/>
+                    <a:lumOff val="60000"/>
+                  </a:schemeClr>
+                </a:solidFill>
+                <a:latin typeface="Consolas"/>
+              </a:rPr>
+              <a:t>  // </a:t>
+            </a:r>
+            <a:r>
+              <a:rPr lang="ru-RU" sz="1250" dirty="0">
+                <a:solidFill>
+                  <a:schemeClr val="tx2">
+                    <a:lumMod val="60000"/>
+                    <a:lumOff val="40000"/>
+                  </a:schemeClr>
+                </a:solidFill>
+                <a:latin typeface="Consolas"/>
+              </a:rPr>
+              <a:t>PII blocklist</a:t>
+            </a:r>
+            <a:r>
+              <a:rPr lang="nb-NO" sz="1250" dirty="0">
+                <a:solidFill>
+                  <a:schemeClr val="tx2">
+                    <a:lumMod val="60000"/>
+                    <a:lumOff val="40000"/>
+                  </a:schemeClr>
+                </a:solidFill>
+                <a:latin typeface="Consolas"/>
+              </a:rPr>
+              <a:t> </a:t>
+            </a:r>
+            <a:r>
+              <a:rPr lang="nb-NO" sz="1250" dirty="0" err="1">
+                <a:solidFill>
+                  <a:schemeClr val="tx2">
+                    <a:lumMod val="60000"/>
+                    <a:lumOff val="40000"/>
+                  </a:schemeClr>
+                </a:solidFill>
+                <a:latin typeface="Consolas"/>
+              </a:rPr>
+              <a:t>completion</a:t>
+            </a:r>
+            <a:endParaRPr lang="ru-RU" sz="1250" dirty="0">
+              <a:solidFill>
+                <a:schemeClr val="tx2">
+                  <a:lumMod val="60000"/>
+                  <a:lumOff val="40000"/>
+                </a:schemeClr>
+              </a:solidFill>
+              <a:latin typeface="Consolas"/>
+            </a:endParaRPr>
+          </a:p>
+          <a:p>
+            <a:r>
+              <a:rPr lang="ru-RU" sz="1250" b="1" dirty="0">
+                <a:solidFill>
+                  <a:schemeClr val="tx2">
+                    <a:lumMod val="40000"/>
+                    <a:lumOff val="60000"/>
+                  </a:schemeClr>
+                </a:solidFill>
+                <a:latin typeface="Consolas"/>
+              </a:rPr>
+              <a:t>    ] : []</a:t>
+            </a:r>
+            <a:endParaRPr sz="1250" b="1" dirty="0">
+              <a:solidFill>
+                <a:schemeClr val="tx2">
+                  <a:lumMod val="40000"/>
+                  <a:lumOff val="60000"/>
+                </a:schemeClr>
+              </a:solidFill>
+              <a:latin typeface="Consolas"/>
+            </a:endParaRPr>
           </a:p>
           <a:p>
             <a:pPr algn="l">
@@ -19974,112 +21183,6 @@
                 <a:latin typeface="Consolas"/>
               </a:rPr>
               <a:t> </a:t>
-            </a:r>
-          </a:p>
-          <a:p>
-            <a:pPr algn="l">
-              <a:lnSpc>
-                <a:spcPct val="100000"/>
-              </a:lnSpc>
-              <a:spcBef>
-                <a:spcPts val="0"/>
-              </a:spcBef>
-              <a:spcAft>
-                <a:spcPts val="0"/>
-              </a:spcAft>
-            </a:pPr>
-            <a:r>
-              <a:rPr sz="1250" dirty="0">
-                <a:solidFill>
-                  <a:srgbClr val="6A9955"/>
-                </a:solidFill>
-                <a:latin typeface="Consolas"/>
-              </a:rPr>
-              <a:t>// attached to the model deployment:</a:t>
-            </a:r>
-          </a:p>
-          <a:p>
-            <a:pPr algn="l">
-              <a:lnSpc>
-                <a:spcPct val="100000"/>
-              </a:lnSpc>
-              <a:spcBef>
-                <a:spcPts val="0"/>
-              </a:spcBef>
-              <a:spcAft>
-                <a:spcPts val="0"/>
-              </a:spcAft>
-            </a:pPr>
-            <a:r>
-              <a:rPr sz="1250" dirty="0">
-                <a:solidFill>
-                  <a:srgbClr val="D4D4D4"/>
-                </a:solidFill>
-                <a:latin typeface="Consolas"/>
-              </a:rPr>
-              <a:t>resource deployment '…/deployments@2024-10-01' = {</a:t>
-            </a:r>
-          </a:p>
-          <a:p>
-            <a:pPr algn="l">
-              <a:lnSpc>
-                <a:spcPct val="100000"/>
-              </a:lnSpc>
-              <a:spcBef>
-                <a:spcPts val="0"/>
-              </a:spcBef>
-              <a:spcAft>
-                <a:spcPts val="0"/>
-              </a:spcAft>
-            </a:pPr>
-            <a:r>
-              <a:rPr sz="1250" dirty="0">
-                <a:solidFill>
-                  <a:srgbClr val="9CDCFE"/>
-                </a:solidFill>
-                <a:latin typeface="Consolas"/>
-              </a:rPr>
-              <a:t>  properties: { </a:t>
-            </a:r>
-            <a:r>
-              <a:rPr sz="1250" dirty="0" err="1">
-                <a:solidFill>
-                  <a:srgbClr val="9CDCFE"/>
-                </a:solidFill>
-                <a:latin typeface="Consolas"/>
-              </a:rPr>
-              <a:t>raiPolicyName</a:t>
-            </a:r>
-            <a:r>
-              <a:rPr sz="1250" dirty="0">
-                <a:solidFill>
-                  <a:srgbClr val="9CDCFE"/>
-                </a:solidFill>
-                <a:latin typeface="Consolas"/>
-              </a:rPr>
-              <a:t>: guardrail.name }   // every chat call runs the shields</a:t>
-            </a:r>
-          </a:p>
-          <a:p>
-            <a:pPr algn="l">
-              <a:lnSpc>
-                <a:spcPct val="100000"/>
-              </a:lnSpc>
-              <a:spcBef>
-                <a:spcPts val="0"/>
-              </a:spcBef>
-              <a:spcAft>
-                <a:spcPts val="0"/>
-              </a:spcAft>
-            </a:pPr>
-            <a:r>
-              <a:rPr sz="1250" dirty="0">
-                <a:solidFill>
-                  <a:srgbClr val="D4D4D4"/>
-                </a:solidFill>
-                <a:latin typeface="Consolas"/>
-              </a:rPr>
-              <a:t>}</a:t>
             </a:r>
           </a:p>
         </p:txBody>
@@ -20182,7 +21285,7 @@
 </p:sld>
 </file>
 
-<file path=ppt/slides/slide25.xml><?xml version="1.0" encoding="utf-8"?>
+<file path=ppt/slides/slide26.xml><?xml version="1.0" encoding="utf-8"?>
 <p:sld xmlns:a="http://schemas.openxmlformats.org/drawingml/2006/main" xmlns:r="http://schemas.openxmlformats.org/officeDocument/2006/relationships" xmlns:p="http://schemas.openxmlformats.org/presentationml/2006/main">
   <p:cSld>
     <p:bg>
@@ -21108,7 +22211,7 @@
 </p:sld>
 </file>
 
-<file path=ppt/slides/slide26.xml><?xml version="1.0" encoding="utf-8"?>
+<file path=ppt/slides/slide27.xml><?xml version="1.0" encoding="utf-8"?>
 <p:sld xmlns:a="http://schemas.openxmlformats.org/drawingml/2006/main" xmlns:r="http://schemas.openxmlformats.org/officeDocument/2006/relationships" xmlns:p="http://schemas.openxmlformats.org/presentationml/2006/main">
   <p:cSld>
     <p:bg>
@@ -22793,7 +23896,7 @@
 </p:sld>
 </file>
 
-<file path=ppt/slides/slide27.xml><?xml version="1.0" encoding="utf-8"?>
+<file path=ppt/slides/slide28.xml><?xml version="1.0" encoding="utf-8"?>
 <p:sld xmlns:a="http://schemas.openxmlformats.org/drawingml/2006/main" xmlns:r="http://schemas.openxmlformats.org/officeDocument/2006/relationships" xmlns:p="http://schemas.openxmlformats.org/presentationml/2006/main">
   <p:cSld>
     <p:bg>
@@ -23951,1072 +25054,6 @@
                 <a:latin typeface="Segoe UI"/>
               </a:rPr>
               <a:t>12</a:t>
-            </a:r>
-          </a:p>
-        </p:txBody>
-      </p:sp>
-    </p:spTree>
-  </p:cSld>
-  <p:clrMapOvr>
-    <a:masterClrMapping/>
-  </p:clrMapOvr>
-</p:sld>
-</file>
-
-<file path=ppt/slides/slide28.xml><?xml version="1.0" encoding="utf-8"?>
-<p:sld xmlns:a="http://schemas.openxmlformats.org/drawingml/2006/main" xmlns:r="http://schemas.openxmlformats.org/officeDocument/2006/relationships" xmlns:p="http://schemas.openxmlformats.org/presentationml/2006/main">
-  <p:cSld>
-    <p:spTree>
-      <p:nvGrpSpPr>
-        <p:cNvPr id="1" name=""/>
-        <p:cNvGrpSpPr/>
-        <p:nvPr/>
-      </p:nvGrpSpPr>
-      <p:grpSpPr>
-        <a:xfrm>
-          <a:off x="0" y="0"/>
-          <a:ext cx="0" cy="0"/>
-          <a:chOff x="0" y="0"/>
-          <a:chExt cx="0" cy="0"/>
-        </a:xfrm>
-      </p:grpSpPr>
-      <p:sp>
-        <p:nvSpPr>
-          <p:cNvPr id="2" name="Rectangle 1"/>
-          <p:cNvSpPr/>
-          <p:nvPr/>
-        </p:nvSpPr>
-        <p:spPr>
-          <a:xfrm>
-            <a:off x="0" y="0"/>
-            <a:ext cx="12188952" cy="164592"/>
-          </a:xfrm>
-          <a:prstGeom prst="rect">
-            <a:avLst/>
-          </a:prstGeom>
-          <a:solidFill>
-            <a:srgbClr val="0078D4"/>
-          </a:solidFill>
-          <a:ln>
-            <a:noFill/>
-          </a:ln>
-          <a:effectLst/>
-        </p:spPr>
-        <p:style>
-          <a:lnRef idx="1">
-            <a:schemeClr val="accent1"/>
-          </a:lnRef>
-          <a:fillRef idx="3">
-            <a:schemeClr val="accent1"/>
-          </a:fillRef>
-          <a:effectRef idx="2">
-            <a:schemeClr val="accent1"/>
-          </a:effectRef>
-          <a:fontRef idx="minor">
-            <a:schemeClr val="lt1"/>
-          </a:fontRef>
-        </p:style>
-        <p:txBody>
-          <a:bodyPr rtlCol="0" anchor="ctr"/>
-          <a:lstStyle/>
-          <a:p>
-            <a:pPr algn="ctr"/>
-            <a:endParaRPr/>
-          </a:p>
-        </p:txBody>
-      </p:sp>
-      <p:sp>
-        <p:nvSpPr>
-          <p:cNvPr id="3" name="TextBox 2"/>
-          <p:cNvSpPr txBox="1"/>
-          <p:nvPr/>
-        </p:nvSpPr>
-        <p:spPr>
-          <a:xfrm>
-            <a:off x="640080" y="411480"/>
-            <a:ext cx="10972800" cy="365760"/>
-          </a:xfrm>
-          <a:prstGeom prst="rect">
-            <a:avLst/>
-          </a:prstGeom>
-          <a:noFill/>
-        </p:spPr>
-        <p:txBody>
-          <a:bodyPr wrap="square">
-            <a:spAutoFit/>
-          </a:bodyPr>
-          <a:lstStyle/>
-          <a:p>
-            <a:pPr algn="l">
-              <a:lnSpc>
-                <a:spcPct val="100000"/>
-              </a:lnSpc>
-              <a:spcAft>
-                <a:spcPts val="600"/>
-              </a:spcAft>
-            </a:pPr>
-            <a:r>
-              <a:rPr sz="1300" b="1">
-                <a:solidFill>
-                  <a:srgbClr val="0078D4"/>
-                </a:solidFill>
-                <a:latin typeface="Segoe UI"/>
-              </a:rPr>
-              <a:t>FOUNDRY AGENT SERVICE · BUILT-IN MEMORY</a:t>
-            </a:r>
-          </a:p>
-        </p:txBody>
-      </p:sp>
-      <p:sp>
-        <p:nvSpPr>
-          <p:cNvPr id="4" name="TextBox 3"/>
-          <p:cNvSpPr txBox="1"/>
-          <p:nvPr/>
-        </p:nvSpPr>
-        <p:spPr>
-          <a:xfrm>
-            <a:off x="640080" y="749808"/>
-            <a:ext cx="10972800" cy="822960"/>
-          </a:xfrm>
-          <a:prstGeom prst="rect">
-            <a:avLst/>
-          </a:prstGeom>
-          <a:noFill/>
-        </p:spPr>
-        <p:txBody>
-          <a:bodyPr wrap="square">
-            <a:spAutoFit/>
-          </a:bodyPr>
-          <a:lstStyle/>
-          <a:p>
-            <a:pPr algn="l">
-              <a:lnSpc>
-                <a:spcPct val="100000"/>
-              </a:lnSpc>
-              <a:spcAft>
-                <a:spcPts val="600"/>
-              </a:spcAft>
-            </a:pPr>
-            <a:r>
-              <a:rPr sz="3000" b="1" dirty="0">
-                <a:solidFill>
-                  <a:srgbClr val="243A5E"/>
-                </a:solidFill>
-                <a:latin typeface="Segoe UI"/>
-              </a:rPr>
-              <a:t>A managed memory subsystem</a:t>
-            </a:r>
-          </a:p>
-        </p:txBody>
-      </p:sp>
-      <p:sp>
-        <p:nvSpPr>
-          <p:cNvPr id="5" name="Rectangle 4"/>
-          <p:cNvSpPr/>
-          <p:nvPr/>
-        </p:nvSpPr>
-        <p:spPr>
-          <a:xfrm>
-            <a:off x="658368" y="1481328"/>
-            <a:ext cx="1005840" cy="45720"/>
-          </a:xfrm>
-          <a:prstGeom prst="rect">
-            <a:avLst/>
-          </a:prstGeom>
-          <a:solidFill>
-            <a:srgbClr val="0078D4"/>
-          </a:solidFill>
-          <a:ln>
-            <a:noFill/>
-          </a:ln>
-          <a:effectLst/>
-        </p:spPr>
-        <p:style>
-          <a:lnRef idx="1">
-            <a:schemeClr val="accent1"/>
-          </a:lnRef>
-          <a:fillRef idx="3">
-            <a:schemeClr val="accent1"/>
-          </a:fillRef>
-          <a:effectRef idx="2">
-            <a:schemeClr val="accent1"/>
-          </a:effectRef>
-          <a:fontRef idx="minor">
-            <a:schemeClr val="lt1"/>
-          </a:fontRef>
-        </p:style>
-        <p:txBody>
-          <a:bodyPr rtlCol="0" anchor="ctr"/>
-          <a:lstStyle/>
-          <a:p>
-            <a:pPr algn="ctr"/>
-            <a:endParaRPr/>
-          </a:p>
-        </p:txBody>
-      </p:sp>
-      <p:sp>
-        <p:nvSpPr>
-          <p:cNvPr id="6" name="TextBox 5"/>
-          <p:cNvSpPr txBox="1"/>
-          <p:nvPr/>
-        </p:nvSpPr>
-        <p:spPr>
-          <a:xfrm>
-            <a:off x="777240" y="1627632"/>
-            <a:ext cx="10607040" cy="457200"/>
-          </a:xfrm>
-          <a:prstGeom prst="rect">
-            <a:avLst/>
-          </a:prstGeom>
-          <a:noFill/>
-        </p:spPr>
-        <p:txBody>
-          <a:bodyPr wrap="square">
-            <a:spAutoFit/>
-          </a:bodyPr>
-          <a:lstStyle/>
-          <a:p>
-            <a:pPr algn="l">
-              <a:lnSpc>
-                <a:spcPct val="105000"/>
-              </a:lnSpc>
-              <a:spcAft>
-                <a:spcPts val="600"/>
-              </a:spcAft>
-            </a:pPr>
-            <a:r>
-              <a:rPr sz="1600" b="0">
-                <a:solidFill>
-                  <a:srgbClr val="605E5C"/>
-                </a:solidFill>
-                <a:latin typeface="Segoe UI"/>
-              </a:rPr>
-              <a:t>Turn it on and Foundry runs the whole pipeline server-side — no vector database to build or run.</a:t>
-            </a:r>
-          </a:p>
-        </p:txBody>
-      </p:sp>
-      <p:sp>
-        <p:nvSpPr>
-          <p:cNvPr id="7" name="TextBox 6"/>
-          <p:cNvSpPr txBox="1"/>
-          <p:nvPr/>
-        </p:nvSpPr>
-        <p:spPr>
-          <a:xfrm>
-            <a:off x="640080" y="6419088"/>
-            <a:ext cx="7315200" cy="320040"/>
-          </a:xfrm>
-          <a:prstGeom prst="rect">
-            <a:avLst/>
-          </a:prstGeom>
-          <a:noFill/>
-        </p:spPr>
-        <p:txBody>
-          <a:bodyPr wrap="square">
-            <a:spAutoFit/>
-          </a:bodyPr>
-          <a:lstStyle/>
-          <a:p>
-            <a:pPr algn="l">
-              <a:lnSpc>
-                <a:spcPct val="100000"/>
-              </a:lnSpc>
-              <a:spcAft>
-                <a:spcPts val="600"/>
-              </a:spcAft>
-            </a:pPr>
-            <a:r>
-              <a:rPr sz="900" b="0">
-                <a:solidFill>
-                  <a:srgbClr val="605E5C"/>
-                </a:solidFill>
-                <a:latin typeface="Segoe UI"/>
-              </a:rPr>
-              <a:t>AI FOUNDRY  ·  security, features and capabilities</a:t>
-            </a:r>
-          </a:p>
-        </p:txBody>
-      </p:sp>
-      <p:sp>
-        <p:nvSpPr>
-          <p:cNvPr id="8" name="TextBox 7"/>
-          <p:cNvSpPr txBox="1"/>
-          <p:nvPr/>
-        </p:nvSpPr>
-        <p:spPr>
-          <a:xfrm>
-            <a:off x="10972800" y="6419088"/>
-            <a:ext cx="822960" cy="320040"/>
-          </a:xfrm>
-          <a:prstGeom prst="rect">
-            <a:avLst/>
-          </a:prstGeom>
-          <a:noFill/>
-        </p:spPr>
-        <p:txBody>
-          <a:bodyPr wrap="square">
-            <a:spAutoFit/>
-          </a:bodyPr>
-          <a:lstStyle/>
-          <a:p>
-            <a:pPr algn="r">
-              <a:lnSpc>
-                <a:spcPct val="100000"/>
-              </a:lnSpc>
-              <a:spcAft>
-                <a:spcPts val="600"/>
-              </a:spcAft>
-            </a:pPr>
-            <a:r>
-              <a:rPr sz="900" b="0">
-                <a:solidFill>
-                  <a:srgbClr val="605E5C"/>
-                </a:solidFill>
-                <a:latin typeface="Segoe UI"/>
-              </a:rPr>
-              <a:t>10</a:t>
-            </a:r>
-          </a:p>
-        </p:txBody>
-      </p:sp>
-      <p:sp>
-        <p:nvSpPr>
-          <p:cNvPr id="9" name="Rounded Rectangle 8"/>
-          <p:cNvSpPr/>
-          <p:nvPr/>
-        </p:nvSpPr>
-        <p:spPr>
-          <a:xfrm>
-            <a:off x="777240" y="2331720"/>
-            <a:ext cx="2395728" cy="2240280"/>
-          </a:xfrm>
-          <a:prstGeom prst="roundRect">
-            <a:avLst>
-              <a:gd name="adj" fmla="val 6000"/>
-            </a:avLst>
-          </a:prstGeom>
-          <a:solidFill>
-            <a:srgbClr val="FFFFFF"/>
-          </a:solidFill>
-          <a:ln w="25400">
-            <a:solidFill>
-              <a:srgbClr val="0078D4"/>
-            </a:solidFill>
-          </a:ln>
-          <a:effectLst/>
-        </p:spPr>
-        <p:style>
-          <a:lnRef idx="1">
-            <a:schemeClr val="accent1"/>
-          </a:lnRef>
-          <a:fillRef idx="3">
-            <a:schemeClr val="accent1"/>
-          </a:fillRef>
-          <a:effectRef idx="2">
-            <a:schemeClr val="accent1"/>
-          </a:effectRef>
-          <a:fontRef idx="minor">
-            <a:schemeClr val="lt1"/>
-          </a:fontRef>
-        </p:style>
-        <p:txBody>
-          <a:bodyPr rtlCol="0" anchor="ctr"/>
-          <a:lstStyle/>
-          <a:p>
-            <a:pPr algn="ctr"/>
-            <a:endParaRPr/>
-          </a:p>
-        </p:txBody>
-      </p:sp>
-      <p:sp>
-        <p:nvSpPr>
-          <p:cNvPr id="10" name="TextBox 9"/>
-          <p:cNvSpPr txBox="1"/>
-          <p:nvPr/>
-        </p:nvSpPr>
-        <p:spPr>
-          <a:xfrm>
-            <a:off x="960120" y="2532888"/>
-            <a:ext cx="2029968" cy="1874520"/>
-          </a:xfrm>
-          <a:prstGeom prst="rect">
-            <a:avLst/>
-          </a:prstGeom>
-          <a:noFill/>
-        </p:spPr>
-        <p:txBody>
-          <a:bodyPr wrap="square">
-            <a:normAutofit/>
-          </a:bodyPr>
-          <a:lstStyle/>
-          <a:p>
-            <a:pPr algn="l">
-              <a:lnSpc>
-                <a:spcPct val="100000"/>
-              </a:lnSpc>
-              <a:spcAft>
-                <a:spcPts val="300"/>
-              </a:spcAft>
-            </a:pPr>
-            <a:r>
-              <a:rPr sz="1000" b="1">
-                <a:solidFill>
-                  <a:srgbClr val="0078D4"/>
-                </a:solidFill>
-                <a:latin typeface="Segoe UI"/>
-              </a:rPr>
-              <a:t>STEP 1</a:t>
-            </a:r>
-          </a:p>
-          <a:p>
-            <a:pPr algn="l">
-              <a:lnSpc>
-                <a:spcPct val="102000"/>
-              </a:lnSpc>
-              <a:spcAft>
-                <a:spcPts val="500"/>
-              </a:spcAft>
-            </a:pPr>
-            <a:r>
-              <a:rPr sz="1400" b="1">
-                <a:solidFill>
-                  <a:srgbClr val="243A5E"/>
-                </a:solidFill>
-                <a:latin typeface="Segoe UI"/>
-              </a:rPr>
-              <a:t>EXTRACTION</a:t>
-            </a:r>
-          </a:p>
-          <a:p>
-            <a:pPr algn="l">
-              <a:lnSpc>
-                <a:spcPct val="105000"/>
-              </a:lnSpc>
-              <a:spcAft>
-                <a:spcPts val="0"/>
-              </a:spcAft>
-            </a:pPr>
-            <a:r>
-              <a:rPr sz="1100" b="0">
-                <a:solidFill>
-                  <a:srgbClr val="605E5C"/>
-                </a:solidFill>
-                <a:latin typeface="Segoe UI"/>
-              </a:rPr>
-              <a:t>The chat model distils durable facts from each conversation — home city, preferred units.</a:t>
-            </a:r>
-          </a:p>
-        </p:txBody>
-      </p:sp>
-      <p:sp>
-        <p:nvSpPr>
-          <p:cNvPr id="11" name="TextBox 10"/>
-          <p:cNvSpPr txBox="1"/>
-          <p:nvPr/>
-        </p:nvSpPr>
-        <p:spPr>
-          <a:xfrm>
-            <a:off x="3182112" y="3232404"/>
-            <a:ext cx="310896" cy="411480"/>
-          </a:xfrm>
-          <a:prstGeom prst="rect">
-            <a:avLst/>
-          </a:prstGeom>
-          <a:noFill/>
-        </p:spPr>
-        <p:txBody>
-          <a:bodyPr wrap="square" anchor="ctr">
-            <a:spAutoFit/>
-          </a:bodyPr>
-          <a:lstStyle/>
-          <a:p>
-            <a:pPr algn="ctr">
-              <a:lnSpc>
-                <a:spcPct val="100000"/>
-              </a:lnSpc>
-            </a:pPr>
-            <a:r>
-              <a:rPr sz="1800" b="1">
-                <a:solidFill>
-                  <a:srgbClr val="0078D4"/>
-                </a:solidFill>
-                <a:latin typeface="Segoe UI"/>
-              </a:rPr>
-              <a:t>▶</a:t>
-            </a:r>
-          </a:p>
-        </p:txBody>
-      </p:sp>
-      <p:sp>
-        <p:nvSpPr>
-          <p:cNvPr id="12" name="Rounded Rectangle 11"/>
-          <p:cNvSpPr/>
-          <p:nvPr/>
-        </p:nvSpPr>
-        <p:spPr>
-          <a:xfrm>
-            <a:off x="3502152" y="2331720"/>
-            <a:ext cx="2395728" cy="2240280"/>
-          </a:xfrm>
-          <a:prstGeom prst="roundRect">
-            <a:avLst>
-              <a:gd name="adj" fmla="val 6000"/>
-            </a:avLst>
-          </a:prstGeom>
-          <a:solidFill>
-            <a:srgbClr val="FFFFFF"/>
-          </a:solidFill>
-          <a:ln w="25400">
-            <a:solidFill>
-              <a:srgbClr val="0078D4"/>
-            </a:solidFill>
-          </a:ln>
-          <a:effectLst/>
-        </p:spPr>
-        <p:style>
-          <a:lnRef idx="1">
-            <a:schemeClr val="accent1"/>
-          </a:lnRef>
-          <a:fillRef idx="3">
-            <a:schemeClr val="accent1"/>
-          </a:fillRef>
-          <a:effectRef idx="2">
-            <a:schemeClr val="accent1"/>
-          </a:effectRef>
-          <a:fontRef idx="minor">
-            <a:schemeClr val="lt1"/>
-          </a:fontRef>
-        </p:style>
-        <p:txBody>
-          <a:bodyPr rtlCol="0" anchor="ctr"/>
-          <a:lstStyle/>
-          <a:p>
-            <a:pPr algn="ctr"/>
-            <a:endParaRPr/>
-          </a:p>
-        </p:txBody>
-      </p:sp>
-      <p:sp>
-        <p:nvSpPr>
-          <p:cNvPr id="13" name="TextBox 12"/>
-          <p:cNvSpPr txBox="1"/>
-          <p:nvPr/>
-        </p:nvSpPr>
-        <p:spPr>
-          <a:xfrm>
-            <a:off x="3685032" y="2532888"/>
-            <a:ext cx="2029968" cy="1874520"/>
-          </a:xfrm>
-          <a:prstGeom prst="rect">
-            <a:avLst/>
-          </a:prstGeom>
-          <a:noFill/>
-        </p:spPr>
-        <p:txBody>
-          <a:bodyPr wrap="square">
-            <a:normAutofit/>
-          </a:bodyPr>
-          <a:lstStyle/>
-          <a:p>
-            <a:pPr algn="l">
-              <a:lnSpc>
-                <a:spcPct val="100000"/>
-              </a:lnSpc>
-              <a:spcAft>
-                <a:spcPts val="300"/>
-              </a:spcAft>
-            </a:pPr>
-            <a:r>
-              <a:rPr sz="1000" b="1">
-                <a:solidFill>
-                  <a:srgbClr val="0078D4"/>
-                </a:solidFill>
-                <a:latin typeface="Segoe UI"/>
-              </a:rPr>
-              <a:t>STEP 2</a:t>
-            </a:r>
-          </a:p>
-          <a:p>
-            <a:pPr algn="l">
-              <a:lnSpc>
-                <a:spcPct val="102000"/>
-              </a:lnSpc>
-              <a:spcAft>
-                <a:spcPts val="500"/>
-              </a:spcAft>
-            </a:pPr>
-            <a:r>
-              <a:rPr sz="1400" b="1">
-                <a:solidFill>
-                  <a:srgbClr val="243A5E"/>
-                </a:solidFill>
-                <a:latin typeface="Segoe UI"/>
-              </a:rPr>
-              <a:t>CONSOLIDATION</a:t>
-            </a:r>
-          </a:p>
-          <a:p>
-            <a:pPr algn="l">
-              <a:lnSpc>
-                <a:spcPct val="105000"/>
-              </a:lnSpc>
-              <a:spcAft>
-                <a:spcPts val="0"/>
-              </a:spcAft>
-            </a:pPr>
-            <a:r>
-              <a:rPr sz="1100" b="0">
-                <a:solidFill>
-                  <a:srgbClr val="605E5C"/>
-                </a:solidFill>
-                <a:latin typeface="Segoe UI"/>
-              </a:rPr>
-              <a:t>Facts are merged, updated and de-duplicated over time; each write resets the item’s freshness clock.</a:t>
-            </a:r>
-          </a:p>
-        </p:txBody>
-      </p:sp>
-      <p:sp>
-        <p:nvSpPr>
-          <p:cNvPr id="14" name="TextBox 13"/>
-          <p:cNvSpPr txBox="1"/>
-          <p:nvPr/>
-        </p:nvSpPr>
-        <p:spPr>
-          <a:xfrm>
-            <a:off x="5907024" y="3232404"/>
-            <a:ext cx="310896" cy="411480"/>
-          </a:xfrm>
-          <a:prstGeom prst="rect">
-            <a:avLst/>
-          </a:prstGeom>
-          <a:noFill/>
-        </p:spPr>
-        <p:txBody>
-          <a:bodyPr wrap="square" anchor="ctr">
-            <a:spAutoFit/>
-          </a:bodyPr>
-          <a:lstStyle/>
-          <a:p>
-            <a:pPr algn="ctr">
-              <a:lnSpc>
-                <a:spcPct val="100000"/>
-              </a:lnSpc>
-            </a:pPr>
-            <a:r>
-              <a:rPr sz="1800" b="1">
-                <a:solidFill>
-                  <a:srgbClr val="0078D4"/>
-                </a:solidFill>
-                <a:latin typeface="Segoe UI"/>
-              </a:rPr>
-              <a:t>▶</a:t>
-            </a:r>
-          </a:p>
-        </p:txBody>
-      </p:sp>
-      <p:sp>
-        <p:nvSpPr>
-          <p:cNvPr id="15" name="Rounded Rectangle 14"/>
-          <p:cNvSpPr/>
-          <p:nvPr/>
-        </p:nvSpPr>
-        <p:spPr>
-          <a:xfrm>
-            <a:off x="6227064" y="2331720"/>
-            <a:ext cx="2395728" cy="2240280"/>
-          </a:xfrm>
-          <a:prstGeom prst="roundRect">
-            <a:avLst>
-              <a:gd name="adj" fmla="val 6000"/>
-            </a:avLst>
-          </a:prstGeom>
-          <a:solidFill>
-            <a:srgbClr val="FFFFFF"/>
-          </a:solidFill>
-          <a:ln w="25400">
-            <a:solidFill>
-              <a:srgbClr val="0078D4"/>
-            </a:solidFill>
-          </a:ln>
-          <a:effectLst/>
-        </p:spPr>
-        <p:style>
-          <a:lnRef idx="1">
-            <a:schemeClr val="accent1"/>
-          </a:lnRef>
-          <a:fillRef idx="3">
-            <a:schemeClr val="accent1"/>
-          </a:fillRef>
-          <a:effectRef idx="2">
-            <a:schemeClr val="accent1"/>
-          </a:effectRef>
-          <a:fontRef idx="minor">
-            <a:schemeClr val="lt1"/>
-          </a:fontRef>
-        </p:style>
-        <p:txBody>
-          <a:bodyPr rtlCol="0" anchor="ctr"/>
-          <a:lstStyle/>
-          <a:p>
-            <a:pPr algn="ctr"/>
-            <a:endParaRPr/>
-          </a:p>
-        </p:txBody>
-      </p:sp>
-      <p:sp>
-        <p:nvSpPr>
-          <p:cNvPr id="16" name="TextBox 15"/>
-          <p:cNvSpPr txBox="1"/>
-          <p:nvPr/>
-        </p:nvSpPr>
-        <p:spPr>
-          <a:xfrm>
-            <a:off x="6409944" y="2532888"/>
-            <a:ext cx="2029968" cy="1874520"/>
-          </a:xfrm>
-          <a:prstGeom prst="rect">
-            <a:avLst/>
-          </a:prstGeom>
-          <a:noFill/>
-        </p:spPr>
-        <p:txBody>
-          <a:bodyPr wrap="square">
-            <a:normAutofit/>
-          </a:bodyPr>
-          <a:lstStyle/>
-          <a:p>
-            <a:pPr algn="l">
-              <a:lnSpc>
-                <a:spcPct val="100000"/>
-              </a:lnSpc>
-              <a:spcAft>
-                <a:spcPts val="300"/>
-              </a:spcAft>
-            </a:pPr>
-            <a:r>
-              <a:rPr sz="1000" b="1">
-                <a:solidFill>
-                  <a:srgbClr val="0078D4"/>
-                </a:solidFill>
-                <a:latin typeface="Segoe UI"/>
-              </a:rPr>
-              <a:t>STEP 3</a:t>
-            </a:r>
-          </a:p>
-          <a:p>
-            <a:pPr algn="l">
-              <a:lnSpc>
-                <a:spcPct val="102000"/>
-              </a:lnSpc>
-              <a:spcAft>
-                <a:spcPts val="500"/>
-              </a:spcAft>
-            </a:pPr>
-            <a:r>
-              <a:rPr sz="1400" b="1">
-                <a:solidFill>
-                  <a:srgbClr val="243A5E"/>
-                </a:solidFill>
-                <a:latin typeface="Segoe UI"/>
-              </a:rPr>
-              <a:t>VECTOR STORAGE</a:t>
-            </a:r>
-          </a:p>
-          <a:p>
-            <a:pPr algn="l">
-              <a:lnSpc>
-                <a:spcPct val="105000"/>
-              </a:lnSpc>
-              <a:spcAft>
-                <a:spcPts val="0"/>
-              </a:spcAft>
-            </a:pPr>
-            <a:r>
-              <a:rPr sz="1100" b="0">
-                <a:solidFill>
-                  <a:srgbClr val="605E5C"/>
-                </a:solidFill>
-                <a:latin typeface="Segoe UI"/>
-              </a:rPr>
-              <a:t>Every memory is embedded and held in a managed vector store — no search service to run yourself.</a:t>
-            </a:r>
-          </a:p>
-        </p:txBody>
-      </p:sp>
-      <p:sp>
-        <p:nvSpPr>
-          <p:cNvPr id="17" name="TextBox 16"/>
-          <p:cNvSpPr txBox="1"/>
-          <p:nvPr/>
-        </p:nvSpPr>
-        <p:spPr>
-          <a:xfrm>
-            <a:off x="8631936" y="3232404"/>
-            <a:ext cx="310896" cy="411480"/>
-          </a:xfrm>
-          <a:prstGeom prst="rect">
-            <a:avLst/>
-          </a:prstGeom>
-          <a:noFill/>
-        </p:spPr>
-        <p:txBody>
-          <a:bodyPr wrap="square" anchor="ctr">
-            <a:spAutoFit/>
-          </a:bodyPr>
-          <a:lstStyle/>
-          <a:p>
-            <a:pPr algn="ctr">
-              <a:lnSpc>
-                <a:spcPct val="100000"/>
-              </a:lnSpc>
-            </a:pPr>
-            <a:r>
-              <a:rPr sz="1800" b="1">
-                <a:solidFill>
-                  <a:srgbClr val="0078D4"/>
-                </a:solidFill>
-                <a:latin typeface="Segoe UI"/>
-              </a:rPr>
-              <a:t>▶</a:t>
-            </a:r>
-          </a:p>
-        </p:txBody>
-      </p:sp>
-      <p:sp>
-        <p:nvSpPr>
-          <p:cNvPr id="18" name="Rounded Rectangle 17"/>
-          <p:cNvSpPr/>
-          <p:nvPr/>
-        </p:nvSpPr>
-        <p:spPr>
-          <a:xfrm>
-            <a:off x="8951976" y="2331720"/>
-            <a:ext cx="2395728" cy="2240280"/>
-          </a:xfrm>
-          <a:prstGeom prst="roundRect">
-            <a:avLst>
-              <a:gd name="adj" fmla="val 6000"/>
-            </a:avLst>
-          </a:prstGeom>
-          <a:solidFill>
-            <a:srgbClr val="FFFFFF"/>
-          </a:solidFill>
-          <a:ln w="25400">
-            <a:solidFill>
-              <a:srgbClr val="0078D4"/>
-            </a:solidFill>
-          </a:ln>
-          <a:effectLst/>
-        </p:spPr>
-        <p:style>
-          <a:lnRef idx="1">
-            <a:schemeClr val="accent1"/>
-          </a:lnRef>
-          <a:fillRef idx="3">
-            <a:schemeClr val="accent1"/>
-          </a:fillRef>
-          <a:effectRef idx="2">
-            <a:schemeClr val="accent1"/>
-          </a:effectRef>
-          <a:fontRef idx="minor">
-            <a:schemeClr val="lt1"/>
-          </a:fontRef>
-        </p:style>
-        <p:txBody>
-          <a:bodyPr rtlCol="0" anchor="ctr"/>
-          <a:lstStyle/>
-          <a:p>
-            <a:pPr algn="ctr"/>
-            <a:endParaRPr/>
-          </a:p>
-        </p:txBody>
-      </p:sp>
-      <p:sp>
-        <p:nvSpPr>
-          <p:cNvPr id="19" name="TextBox 18"/>
-          <p:cNvSpPr txBox="1"/>
-          <p:nvPr/>
-        </p:nvSpPr>
-        <p:spPr>
-          <a:xfrm>
-            <a:off x="9134855" y="2532888"/>
-            <a:ext cx="2029968" cy="1874520"/>
-          </a:xfrm>
-          <a:prstGeom prst="rect">
-            <a:avLst/>
-          </a:prstGeom>
-          <a:noFill/>
-        </p:spPr>
-        <p:txBody>
-          <a:bodyPr wrap="square">
-            <a:normAutofit/>
-          </a:bodyPr>
-          <a:lstStyle/>
-          <a:p>
-            <a:pPr algn="l">
-              <a:lnSpc>
-                <a:spcPct val="100000"/>
-              </a:lnSpc>
-              <a:spcAft>
-                <a:spcPts val="300"/>
-              </a:spcAft>
-            </a:pPr>
-            <a:r>
-              <a:rPr sz="1000" b="1">
-                <a:solidFill>
-                  <a:srgbClr val="0078D4"/>
-                </a:solidFill>
-                <a:latin typeface="Segoe UI"/>
-              </a:rPr>
-              <a:t>STEP 4</a:t>
-            </a:r>
-          </a:p>
-          <a:p>
-            <a:pPr algn="l">
-              <a:lnSpc>
-                <a:spcPct val="102000"/>
-              </a:lnSpc>
-              <a:spcAft>
-                <a:spcPts val="500"/>
-              </a:spcAft>
-            </a:pPr>
-            <a:r>
-              <a:rPr sz="1400" b="1">
-                <a:solidFill>
-                  <a:srgbClr val="243A5E"/>
-                </a:solidFill>
-                <a:latin typeface="Segoe UI"/>
-              </a:rPr>
-              <a:t>SEMANTIC RETRIEVAL</a:t>
-            </a:r>
-          </a:p>
-          <a:p>
-            <a:pPr algn="l">
-              <a:lnSpc>
-                <a:spcPct val="105000"/>
-              </a:lnSpc>
-              <a:spcAft>
-                <a:spcPts val="0"/>
-              </a:spcAft>
-            </a:pPr>
-            <a:r>
-              <a:rPr sz="1100" b="0">
-                <a:solidFill>
-                  <a:srgbClr val="605E5C"/>
-                </a:solidFill>
-                <a:latin typeface="Segoe UI"/>
-              </a:rPr>
-              <a:t>The most relevant memories are recalled by meaning and added to the next prompt.</a:t>
-            </a:r>
-          </a:p>
-        </p:txBody>
-      </p:sp>
-      <p:sp>
-        <p:nvSpPr>
-          <p:cNvPr id="20" name="Rounded Rectangle 19"/>
-          <p:cNvSpPr/>
-          <p:nvPr/>
-        </p:nvSpPr>
-        <p:spPr>
-          <a:xfrm>
-            <a:off x="777240" y="4773168"/>
-            <a:ext cx="10607040" cy="1024128"/>
-          </a:xfrm>
-          <a:prstGeom prst="roundRect">
-            <a:avLst>
-              <a:gd name="adj" fmla="val 5000"/>
-            </a:avLst>
-          </a:prstGeom>
-          <a:solidFill>
-            <a:srgbClr val="243A5E"/>
-          </a:solidFill>
-          <a:ln>
-            <a:noFill/>
-          </a:ln>
-          <a:effectLst/>
-        </p:spPr>
-        <p:style>
-          <a:lnRef idx="1">
-            <a:schemeClr val="accent1"/>
-          </a:lnRef>
-          <a:fillRef idx="3">
-            <a:schemeClr val="accent1"/>
-          </a:fillRef>
-          <a:effectRef idx="2">
-            <a:schemeClr val="accent1"/>
-          </a:effectRef>
-          <a:fontRef idx="minor">
-            <a:schemeClr val="lt1"/>
-          </a:fontRef>
-        </p:style>
-        <p:txBody>
-          <a:bodyPr rtlCol="0" anchor="ctr"/>
-          <a:lstStyle/>
-          <a:p>
-            <a:pPr algn="ctr"/>
-            <a:endParaRPr/>
-          </a:p>
-        </p:txBody>
-      </p:sp>
-      <p:sp>
-        <p:nvSpPr>
-          <p:cNvPr id="21" name="TextBox 20"/>
-          <p:cNvSpPr txBox="1"/>
-          <p:nvPr/>
-        </p:nvSpPr>
-        <p:spPr>
-          <a:xfrm>
-            <a:off x="1051560" y="4773168"/>
-            <a:ext cx="10058400" cy="1024128"/>
-          </a:xfrm>
-          <a:prstGeom prst="rect">
-            <a:avLst/>
-          </a:prstGeom>
-          <a:noFill/>
-        </p:spPr>
-        <p:txBody>
-          <a:bodyPr wrap="square" anchor="ctr">
-            <a:spAutoFit/>
-          </a:bodyPr>
-          <a:lstStyle/>
-          <a:p>
-            <a:pPr algn="l">
-              <a:lnSpc>
-                <a:spcPct val="105000"/>
-              </a:lnSpc>
-              <a:spcAft>
-                <a:spcPts val="400"/>
-              </a:spcAft>
-            </a:pPr>
-            <a:r>
-              <a:rPr sz="1700" b="1">
-                <a:solidFill>
-                  <a:srgbClr val="FFFFFF"/>
-                </a:solidFill>
-                <a:latin typeface="Segoe UI"/>
-              </a:rPr>
-              <a:t>All four stages run inside Foundry’s managed loop.</a:t>
-            </a:r>
-          </a:p>
-          <a:p>
-            <a:pPr algn="l">
-              <a:lnSpc>
-                <a:spcPct val="105000"/>
-              </a:lnSpc>
-              <a:spcAft>
-                <a:spcPts val="0"/>
-              </a:spcAft>
-            </a:pPr>
-            <a:r>
-              <a:rPr sz="1300" b="0">
-                <a:solidFill>
-                  <a:srgbClr val="C7D6EA"/>
-                </a:solidFill>
-                <a:latin typeface="Segoe UI"/>
-              </a:rPr>
-              <a:t>You bring two model deployments; the platform does the extraction, vectorization, storage and recall. That same convenience is why the next slides treat memory as new attack surface.</a:t>
             </a:r>
           </a:p>
         </p:txBody>
@@ -25128,7 +25165,7 @@
                 </a:solidFill>
                 <a:latin typeface="Segoe UI"/>
               </a:rPr>
-              <a:t>BEFORE YOU TURN IT ON · OPERATIONS, COST &amp; CONFIG</a:t>
+              <a:t>FOUNDRY AGENT SERVICE · BUILT-IN MEMORY</a:t>
             </a:r>
           </a:p>
         </p:txBody>
@@ -25164,13 +25201,13 @@
               </a:spcAft>
             </a:pPr>
             <a:r>
-              <a:rPr sz="3000" b="1">
+              <a:rPr sz="3000" b="1" dirty="0">
                 <a:solidFill>
                   <a:srgbClr val="243A5E"/>
                 </a:solidFill>
                 <a:latin typeface="Segoe UI"/>
               </a:rPr>
-              <a:t>Size, cost, TTL &amp; the embedding dependency</a:t>
+              <a:t>A managed memory subsystem</a:t>
             </a:r>
           </a:p>
         </p:txBody>
@@ -25257,7 +25294,7 @@
                 </a:solidFill>
                 <a:latin typeface="Segoe UI"/>
               </a:rPr>
-              <a:t>Four decisions are yours before flipping deployMemory = true — the loop won’t make them for you.</a:t>
+              <a:t>Turn it on and Foundry runs the whole pipeline server-side — no vector database to build or run.</a:t>
             </a:r>
           </a:p>
         </p:txBody>
@@ -25341,7 +25378,7 @@
                 </a:solidFill>
                 <a:latin typeface="Segoe UI"/>
               </a:rPr>
-              <a:t>11</a:t>
+              <a:t>10</a:t>
             </a:r>
           </a:p>
         </p:txBody>
@@ -25354,12 +25391,12 @@
         </p:nvSpPr>
         <p:spPr>
           <a:xfrm>
-            <a:off x="777240" y="2240280"/>
-            <a:ext cx="5120640" cy="1783080"/>
+            <a:off x="777240" y="2331720"/>
+            <a:ext cx="2395728" cy="2240280"/>
           </a:xfrm>
           <a:prstGeom prst="roundRect">
             <a:avLst>
-              <a:gd name="adj" fmla="val 5000"/>
+              <a:gd name="adj" fmla="val 6000"/>
             </a:avLst>
           </a:prstGeom>
           <a:solidFill>
@@ -25403,8 +25440,8 @@
         </p:nvSpPr>
         <p:spPr>
           <a:xfrm>
-            <a:off x="1033271" y="2404872"/>
-            <a:ext cx="4608575" cy="1472184"/>
+            <a:off x="960120" y="2532888"/>
+            <a:ext cx="2029968" cy="1874520"/>
           </a:xfrm>
           <a:prstGeom prst="rect">
             <a:avLst/>
@@ -25426,13 +25463,13 @@
               </a:spcAft>
             </a:pPr>
             <a:r>
-              <a:rPr sz="1300" b="1">
+              <a:rPr sz="1000" b="1">
                 <a:solidFill>
                   <a:srgbClr val="0078D4"/>
                 </a:solidFill>
                 <a:latin typeface="Segoe UI"/>
               </a:rPr>
-              <a:t>SIZE</a:t>
+              <a:t>STEP 1</a:t>
             </a:r>
           </a:p>
           <a:p>
@@ -25441,7 +25478,7 @@
                 <a:spcPct val="102000"/>
               </a:lnSpc>
               <a:spcAft>
-                <a:spcPts val="400"/>
+                <a:spcPts val="500"/>
               </a:spcAft>
             </a:pPr>
             <a:r>
@@ -25451,7 +25488,7 @@
                 </a:solidFill>
                 <a:latin typeface="Segoe UI"/>
               </a:rPr>
-              <a:t>Items, not gigabytes.</a:t>
+              <a:t>EXTRACTION</a:t>
             </a:r>
           </a:p>
           <a:p>
@@ -25464,31 +25501,70 @@
               </a:spcAft>
             </a:pPr>
             <a:r>
-              <a:rPr sz="1150" b="0">
+              <a:rPr sz="1100" b="0">
                 <a:solidFill>
                   <a:srgbClr val="605E5C"/>
                 </a:solidFill>
                 <a:latin typeface="Segoe UI"/>
               </a:rPr>
-              <a:t>≈ 10,000 memories per user-scope, ~1,000 req/min (reported · preview · unconfirmed; absent from the official quota doc). A weather bot stores a handful per user.</a:t>
-            </a:r>
-          </a:p>
-        </p:txBody>
-      </p:sp>
-      <p:sp>
-        <p:nvSpPr>
-          <p:cNvPr id="11" name="Rounded Rectangle 10"/>
+              <a:t>The chat model distils durable facts from each conversation — home city, preferred units.</a:t>
+            </a:r>
+          </a:p>
+        </p:txBody>
+      </p:sp>
+      <p:sp>
+        <p:nvSpPr>
+          <p:cNvPr id="11" name="TextBox 10"/>
+          <p:cNvSpPr txBox="1"/>
+          <p:nvPr/>
+        </p:nvSpPr>
+        <p:spPr>
+          <a:xfrm>
+            <a:off x="3182112" y="3232404"/>
+            <a:ext cx="310896" cy="411480"/>
+          </a:xfrm>
+          <a:prstGeom prst="rect">
+            <a:avLst/>
+          </a:prstGeom>
+          <a:noFill/>
+        </p:spPr>
+        <p:txBody>
+          <a:bodyPr wrap="square" anchor="ctr">
+            <a:spAutoFit/>
+          </a:bodyPr>
+          <a:lstStyle/>
+          <a:p>
+            <a:pPr algn="ctr">
+              <a:lnSpc>
+                <a:spcPct val="100000"/>
+              </a:lnSpc>
+            </a:pPr>
+            <a:r>
+              <a:rPr sz="1800" b="1">
+                <a:solidFill>
+                  <a:srgbClr val="0078D4"/>
+                </a:solidFill>
+                <a:latin typeface="Segoe UI"/>
+              </a:rPr>
+              <a:t>▶</a:t>
+            </a:r>
+          </a:p>
+        </p:txBody>
+      </p:sp>
+      <p:sp>
+        <p:nvSpPr>
+          <p:cNvPr id="12" name="Rounded Rectangle 11"/>
           <p:cNvSpPr/>
           <p:nvPr/>
         </p:nvSpPr>
         <p:spPr>
           <a:xfrm>
-            <a:off x="6263640" y="2240280"/>
-            <a:ext cx="5120640" cy="1783080"/>
+            <a:off x="3502152" y="2331720"/>
+            <a:ext cx="2395728" cy="2240280"/>
           </a:xfrm>
           <a:prstGeom prst="roundRect">
             <a:avLst>
-              <a:gd name="adj" fmla="val 5000"/>
+              <a:gd name="adj" fmla="val 6000"/>
             </a:avLst>
           </a:prstGeom>
           <a:solidFill>
@@ -25496,7 +25572,7 @@
           </a:solidFill>
           <a:ln w="25400">
             <a:solidFill>
-              <a:srgbClr val="107C10"/>
+              <a:srgbClr val="0078D4"/>
             </a:solidFill>
           </a:ln>
           <a:effectLst/>
@@ -25526,14 +25602,14 @@
       </p:sp>
       <p:sp>
         <p:nvSpPr>
-          <p:cNvPr id="12" name="TextBox 11"/>
+          <p:cNvPr id="13" name="TextBox 12"/>
           <p:cNvSpPr txBox="1"/>
           <p:nvPr/>
         </p:nvSpPr>
         <p:spPr>
           <a:xfrm>
-            <a:off x="6519672" y="2404872"/>
-            <a:ext cx="4608575" cy="1472184"/>
+            <a:off x="3685032" y="2532888"/>
+            <a:ext cx="2029968" cy="1874520"/>
           </a:xfrm>
           <a:prstGeom prst="rect">
             <a:avLst/>
@@ -25555,13 +25631,13 @@
               </a:spcAft>
             </a:pPr>
             <a:r>
-              <a:rPr sz="1300" b="1">
-                <a:solidFill>
-                  <a:srgbClr val="107C10"/>
-                </a:solidFill>
-                <a:latin typeface="Segoe UI"/>
-              </a:rPr>
-              <a:t>COST</a:t>
+              <a:rPr sz="1000" b="1">
+                <a:solidFill>
+                  <a:srgbClr val="0078D4"/>
+                </a:solidFill>
+                <a:latin typeface="Segoe UI"/>
+              </a:rPr>
+              <a:t>STEP 2</a:t>
             </a:r>
           </a:p>
           <a:p>
@@ -25570,7 +25646,7 @@
                 <a:spcPct val="102000"/>
               </a:lnSpc>
               <a:spcAft>
-                <a:spcPts val="400"/>
+                <a:spcPts val="500"/>
               </a:spcAft>
             </a:pPr>
             <a:r>
@@ -25580,7 +25656,7 @@
                 </a:solidFill>
                 <a:latin typeface="Segoe UI"/>
               </a:rPr>
-              <a:t>Free in preview.</a:t>
+              <a:t>CONSOLIDATION</a:t>
             </a:r>
           </a:p>
           <a:p>
@@ -25593,31 +25669,70 @@
               </a:spcAft>
             </a:pPr>
             <a:r>
-              <a:rPr sz="1150" b="0">
+              <a:rPr sz="1100" b="0">
                 <a:solidFill>
                   <a:srgbClr val="605E5C"/>
                 </a:solidFill>
                 <a:latin typeface="Segoe UI"/>
               </a:rPr>
-              <a:t>You pay only the chat + embedding tokens spent on extraction &amp; retrieval — no fixed memory fee. GA pricing not yet published.</a:t>
-            </a:r>
-          </a:p>
-        </p:txBody>
-      </p:sp>
-      <p:sp>
-        <p:nvSpPr>
-          <p:cNvPr id="13" name="Rounded Rectangle 12"/>
+              <a:t>Facts are merged, updated and de-duplicated over time; each write resets the item’s freshness clock.</a:t>
+            </a:r>
+          </a:p>
+        </p:txBody>
+      </p:sp>
+      <p:sp>
+        <p:nvSpPr>
+          <p:cNvPr id="14" name="TextBox 13"/>
+          <p:cNvSpPr txBox="1"/>
+          <p:nvPr/>
+        </p:nvSpPr>
+        <p:spPr>
+          <a:xfrm>
+            <a:off x="5907024" y="3232404"/>
+            <a:ext cx="310896" cy="411480"/>
+          </a:xfrm>
+          <a:prstGeom prst="rect">
+            <a:avLst/>
+          </a:prstGeom>
+          <a:noFill/>
+        </p:spPr>
+        <p:txBody>
+          <a:bodyPr wrap="square" anchor="ctr">
+            <a:spAutoFit/>
+          </a:bodyPr>
+          <a:lstStyle/>
+          <a:p>
+            <a:pPr algn="ctr">
+              <a:lnSpc>
+                <a:spcPct val="100000"/>
+              </a:lnSpc>
+            </a:pPr>
+            <a:r>
+              <a:rPr sz="1800" b="1">
+                <a:solidFill>
+                  <a:srgbClr val="0078D4"/>
+                </a:solidFill>
+                <a:latin typeface="Segoe UI"/>
+              </a:rPr>
+              <a:t>▶</a:t>
+            </a:r>
+          </a:p>
+        </p:txBody>
+      </p:sp>
+      <p:sp>
+        <p:nvSpPr>
+          <p:cNvPr id="15" name="Rounded Rectangle 14"/>
           <p:cNvSpPr/>
           <p:nvPr/>
         </p:nvSpPr>
         <p:spPr>
           <a:xfrm>
-            <a:off x="777240" y="4114800"/>
-            <a:ext cx="5120640" cy="1783080"/>
+            <a:off x="6227064" y="2331720"/>
+            <a:ext cx="2395728" cy="2240280"/>
           </a:xfrm>
           <a:prstGeom prst="roundRect">
             <a:avLst>
-              <a:gd name="adj" fmla="val 5000"/>
+              <a:gd name="adj" fmla="val 6000"/>
             </a:avLst>
           </a:prstGeom>
           <a:solidFill>
@@ -25625,7 +25740,7 @@
           </a:solidFill>
           <a:ln w="25400">
             <a:solidFill>
-              <a:srgbClr val="5C2D91"/>
+              <a:srgbClr val="0078D4"/>
             </a:solidFill>
           </a:ln>
           <a:effectLst/>
@@ -25655,14 +25770,14 @@
       </p:sp>
       <p:sp>
         <p:nvSpPr>
-          <p:cNvPr id="14" name="TextBox 13"/>
+          <p:cNvPr id="16" name="TextBox 15"/>
           <p:cNvSpPr txBox="1"/>
           <p:nvPr/>
         </p:nvSpPr>
         <p:spPr>
           <a:xfrm>
-            <a:off x="1033271" y="4279392"/>
-            <a:ext cx="4608575" cy="1472184"/>
+            <a:off x="6409944" y="2532888"/>
+            <a:ext cx="2029968" cy="1874520"/>
           </a:xfrm>
           <a:prstGeom prst="rect">
             <a:avLst/>
@@ -25684,13 +25799,13 @@
               </a:spcAft>
             </a:pPr>
             <a:r>
-              <a:rPr sz="1300" b="1">
-                <a:solidFill>
-                  <a:srgbClr val="5C2D91"/>
-                </a:solidFill>
-                <a:latin typeface="Segoe UI"/>
-              </a:rPr>
-              <a:t>RETENTION · TTL</a:t>
+              <a:rPr sz="1000" b="1">
+                <a:solidFill>
+                  <a:srgbClr val="0078D4"/>
+                </a:solidFill>
+                <a:latin typeface="Segoe UI"/>
+              </a:rPr>
+              <a:t>STEP 3</a:t>
             </a:r>
           </a:p>
           <a:p>
@@ -25699,7 +25814,7 @@
                 <a:spcPct val="102000"/>
               </a:lnSpc>
               <a:spcAft>
-                <a:spcPts val="400"/>
+                <a:spcPts val="500"/>
               </a:spcAft>
             </a:pPr>
             <a:r>
@@ -25709,7 +25824,7 @@
                 </a:solidFill>
                 <a:latin typeface="Segoe UI"/>
               </a:rPr>
-              <a:t>Sliding, set at create time.</a:t>
+              <a:t>VECTOR STORAGE</a:t>
             </a:r>
           </a:p>
           <a:p>
@@ -25722,31 +25837,70 @@
               </a:spcAft>
             </a:pPr>
             <a:r>
-              <a:rPr sz="1150" b="0">
+              <a:rPr sz="1100" b="0">
                 <a:solidFill>
                   <a:srgbClr val="605E5C"/>
                 </a:solidFill>
                 <a:latin typeface="Segoe UI"/>
               </a:rPr>
-              <a:t>Reset on every update. ~90 days suits low-cadence weather use; 0 = never expires — unbounded PII, avoid.</a:t>
-            </a:r>
-          </a:p>
-        </p:txBody>
-      </p:sp>
-      <p:sp>
-        <p:nvSpPr>
-          <p:cNvPr id="15" name="Rounded Rectangle 14"/>
+              <a:t>Every memory is embedded and held in a managed vector store — no search service to run yourself.</a:t>
+            </a:r>
+          </a:p>
+        </p:txBody>
+      </p:sp>
+      <p:sp>
+        <p:nvSpPr>
+          <p:cNvPr id="17" name="TextBox 16"/>
+          <p:cNvSpPr txBox="1"/>
+          <p:nvPr/>
+        </p:nvSpPr>
+        <p:spPr>
+          <a:xfrm>
+            <a:off x="8631936" y="3232404"/>
+            <a:ext cx="310896" cy="411480"/>
+          </a:xfrm>
+          <a:prstGeom prst="rect">
+            <a:avLst/>
+          </a:prstGeom>
+          <a:noFill/>
+        </p:spPr>
+        <p:txBody>
+          <a:bodyPr wrap="square" anchor="ctr">
+            <a:spAutoFit/>
+          </a:bodyPr>
+          <a:lstStyle/>
+          <a:p>
+            <a:pPr algn="ctr">
+              <a:lnSpc>
+                <a:spcPct val="100000"/>
+              </a:lnSpc>
+            </a:pPr>
+            <a:r>
+              <a:rPr sz="1800" b="1">
+                <a:solidFill>
+                  <a:srgbClr val="0078D4"/>
+                </a:solidFill>
+                <a:latin typeface="Segoe UI"/>
+              </a:rPr>
+              <a:t>▶</a:t>
+            </a:r>
+          </a:p>
+        </p:txBody>
+      </p:sp>
+      <p:sp>
+        <p:nvSpPr>
+          <p:cNvPr id="18" name="Rounded Rectangle 17"/>
           <p:cNvSpPr/>
           <p:nvPr/>
         </p:nvSpPr>
         <p:spPr>
           <a:xfrm>
-            <a:off x="6263640" y="4114800"/>
-            <a:ext cx="5120640" cy="1783080"/>
+            <a:off x="8951976" y="2331720"/>
+            <a:ext cx="2395728" cy="2240280"/>
           </a:xfrm>
           <a:prstGeom prst="roundRect">
             <a:avLst>
-              <a:gd name="adj" fmla="val 5000"/>
+              <a:gd name="adj" fmla="val 6000"/>
             </a:avLst>
           </a:prstGeom>
           <a:solidFill>
@@ -25754,7 +25908,7 @@
           </a:solidFill>
           <a:ln w="25400">
             <a:solidFill>
-              <a:srgbClr val="C5292A"/>
+              <a:srgbClr val="0078D4"/>
             </a:solidFill>
           </a:ln>
           <a:effectLst/>
@@ -25784,14 +25938,14 @@
       </p:sp>
       <p:sp>
         <p:nvSpPr>
-          <p:cNvPr id="16" name="TextBox 15"/>
+          <p:cNvPr id="19" name="TextBox 18"/>
           <p:cNvSpPr txBox="1"/>
           <p:nvPr/>
         </p:nvSpPr>
         <p:spPr>
           <a:xfrm>
-            <a:off x="6519672" y="4279392"/>
-            <a:ext cx="4608575" cy="1472184"/>
+            <a:off x="9134855" y="2532888"/>
+            <a:ext cx="2029968" cy="1874520"/>
           </a:xfrm>
           <a:prstGeom prst="rect">
             <a:avLst/>
@@ -25813,31 +25967,13 @@
               </a:spcAft>
             </a:pPr>
             <a:r>
-              <a:rPr sz="1300" b="1">
-                <a:solidFill>
-                  <a:srgbClr val="C5292A"/>
-                </a:solidFill>
-                <a:latin typeface="Segoe UI"/>
-              </a:rPr>
-              <a:t>EMBEDDING </a:t>
-            </a:r>
-            <a:r>
-              <a:rPr lang="en-US" sz="1300" b="1">
-                <a:solidFill>
-                  <a:srgbClr val="C5292A"/>
-                </a:solidFill>
-                <a:latin typeface="Segoe UI"/>
-              </a:rPr>
-              <a:t>MODEL </a:t>
-            </a:r>
-            <a:r>
-              <a:rPr sz="1300" b="1">
-                <a:solidFill>
-                  <a:srgbClr val="C5292A"/>
-                </a:solidFill>
-                <a:latin typeface="Segoe UI"/>
-              </a:rPr>
-              <a:t>DEPENDENCY</a:t>
+              <a:rPr sz="1000" b="1">
+                <a:solidFill>
+                  <a:srgbClr val="0078D4"/>
+                </a:solidFill>
+                <a:latin typeface="Segoe UI"/>
+              </a:rPr>
+              <a:t>STEP 4</a:t>
             </a:r>
           </a:p>
           <a:p>
@@ -25846,17 +25982,17 @@
                 <a:spcPct val="102000"/>
               </a:lnSpc>
               <a:spcAft>
-                <a:spcPts val="400"/>
-              </a:spcAft>
-            </a:pPr>
-            <a:r>
-              <a:rPr sz="1400" b="1" dirty="0">
+                <a:spcPts val="500"/>
+              </a:spcAft>
+            </a:pPr>
+            <a:r>
+              <a:rPr sz="1400" b="1">
                 <a:solidFill>
                   <a:srgbClr val="243A5E"/>
                 </a:solidFill>
                 <a:latin typeface="Segoe UI"/>
               </a:rPr>
-              <a:t>Not built in — you bring it.</a:t>
+              <a:t>SEMANTIC RETRIEVAL</a:t>
             </a:r>
           </a:p>
           <a:p>
@@ -25869,27 +26005,74 @@
               </a:spcAft>
             </a:pPr>
             <a:r>
-              <a:rPr sz="1150" b="0" dirty="0">
+              <a:rPr sz="1100" b="0">
                 <a:solidFill>
                   <a:srgbClr val="605E5C"/>
                 </a:solidFill>
                 <a:latin typeface="Segoe UI"/>
               </a:rPr>
-              <a:t>Deploy your own embedding + chat model (e.g. text-embedding-3-small) and name both on the store.</a:t>
-            </a:r>
-          </a:p>
-        </p:txBody>
-      </p:sp>
-      <p:sp>
-        <p:nvSpPr>
-          <p:cNvPr id="17" name="TextBox 16"/>
+              <a:t>The most relevant memories are recalled by meaning and added to the next prompt.</a:t>
+            </a:r>
+          </a:p>
+        </p:txBody>
+      </p:sp>
+      <p:sp>
+        <p:nvSpPr>
+          <p:cNvPr id="20" name="Rounded Rectangle 19"/>
+          <p:cNvSpPr/>
+          <p:nvPr/>
+        </p:nvSpPr>
+        <p:spPr>
+          <a:xfrm>
+            <a:off x="777240" y="4773168"/>
+            <a:ext cx="10607040" cy="1024128"/>
+          </a:xfrm>
+          <a:prstGeom prst="roundRect">
+            <a:avLst>
+              <a:gd name="adj" fmla="val 5000"/>
+            </a:avLst>
+          </a:prstGeom>
+          <a:solidFill>
+            <a:srgbClr val="243A5E"/>
+          </a:solidFill>
+          <a:ln>
+            <a:noFill/>
+          </a:ln>
+          <a:effectLst/>
+        </p:spPr>
+        <p:style>
+          <a:lnRef idx="1">
+            <a:schemeClr val="accent1"/>
+          </a:lnRef>
+          <a:fillRef idx="3">
+            <a:schemeClr val="accent1"/>
+          </a:fillRef>
+          <a:effectRef idx="2">
+            <a:schemeClr val="accent1"/>
+          </a:effectRef>
+          <a:fontRef idx="minor">
+            <a:schemeClr val="lt1"/>
+          </a:fontRef>
+        </p:style>
+        <p:txBody>
+          <a:bodyPr rtlCol="0" anchor="ctr"/>
+          <a:lstStyle/>
+          <a:p>
+            <a:pPr algn="ctr"/>
+            <a:endParaRPr/>
+          </a:p>
+        </p:txBody>
+      </p:sp>
+      <p:sp>
+        <p:nvSpPr>
+          <p:cNvPr id="21" name="TextBox 20"/>
           <p:cNvSpPr txBox="1"/>
           <p:nvPr/>
         </p:nvSpPr>
         <p:spPr>
           <a:xfrm>
-            <a:off x="777240" y="5989320"/>
-            <a:ext cx="10607040" cy="310896"/>
+            <a:off x="1051560" y="4773168"/>
+            <a:ext cx="10058400" cy="1024128"/>
           </a:xfrm>
           <a:prstGeom prst="rect">
             <a:avLst/>
@@ -25897,24 +26080,46 @@
           <a:noFill/>
         </p:spPr>
         <p:txBody>
-          <a:bodyPr wrap="square">
+          <a:bodyPr wrap="square" anchor="ctr">
             <a:spAutoFit/>
           </a:bodyPr>
           <a:lstStyle/>
           <a:p>
             <a:pPr algn="l">
               <a:lnSpc>
-                <a:spcPct val="100000"/>
+                <a:spcPct val="105000"/>
               </a:lnSpc>
-            </a:pPr>
-            <a:r>
-              <a:rPr sz="1250" b="1">
-                <a:solidFill>
-                  <a:srgbClr val="243A5E"/>
-                </a:solidFill>
-                <a:latin typeface="Segoe UI"/>
-              </a:rPr>
-              <a:t>Today Gislefoss sets deployMemory = false → the agent is stateless and memory costs nothing.</a:t>
+              <a:spcAft>
+                <a:spcPts val="400"/>
+              </a:spcAft>
+            </a:pPr>
+            <a:r>
+              <a:rPr sz="1700" b="1">
+                <a:solidFill>
+                  <a:srgbClr val="FFFFFF"/>
+                </a:solidFill>
+                <a:latin typeface="Segoe UI"/>
+              </a:rPr>
+              <a:t>All four stages run inside Foundry’s managed loop.</a:t>
+            </a:r>
+          </a:p>
+          <a:p>
+            <a:pPr algn="l">
+              <a:lnSpc>
+                <a:spcPct val="105000"/>
+              </a:lnSpc>
+              <a:spcAft>
+                <a:spcPts val="0"/>
+              </a:spcAft>
+            </a:pPr>
+            <a:r>
+              <a:rPr sz="1300" b="0">
+                <a:solidFill>
+                  <a:srgbClr val="C7D6EA"/>
+                </a:solidFill>
+                <a:latin typeface="Segoe UI"/>
+              </a:rPr>
+              <a:t>You bring two model deployments; the platform does the extraction, vectorization, storage and recall. That same convenience is why the next slides treat memory as new attack surface.</a:t>
             </a:r>
           </a:p>
         </p:txBody>
@@ -27862,7 +28067,7 @@
                 </a:solidFill>
                 <a:latin typeface="Segoe UI"/>
               </a:rPr>
-              <a:t>FOUNDRY AGENT SERVICE · MEMORY FROM EXTERNAL AGENTS</a:t>
+              <a:t>BEFORE YOU TURN IT ON · OPERATIONS, COST &amp; CONFIG</a:t>
             </a:r>
           </a:p>
         </p:txBody>
@@ -27904,7 +28109,7 @@
                 </a:solidFill>
                 <a:latin typeface="Segoe UI"/>
               </a:rPr>
-              <a:t>Use the memory store from your own host</a:t>
+              <a:t>Size, cost, TTL &amp; the embedding dependency</a:t>
             </a:r>
           </a:p>
         </p:txBody>
@@ -27991,7 +28196,7 @@
                 </a:solidFill>
                 <a:latin typeface="Segoe UI"/>
               </a:rPr>
-              <a:t>The store is a project data-plane service — reachable from a Web App, Container App or AKS over REST/SDK with Entra auth.</a:t>
+              <a:t>Four decisions are yours before flipping deployMemory = true — the loop won’t make them for you.</a:t>
             </a:r>
           </a:p>
         </p:txBody>
@@ -28075,7 +28280,7 @@
                 </a:solidFill>
                 <a:latin typeface="Segoe UI"/>
               </a:rPr>
-              <a:t>12</a:t>
+              <a:t>11</a:t>
             </a:r>
           </a:p>
         </p:txBody>
@@ -28138,7 +28343,7 @@
         <p:spPr>
           <a:xfrm>
             <a:off x="1033271" y="2404872"/>
-            <a:ext cx="4608576" cy="1472184"/>
+            <a:ext cx="4608575" cy="1472184"/>
           </a:xfrm>
           <a:prstGeom prst="rect">
             <a:avLst/>
@@ -28166,7 +28371,7 @@
                 </a:solidFill>
                 <a:latin typeface="Segoe UI"/>
               </a:rPr>
-              <a:t>EXTERNAL AGENTS · ANY HOST</a:t>
+              <a:t>SIZE</a:t>
             </a:r>
           </a:p>
           <a:p>
@@ -28185,7 +28390,7 @@
                 </a:solidFill>
                 <a:latin typeface="Segoe UI"/>
               </a:rPr>
-              <a:t>Web App, Container App or AKS.</a:t>
+              <a:t>Items, not gigabytes.</a:t>
             </a:r>
           </a:p>
           <a:p>
@@ -28204,14 +28409,14 @@
                 </a:solidFill>
                 <a:latin typeface="Segoe UI"/>
               </a:rPr>
-              <a:t>The memory store is a project data-plane resource, decoupled from where the agent runs. Call it over REST/SDK with a Microsoft Entra token (Foundry User role) — from AKS, via workload identity.</a:t>
-            </a:r>
-          </a:p>
-        </p:txBody>
-      </p:sp>
-      <p:sp>
-        <p:nvSpPr>
-          <p:cNvPr id="11" name="Rounded Rectangle 8"/>
+              <a:t>≈ 10,000 memories per user-scope, ~1,000 req/min (reported · preview · unconfirmed; absent from the official quota doc). A weather bot stores a handful per user.</a:t>
+            </a:r>
+          </a:p>
+        </p:txBody>
+      </p:sp>
+      <p:sp>
+        <p:nvSpPr>
+          <p:cNvPr id="11" name="Rounded Rectangle 10"/>
           <p:cNvSpPr/>
           <p:nvPr/>
         </p:nvSpPr>
@@ -28260,14 +28465,14 @@
       </p:sp>
       <p:sp>
         <p:nvSpPr>
-          <p:cNvPr id="12" name="TextBox 9"/>
+          <p:cNvPr id="12" name="TextBox 11"/>
           <p:cNvSpPr txBox="1"/>
           <p:nvPr/>
         </p:nvSpPr>
         <p:spPr>
           <a:xfrm>
             <a:off x="6519672" y="2404872"/>
-            <a:ext cx="4608576" cy="1472184"/>
+            <a:ext cx="4608575" cy="1472184"/>
           </a:xfrm>
           <a:prstGeom prst="rect">
             <a:avLst/>
@@ -28295,7 +28500,7 @@
                 </a:solidFill>
                 <a:latin typeface="Segoe UI"/>
               </a:rPr>
-              <a:t>TWO WAYS TO CALL IT</a:t>
+              <a:t>COST</a:t>
             </a:r>
           </a:p>
           <a:p>
@@ -28314,7 +28519,7 @@
                 </a:solidFill>
                 <a:latin typeface="Segoe UI"/>
               </a:rPr>
-              <a:t>Search tool, or low-level APIs.</a:t>
+              <a:t>Free in preview.</a:t>
             </a:r>
           </a:p>
           <a:p>
@@ -28333,14 +28538,14 @@
                 </a:solidFill>
                 <a:latin typeface="Segoe UI"/>
               </a:rPr>
-              <a:t>Attach the memory_search tool to a Foundry prompt agent (auto extract + retrieve via the Responses API), or drive the store yourself: update_memories / search_memories / item CRUD, passing scope on every call.</a:t>
-            </a:r>
-          </a:p>
-        </p:txBody>
-      </p:sp>
-      <p:sp>
-        <p:nvSpPr>
-          <p:cNvPr id="13" name="Rounded Rectangle 8"/>
+              <a:t>You pay only the chat + embedding tokens spent on extraction &amp; retrieval — no fixed memory fee. GA pricing not yet published.</a:t>
+            </a:r>
+          </a:p>
+        </p:txBody>
+      </p:sp>
+      <p:sp>
+        <p:nvSpPr>
+          <p:cNvPr id="13" name="Rounded Rectangle 12"/>
           <p:cNvSpPr/>
           <p:nvPr/>
         </p:nvSpPr>
@@ -28389,14 +28594,14 @@
       </p:sp>
       <p:sp>
         <p:nvSpPr>
-          <p:cNvPr id="14" name="TextBox 9"/>
+          <p:cNvPr id="14" name="TextBox 13"/>
           <p:cNvSpPr txBox="1"/>
           <p:nvPr/>
         </p:nvSpPr>
         <p:spPr>
           <a:xfrm>
             <a:off x="1033271" y="4279392"/>
-            <a:ext cx="4608576" cy="1472184"/>
+            <a:ext cx="4608575" cy="1472184"/>
           </a:xfrm>
           <a:prstGeom prst="rect">
             <a:avLst/>
@@ -28424,7 +28629,7 @@
                 </a:solidFill>
                 <a:latin typeface="Segoe UI"/>
               </a:rPr>
-              <a:t>LIMITATIONS</a:t>
+              <a:t>RETENTION · TTL</a:t>
             </a:r>
           </a:p>
           <a:p>
@@ -28443,7 +28648,7 @@
                 </a:solidFill>
                 <a:latin typeface="Segoe UI"/>
               </a:rPr>
-              <a:t>Public endpoint, explicit scope.</a:t>
+              <a:t>Sliding, set at create time.</a:t>
             </a:r>
           </a:p>
           <a:p>
@@ -28462,14 +28667,14 @@
                 </a:solidFill>
                 <a:latin typeface="Segoe UI"/>
               </a:rPr>
-              <a:t>No VNet / Private Link for memory stores — public data-plane only. Low-level calls need an explicit scope (no identity auto-resolution). Preview: some store options are create-time only; poisoning defense is yours.</a:t>
-            </a:r>
-          </a:p>
-        </p:txBody>
-      </p:sp>
-      <p:sp>
-        <p:nvSpPr>
-          <p:cNvPr id="15" name="Rounded Rectangle 8"/>
+              <a:t>Reset on every update. ~90 days suits low-cadence weather use; 0 = never expires — unbounded PII, avoid.</a:t>
+            </a:r>
+          </a:p>
+        </p:txBody>
+      </p:sp>
+      <p:sp>
+        <p:nvSpPr>
+          <p:cNvPr id="15" name="Rounded Rectangle 14"/>
           <p:cNvSpPr/>
           <p:nvPr/>
         </p:nvSpPr>
@@ -28518,14 +28723,14 @@
       </p:sp>
       <p:sp>
         <p:nvSpPr>
-          <p:cNvPr id="16" name="TextBox 9"/>
+          <p:cNvPr id="16" name="TextBox 15"/>
           <p:cNvSpPr txBox="1"/>
           <p:nvPr/>
         </p:nvSpPr>
         <p:spPr>
           <a:xfrm>
             <a:off x="6519672" y="4279392"/>
-            <a:ext cx="4608576" cy="1472184"/>
+            <a:ext cx="4608575" cy="1472184"/>
           </a:xfrm>
           <a:prstGeom prst="rect">
             <a:avLst/>
@@ -28553,7 +28758,25 @@
                 </a:solidFill>
                 <a:latin typeface="Segoe UI"/>
               </a:rPr>
-              <a:t>QUOTAS · MODEL DEPENDENCY</a:t>
+              <a:t>EMBEDDING </a:t>
+            </a:r>
+            <a:r>
+              <a:rPr lang="en-US" sz="1300" b="1">
+                <a:solidFill>
+                  <a:srgbClr val="C5292A"/>
+                </a:solidFill>
+                <a:latin typeface="Segoe UI"/>
+              </a:rPr>
+              <a:t>MODEL </a:t>
+            </a:r>
+            <a:r>
+              <a:rPr sz="1300" b="1">
+                <a:solidFill>
+                  <a:srgbClr val="C5292A"/>
+                </a:solidFill>
+                <a:latin typeface="Segoe UI"/>
+              </a:rPr>
+              <a:t>DEPENDENCY</a:t>
             </a:r>
           </a:p>
           <a:p>
@@ -28566,13 +28789,13 @@
               </a:spcAft>
             </a:pPr>
             <a:r>
-              <a:rPr sz="1400" b="1">
+              <a:rPr sz="1400" b="1" dirty="0">
                 <a:solidFill>
                   <a:srgbClr val="243A5E"/>
                 </a:solidFill>
                 <a:latin typeface="Segoe UI"/>
               </a:rPr>
-              <a:t>Per store; bring your own models.</a:t>
+              <a:t>Not built in — you bring it.</a:t>
             </a:r>
           </a:p>
           <a:p>
@@ -28585,13 +28808,13 @@
               </a:spcAft>
             </a:pPr>
             <a:r>
-              <a:rPr sz="1150" b="0">
+              <a:rPr sz="1150" b="0" dirty="0">
                 <a:solidFill>
                   <a:srgbClr val="605E5C"/>
                 </a:solidFill>
                 <a:latin typeface="Segoe UI"/>
               </a:rPr>
-              <a:t>100 scopes / store · 10,000 memories / scope · 1,000 search/min · 1,000 update/min. Requires compatible Azure OpenAI chat + embedding deployments in the project — you pay for that usage.</a:t>
+              <a:t>Deploy your own embedding + chat model (e.g. text-embedding-3-small) and name both on the store.</a:t>
             </a:r>
           </a:p>
         </p:txBody>
@@ -28630,7 +28853,7 @@
                 </a:solidFill>
                 <a:latin typeface="Segoe UI"/>
               </a:rPr>
-              <a:t>Gislefoss's memory.bicep store is reachable from a Web App, Container App or AKS pod via the low-level APIs.</a:t>
+              <a:t>Today Gislefoss sets deployMemory = false → the agent is stateless and memory costs nothing.</a:t>
             </a:r>
           </a:p>
         </p:txBody>
@@ -28644,6 +28867,886 @@
 </file>
 
 <file path=ppt/slides/slide31.xml><?xml version="1.0" encoding="utf-8"?>
+<p:sld xmlns:a="http://schemas.openxmlformats.org/drawingml/2006/main" xmlns:r="http://schemas.openxmlformats.org/officeDocument/2006/relationships" xmlns:p="http://schemas.openxmlformats.org/presentationml/2006/main">
+  <p:cSld>
+    <p:spTree>
+      <p:nvGrpSpPr>
+        <p:cNvPr id="1" name=""/>
+        <p:cNvGrpSpPr/>
+        <p:nvPr/>
+      </p:nvGrpSpPr>
+      <p:grpSpPr>
+        <a:xfrm>
+          <a:off x="0" y="0"/>
+          <a:ext cx="0" cy="0"/>
+          <a:chOff x="0" y="0"/>
+          <a:chExt cx="0" cy="0"/>
+        </a:xfrm>
+      </p:grpSpPr>
+      <p:sp>
+        <p:nvSpPr>
+          <p:cNvPr id="2" name="Rectangle 1"/>
+          <p:cNvSpPr/>
+          <p:nvPr/>
+        </p:nvSpPr>
+        <p:spPr>
+          <a:xfrm>
+            <a:off x="0" y="0"/>
+            <a:ext cx="12188952" cy="164592"/>
+          </a:xfrm>
+          <a:prstGeom prst="rect">
+            <a:avLst/>
+          </a:prstGeom>
+          <a:solidFill>
+            <a:srgbClr val="0078D4"/>
+          </a:solidFill>
+          <a:ln>
+            <a:noFill/>
+          </a:ln>
+          <a:effectLst/>
+        </p:spPr>
+        <p:style>
+          <a:lnRef idx="1">
+            <a:schemeClr val="accent1"/>
+          </a:lnRef>
+          <a:fillRef idx="3">
+            <a:schemeClr val="accent1"/>
+          </a:fillRef>
+          <a:effectRef idx="2">
+            <a:schemeClr val="accent1"/>
+          </a:effectRef>
+          <a:fontRef idx="minor">
+            <a:schemeClr val="lt1"/>
+          </a:fontRef>
+        </p:style>
+        <p:txBody>
+          <a:bodyPr rtlCol="0" anchor="ctr"/>
+          <a:lstStyle/>
+          <a:p>
+            <a:pPr algn="ctr"/>
+            <a:endParaRPr/>
+          </a:p>
+        </p:txBody>
+      </p:sp>
+      <p:sp>
+        <p:nvSpPr>
+          <p:cNvPr id="3" name="TextBox 2"/>
+          <p:cNvSpPr txBox="1"/>
+          <p:nvPr/>
+        </p:nvSpPr>
+        <p:spPr>
+          <a:xfrm>
+            <a:off x="640080" y="411480"/>
+            <a:ext cx="10972800" cy="365760"/>
+          </a:xfrm>
+          <a:prstGeom prst="rect">
+            <a:avLst/>
+          </a:prstGeom>
+          <a:noFill/>
+        </p:spPr>
+        <p:txBody>
+          <a:bodyPr wrap="square">
+            <a:spAutoFit/>
+          </a:bodyPr>
+          <a:lstStyle/>
+          <a:p>
+            <a:pPr algn="l">
+              <a:lnSpc>
+                <a:spcPct val="100000"/>
+              </a:lnSpc>
+              <a:spcAft>
+                <a:spcPts val="600"/>
+              </a:spcAft>
+            </a:pPr>
+            <a:r>
+              <a:rPr sz="1300" b="1">
+                <a:solidFill>
+                  <a:srgbClr val="0078D4"/>
+                </a:solidFill>
+                <a:latin typeface="Segoe UI"/>
+              </a:rPr>
+              <a:t>FOUNDRY AGENT SERVICE · MEMORY FROM EXTERNAL AGENTS</a:t>
+            </a:r>
+          </a:p>
+        </p:txBody>
+      </p:sp>
+      <p:sp>
+        <p:nvSpPr>
+          <p:cNvPr id="4" name="TextBox 3"/>
+          <p:cNvSpPr txBox="1"/>
+          <p:nvPr/>
+        </p:nvSpPr>
+        <p:spPr>
+          <a:xfrm>
+            <a:off x="640080" y="749808"/>
+            <a:ext cx="10972800" cy="822960"/>
+          </a:xfrm>
+          <a:prstGeom prst="rect">
+            <a:avLst/>
+          </a:prstGeom>
+          <a:noFill/>
+        </p:spPr>
+        <p:txBody>
+          <a:bodyPr wrap="square">
+            <a:spAutoFit/>
+          </a:bodyPr>
+          <a:lstStyle/>
+          <a:p>
+            <a:pPr algn="l">
+              <a:lnSpc>
+                <a:spcPct val="100000"/>
+              </a:lnSpc>
+              <a:spcAft>
+                <a:spcPts val="600"/>
+              </a:spcAft>
+            </a:pPr>
+            <a:r>
+              <a:rPr sz="3000" b="1">
+                <a:solidFill>
+                  <a:srgbClr val="243A5E"/>
+                </a:solidFill>
+                <a:latin typeface="Segoe UI"/>
+              </a:rPr>
+              <a:t>Use the memory store from your own host</a:t>
+            </a:r>
+          </a:p>
+        </p:txBody>
+      </p:sp>
+      <p:sp>
+        <p:nvSpPr>
+          <p:cNvPr id="5" name="Rectangle 4"/>
+          <p:cNvSpPr/>
+          <p:nvPr/>
+        </p:nvSpPr>
+        <p:spPr>
+          <a:xfrm>
+            <a:off x="658368" y="1481328"/>
+            <a:ext cx="1005840" cy="45720"/>
+          </a:xfrm>
+          <a:prstGeom prst="rect">
+            <a:avLst/>
+          </a:prstGeom>
+          <a:solidFill>
+            <a:srgbClr val="0078D4"/>
+          </a:solidFill>
+          <a:ln>
+            <a:noFill/>
+          </a:ln>
+          <a:effectLst/>
+        </p:spPr>
+        <p:style>
+          <a:lnRef idx="1">
+            <a:schemeClr val="accent1"/>
+          </a:lnRef>
+          <a:fillRef idx="3">
+            <a:schemeClr val="accent1"/>
+          </a:fillRef>
+          <a:effectRef idx="2">
+            <a:schemeClr val="accent1"/>
+          </a:effectRef>
+          <a:fontRef idx="minor">
+            <a:schemeClr val="lt1"/>
+          </a:fontRef>
+        </p:style>
+        <p:txBody>
+          <a:bodyPr rtlCol="0" anchor="ctr"/>
+          <a:lstStyle/>
+          <a:p>
+            <a:pPr algn="ctr"/>
+            <a:endParaRPr/>
+          </a:p>
+        </p:txBody>
+      </p:sp>
+      <p:sp>
+        <p:nvSpPr>
+          <p:cNvPr id="6" name="TextBox 5"/>
+          <p:cNvSpPr txBox="1"/>
+          <p:nvPr/>
+        </p:nvSpPr>
+        <p:spPr>
+          <a:xfrm>
+            <a:off x="777240" y="1627632"/>
+            <a:ext cx="10607040" cy="457200"/>
+          </a:xfrm>
+          <a:prstGeom prst="rect">
+            <a:avLst/>
+          </a:prstGeom>
+          <a:noFill/>
+        </p:spPr>
+        <p:txBody>
+          <a:bodyPr wrap="square">
+            <a:spAutoFit/>
+          </a:bodyPr>
+          <a:lstStyle/>
+          <a:p>
+            <a:pPr algn="l">
+              <a:lnSpc>
+                <a:spcPct val="105000"/>
+              </a:lnSpc>
+              <a:spcAft>
+                <a:spcPts val="600"/>
+              </a:spcAft>
+            </a:pPr>
+            <a:r>
+              <a:rPr sz="1600" b="0">
+                <a:solidFill>
+                  <a:srgbClr val="605E5C"/>
+                </a:solidFill>
+                <a:latin typeface="Segoe UI"/>
+              </a:rPr>
+              <a:t>The store is a project data-plane service — reachable from a Web App, Container App or AKS over REST/SDK with Entra auth.</a:t>
+            </a:r>
+          </a:p>
+        </p:txBody>
+      </p:sp>
+      <p:sp>
+        <p:nvSpPr>
+          <p:cNvPr id="7" name="TextBox 6"/>
+          <p:cNvSpPr txBox="1"/>
+          <p:nvPr/>
+        </p:nvSpPr>
+        <p:spPr>
+          <a:xfrm>
+            <a:off x="640080" y="6419088"/>
+            <a:ext cx="7315200" cy="320040"/>
+          </a:xfrm>
+          <a:prstGeom prst="rect">
+            <a:avLst/>
+          </a:prstGeom>
+          <a:noFill/>
+        </p:spPr>
+        <p:txBody>
+          <a:bodyPr wrap="square">
+            <a:spAutoFit/>
+          </a:bodyPr>
+          <a:lstStyle/>
+          <a:p>
+            <a:pPr algn="l">
+              <a:lnSpc>
+                <a:spcPct val="100000"/>
+              </a:lnSpc>
+              <a:spcAft>
+                <a:spcPts val="600"/>
+              </a:spcAft>
+            </a:pPr>
+            <a:r>
+              <a:rPr sz="900" b="0">
+                <a:solidFill>
+                  <a:srgbClr val="605E5C"/>
+                </a:solidFill>
+                <a:latin typeface="Segoe UI"/>
+              </a:rPr>
+              <a:t>AI FOUNDRY  ·  security, features and capabilities</a:t>
+            </a:r>
+          </a:p>
+        </p:txBody>
+      </p:sp>
+      <p:sp>
+        <p:nvSpPr>
+          <p:cNvPr id="8" name="TextBox 7"/>
+          <p:cNvSpPr txBox="1"/>
+          <p:nvPr/>
+        </p:nvSpPr>
+        <p:spPr>
+          <a:xfrm>
+            <a:off x="10972800" y="6419088"/>
+            <a:ext cx="822960" cy="320040"/>
+          </a:xfrm>
+          <a:prstGeom prst="rect">
+            <a:avLst/>
+          </a:prstGeom>
+          <a:noFill/>
+        </p:spPr>
+        <p:txBody>
+          <a:bodyPr wrap="square">
+            <a:spAutoFit/>
+          </a:bodyPr>
+          <a:lstStyle/>
+          <a:p>
+            <a:pPr algn="r">
+              <a:lnSpc>
+                <a:spcPct val="100000"/>
+              </a:lnSpc>
+              <a:spcAft>
+                <a:spcPts val="600"/>
+              </a:spcAft>
+            </a:pPr>
+            <a:r>
+              <a:rPr sz="900" b="0">
+                <a:solidFill>
+                  <a:srgbClr val="605E5C"/>
+                </a:solidFill>
+                <a:latin typeface="Segoe UI"/>
+              </a:rPr>
+              <a:t>12</a:t>
+            </a:r>
+          </a:p>
+        </p:txBody>
+      </p:sp>
+      <p:sp>
+        <p:nvSpPr>
+          <p:cNvPr id="9" name="Rounded Rectangle 8"/>
+          <p:cNvSpPr/>
+          <p:nvPr/>
+        </p:nvSpPr>
+        <p:spPr>
+          <a:xfrm>
+            <a:off x="777240" y="2240280"/>
+            <a:ext cx="5120640" cy="1783080"/>
+          </a:xfrm>
+          <a:prstGeom prst="roundRect">
+            <a:avLst>
+              <a:gd name="adj" fmla="val 5000"/>
+            </a:avLst>
+          </a:prstGeom>
+          <a:solidFill>
+            <a:srgbClr val="FFFFFF"/>
+          </a:solidFill>
+          <a:ln w="25400">
+            <a:solidFill>
+              <a:srgbClr val="0078D4"/>
+            </a:solidFill>
+          </a:ln>
+          <a:effectLst/>
+        </p:spPr>
+        <p:style>
+          <a:lnRef idx="1">
+            <a:schemeClr val="accent1"/>
+          </a:lnRef>
+          <a:fillRef idx="3">
+            <a:schemeClr val="accent1"/>
+          </a:fillRef>
+          <a:effectRef idx="2">
+            <a:schemeClr val="accent1"/>
+          </a:effectRef>
+          <a:fontRef idx="minor">
+            <a:schemeClr val="lt1"/>
+          </a:fontRef>
+        </p:style>
+        <p:txBody>
+          <a:bodyPr rtlCol="0" anchor="ctr"/>
+          <a:lstStyle/>
+          <a:p>
+            <a:pPr algn="ctr"/>
+            <a:endParaRPr/>
+          </a:p>
+        </p:txBody>
+      </p:sp>
+      <p:sp>
+        <p:nvSpPr>
+          <p:cNvPr id="10" name="TextBox 9"/>
+          <p:cNvSpPr txBox="1"/>
+          <p:nvPr/>
+        </p:nvSpPr>
+        <p:spPr>
+          <a:xfrm>
+            <a:off x="1033271" y="2404872"/>
+            <a:ext cx="4608576" cy="1472184"/>
+          </a:xfrm>
+          <a:prstGeom prst="rect">
+            <a:avLst/>
+          </a:prstGeom>
+          <a:noFill/>
+        </p:spPr>
+        <p:txBody>
+          <a:bodyPr wrap="square">
+            <a:normAutofit/>
+          </a:bodyPr>
+          <a:lstStyle/>
+          <a:p>
+            <a:pPr algn="l">
+              <a:lnSpc>
+                <a:spcPct val="100000"/>
+              </a:lnSpc>
+              <a:spcAft>
+                <a:spcPts val="300"/>
+              </a:spcAft>
+            </a:pPr>
+            <a:r>
+              <a:rPr sz="1300" b="1">
+                <a:solidFill>
+                  <a:srgbClr val="0078D4"/>
+                </a:solidFill>
+                <a:latin typeface="Segoe UI"/>
+              </a:rPr>
+              <a:t>EXTERNAL AGENTS · ANY HOST</a:t>
+            </a:r>
+          </a:p>
+          <a:p>
+            <a:pPr algn="l">
+              <a:lnSpc>
+                <a:spcPct val="102000"/>
+              </a:lnSpc>
+              <a:spcAft>
+                <a:spcPts val="400"/>
+              </a:spcAft>
+            </a:pPr>
+            <a:r>
+              <a:rPr sz="1400" b="1">
+                <a:solidFill>
+                  <a:srgbClr val="243A5E"/>
+                </a:solidFill>
+                <a:latin typeface="Segoe UI"/>
+              </a:rPr>
+              <a:t>Web App, Container App or AKS.</a:t>
+            </a:r>
+          </a:p>
+          <a:p>
+            <a:pPr algn="l">
+              <a:lnSpc>
+                <a:spcPct val="105000"/>
+              </a:lnSpc>
+              <a:spcAft>
+                <a:spcPts val="0"/>
+              </a:spcAft>
+            </a:pPr>
+            <a:r>
+              <a:rPr sz="1150" b="0">
+                <a:solidFill>
+                  <a:srgbClr val="605E5C"/>
+                </a:solidFill>
+                <a:latin typeface="Segoe UI"/>
+              </a:rPr>
+              <a:t>The memory store is a project data-plane resource, decoupled from where the agent runs. Call it over REST/SDK with a Microsoft Entra token (Foundry User role) — from AKS, via workload identity.</a:t>
+            </a:r>
+          </a:p>
+        </p:txBody>
+      </p:sp>
+      <p:sp>
+        <p:nvSpPr>
+          <p:cNvPr id="11" name="Rounded Rectangle 8"/>
+          <p:cNvSpPr/>
+          <p:nvPr/>
+        </p:nvSpPr>
+        <p:spPr>
+          <a:xfrm>
+            <a:off x="6263640" y="2240280"/>
+            <a:ext cx="5120640" cy="1783080"/>
+          </a:xfrm>
+          <a:prstGeom prst="roundRect">
+            <a:avLst>
+              <a:gd name="adj" fmla="val 5000"/>
+            </a:avLst>
+          </a:prstGeom>
+          <a:solidFill>
+            <a:srgbClr val="FFFFFF"/>
+          </a:solidFill>
+          <a:ln w="25400">
+            <a:solidFill>
+              <a:srgbClr val="107C10"/>
+            </a:solidFill>
+          </a:ln>
+          <a:effectLst/>
+        </p:spPr>
+        <p:style>
+          <a:lnRef idx="1">
+            <a:schemeClr val="accent1"/>
+          </a:lnRef>
+          <a:fillRef idx="3">
+            <a:schemeClr val="accent1"/>
+          </a:fillRef>
+          <a:effectRef idx="2">
+            <a:schemeClr val="accent1"/>
+          </a:effectRef>
+          <a:fontRef idx="minor">
+            <a:schemeClr val="lt1"/>
+          </a:fontRef>
+        </p:style>
+        <p:txBody>
+          <a:bodyPr rtlCol="0" anchor="ctr"/>
+          <a:lstStyle/>
+          <a:p>
+            <a:pPr algn="ctr"/>
+            <a:endParaRPr/>
+          </a:p>
+        </p:txBody>
+      </p:sp>
+      <p:sp>
+        <p:nvSpPr>
+          <p:cNvPr id="12" name="TextBox 9"/>
+          <p:cNvSpPr txBox="1"/>
+          <p:nvPr/>
+        </p:nvSpPr>
+        <p:spPr>
+          <a:xfrm>
+            <a:off x="6519672" y="2404872"/>
+            <a:ext cx="4608576" cy="1472184"/>
+          </a:xfrm>
+          <a:prstGeom prst="rect">
+            <a:avLst/>
+          </a:prstGeom>
+          <a:noFill/>
+        </p:spPr>
+        <p:txBody>
+          <a:bodyPr wrap="square">
+            <a:normAutofit/>
+          </a:bodyPr>
+          <a:lstStyle/>
+          <a:p>
+            <a:pPr algn="l">
+              <a:lnSpc>
+                <a:spcPct val="100000"/>
+              </a:lnSpc>
+              <a:spcAft>
+                <a:spcPts val="300"/>
+              </a:spcAft>
+            </a:pPr>
+            <a:r>
+              <a:rPr sz="1300" b="1">
+                <a:solidFill>
+                  <a:srgbClr val="107C10"/>
+                </a:solidFill>
+                <a:latin typeface="Segoe UI"/>
+              </a:rPr>
+              <a:t>TWO WAYS TO CALL IT</a:t>
+            </a:r>
+          </a:p>
+          <a:p>
+            <a:pPr algn="l">
+              <a:lnSpc>
+                <a:spcPct val="102000"/>
+              </a:lnSpc>
+              <a:spcAft>
+                <a:spcPts val="400"/>
+              </a:spcAft>
+            </a:pPr>
+            <a:r>
+              <a:rPr sz="1400" b="1">
+                <a:solidFill>
+                  <a:srgbClr val="243A5E"/>
+                </a:solidFill>
+                <a:latin typeface="Segoe UI"/>
+              </a:rPr>
+              <a:t>Search tool, or low-level APIs.</a:t>
+            </a:r>
+          </a:p>
+          <a:p>
+            <a:pPr algn="l">
+              <a:lnSpc>
+                <a:spcPct val="105000"/>
+              </a:lnSpc>
+              <a:spcAft>
+                <a:spcPts val="0"/>
+              </a:spcAft>
+            </a:pPr>
+            <a:r>
+              <a:rPr sz="1150" b="0">
+                <a:solidFill>
+                  <a:srgbClr val="605E5C"/>
+                </a:solidFill>
+                <a:latin typeface="Segoe UI"/>
+              </a:rPr>
+              <a:t>Attach the memory_search tool to a Foundry prompt agent (auto extract + retrieve via the Responses API), or drive the store yourself: update_memories / search_memories / item CRUD, passing scope on every call.</a:t>
+            </a:r>
+          </a:p>
+        </p:txBody>
+      </p:sp>
+      <p:sp>
+        <p:nvSpPr>
+          <p:cNvPr id="13" name="Rounded Rectangle 8"/>
+          <p:cNvSpPr/>
+          <p:nvPr/>
+        </p:nvSpPr>
+        <p:spPr>
+          <a:xfrm>
+            <a:off x="777240" y="4114800"/>
+            <a:ext cx="5120640" cy="1783080"/>
+          </a:xfrm>
+          <a:prstGeom prst="roundRect">
+            <a:avLst>
+              <a:gd name="adj" fmla="val 5000"/>
+            </a:avLst>
+          </a:prstGeom>
+          <a:solidFill>
+            <a:srgbClr val="FFFFFF"/>
+          </a:solidFill>
+          <a:ln w="25400">
+            <a:solidFill>
+              <a:srgbClr val="5C2D91"/>
+            </a:solidFill>
+          </a:ln>
+          <a:effectLst/>
+        </p:spPr>
+        <p:style>
+          <a:lnRef idx="1">
+            <a:schemeClr val="accent1"/>
+          </a:lnRef>
+          <a:fillRef idx="3">
+            <a:schemeClr val="accent1"/>
+          </a:fillRef>
+          <a:effectRef idx="2">
+            <a:schemeClr val="accent1"/>
+          </a:effectRef>
+          <a:fontRef idx="minor">
+            <a:schemeClr val="lt1"/>
+          </a:fontRef>
+        </p:style>
+        <p:txBody>
+          <a:bodyPr rtlCol="0" anchor="ctr"/>
+          <a:lstStyle/>
+          <a:p>
+            <a:pPr algn="ctr"/>
+            <a:endParaRPr/>
+          </a:p>
+        </p:txBody>
+      </p:sp>
+      <p:sp>
+        <p:nvSpPr>
+          <p:cNvPr id="14" name="TextBox 9"/>
+          <p:cNvSpPr txBox="1"/>
+          <p:nvPr/>
+        </p:nvSpPr>
+        <p:spPr>
+          <a:xfrm>
+            <a:off x="1033271" y="4279392"/>
+            <a:ext cx="4608576" cy="1472184"/>
+          </a:xfrm>
+          <a:prstGeom prst="rect">
+            <a:avLst/>
+          </a:prstGeom>
+          <a:noFill/>
+        </p:spPr>
+        <p:txBody>
+          <a:bodyPr wrap="square">
+            <a:normAutofit/>
+          </a:bodyPr>
+          <a:lstStyle/>
+          <a:p>
+            <a:pPr algn="l">
+              <a:lnSpc>
+                <a:spcPct val="100000"/>
+              </a:lnSpc>
+              <a:spcAft>
+                <a:spcPts val="300"/>
+              </a:spcAft>
+            </a:pPr>
+            <a:r>
+              <a:rPr sz="1300" b="1">
+                <a:solidFill>
+                  <a:srgbClr val="5C2D91"/>
+                </a:solidFill>
+                <a:latin typeface="Segoe UI"/>
+              </a:rPr>
+              <a:t>LIMITATIONS</a:t>
+            </a:r>
+          </a:p>
+          <a:p>
+            <a:pPr algn="l">
+              <a:lnSpc>
+                <a:spcPct val="102000"/>
+              </a:lnSpc>
+              <a:spcAft>
+                <a:spcPts val="400"/>
+              </a:spcAft>
+            </a:pPr>
+            <a:r>
+              <a:rPr sz="1400" b="1">
+                <a:solidFill>
+                  <a:srgbClr val="243A5E"/>
+                </a:solidFill>
+                <a:latin typeface="Segoe UI"/>
+              </a:rPr>
+              <a:t>Public endpoint, explicit scope.</a:t>
+            </a:r>
+          </a:p>
+          <a:p>
+            <a:pPr algn="l">
+              <a:lnSpc>
+                <a:spcPct val="105000"/>
+              </a:lnSpc>
+              <a:spcAft>
+                <a:spcPts val="0"/>
+              </a:spcAft>
+            </a:pPr>
+            <a:r>
+              <a:rPr sz="1150" b="0">
+                <a:solidFill>
+                  <a:srgbClr val="605E5C"/>
+                </a:solidFill>
+                <a:latin typeface="Segoe UI"/>
+              </a:rPr>
+              <a:t>No VNet / Private Link for memory stores — public data-plane only. Low-level calls need an explicit scope (no identity auto-resolution). Preview: some store options are create-time only; poisoning defense is yours.</a:t>
+            </a:r>
+          </a:p>
+        </p:txBody>
+      </p:sp>
+      <p:sp>
+        <p:nvSpPr>
+          <p:cNvPr id="15" name="Rounded Rectangle 8"/>
+          <p:cNvSpPr/>
+          <p:nvPr/>
+        </p:nvSpPr>
+        <p:spPr>
+          <a:xfrm>
+            <a:off x="6263640" y="4114800"/>
+            <a:ext cx="5120640" cy="1783080"/>
+          </a:xfrm>
+          <a:prstGeom prst="roundRect">
+            <a:avLst>
+              <a:gd name="adj" fmla="val 5000"/>
+            </a:avLst>
+          </a:prstGeom>
+          <a:solidFill>
+            <a:srgbClr val="FFFFFF"/>
+          </a:solidFill>
+          <a:ln w="25400">
+            <a:solidFill>
+              <a:srgbClr val="C5292A"/>
+            </a:solidFill>
+          </a:ln>
+          <a:effectLst/>
+        </p:spPr>
+        <p:style>
+          <a:lnRef idx="1">
+            <a:schemeClr val="accent1"/>
+          </a:lnRef>
+          <a:fillRef idx="3">
+            <a:schemeClr val="accent1"/>
+          </a:fillRef>
+          <a:effectRef idx="2">
+            <a:schemeClr val="accent1"/>
+          </a:effectRef>
+          <a:fontRef idx="minor">
+            <a:schemeClr val="lt1"/>
+          </a:fontRef>
+        </p:style>
+        <p:txBody>
+          <a:bodyPr rtlCol="0" anchor="ctr"/>
+          <a:lstStyle/>
+          <a:p>
+            <a:pPr algn="ctr"/>
+            <a:endParaRPr/>
+          </a:p>
+        </p:txBody>
+      </p:sp>
+      <p:sp>
+        <p:nvSpPr>
+          <p:cNvPr id="16" name="TextBox 9"/>
+          <p:cNvSpPr txBox="1"/>
+          <p:nvPr/>
+        </p:nvSpPr>
+        <p:spPr>
+          <a:xfrm>
+            <a:off x="6519672" y="4279392"/>
+            <a:ext cx="4608576" cy="1472184"/>
+          </a:xfrm>
+          <a:prstGeom prst="rect">
+            <a:avLst/>
+          </a:prstGeom>
+          <a:noFill/>
+        </p:spPr>
+        <p:txBody>
+          <a:bodyPr wrap="square">
+            <a:normAutofit/>
+          </a:bodyPr>
+          <a:lstStyle/>
+          <a:p>
+            <a:pPr algn="l">
+              <a:lnSpc>
+                <a:spcPct val="100000"/>
+              </a:lnSpc>
+              <a:spcAft>
+                <a:spcPts val="300"/>
+              </a:spcAft>
+            </a:pPr>
+            <a:r>
+              <a:rPr sz="1300" b="1">
+                <a:solidFill>
+                  <a:srgbClr val="C5292A"/>
+                </a:solidFill>
+                <a:latin typeface="Segoe UI"/>
+              </a:rPr>
+              <a:t>QUOTAS · MODEL DEPENDENCY</a:t>
+            </a:r>
+          </a:p>
+          <a:p>
+            <a:pPr algn="l">
+              <a:lnSpc>
+                <a:spcPct val="102000"/>
+              </a:lnSpc>
+              <a:spcAft>
+                <a:spcPts val="400"/>
+              </a:spcAft>
+            </a:pPr>
+            <a:r>
+              <a:rPr sz="1400" b="1">
+                <a:solidFill>
+                  <a:srgbClr val="243A5E"/>
+                </a:solidFill>
+                <a:latin typeface="Segoe UI"/>
+              </a:rPr>
+              <a:t>Per store; bring your own models.</a:t>
+            </a:r>
+          </a:p>
+          <a:p>
+            <a:pPr algn="l">
+              <a:lnSpc>
+                <a:spcPct val="105000"/>
+              </a:lnSpc>
+              <a:spcAft>
+                <a:spcPts val="0"/>
+              </a:spcAft>
+            </a:pPr>
+            <a:r>
+              <a:rPr sz="1150" b="0">
+                <a:solidFill>
+                  <a:srgbClr val="605E5C"/>
+                </a:solidFill>
+                <a:latin typeface="Segoe UI"/>
+              </a:rPr>
+              <a:t>100 scopes / store · 10,000 memories / scope · 1,000 search/min · 1,000 update/min. Requires compatible Azure OpenAI chat + embedding deployments in the project — you pay for that usage.</a:t>
+            </a:r>
+          </a:p>
+        </p:txBody>
+      </p:sp>
+      <p:sp>
+        <p:nvSpPr>
+          <p:cNvPr id="17" name="TextBox 16"/>
+          <p:cNvSpPr txBox="1"/>
+          <p:nvPr/>
+        </p:nvSpPr>
+        <p:spPr>
+          <a:xfrm>
+            <a:off x="777240" y="5989320"/>
+            <a:ext cx="10607040" cy="310896"/>
+          </a:xfrm>
+          <a:prstGeom prst="rect">
+            <a:avLst/>
+          </a:prstGeom>
+          <a:noFill/>
+        </p:spPr>
+        <p:txBody>
+          <a:bodyPr wrap="square">
+            <a:spAutoFit/>
+          </a:bodyPr>
+          <a:lstStyle/>
+          <a:p>
+            <a:pPr algn="l">
+              <a:lnSpc>
+                <a:spcPct val="100000"/>
+              </a:lnSpc>
+            </a:pPr>
+            <a:r>
+              <a:rPr sz="1250" b="1">
+                <a:solidFill>
+                  <a:srgbClr val="243A5E"/>
+                </a:solidFill>
+                <a:latin typeface="Segoe UI"/>
+              </a:rPr>
+              <a:t>Gislefoss's memory.bicep store is reachable from a Web App, Container App or AKS pod via the low-level APIs.</a:t>
+            </a:r>
+          </a:p>
+        </p:txBody>
+      </p:sp>
+    </p:spTree>
+  </p:cSld>
+  <p:clrMapOvr>
+    <a:masterClrMapping/>
+  </p:clrMapOvr>
+</p:sld>
+</file>
+
+<file path=ppt/slides/slide32.xml><?xml version="1.0" encoding="utf-8"?>
 <p:sld xmlns:a="http://schemas.openxmlformats.org/drawingml/2006/main" xmlns:r="http://schemas.openxmlformats.org/officeDocument/2006/relationships" xmlns:p="http://schemas.openxmlformats.org/presentationml/2006/main">
   <p:cSld>
     <p:spTree>

</xml_diff>